<commit_message>
fix: repair Korean fonts in instructor PPT and diagrams
Regenerate diagram PNGs with NanumGothic, set 맑은 고딕 for both
latin and east-asian run fonts in python-pptx, and replace broken
JPEG embeds in VIEW_강사발표.html with the new PNGs.

Co-authored-by: ho0215 <ho0215@users.noreply.github.com>
</commit_message>
<xml_diff>
--- a/docs/presentation/ppt/Aniverse_발표_강사용.pptx
+++ b/docs/presentation/ppt/Aniverse_발표_강사용.pptx
@@ -3170,7 +3170,9 @@
                 <a:solidFill>
                   <a:srgbClr val="FFFFFF"/>
                 </a:solidFill>
-                <a:latin typeface="Malgun Gothic"/>
+                <a:latin typeface="맑은 고딕"/>
+                <a:ea typeface="맑은 고딕"/>
+                <a:cs typeface="맑은 고딕"/>
               </a:rPr>
               <a:t>Aniverse</a:t>
             </a:r>
@@ -3186,7 +3188,9 @@
                 <a:solidFill>
                   <a:srgbClr val="BFDBFE"/>
                 </a:solidFill>
-                <a:latin typeface="Malgun Gothic"/>
+                <a:latin typeface="맑은 고딕"/>
+                <a:ea typeface="맑은 고딕"/>
+                <a:cs typeface="맑은 고딕"/>
               </a:rPr>
               <a:t>온프레미스 3-Tier 서비스 → AWS 이전</a:t>
             </a:r>
@@ -3202,7 +3206,9 @@
                 <a:solidFill>
                   <a:srgbClr val="93C5FD"/>
                 </a:solidFill>
-                <a:latin typeface="Malgun Gothic"/>
+                <a:latin typeface="맑은 고딕"/>
+                <a:ea typeface="맑은 고딕"/>
+                <a:cs typeface="맑은 고딕"/>
               </a:rPr>
               <a:t>Terraform 모듈 구성 · GitHub Actions · CI/CD · HA · 보안</a:t>
             </a:r>
@@ -3218,7 +3224,9 @@
                 <a:solidFill>
                   <a:srgbClr val="7DD3FC"/>
                 </a:solidFill>
-                <a:latin typeface="Malgun Gothic"/>
+                <a:latin typeface="맑은 고딕"/>
+                <a:ea typeface="맑은 고딕"/>
+                <a:cs typeface="맑은 고딕"/>
               </a:rPr>
               <a:t>https://aniverse.my</a:t>
             </a:r>
@@ -3313,7 +3321,9 @@
                 <a:solidFill>
                   <a:srgbClr val="FFFFFF"/>
                 </a:solidFill>
-                <a:latin typeface="Malgun Gothic"/>
+                <a:latin typeface="맑은 고딕"/>
+                <a:ea typeface="맑은 고딕"/>
+                <a:cs typeface="맑은 고딕"/>
               </a:rPr>
               <a:t>4. GitHub Actions (2)</a:t>
             </a:r>
@@ -3329,7 +3339,9 @@
                 <a:solidFill>
                   <a:srgbClr val="93C5FD"/>
                 </a:solidFill>
-                <a:latin typeface="Malgun Gothic"/>
+                <a:latin typeface="맑은 고딕"/>
+                <a:ea typeface="맑은 고딕"/>
+                <a:cs typeface="맑은 고딕"/>
               </a:rPr>
               <a:t>실제로 돌아가는 파이프라인</a:t>
             </a:r>
@@ -3383,7 +3395,9 @@
                 <a:solidFill>
                   <a:srgbClr val="2563EB"/>
                 </a:solidFill>
-                <a:latin typeface="Malgun Gothic"/>
+                <a:latin typeface="맑은 고딕"/>
+                <a:ea typeface="맑은 고딕"/>
+                <a:cs typeface="맑은 고딕"/>
               </a:rPr>
               <a:t>anime-project-infra</a:t>
             </a:r>
@@ -3399,7 +3413,9 @@
                 <a:solidFill>
                   <a:srgbClr val="0F172A"/>
                 </a:solidFill>
-                <a:latin typeface="Malgun Gothic"/>
+                <a:latin typeface="맑은 고딕"/>
+                <a:ea typeface="맑은 고딕"/>
+                <a:cs typeface="맑은 고딕"/>
               </a:rPr>
               <a:t>• trigger: main push / workflow_dispatch</a:t>
             </a:r>
@@ -3415,7 +3431,9 @@
                 <a:solidFill>
                   <a:srgbClr val="0F172A"/>
                 </a:solidFill>
-                <a:latin typeface="Malgun Gothic"/>
+                <a:latin typeface="맑은 고딕"/>
+                <a:ea typeface="맑은 고딕"/>
+                <a:cs typeface="맑은 고딕"/>
               </a:rPr>
               <a:t>• steps: checkout → setup TF → fmt</a:t>
             </a:r>
@@ -3431,7 +3449,9 @@
                 <a:solidFill>
                   <a:srgbClr val="0F172A"/>
                 </a:solidFill>
-                <a:latin typeface="Malgun Gothic"/>
+                <a:latin typeface="맑은 고딕"/>
+                <a:ea typeface="맑은 고딕"/>
+                <a:cs typeface="맑은 고딕"/>
               </a:rPr>
               <a:t>•         validate → plan → apply</a:t>
             </a:r>
@@ -3447,7 +3467,9 @@
                 <a:solidFill>
                   <a:srgbClr val="0F172A"/>
                 </a:solidFill>
-                <a:latin typeface="Malgun Gothic"/>
+                <a:latin typeface="맑은 고딕"/>
+                <a:ea typeface="맑은 고딕"/>
+                <a:cs typeface="맑은 고딕"/>
               </a:rPr>
               <a:t>• 결과: VPC/ALB/ASG/RDS/S3/WAF 갱신</a:t>
             </a:r>
@@ -3463,7 +3485,9 @@
                 <a:solidFill>
                   <a:srgbClr val="0F172A"/>
                 </a:solidFill>
-                <a:latin typeface="Malgun Gothic"/>
+                <a:latin typeface="맑은 고딕"/>
+                <a:ea typeface="맑은 고딕"/>
+                <a:cs typeface="맑은 고딕"/>
               </a:rPr>
               <a:t>• Secrets: AWS 자격증명, TF_VAR_*</a:t>
             </a:r>
@@ -3517,7 +3541,9 @@
                 <a:solidFill>
                   <a:srgbClr val="EA580C"/>
                 </a:solidFill>
-                <a:latin typeface="Malgun Gothic"/>
+                <a:latin typeface="맑은 고딕"/>
+                <a:ea typeface="맑은 고딕"/>
+                <a:cs typeface="맑은 고딕"/>
               </a:rPr>
               <a:t>anime-project</a:t>
             </a:r>
@@ -3533,7 +3559,9 @@
                 <a:solidFill>
                   <a:srgbClr val="0F172A"/>
                 </a:solidFill>
-                <a:latin typeface="Malgun Gothic"/>
+                <a:latin typeface="맑은 고딕"/>
+                <a:ea typeface="맑은 고딕"/>
+                <a:cs typeface="맑은 고딕"/>
               </a:rPr>
               <a:t>• trigger: main push / workflow_dispatch</a:t>
             </a:r>
@@ -3549,7 +3577,9 @@
                 <a:solidFill>
                   <a:srgbClr val="0F172A"/>
                 </a:solidFill>
-                <a:latin typeface="Malgun Gothic"/>
+                <a:latin typeface="맑은 고딕"/>
+                <a:ea typeface="맑은 고딕"/>
+                <a:cs typeface="맑은 고딕"/>
               </a:rPr>
               <a:t>• steps: media → S3 sync</a:t>
             </a:r>
@@ -3565,7 +3595,9 @@
                 <a:solidFill>
                   <a:srgbClr val="0F172A"/>
                 </a:solidFill>
-                <a:latin typeface="Malgun Gothic"/>
+                <a:latin typeface="맑은 고딕"/>
+                <a:ea typeface="맑은 고딕"/>
+                <a:cs typeface="맑은 고딕"/>
               </a:rPr>
               <a:t>•         앱 zip 패키징 → deploy S3</a:t>
             </a:r>
@@ -3581,7 +3613,9 @@
                 <a:solidFill>
                   <a:srgbClr val="0F172A"/>
                 </a:solidFill>
-                <a:latin typeface="Malgun Gothic"/>
+                <a:latin typeface="맑은 고딕"/>
+                <a:ea typeface="맑은 고딕"/>
+                <a:cs typeface="맑은 고딕"/>
               </a:rPr>
               <a:t>•         CodeDeploy → ASG 배포</a:t>
             </a:r>
@@ -3597,7 +3631,9 @@
                 <a:solidFill>
                   <a:srgbClr val="0F172A"/>
                 </a:solidFill>
-                <a:latin typeface="Malgun Gothic"/>
+                <a:latin typeface="맑은 고딕"/>
+                <a:ea typeface="맑은 고딕"/>
+                <a:cs typeface="맑은 고딕"/>
               </a:rPr>
               <a:t>• hooks: install → migrate → Daphne 기동</a:t>
             </a:r>
@@ -3632,7 +3668,9 @@
                 <a:solidFill>
                   <a:srgbClr val="475569"/>
                 </a:solidFill>
-                <a:latin typeface="Malgun Gothic"/>
+                <a:latin typeface="맑은 고딕"/>
+                <a:ea typeface="맑은 고딕"/>
+                <a:cs typeface="맑은 고딕"/>
               </a:rPr>
               <a:t>Aniverse · 온프레미스 3-tier → AWS   |   10/12</a:t>
             </a:r>
@@ -3727,7 +3765,9 @@
                 <a:solidFill>
                   <a:srgbClr val="FFFFFF"/>
                 </a:solidFill>
-                <a:latin typeface="Malgun Gothic"/>
+                <a:latin typeface="맑은 고딕"/>
+                <a:ea typeface="맑은 고딕"/>
+                <a:cs typeface="맑은 고딕"/>
               </a:rPr>
               <a:t>5. CI/CD · HA · 모니터링 · 보안</a:t>
             </a:r>
@@ -3743,7 +3783,9 @@
                 <a:solidFill>
                   <a:srgbClr val="93C5FD"/>
                 </a:solidFill>
-                <a:latin typeface="Malgun Gothic"/>
+                <a:latin typeface="맑은 고딕"/>
+                <a:ea typeface="맑은 고딕"/>
+                <a:cs typeface="맑은 고딕"/>
               </a:rPr>
               <a:t>배포·가용성·관측·보안을 한 장으로</a:t>
             </a:r>
@@ -3802,7 +3844,9 @@
                 <a:solidFill>
                   <a:srgbClr val="475569"/>
                 </a:solidFill>
-                <a:latin typeface="Malgun Gothic"/>
+                <a:latin typeface="맑은 고딕"/>
+                <a:ea typeface="맑은 고딕"/>
+                <a:cs typeface="맑은 고딕"/>
               </a:rPr>
               <a:t>Aniverse · 온프레미스 3-tier → AWS   |   11/12</a:t>
             </a:r>
@@ -3897,7 +3941,9 @@
                 <a:solidFill>
                   <a:srgbClr val="FFFFFF"/>
                 </a:solidFill>
-                <a:latin typeface="Malgun Gothic"/>
+                <a:latin typeface="맑은 고딕"/>
+                <a:ea typeface="맑은 고딕"/>
+                <a:cs typeface="맑은 고딕"/>
               </a:rPr>
               <a:t>5. 적용 내용 상세</a:t>
             </a:r>
@@ -3913,7 +3959,9 @@
                 <a:solidFill>
                   <a:srgbClr val="93C5FD"/>
                 </a:solidFill>
-                <a:latin typeface="Malgun Gothic"/>
+                <a:latin typeface="맑은 고딕"/>
+                <a:ea typeface="맑은 고딕"/>
+                <a:cs typeface="맑은 고딕"/>
               </a:rPr>
               <a:t>서비스가 실제로 어떻게 버티는지</a:t>
             </a:r>
@@ -3967,7 +4015,9 @@
                 <a:solidFill>
                   <a:srgbClr val="2563EB"/>
                 </a:solidFill>
-                <a:latin typeface="Malgun Gothic"/>
+                <a:latin typeface="맑은 고딕"/>
+                <a:ea typeface="맑은 고딕"/>
+                <a:cs typeface="맑은 고딕"/>
               </a:rPr>
               <a:t>CI/CD</a:t>
             </a:r>
@@ -3983,7 +4033,9 @@
                 <a:solidFill>
                   <a:srgbClr val="0F172A"/>
                 </a:solidFill>
-                <a:latin typeface="Malgun Gothic"/>
+                <a:latin typeface="맑은 고딕"/>
+                <a:ea typeface="맑은 고딕"/>
+                <a:cs typeface="맑은 고딕"/>
               </a:rPr>
               <a:t>• Actions + CodeDeploy로 배포 경로 고정</a:t>
             </a:r>
@@ -3999,7 +4051,9 @@
                 <a:solidFill>
                   <a:srgbClr val="0F172A"/>
                 </a:solidFill>
-                <a:latin typeface="Malgun Gothic"/>
+                <a:latin typeface="맑은 고딕"/>
+                <a:ea typeface="맑은 고딕"/>
+                <a:cs typeface="맑은 고딕"/>
               </a:rPr>
               <a:t>• ALB /health/ 로 배포 성공 판정</a:t>
             </a:r>
@@ -4015,7 +4069,9 @@
                 <a:solidFill>
                   <a:srgbClr val="0F172A"/>
                 </a:solidFill>
-                <a:latin typeface="Malgun Gothic"/>
+                <a:latin typeface="맑은 고딕"/>
+                <a:ea typeface="맑은 고딕"/>
+                <a:cs typeface="맑은 고딕"/>
               </a:rPr>
               <a:t>• 실패 시 Actions·배포 로그로 추적</a:t>
             </a:r>
@@ -4069,7 +4125,9 @@
                 <a:solidFill>
                   <a:srgbClr val="EA580C"/>
                 </a:solidFill>
-                <a:latin typeface="Malgun Gothic"/>
+                <a:latin typeface="맑은 고딕"/>
+                <a:ea typeface="맑은 고딕"/>
+                <a:cs typeface="맑은 고딕"/>
               </a:rPr>
               <a:t>고가용성</a:t>
             </a:r>
@@ -4085,7 +4143,9 @@
                 <a:solidFill>
                   <a:srgbClr val="0F172A"/>
                 </a:solidFill>
-                <a:latin typeface="Malgun Gothic"/>
+                <a:latin typeface="맑은 고딕"/>
+                <a:ea typeface="맑은 고딕"/>
+                <a:cs typeface="맑은 고딕"/>
               </a:rPr>
               <a:t>• ALB로 트래픽 분산</a:t>
             </a:r>
@@ -4101,7 +4161,9 @@
                 <a:solidFill>
                   <a:srgbClr val="0F172A"/>
                 </a:solidFill>
-                <a:latin typeface="Malgun Gothic"/>
+                <a:latin typeface="맑은 고딕"/>
+                <a:ea typeface="맑은 고딕"/>
+                <a:cs typeface="맑은 고딕"/>
               </a:rPr>
               <a:t>• ASG로 인스턴스 교체·확장</a:t>
             </a:r>
@@ -4117,7 +4179,9 @@
                 <a:solidFill>
                   <a:srgbClr val="0F172A"/>
                 </a:solidFill>
-                <a:latin typeface="Malgun Gothic"/>
+                <a:latin typeface="맑은 고딕"/>
+                <a:ea typeface="맑은 고딕"/>
+                <a:cs typeface="맑은 고딕"/>
               </a:rPr>
               <a:t>• App/DB 서브넷 분리 배치</a:t>
             </a:r>
@@ -4171,7 +4235,9 @@
                 <a:solidFill>
                   <a:srgbClr val="0D9488"/>
                 </a:solidFill>
-                <a:latin typeface="Malgun Gothic"/>
+                <a:latin typeface="맑은 고딕"/>
+                <a:ea typeface="맑은 고딕"/>
+                <a:cs typeface="맑은 고딕"/>
               </a:rPr>
               <a:t>모니터링</a:t>
             </a:r>
@@ -4187,7 +4253,9 @@
                 <a:solidFill>
                   <a:srgbClr val="0F172A"/>
                 </a:solidFill>
-                <a:latin typeface="Malgun Gothic"/>
+                <a:latin typeface="맑은 고딕"/>
+                <a:ea typeface="맑은 고딕"/>
+                <a:cs typeface="맑은 고딕"/>
               </a:rPr>
               <a:t>• CloudWatch 알람</a:t>
             </a:r>
@@ -4203,7 +4271,9 @@
                 <a:solidFill>
                   <a:srgbClr val="0F172A"/>
                 </a:solidFill>
-                <a:latin typeface="Malgun Gothic"/>
+                <a:latin typeface="맑은 고딕"/>
+                <a:ea typeface="맑은 고딕"/>
+                <a:cs typeface="맑은 고딕"/>
               </a:rPr>
               <a:t>• Target Group health 확인</a:t>
             </a:r>
@@ -4219,7 +4289,9 @@
                 <a:solidFill>
                   <a:srgbClr val="0F172A"/>
                 </a:solidFill>
-                <a:latin typeface="Malgun Gothic"/>
+                <a:latin typeface="맑은 고딕"/>
+                <a:ea typeface="맑은 고딕"/>
+                <a:cs typeface="맑은 고딕"/>
               </a:rPr>
               <a:t>• SSM으로 서버 점검</a:t>
             </a:r>
@@ -4273,7 +4345,9 @@
                 <a:solidFill>
                   <a:srgbClr val="DC2626"/>
                 </a:solidFill>
-                <a:latin typeface="Malgun Gothic"/>
+                <a:latin typeface="맑은 고딕"/>
+                <a:ea typeface="맑은 고딕"/>
+                <a:cs typeface="맑은 고딕"/>
               </a:rPr>
               <a:t>보안</a:t>
             </a:r>
@@ -4289,7 +4363,9 @@
                 <a:solidFill>
                   <a:srgbClr val="0F172A"/>
                 </a:solidFill>
-                <a:latin typeface="Malgun Gothic"/>
+                <a:latin typeface="맑은 고딕"/>
+                <a:ea typeface="맑은 고딕"/>
+                <a:cs typeface="맑은 고딕"/>
               </a:rPr>
               <a:t>• SG 최소 포트 개방</a:t>
             </a:r>
@@ -4305,7 +4381,9 @@
                 <a:solidFill>
                   <a:srgbClr val="0F172A"/>
                 </a:solidFill>
-                <a:latin typeface="Malgun Gothic"/>
+                <a:latin typeface="맑은 고딕"/>
+                <a:ea typeface="맑은 고딕"/>
+                <a:cs typeface="맑은 고딕"/>
               </a:rPr>
               <a:t>• Secrets Manager로 키 주입</a:t>
             </a:r>
@@ -4321,7 +4399,9 @@
                 <a:solidFill>
                   <a:srgbClr val="0F172A"/>
                 </a:solidFill>
-                <a:latin typeface="Malgun Gothic"/>
+                <a:latin typeface="맑은 고딕"/>
+                <a:ea typeface="맑은 고딕"/>
+                <a:cs typeface="맑은 고딕"/>
               </a:rPr>
               <a:t>• ACM HTTPS + WAF(SQLi/Rate)</a:t>
             </a:r>
@@ -4356,7 +4436,9 @@
                 <a:solidFill>
                   <a:srgbClr val="475569"/>
                 </a:solidFill>
-                <a:latin typeface="Malgun Gothic"/>
+                <a:latin typeface="맑은 고딕"/>
+                <a:ea typeface="맑은 고딕"/>
+                <a:cs typeface="맑은 고딕"/>
               </a:rPr>
               <a:t>Aniverse · 온프레미스 3-tier → AWS   |   12/12</a:t>
             </a:r>
@@ -4451,7 +4533,9 @@
                 <a:solidFill>
                   <a:srgbClr val="93C5FD"/>
                 </a:solidFill>
-                <a:latin typeface="Malgun Gothic"/>
+                <a:latin typeface="맑은 고딕"/>
+                <a:ea typeface="맑은 고딕"/>
+                <a:cs typeface="맑은 고딕"/>
               </a:rPr>
               <a:t>정리</a:t>
             </a:r>
@@ -4467,7 +4551,9 @@
                 <a:solidFill>
                   <a:srgbClr val="FFFFFF"/>
                 </a:solidFill>
-                <a:latin typeface="Malgun Gothic"/>
+                <a:latin typeface="맑은 고딕"/>
+                <a:ea typeface="맑은 고딕"/>
+                <a:cs typeface="맑은 고딕"/>
               </a:rPr>
               <a:t>3-Tier 수동 서버 → AWS 모듈형 인프라 + 자동 배포</a:t>
             </a:r>
@@ -4483,7 +4569,9 @@
                 <a:solidFill>
                   <a:srgbClr val="BFDBFE"/>
                 </a:solidFill>
-                <a:latin typeface="Malgun Gothic"/>
+                <a:latin typeface="맑은 고딕"/>
+                <a:ea typeface="맑은 고딕"/>
+                <a:cs typeface="맑은 고딕"/>
               </a:rPr>
               <a:t>서이(망) · 유민(트래픽) · 윤주(데이터) · 현우(자동화)</a:t>
             </a:r>
@@ -4499,7 +4587,9 @@
                 <a:solidFill>
                   <a:srgbClr val="7DD3FC"/>
                 </a:solidFill>
-                <a:latin typeface="Malgun Gothic"/>
+                <a:latin typeface="맑은 고딕"/>
+                <a:ea typeface="맑은 고딕"/>
+                <a:cs typeface="맑은 고딕"/>
               </a:rPr>
               <a:t>https://aniverse.my</a:t>
             </a:r>
@@ -4594,7 +4684,9 @@
                 <a:solidFill>
                   <a:srgbClr val="FFFFFF"/>
                 </a:solidFill>
-                <a:latin typeface="Malgun Gothic"/>
+                <a:latin typeface="맑은 고딕"/>
+                <a:ea typeface="맑은 고딕"/>
+                <a:cs typeface="맑은 고딕"/>
               </a:rPr>
               <a:t>목차</a:t>
             </a:r>
@@ -4648,7 +4740,9 @@
                 <a:solidFill>
                   <a:srgbClr val="0F172A"/>
                 </a:solidFill>
-                <a:latin typeface="Malgun Gothic"/>
+                <a:latin typeface="맑은 고딕"/>
+                <a:ea typeface="맑은 고딕"/>
+                <a:cs typeface="맑은 고딕"/>
               </a:rPr>
               <a:t>01  AWS 이전하면서 맡은 역할</a:t>
             </a:r>
@@ -4702,7 +4796,9 @@
                 <a:solidFill>
                   <a:srgbClr val="0F172A"/>
                 </a:solidFill>
-                <a:latin typeface="Malgun Gothic"/>
+                <a:latin typeface="맑은 고딕"/>
+                <a:ea typeface="맑은 고딕"/>
+                <a:cs typeface="맑은 고딕"/>
               </a:rPr>
               <a:t>02  온프레미스 운영에서 어려웠던 점</a:t>
             </a:r>
@@ -4756,7 +4852,9 @@
                 <a:solidFill>
                   <a:srgbClr val="0F172A"/>
                 </a:solidFill>
-                <a:latin typeface="Malgun Gothic"/>
+                <a:latin typeface="맑은 고딕"/>
+                <a:ea typeface="맑은 고딕"/>
+                <a:cs typeface="맑은 고딕"/>
               </a:rPr>
               <a:t>03  Terraform으로 구성한 인프라</a:t>
             </a:r>
@@ -4810,7 +4908,9 @@
                 <a:solidFill>
                   <a:srgbClr val="0F172A"/>
                 </a:solidFill>
-                <a:latin typeface="Malgun Gothic"/>
+                <a:latin typeface="맑은 고딕"/>
+                <a:ea typeface="맑은 고딕"/>
+                <a:cs typeface="맑은 고딕"/>
               </a:rPr>
               <a:t>04  GitHub Actions 자동화</a:t>
             </a:r>
@@ -4864,7 +4964,9 @@
                 <a:solidFill>
                   <a:srgbClr val="0F172A"/>
                 </a:solidFill>
-                <a:latin typeface="Malgun Gothic"/>
+                <a:latin typeface="맑은 고딕"/>
+                <a:ea typeface="맑은 고딕"/>
+                <a:cs typeface="맑은 고딕"/>
               </a:rPr>
               <a:t>05  CI/CD · 고가용성 · 모니터링 · 보안</a:t>
             </a:r>
@@ -4899,7 +5001,9 @@
                 <a:solidFill>
                   <a:srgbClr val="475569"/>
                 </a:solidFill>
-                <a:latin typeface="Malgun Gothic"/>
+                <a:latin typeface="맑은 고딕"/>
+                <a:ea typeface="맑은 고딕"/>
+                <a:cs typeface="맑은 고딕"/>
               </a:rPr>
               <a:t>Aniverse · 온프레미스 3-tier → AWS   |   2/12</a:t>
             </a:r>
@@ -4994,7 +5098,9 @@
                 <a:solidFill>
                   <a:srgbClr val="FFFFFF"/>
                 </a:solidFill>
-                <a:latin typeface="Malgun Gothic"/>
+                <a:latin typeface="맑은 고딕"/>
+                <a:ea typeface="맑은 고딕"/>
+                <a:cs typeface="맑은 고딕"/>
               </a:rPr>
               <a:t>1. AWS 이전 — 맡은 역할</a:t>
             </a:r>
@@ -5010,7 +5116,9 @@
                 <a:solidFill>
                   <a:srgbClr val="93C5FD"/>
                 </a:solidFill>
-                <a:latin typeface="Malgun Gothic"/>
+                <a:latin typeface="맑은 고딕"/>
+                <a:ea typeface="맑은 고딕"/>
+                <a:cs typeface="맑은 고딕"/>
               </a:rPr>
               <a:t>앱 기능 담당과 별도로, 인프라 모듈을 나눠 담당</a:t>
             </a:r>
@@ -5064,7 +5172,9 @@
                 <a:solidFill>
                   <a:srgbClr val="7C3AED"/>
                 </a:solidFill>
-                <a:latin typeface="Malgun Gothic"/>
+                <a:latin typeface="맑은 고딕"/>
+                <a:ea typeface="맑은 고딕"/>
+                <a:cs typeface="맑은 고딕"/>
               </a:rPr>
               <a:t>박서이</a:t>
             </a:r>
@@ -5080,7 +5190,9 @@
                 <a:solidFill>
                   <a:srgbClr val="0F172A"/>
                 </a:solidFill>
-                <a:latin typeface="Malgun Gothic"/>
+                <a:latin typeface="맑은 고딕"/>
+                <a:ea typeface="맑은 고딕"/>
+                <a:cs typeface="맑은 고딕"/>
               </a:rPr>
               <a:t>Network &amp; Security</a:t>
             </a:r>
@@ -5096,7 +5208,9 @@
                 <a:solidFill>
                   <a:srgbClr val="475569"/>
                 </a:solidFill>
-                <a:latin typeface="Malgun Gothic"/>
+                <a:latin typeface="맑은 고딕"/>
+                <a:ea typeface="맑은 고딕"/>
+                <a:cs typeface="맑은 고딕"/>
               </a:rPr>
               <a:t>modules/network
 security · nat</a:t>
@@ -5113,7 +5227,9 @@
                 <a:solidFill>
                   <a:srgbClr val="CBD5E1"/>
                 </a:solidFill>
-                <a:latin typeface="Malgun Gothic"/>
+                <a:latin typeface="맑은 고딕"/>
+                <a:ea typeface="맑은 고딕"/>
+                <a:cs typeface="맑은 고딕"/>
               </a:rPr>
               <a:t>────────</a:t>
             </a:r>
@@ -5129,7 +5245,9 @@
                 <a:solidFill>
                   <a:srgbClr val="0F172A"/>
                 </a:solidFill>
-                <a:latin typeface="Malgun Gothic"/>
+                <a:latin typeface="맑은 고딕"/>
+                <a:ea typeface="맑은 고딕"/>
+                <a:cs typeface="맑은 고딕"/>
               </a:rPr>
               <a:t>VPC / Subnet / IGW
 NAT Instance
@@ -5185,7 +5303,9 @@
                 <a:solidFill>
                   <a:srgbClr val="EA580C"/>
                 </a:solidFill>
-                <a:latin typeface="Malgun Gothic"/>
+                <a:latin typeface="맑은 고딕"/>
+                <a:ea typeface="맑은 고딕"/>
+                <a:cs typeface="맑은 고딕"/>
               </a:rPr>
               <a:t>강유민</a:t>
             </a:r>
@@ -5201,7 +5321,9 @@
                 <a:solidFill>
                   <a:srgbClr val="0F172A"/>
                 </a:solidFill>
-                <a:latin typeface="Malgun Gothic"/>
+                <a:latin typeface="맑은 고딕"/>
+                <a:ea typeface="맑은 고딕"/>
+                <a:cs typeface="맑은 고딕"/>
               </a:rPr>
               <a:t>Compute &amp; Traffic</a:t>
             </a:r>
@@ -5217,7 +5339,9 @@
                 <a:solidFill>
                   <a:srgbClr val="475569"/>
                 </a:solidFill>
-                <a:latin typeface="Malgun Gothic"/>
+                <a:latin typeface="맑은 고딕"/>
+                <a:ea typeface="맑은 고딕"/>
+                <a:cs typeface="맑은 고딕"/>
               </a:rPr>
               <a:t>modules/alb
 modules/compute</a:t>
@@ -5234,7 +5358,9 @@
                 <a:solidFill>
                   <a:srgbClr val="CBD5E1"/>
                 </a:solidFill>
-                <a:latin typeface="Malgun Gothic"/>
+                <a:latin typeface="맑은 고딕"/>
+                <a:ea typeface="맑은 고딕"/>
+                <a:cs typeface="맑은 고딕"/>
               </a:rPr>
               <a:t>────────</a:t>
             </a:r>
@@ -5250,7 +5376,9 @@
                 <a:solidFill>
                   <a:srgbClr val="0F172A"/>
                 </a:solidFill>
-                <a:latin typeface="Malgun Gothic"/>
+                <a:latin typeface="맑은 고딕"/>
+                <a:ea typeface="맑은 고딕"/>
+                <a:cs typeface="맑은 고딕"/>
               </a:rPr>
               <a:t>ALB / Target Group
 Launch Template / ASG
@@ -5306,7 +5434,9 @@
                 <a:solidFill>
                   <a:srgbClr val="16A34A"/>
                 </a:solidFill>
-                <a:latin typeface="Malgun Gothic"/>
+                <a:latin typeface="맑은 고딕"/>
+                <a:ea typeface="맑은 고딕"/>
+                <a:cs typeface="맑은 고딕"/>
               </a:rPr>
               <a:t>김윤주</a:t>
             </a:r>
@@ -5322,7 +5452,9 @@
                 <a:solidFill>
                   <a:srgbClr val="0F172A"/>
                 </a:solidFill>
-                <a:latin typeface="Malgun Gothic"/>
+                <a:latin typeface="맑은 고딕"/>
+                <a:ea typeface="맑은 고딕"/>
+                <a:cs typeface="맑은 고딕"/>
               </a:rPr>
               <a:t>Data &amp; Storage</a:t>
             </a:r>
@@ -5338,7 +5470,9 @@
                 <a:solidFill>
                   <a:srgbClr val="475569"/>
                 </a:solidFill>
-                <a:latin typeface="Malgun Gothic"/>
+                <a:latin typeface="맑은 고딕"/>
+                <a:ea typeface="맑은 고딕"/>
+                <a:cs typeface="맑은 고딕"/>
               </a:rPr>
               <a:t>modules/database
 modules/storage</a:t>
@@ -5355,7 +5489,9 @@
                 <a:solidFill>
                   <a:srgbClr val="CBD5E1"/>
                 </a:solidFill>
-                <a:latin typeface="Malgun Gothic"/>
+                <a:latin typeface="맑은 고딕"/>
+                <a:ea typeface="맑은 고딕"/>
+                <a:cs typeface="맑은 고딕"/>
               </a:rPr>
               <a:t>────────</a:t>
             </a:r>
@@ -5371,7 +5507,9 @@
                 <a:solidFill>
                   <a:srgbClr val="0F172A"/>
                 </a:solidFill>
-                <a:latin typeface="Malgun Gothic"/>
+                <a:latin typeface="맑은 고딕"/>
+                <a:ea typeface="맑은 고딕"/>
+                <a:cs typeface="맑은 고딕"/>
               </a:rPr>
               <a:t>RDS MariaDB
 EFS · S3
@@ -5427,7 +5565,9 @@
                 <a:solidFill>
                   <a:srgbClr val="DC2626"/>
                 </a:solidFill>
-                <a:latin typeface="Malgun Gothic"/>
+                <a:latin typeface="맑은 고딕"/>
+                <a:ea typeface="맑은 고딕"/>
+                <a:cs typeface="맑은 고딕"/>
               </a:rPr>
               <a:t>김현우</a:t>
             </a:r>
@@ -5443,7 +5583,9 @@
                 <a:solidFill>
                   <a:srgbClr val="0F172A"/>
                 </a:solidFill>
-                <a:latin typeface="Malgun Gothic"/>
+                <a:latin typeface="맑은 고딕"/>
+                <a:ea typeface="맑은 고딕"/>
+                <a:cs typeface="맑은 고딕"/>
               </a:rPr>
               <a:t>DevOps &amp; CI/CD</a:t>
             </a:r>
@@ -5459,7 +5601,9 @@
                 <a:solidFill>
                   <a:srgbClr val="475569"/>
                 </a:solidFill>
-                <a:latin typeface="Malgun Gothic"/>
+                <a:latin typeface="맑은 고딕"/>
+                <a:ea typeface="맑은 고딕"/>
+                <a:cs typeface="맑은 고딕"/>
               </a:rPr>
               <a:t>environments/dev
 cicd · Actions</a:t>
@@ -5476,7 +5620,9 @@
                 <a:solidFill>
                   <a:srgbClr val="CBD5E1"/>
                 </a:solidFill>
-                <a:latin typeface="Malgun Gothic"/>
+                <a:latin typeface="맑은 고딕"/>
+                <a:ea typeface="맑은 고딕"/>
+                <a:cs typeface="맑은 고딕"/>
               </a:rPr>
               <a:t>────────</a:t>
             </a:r>
@@ -5492,7 +5638,9 @@
                 <a:solidFill>
                   <a:srgbClr val="0F172A"/>
                 </a:solidFill>
-                <a:latin typeface="Malgun Gothic"/>
+                <a:latin typeface="맑은 고딕"/>
+                <a:ea typeface="맑은 고딕"/>
+                <a:cs typeface="맑은 고딕"/>
               </a:rPr>
               <a:t>모듈 조립·Apply
 CodeDeploy / SSM
@@ -5529,7 +5677,9 @@
                 <a:solidFill>
                   <a:srgbClr val="475569"/>
                 </a:solidFill>
-                <a:latin typeface="Malgun Gothic"/>
+                <a:latin typeface="맑은 고딕"/>
+                <a:ea typeface="맑은 고딕"/>
+                <a:cs typeface="맑은 고딕"/>
               </a:rPr>
               <a:t>Aniverse · 온프레미스 3-tier → AWS   |   3/12</a:t>
             </a:r>
@@ -5624,7 +5774,9 @@
                 <a:solidFill>
                   <a:srgbClr val="FFFFFF"/>
                 </a:solidFill>
-                <a:latin typeface="Malgun Gothic"/>
+                <a:latin typeface="맑은 고딕"/>
+                <a:ea typeface="맑은 고딕"/>
+                <a:cs typeface="맑은 고딕"/>
               </a:rPr>
               <a:t>2. 온프레미스에서 어려웠던 점 (1)</a:t>
             </a:r>
@@ -5640,7 +5792,9 @@
                 <a:solidFill>
                   <a:srgbClr val="93C5FD"/>
                 </a:solidFill>
-                <a:latin typeface="Malgun Gothic"/>
+                <a:latin typeface="맑은 고딕"/>
+                <a:ea typeface="맑은 고딕"/>
+                <a:cs typeface="맑은 고딕"/>
               </a:rPr>
               <a:t>3-Tier: Nginx · Django · NFS/MariaDB 를 서버별로 직접 운영</a:t>
             </a:r>
@@ -5699,7 +5853,9 @@
                 <a:solidFill>
                   <a:srgbClr val="475569"/>
                 </a:solidFill>
-                <a:latin typeface="Malgun Gothic"/>
+                <a:latin typeface="맑은 고딕"/>
+                <a:ea typeface="맑은 고딕"/>
+                <a:cs typeface="맑은 고딕"/>
               </a:rPr>
               <a:t>Aniverse · 온프레미스 3-tier → AWS   |   4/12</a:t>
             </a:r>
@@ -5794,7 +5950,9 @@
                 <a:solidFill>
                   <a:srgbClr val="FFFFFF"/>
                 </a:solidFill>
-                <a:latin typeface="Malgun Gothic"/>
+                <a:latin typeface="맑은 고딕"/>
+                <a:ea typeface="맑은 고딕"/>
+                <a:cs typeface="맑은 고딕"/>
               </a:rPr>
               <a:t>2. 온프레미스에서 어려웠던 점 (2)</a:t>
             </a:r>
@@ -5810,7 +5968,9 @@
                 <a:solidFill>
                   <a:srgbClr val="93C5FD"/>
                 </a:solidFill>
-                <a:latin typeface="Malgun Gothic"/>
+                <a:latin typeface="맑은 고딕"/>
+                <a:ea typeface="맑은 고딕"/>
+                <a:cs typeface="맑은 고딕"/>
               </a:rPr>
               <a:t>수동 운영이 만든 반복 문제</a:t>
             </a:r>
@@ -5864,7 +6024,9 @@
                 <a:solidFill>
                   <a:srgbClr val="DC2626"/>
                 </a:solidFill>
-                <a:latin typeface="Malgun Gothic"/>
+                <a:latin typeface="맑은 고딕"/>
+                <a:ea typeface="맑은 고딕"/>
+                <a:cs typeface="맑은 고딕"/>
               </a:rPr>
               <a:t>① 배포가 전부 수작업</a:t>
             </a:r>
@@ -5880,7 +6042,9 @@
                 <a:solidFill>
                   <a:srgbClr val="0F172A"/>
                 </a:solidFill>
-                <a:latin typeface="Malgun Gothic"/>
+                <a:latin typeface="맑은 고딕"/>
+                <a:ea typeface="맑은 고딕"/>
+                <a:cs typeface="맑은 고딕"/>
               </a:rPr>
               <a:t>• 서버 4대에 SSH로 접속해 pull · restart</a:t>
             </a:r>
@@ -5896,7 +6060,9 @@
                 <a:solidFill>
                   <a:srgbClr val="0F172A"/>
                 </a:solidFill>
-                <a:latin typeface="Malgun Gothic"/>
+                <a:latin typeface="맑은 고딕"/>
+                <a:ea typeface="맑은 고딕"/>
+                <a:cs typeface="맑은 고딕"/>
               </a:rPr>
               <a:t>• 순서가 조금만 달라져도 결과가 달라짐</a:t>
             </a:r>
@@ -5912,7 +6078,9 @@
                 <a:solidFill>
                   <a:srgbClr val="0F172A"/>
                 </a:solidFill>
-                <a:latin typeface="Malgun Gothic"/>
+                <a:latin typeface="맑은 고딕"/>
+                <a:ea typeface="맑은 고딕"/>
+                <a:cs typeface="맑은 고딕"/>
               </a:rPr>
               <a:t>• 누가 언제 무엇을 배포했는지 기록이 남기 어려움</a:t>
             </a:r>
@@ -5966,7 +6134,9 @@
                 <a:solidFill>
                   <a:srgbClr val="DC2626"/>
                 </a:solidFill>
-                <a:latin typeface="Malgun Gothic"/>
+                <a:latin typeface="맑은 고딕"/>
+                <a:ea typeface="맑은 고딕"/>
+                <a:cs typeface="맑은 고딕"/>
               </a:rPr>
               <a:t>② 환경 불일치</a:t>
             </a:r>
@@ -5982,7 +6152,9 @@
                 <a:solidFill>
                   <a:srgbClr val="0F172A"/>
                 </a:solidFill>
-                <a:latin typeface="Malgun Gothic"/>
+                <a:latin typeface="맑은 고딕"/>
+                <a:ea typeface="맑은 고딕"/>
+                <a:cs typeface="맑은 고딕"/>
               </a:rPr>
               <a:t>• 로컬에서는 되는데 서버에서만 실패하는 경우 빈번</a:t>
             </a:r>
@@ -5998,7 +6170,9 @@
                 <a:solidFill>
                   <a:srgbClr val="0F172A"/>
                 </a:solidFill>
-                <a:latin typeface="Malgun Gothic"/>
+                <a:latin typeface="맑은 고딕"/>
+                <a:ea typeface="맑은 고딕"/>
+                <a:cs typeface="맑은 고딕"/>
               </a:rPr>
               <a:t>• 패키지·환경변수·권한 설정이 사람 기억에 의존</a:t>
             </a:r>
@@ -6014,7 +6188,9 @@
                 <a:solidFill>
                   <a:srgbClr val="0F172A"/>
                 </a:solidFill>
-                <a:latin typeface="Malgun Gothic"/>
+                <a:latin typeface="맑은 고딕"/>
+                <a:ea typeface="맑은 고딕"/>
+                <a:cs typeface="맑은 고딕"/>
               </a:rPr>
               <a:t>• 원인 파악에 시간을 대부분 소모</a:t>
             </a:r>
@@ -6068,7 +6244,9 @@
                 <a:solidFill>
                   <a:srgbClr val="DC2626"/>
                 </a:solidFill>
-                <a:latin typeface="Malgun Gothic"/>
+                <a:latin typeface="맑은 고딕"/>
+                <a:ea typeface="맑은 고딕"/>
+                <a:cs typeface="맑은 고딕"/>
               </a:rPr>
               <a:t>③ 장애·확장 대응이 느림</a:t>
             </a:r>
@@ -6084,7 +6262,9 @@
                 <a:solidFill>
                   <a:srgbClr val="0F172A"/>
                 </a:solidFill>
-                <a:latin typeface="Malgun Gothic"/>
+                <a:latin typeface="맑은 고딕"/>
+                <a:ea typeface="맑은 고딕"/>
+                <a:cs typeface="맑은 고딕"/>
               </a:rPr>
               <a:t>• 트래픽 증가 시 서버를 직접 추가·설정</a:t>
             </a:r>
@@ -6100,7 +6280,9 @@
                 <a:solidFill>
                   <a:srgbClr val="0F172A"/>
                 </a:solidFill>
-                <a:latin typeface="Malgun Gothic"/>
+                <a:latin typeface="맑은 고딕"/>
+                <a:ea typeface="맑은 고딕"/>
+                <a:cs typeface="맑은 고딕"/>
               </a:rPr>
               <a:t>• 한 대 장애가 곧 서비스 전체 영향으로 이어짐</a:t>
             </a:r>
@@ -6116,7 +6298,9 @@
                 <a:solidFill>
                   <a:srgbClr val="0F172A"/>
                 </a:solidFill>
-                <a:latin typeface="Malgun Gothic"/>
+                <a:latin typeface="맑은 고딕"/>
+                <a:ea typeface="맑은 고딕"/>
+                <a:cs typeface="맑은 고딕"/>
               </a:rPr>
               <a:t>• 복구 절차가 문서화되어 있어도 재현이 어려움</a:t>
             </a:r>
@@ -6170,7 +6354,9 @@
                 <a:solidFill>
                   <a:srgbClr val="DC2626"/>
                 </a:solidFill>
-                <a:latin typeface="Malgun Gothic"/>
+                <a:latin typeface="맑은 고딕"/>
+                <a:ea typeface="맑은 고딕"/>
+                <a:cs typeface="맑은 고딕"/>
               </a:rPr>
               <a:t>④ 보안·비밀값 관리</a:t>
             </a:r>
@@ -6186,7 +6372,9 @@
                 <a:solidFill>
                   <a:srgbClr val="0F172A"/>
                 </a:solidFill>
-                <a:latin typeface="Malgun Gothic"/>
+                <a:latin typeface="맑은 고딕"/>
+                <a:ea typeface="맑은 고딕"/>
+                <a:cs typeface="맑은 고딕"/>
               </a:rPr>
               <a:t>• .env, API Key가 서버 파일에 흩어져 존재</a:t>
             </a:r>
@@ -6202,7 +6390,9 @@
                 <a:solidFill>
                   <a:srgbClr val="0F172A"/>
                 </a:solidFill>
-                <a:latin typeface="Malgun Gothic"/>
+                <a:latin typeface="맑은 고딕"/>
+                <a:ea typeface="맑은 고딕"/>
+                <a:cs typeface="맑은 고딕"/>
               </a:rPr>
               <a:t>• HTTPS·방화벽 규칙을 서버마다 따로 맞춤</a:t>
             </a:r>
@@ -6218,7 +6408,9 @@
                 <a:solidFill>
                   <a:srgbClr val="0F172A"/>
                 </a:solidFill>
-                <a:latin typeface="Malgun Gothic"/>
+                <a:latin typeface="맑은 고딕"/>
+                <a:ea typeface="맑은 고딕"/>
+                <a:cs typeface="맑은 고딕"/>
               </a:rPr>
               <a:t>• 권한/키 교체 시 누락 위험이 큼</a:t>
             </a:r>
@@ -6253,7 +6445,9 @@
                 <a:solidFill>
                   <a:srgbClr val="475569"/>
                 </a:solidFill>
-                <a:latin typeface="Malgun Gothic"/>
+                <a:latin typeface="맑은 고딕"/>
+                <a:ea typeface="맑은 고딕"/>
+                <a:cs typeface="맑은 고딕"/>
               </a:rPr>
               <a:t>Aniverse · 온프레미스 3-tier → AWS   |   5/12</a:t>
             </a:r>
@@ -6348,7 +6542,9 @@
                 <a:solidFill>
                   <a:srgbClr val="FFFFFF"/>
                 </a:solidFill>
-                <a:latin typeface="Malgun Gothic"/>
+                <a:latin typeface="맑은 고딕"/>
+                <a:ea typeface="맑은 고딕"/>
+                <a:cs typeface="맑은 고딕"/>
               </a:rPr>
               <a:t>3. Terraform 인프라 구성 (1)</a:t>
             </a:r>
@@ -6364,7 +6560,9 @@
                 <a:solidFill>
                   <a:srgbClr val="93C5FD"/>
                 </a:solidFill>
-                <a:latin typeface="Malgun Gothic"/>
+                <a:latin typeface="맑은 고딕"/>
+                <a:ea typeface="맑은 고딕"/>
+                <a:cs typeface="맑은 고딕"/>
               </a:rPr>
               <a:t>온프레미스 3-Tier를 AWS 서비스로 대응</a:t>
             </a:r>
@@ -6423,7 +6621,9 @@
                 <a:solidFill>
                   <a:srgbClr val="475569"/>
                 </a:solidFill>
-                <a:latin typeface="Malgun Gothic"/>
+                <a:latin typeface="맑은 고딕"/>
+                <a:ea typeface="맑은 고딕"/>
+                <a:cs typeface="맑은 고딕"/>
               </a:rPr>
               <a:t>Aniverse · 온프레미스 3-tier → AWS   |   6/12</a:t>
             </a:r>
@@ -6518,7 +6718,9 @@
                 <a:solidFill>
                   <a:srgbClr val="FFFFFF"/>
                 </a:solidFill>
-                <a:latin typeface="Malgun Gothic"/>
+                <a:latin typeface="맑은 고딕"/>
+                <a:ea typeface="맑은 고딕"/>
+                <a:cs typeface="맑은 고딕"/>
               </a:rPr>
               <a:t>3. Terraform 인프라 구성 (2)</a:t>
             </a:r>
@@ -6534,7 +6736,9 @@
                 <a:solidFill>
                   <a:srgbClr val="93C5FD"/>
                 </a:solidFill>
-                <a:latin typeface="Malgun Gothic"/>
+                <a:latin typeface="맑은 고딕"/>
+                <a:ea typeface="맑은 고딕"/>
+                <a:cs typeface="맑은 고딕"/>
               </a:rPr>
               <a:t>모듈을 나눠 만들고 environments/dev 에서 조립</a:t>
             </a:r>
@@ -6593,7 +6797,9 @@
                 <a:solidFill>
                   <a:srgbClr val="475569"/>
                 </a:solidFill>
-                <a:latin typeface="Malgun Gothic"/>
+                <a:latin typeface="맑은 고딕"/>
+                <a:ea typeface="맑은 고딕"/>
+                <a:cs typeface="맑은 고딕"/>
               </a:rPr>
               <a:t>Aniverse · 온프레미스 3-tier → AWS   |   7/12</a:t>
             </a:r>
@@ -6688,7 +6894,9 @@
                 <a:solidFill>
                   <a:srgbClr val="FFFFFF"/>
                 </a:solidFill>
-                <a:latin typeface="Malgun Gothic"/>
+                <a:latin typeface="맑은 고딕"/>
+                <a:ea typeface="맑은 고딕"/>
+                <a:cs typeface="맑은 고딕"/>
               </a:rPr>
               <a:t>3. Terraform 인프라 구성 (3)</a:t>
             </a:r>
@@ -6704,7 +6912,9 @@
                 <a:solidFill>
                   <a:srgbClr val="93C5FD"/>
                 </a:solidFill>
-                <a:latin typeface="Malgun Gothic"/>
+                <a:latin typeface="맑은 고딕"/>
+                <a:ea typeface="맑은 고딕"/>
+                <a:cs typeface="맑은 고딕"/>
               </a:rPr>
               <a:t>주요 리소스와 연결 관계</a:t>
             </a:r>
@@ -6758,7 +6968,9 @@
                 <a:solidFill>
                   <a:srgbClr val="2563EB"/>
                 </a:solidFill>
-                <a:latin typeface="Malgun Gothic"/>
+                <a:latin typeface="맑은 고딕"/>
+                <a:ea typeface="맑은 고딕"/>
+                <a:cs typeface="맑은 고딕"/>
               </a:rPr>
               <a:t>계층별 구성</a:t>
             </a:r>
@@ -6774,7 +6986,9 @@
                 <a:solidFill>
                   <a:srgbClr val="0F172A"/>
                 </a:solidFill>
-                <a:latin typeface="Malgun Gothic"/>
+                <a:latin typeface="맑은 고딕"/>
+                <a:ea typeface="맑은 고딕"/>
+                <a:cs typeface="맑은 고딕"/>
               </a:rPr>
               <a:t>• Network: VPC · Public/Private Subnet · IGW · NAT</a:t>
             </a:r>
@@ -6790,7 +7004,9 @@
                 <a:solidFill>
                   <a:srgbClr val="0F172A"/>
                 </a:solidFill>
-                <a:latin typeface="Malgun Gothic"/>
+                <a:latin typeface="맑은 고딕"/>
+                <a:ea typeface="맑은 고딕"/>
+                <a:cs typeface="맑은 고딕"/>
               </a:rPr>
               <a:t>• Security: ALB/App/DB/EFS용 Security Group</a:t>
             </a:r>
@@ -6806,7 +7022,9 @@
                 <a:solidFill>
                   <a:srgbClr val="0F172A"/>
                 </a:solidFill>
-                <a:latin typeface="Malgun Gothic"/>
+                <a:latin typeface="맑은 고딕"/>
+                <a:ea typeface="맑은 고딕"/>
+                <a:cs typeface="맑은 고딕"/>
               </a:rPr>
               <a:t>• Traffic: ALB · Target Group · HTTPS Listener</a:t>
             </a:r>
@@ -6822,7 +7040,9 @@
                 <a:solidFill>
                   <a:srgbClr val="0F172A"/>
                 </a:solidFill>
-                <a:latin typeface="Malgun Gothic"/>
+                <a:latin typeface="맑은 고딕"/>
+                <a:ea typeface="맑은 고딕"/>
+                <a:cs typeface="맑은 고딕"/>
               </a:rPr>
               <a:t>• Compute: Launch Template · ASG · IAM Role</a:t>
             </a:r>
@@ -6838,7 +7058,9 @@
                 <a:solidFill>
                   <a:srgbClr val="0F172A"/>
                 </a:solidFill>
-                <a:latin typeface="Malgun Gothic"/>
+                <a:latin typeface="맑은 고딕"/>
+                <a:ea typeface="맑은 고딕"/>
+                <a:cs typeface="맑은 고딕"/>
               </a:rPr>
               <a:t>• Data: RDS MariaDB · EFS · S3</a:t>
             </a:r>
@@ -6854,7 +7076,9 @@
                 <a:solidFill>
                   <a:srgbClr val="0F172A"/>
                 </a:solidFill>
-                <a:latin typeface="Malgun Gothic"/>
+                <a:latin typeface="맑은 고딕"/>
+                <a:ea typeface="맑은 고딕"/>
+                <a:cs typeface="맑은 고딕"/>
               </a:rPr>
               <a:t>• Ops: Secrets Manager · WAF · Redis · CodeDeploy</a:t>
             </a:r>
@@ -6908,7 +7132,9 @@
                 <a:solidFill>
                   <a:srgbClr val="0D9488"/>
                 </a:solidFill>
-                <a:latin typeface="Malgun Gothic"/>
+                <a:latin typeface="맑은 고딕"/>
+                <a:ea typeface="맑은 고딕"/>
+                <a:cs typeface="맑은 고딕"/>
               </a:rPr>
               <a:t>조립 방식</a:t>
             </a:r>
@@ -6924,7 +7150,9 @@
                 <a:solidFill>
                   <a:srgbClr val="0F172A"/>
                 </a:solidFill>
-                <a:latin typeface="Malgun Gothic"/>
+                <a:latin typeface="맑은 고딕"/>
+                <a:ea typeface="맑은 고딕"/>
+                <a:cs typeface="맑은 고딕"/>
               </a:rPr>
               <a:t>1) 팀원이 모듈 PR로 기능 단위 작성</a:t>
             </a:r>
@@ -6940,7 +7168,9 @@
                 <a:solidFill>
                   <a:srgbClr val="0F172A"/>
                 </a:solidFill>
-                <a:latin typeface="Malgun Gothic"/>
+                <a:latin typeface="맑은 고딕"/>
+                <a:ea typeface="맑은 고딕"/>
+                <a:cs typeface="맑은 고딕"/>
               </a:rPr>
               <a:t>2) outputs.tf 로 vpc_id, sg_id 등 연결</a:t>
             </a:r>
@@ -6956,7 +7186,9 @@
                 <a:solidFill>
                   <a:srgbClr val="0F172A"/>
                 </a:solidFill>
-                <a:latin typeface="Malgun Gothic"/>
+                <a:latin typeface="맑은 고딕"/>
+                <a:ea typeface="맑은 고딕"/>
+                <a:cs typeface="맑은 고딕"/>
               </a:rPr>
               <a:t>3) environments/dev/main.tf 에서 module 호출</a:t>
             </a:r>
@@ -6972,7 +7204,9 @@
                 <a:solidFill>
                   <a:srgbClr val="0F172A"/>
                 </a:solidFill>
-                <a:latin typeface="Malgun Gothic"/>
+                <a:latin typeface="맑은 고딕"/>
+                <a:ea typeface="맑은 고딕"/>
+                <a:cs typeface="맑은 고딕"/>
               </a:rPr>
               <a:t>4) terraform plan / apply 로 한 번에 반영</a:t>
             </a:r>
@@ -6988,7 +7222,9 @@
                 <a:solidFill>
                   <a:srgbClr val="0F172A"/>
                 </a:solidFill>
-                <a:latin typeface="Malgun Gothic"/>
+                <a:latin typeface="맑은 고딕"/>
+                <a:ea typeface="맑은 고딕"/>
+                <a:cs typeface="맑은 고딕"/>
               </a:rPr>
               <a:t/>
             </a:r>
@@ -7004,7 +7240,9 @@
                 <a:solidFill>
                   <a:srgbClr val="0F172A"/>
                 </a:solidFill>
-                <a:latin typeface="Malgun Gothic"/>
+                <a:latin typeface="맑은 고딕"/>
+                <a:ea typeface="맑은 고딕"/>
+                <a:cs typeface="맑은 고딕"/>
               </a:rPr>
               <a:t>결과</a:t>
             </a:r>
@@ -7020,7 +7258,9 @@
                 <a:solidFill>
                   <a:srgbClr val="0F172A"/>
                 </a:solidFill>
-                <a:latin typeface="Malgun Gothic"/>
+                <a:latin typeface="맑은 고딕"/>
+                <a:ea typeface="맑은 고딕"/>
+                <a:cs typeface="맑은 고딕"/>
               </a:rPr>
               <a:t>• 인프라가 코드로 리뷰·재현 가능</a:t>
             </a:r>
@@ -7036,7 +7276,9 @@
                 <a:solidFill>
                   <a:srgbClr val="0F172A"/>
                 </a:solidFill>
-                <a:latin typeface="Malgun Gothic"/>
+                <a:latin typeface="맑은 고딕"/>
+                <a:ea typeface="맑은 고딕"/>
+                <a:cs typeface="맑은 고딕"/>
               </a:rPr>
               <a:t>• 서버 ‘기억 의존’ 감소</a:t>
             </a:r>
@@ -7071,7 +7313,9 @@
                 <a:solidFill>
                   <a:srgbClr val="475569"/>
                 </a:solidFill>
-                <a:latin typeface="Malgun Gothic"/>
+                <a:latin typeface="맑은 고딕"/>
+                <a:ea typeface="맑은 고딕"/>
+                <a:cs typeface="맑은 고딕"/>
               </a:rPr>
               <a:t>Aniverse · 온프레미스 3-tier → AWS   |   8/12</a:t>
             </a:r>
@@ -7166,7 +7410,9 @@
                 <a:solidFill>
                   <a:srgbClr val="FFFFFF"/>
                 </a:solidFill>
-                <a:latin typeface="Malgun Gothic"/>
+                <a:latin typeface="맑은 고딕"/>
+                <a:ea typeface="맑은 고딕"/>
+                <a:cs typeface="맑은 고딕"/>
               </a:rPr>
               <a:t>4. GitHub Actions (1)</a:t>
             </a:r>
@@ -7182,7 +7428,9 @@
                 <a:solidFill>
                   <a:srgbClr val="93C5FD"/>
                 </a:solidFill>
-                <a:latin typeface="Malgun Gothic"/>
+                <a:latin typeface="맑은 고딕"/>
+                <a:ea typeface="맑은 고딕"/>
+                <a:cs typeface="맑은 고딕"/>
               </a:rPr>
               <a:t>인프라 저장소 / 앱 저장소를 나눠 자동화</a:t>
             </a:r>
@@ -7241,7 +7489,9 @@
                 <a:solidFill>
                   <a:srgbClr val="475569"/>
                 </a:solidFill>
-                <a:latin typeface="Malgun Gothic"/>
+                <a:latin typeface="맑은 고딕"/>
+                <a:ea typeface="맑은 고딕"/>
+                <a:cs typeface="맑은 고딕"/>
               </a:rPr>
               <a:t>Aniverse · 온프레미스 3-tier → AWS   |   9/12</a:t>
             </a:r>

</xml_diff>

<commit_message>
docs: add HTTPS and WAF section to instructor presentation
Add TOC item 06 and two trailing slides covering ACM/ALB HTTPS and
ALB-associated WAF rules, with a new flow diagram and HTML/notes update.

Co-authored-by: ho0215 <ho0215@users.noreply.github.com>
</commit_message>
<xml_diff>
--- a/docs/presentation/ppt/Aniverse_발표_강사용.pptx
+++ b/docs/presentation/ppt/Aniverse_발표_강사용.pptx
@@ -18,6 +18,8 @@
     <p:sldId id="266" r:id="rId17"/>
     <p:sldId id="267" r:id="rId18"/>
     <p:sldId id="268" r:id="rId19"/>
+    <p:sldId id="269" r:id="rId20"/>
+    <p:sldId id="270" r:id="rId21"/>
   </p:sldIdLst>
   <p:sldSz cx="12191695" cy="6858000" type="screen4x3"/>
   <p:notesSz cx="6858000" cy="9144000"/>
@@ -3210,7 +3212,7 @@
                 <a:ea typeface="맑은 고딕"/>
                 <a:cs typeface="맑은 고딕"/>
               </a:rPr>
-              <a:t>Terraform 모듈 구성 · GitHub Actions · CI/CD · HA · 보안</a:t>
+              <a:t>Terraform · Actions · CI/CD · HA · HTTPS · WAF</a:t>
             </a:r>
           </a:p>
           <a:p>
@@ -3672,7 +3674,7 @@
                 <a:ea typeface="맑은 고딕"/>
                 <a:cs typeface="맑은 고딕"/>
               </a:rPr>
-              <a:t>Aniverse · 온프레미스 3-tier → AWS   |   10/12</a:t>
+              <a:t>Aniverse · 온프레미스 3-tier → AWS   |   10/14</a:t>
             </a:r>
           </a:p>
         </p:txBody>
@@ -3848,7 +3850,7 @@
                 <a:ea typeface="맑은 고딕"/>
                 <a:cs typeface="맑은 고딕"/>
               </a:rPr>
-              <a:t>Aniverse · 온프레미스 3-tier → AWS   |   11/12</a:t>
+              <a:t>Aniverse · 온프레미스 3-tier → AWS   |   11/14</a:t>
             </a:r>
           </a:p>
         </p:txBody>
@@ -4440,7 +4442,7 @@
                 <a:ea typeface="맑은 고딕"/>
                 <a:cs typeface="맑은 고딕"/>
               </a:rPr>
-              <a:t>Aniverse · 온프레미스 3-tier → AWS   |   12/12</a:t>
+              <a:t>Aniverse · 온프레미스 3-tier → AWS   |   12/14</a:t>
             </a:r>
           </a:p>
         </p:txBody>
@@ -4472,7 +4474,7 @@
         <p:spPr>
           <a:xfrm>
             <a:off x="0" y="0"/>
-            <a:ext cx="12191695" cy="6858000"/>
+            <a:ext cx="12191695" cy="777240"/>
           </a:xfrm>
           <a:prstGeom prst="rect">
             <a:avLst/>
@@ -4514,8 +4516,8 @@
         </p:nvSpPr>
         <p:spPr>
           <a:xfrm>
-            <a:off x="731520" y="1645920"/>
-            <a:ext cx="10698480" cy="3657600"/>
+            <a:off x="411480" y="109728"/>
+            <a:ext cx="11338560" cy="594360"/>
           </a:xfrm>
           <a:prstGeom prst="rect">
             <a:avLst/>
@@ -4529,6 +4531,914 @@
           <a:lstStyle/>
           <a:p>
             <a:r>
+              <a:rPr sz="2200" b="1">
+                <a:solidFill>
+                  <a:srgbClr val="FFFFFF"/>
+                </a:solidFill>
+                <a:latin typeface="맑은 고딕"/>
+                <a:ea typeface="맑은 고딕"/>
+                <a:cs typeface="맑은 고딕"/>
+              </a:rPr>
+              <a:t>6. HTTPS · WAF (1)</a:t>
+            </a:r>
+          </a:p>
+          <a:p>
+            <a:pPr>
+              <a:spcBef>
+                <a:spcPts val="200"/>
+              </a:spcBef>
+            </a:pPr>
+            <a:r>
+              <a:rPr sz="1200" b="0">
+                <a:solidFill>
+                  <a:srgbClr val="93C5FD"/>
+                </a:solidFill>
+                <a:latin typeface="맑은 고딕"/>
+                <a:ea typeface="맑은 고딕"/>
+                <a:cs typeface="맑은 고딕"/>
+              </a:rPr>
+              <a:t>도메인부터 ALB까지 암호화·필터링 경로</a:t>
+            </a:r>
+          </a:p>
+        </p:txBody>
+      </p:sp>
+      <p:pic>
+        <p:nvPicPr>
+          <p:cNvPr id="4" name="Picture 3" descr="06_https_waf.png"/>
+          <p:cNvPicPr>
+            <a:picLocks noChangeAspect="1"/>
+          </p:cNvPicPr>
+          <p:nvPr/>
+        </p:nvPicPr>
+        <p:blipFill>
+          <a:blip r:embed="rId2"/>
+          <a:stretch>
+            <a:fillRect/>
+          </a:stretch>
+        </p:blipFill>
+        <p:spPr>
+          <a:xfrm>
+            <a:off x="320040" y="914400"/>
+            <a:ext cx="11521440" cy="6480810"/>
+          </a:xfrm>
+          <a:prstGeom prst="rect">
+            <a:avLst/>
+          </a:prstGeom>
+        </p:spPr>
+      </p:pic>
+      <p:sp>
+        <p:nvSpPr>
+          <p:cNvPr id="5" name="TextBox 4"/>
+          <p:cNvSpPr txBox="1"/>
+          <p:nvPr/>
+        </p:nvSpPr>
+        <p:spPr>
+          <a:xfrm>
+            <a:off x="411480" y="6446520"/>
+            <a:ext cx="11338560" cy="274320"/>
+          </a:xfrm>
+          <a:prstGeom prst="rect">
+            <a:avLst/>
+          </a:prstGeom>
+          <a:noFill/>
+        </p:spPr>
+        <p:txBody>
+          <a:bodyPr wrap="none">
+            <a:spAutoFit/>
+          </a:bodyPr>
+          <a:lstStyle/>
+          <a:p>
+            <a:pPr algn="r"/>
+            <a:r>
+              <a:rPr sz="1000" b="0">
+                <a:solidFill>
+                  <a:srgbClr val="475569"/>
+                </a:solidFill>
+                <a:latin typeface="맑은 고딕"/>
+                <a:ea typeface="맑은 고딕"/>
+                <a:cs typeface="맑은 고딕"/>
+              </a:rPr>
+              <a:t>Aniverse · 온프레미스 3-tier → AWS   |   13/14</a:t>
+            </a:r>
+          </a:p>
+        </p:txBody>
+      </p:sp>
+    </p:spTree>
+  </p:cSld>
+  <p:clrMapOvr>
+    <a:masterClrMapping/>
+  </p:clrMapOvr>
+</p:sld>
+</file>
+
+<file path=ppt/slides/slide14.xml><?xml version="1.0" encoding="utf-8"?>
+<p:sld xmlns:a="http://schemas.openxmlformats.org/drawingml/2006/main" xmlns:p="http://schemas.openxmlformats.org/presentationml/2006/main" xmlns:r="http://schemas.openxmlformats.org/officeDocument/2006/relationships">
+  <p:cSld>
+    <p:spTree>
+      <p:nvGrpSpPr>
+        <p:cNvPr id="1" name=""/>
+        <p:cNvGrpSpPr/>
+        <p:nvPr/>
+      </p:nvGrpSpPr>
+      <p:grpSpPr/>
+      <p:sp>
+        <p:nvSpPr>
+          <p:cNvPr id="2" name="Rectangle 1"/>
+          <p:cNvSpPr/>
+          <p:nvPr/>
+        </p:nvSpPr>
+        <p:spPr>
+          <a:xfrm>
+            <a:off x="0" y="0"/>
+            <a:ext cx="12191695" cy="777240"/>
+          </a:xfrm>
+          <a:prstGeom prst="rect">
+            <a:avLst/>
+          </a:prstGeom>
+          <a:solidFill>
+            <a:srgbClr val="0F172A"/>
+          </a:solidFill>
+          <a:ln>
+            <a:noFill/>
+          </a:ln>
+        </p:spPr>
+        <p:style>
+          <a:lnRef idx="1">
+            <a:schemeClr val="accent1"/>
+          </a:lnRef>
+          <a:fillRef idx="3">
+            <a:schemeClr val="accent1"/>
+          </a:fillRef>
+          <a:effectRef idx="2">
+            <a:schemeClr val="accent1"/>
+          </a:effectRef>
+          <a:fontRef idx="minor">
+            <a:schemeClr val="lt1"/>
+          </a:fontRef>
+        </p:style>
+        <p:txBody>
+          <a:bodyPr rtlCol="0" anchor="ctr"/>
+          <a:lstStyle/>
+          <a:p>
+            <a:pPr algn="ctr"/>
+          </a:p>
+        </p:txBody>
+      </p:sp>
+      <p:sp>
+        <p:nvSpPr>
+          <p:cNvPr id="3" name="TextBox 2"/>
+          <p:cNvSpPr txBox="1"/>
+          <p:nvPr/>
+        </p:nvSpPr>
+        <p:spPr>
+          <a:xfrm>
+            <a:off x="411480" y="109728"/>
+            <a:ext cx="11338560" cy="594360"/>
+          </a:xfrm>
+          <a:prstGeom prst="rect">
+            <a:avLst/>
+          </a:prstGeom>
+          <a:noFill/>
+        </p:spPr>
+        <p:txBody>
+          <a:bodyPr wrap="square">
+            <a:spAutoFit/>
+          </a:bodyPr>
+          <a:lstStyle/>
+          <a:p>
+            <a:r>
+              <a:rPr sz="2200" b="1">
+                <a:solidFill>
+                  <a:srgbClr val="FFFFFF"/>
+                </a:solidFill>
+                <a:latin typeface="맑은 고딕"/>
+                <a:ea typeface="맑은 고딕"/>
+                <a:cs typeface="맑은 고딕"/>
+              </a:rPr>
+              <a:t>6. HTTPS · WAF (2)</a:t>
+            </a:r>
+          </a:p>
+          <a:p>
+            <a:pPr>
+              <a:spcBef>
+                <a:spcPts val="200"/>
+              </a:spcBef>
+            </a:pPr>
+            <a:r>
+              <a:rPr sz="1200" b="0">
+                <a:solidFill>
+                  <a:srgbClr val="93C5FD"/>
+                </a:solidFill>
+                <a:latin typeface="맑은 고딕"/>
+                <a:ea typeface="맑은 고딕"/>
+                <a:cs typeface="맑은 고딕"/>
+              </a:rPr>
+              <a:t>Terraform으로 고정한 보안 엣지</a:t>
+            </a:r>
+          </a:p>
+        </p:txBody>
+      </p:sp>
+      <p:sp>
+        <p:nvSpPr>
+          <p:cNvPr id="4" name="Rounded Rectangle 3"/>
+          <p:cNvSpPr/>
+          <p:nvPr/>
+        </p:nvSpPr>
+        <p:spPr>
+          <a:xfrm>
+            <a:off x="320040" y="1051560"/>
+            <a:ext cx="5669280" cy="5029200"/>
+          </a:xfrm>
+          <a:prstGeom prst="roundRect">
+            <a:avLst/>
+          </a:prstGeom>
+          <a:solidFill>
+            <a:srgbClr val="EFF6FF"/>
+          </a:solidFill>
+          <a:ln w="19050">
+            <a:solidFill>
+              <a:srgbClr val="0D9488"/>
+            </a:solidFill>
+          </a:ln>
+        </p:spPr>
+        <p:style>
+          <a:lnRef idx="1">
+            <a:schemeClr val="accent1"/>
+          </a:lnRef>
+          <a:fillRef idx="3">
+            <a:schemeClr val="accent1"/>
+          </a:fillRef>
+          <a:effectRef idx="2">
+            <a:schemeClr val="accent1"/>
+          </a:effectRef>
+          <a:fontRef idx="minor">
+            <a:schemeClr val="lt1"/>
+          </a:fontRef>
+        </p:style>
+        <p:txBody>
+          <a:bodyPr rtlCol="0" anchor="ctr" wrap="square"/>
+          <a:lstStyle/>
+          <a:p>
+            <a:pPr algn="ctr"/>
+            <a:r>
+              <a:rPr sz="1800" b="1">
+                <a:solidFill>
+                  <a:srgbClr val="0D9488"/>
+                </a:solidFill>
+                <a:latin typeface="맑은 고딕"/>
+                <a:ea typeface="맑은 고딕"/>
+                <a:cs typeface="맑은 고딕"/>
+              </a:rPr>
+              <a:t>HTTPS — ACM + ALB</a:t>
+            </a:r>
+          </a:p>
+          <a:p>
+            <a:pPr>
+              <a:spcBef>
+                <a:spcPts val="500"/>
+              </a:spcBef>
+            </a:pPr>
+            <a:r>
+              <a:rPr sz="1300" b="0">
+                <a:solidFill>
+                  <a:srgbClr val="0F172A"/>
+                </a:solidFill>
+                <a:latin typeface="맑은 고딕"/>
+                <a:ea typeface="맑은 고딕"/>
+                <a:cs typeface="맑은 고딕"/>
+              </a:rPr>
+              <a:t>modules/acm</a:t>
+            </a:r>
+          </a:p>
+          <a:p>
+            <a:pPr>
+              <a:spcBef>
+                <a:spcPts val="500"/>
+              </a:spcBef>
+            </a:pPr>
+            <a:r>
+              <a:rPr sz="1300" b="0">
+                <a:solidFill>
+                  <a:srgbClr val="0F172A"/>
+                </a:solidFill>
+                <a:latin typeface="맑은 고딕"/>
+                <a:ea typeface="맑은 고딕"/>
+                <a:cs typeface="맑은 고딕"/>
+              </a:rPr>
+              <a:t>• aniverse.my DNS 검증 인증서</a:t>
+            </a:r>
+          </a:p>
+          <a:p>
+            <a:pPr>
+              <a:spcBef>
+                <a:spcPts val="500"/>
+              </a:spcBef>
+            </a:pPr>
+            <a:r>
+              <a:rPr sz="1300" b="0">
+                <a:solidFill>
+                  <a:srgbClr val="0F172A"/>
+                </a:solidFill>
+                <a:latin typeface="맑은 고딕"/>
+                <a:ea typeface="맑은 고딕"/>
+                <a:cs typeface="맑은 고딕"/>
+              </a:rPr>
+              <a:t>• www SAN 포함 · Route53 검증 레코드</a:t>
+            </a:r>
+          </a:p>
+          <a:p>
+            <a:pPr>
+              <a:spcBef>
+                <a:spcPts val="500"/>
+              </a:spcBef>
+            </a:pPr>
+            <a:r>
+              <a:rPr sz="1300" b="0">
+                <a:solidFill>
+                  <a:srgbClr val="0F172A"/>
+                </a:solidFill>
+                <a:latin typeface="맑은 고딕"/>
+                <a:ea typeface="맑은 고딕"/>
+                <a:cs typeface="맑은 고딕"/>
+              </a:rPr>
+              <a:t/>
+            </a:r>
+          </a:p>
+          <a:p>
+            <a:pPr>
+              <a:spcBef>
+                <a:spcPts val="500"/>
+              </a:spcBef>
+            </a:pPr>
+            <a:r>
+              <a:rPr sz="1300" b="0">
+                <a:solidFill>
+                  <a:srgbClr val="0F172A"/>
+                </a:solidFill>
+                <a:latin typeface="맑은 고딕"/>
+                <a:ea typeface="맑은 고딕"/>
+                <a:cs typeface="맑은 고딕"/>
+              </a:rPr>
+              <a:t>modules/alb</a:t>
+            </a:r>
+          </a:p>
+          <a:p>
+            <a:pPr>
+              <a:spcBef>
+                <a:spcPts val="500"/>
+              </a:spcBef>
+            </a:pPr>
+            <a:r>
+              <a:rPr sz="1300" b="0">
+                <a:solidFill>
+                  <a:srgbClr val="0F172A"/>
+                </a:solidFill>
+                <a:latin typeface="맑은 고딕"/>
+                <a:ea typeface="맑은 고딕"/>
+                <a:cs typeface="맑은 고딕"/>
+              </a:rPr>
+              <a:t>• 443 HTTPS Listener (TLS 1.3)</a:t>
+            </a:r>
+          </a:p>
+          <a:p>
+            <a:pPr>
+              <a:spcBef>
+                <a:spcPts val="500"/>
+              </a:spcBef>
+            </a:pPr>
+            <a:r>
+              <a:rPr sz="1300" b="0">
+                <a:solidFill>
+                  <a:srgbClr val="0F172A"/>
+                </a:solidFill>
+                <a:latin typeface="맑은 고딕"/>
+                <a:ea typeface="맑은 고딕"/>
+                <a:cs typeface="맑은 고딕"/>
+              </a:rPr>
+              <a:t>• 80 → 443 HTTP 301 redirect</a:t>
+            </a:r>
+          </a:p>
+          <a:p>
+            <a:pPr>
+              <a:spcBef>
+                <a:spcPts val="500"/>
+              </a:spcBef>
+            </a:pPr>
+            <a:r>
+              <a:rPr sz="1300" b="0">
+                <a:solidFill>
+                  <a:srgbClr val="0F172A"/>
+                </a:solidFill>
+                <a:latin typeface="맑은 고딕"/>
+                <a:ea typeface="맑은 고딕"/>
+                <a:cs typeface="맑은 고딕"/>
+              </a:rPr>
+              <a:t>• Target Group → ASG/EC2</a:t>
+            </a:r>
+          </a:p>
+          <a:p>
+            <a:pPr>
+              <a:spcBef>
+                <a:spcPts val="500"/>
+              </a:spcBef>
+            </a:pPr>
+            <a:r>
+              <a:rPr sz="1300" b="0">
+                <a:solidFill>
+                  <a:srgbClr val="0F172A"/>
+                </a:solidFill>
+                <a:latin typeface="맑은 고딕"/>
+                <a:ea typeface="맑은 고딕"/>
+                <a:cs typeface="맑은 고딕"/>
+              </a:rPr>
+              <a:t/>
+            </a:r>
+          </a:p>
+          <a:p>
+            <a:pPr>
+              <a:spcBef>
+                <a:spcPts val="500"/>
+              </a:spcBef>
+            </a:pPr>
+            <a:r>
+              <a:rPr sz="1300" b="0">
+                <a:solidFill>
+                  <a:srgbClr val="0F172A"/>
+                </a:solidFill>
+                <a:latin typeface="맑은 고딕"/>
+                <a:ea typeface="맑은 고딕"/>
+                <a:cs typeface="맑은 고딕"/>
+              </a:rPr>
+              <a:t>앱 연동</a:t>
+            </a:r>
+          </a:p>
+          <a:p>
+            <a:pPr>
+              <a:spcBef>
+                <a:spcPts val="500"/>
+              </a:spcBef>
+            </a:pPr>
+            <a:r>
+              <a:rPr sz="1300" b="0">
+                <a:solidFill>
+                  <a:srgbClr val="0F172A"/>
+                </a:solidFill>
+                <a:latin typeface="맑은 고딕"/>
+                <a:ea typeface="맑은 고딕"/>
+                <a:cs typeface="맑은 고딕"/>
+              </a:rPr>
+              <a:t>• Secrets: USE_HTTPS=True</a:t>
+            </a:r>
+          </a:p>
+          <a:p>
+            <a:pPr>
+              <a:spcBef>
+                <a:spcPts val="500"/>
+              </a:spcBef>
+            </a:pPr>
+            <a:r>
+              <a:rPr sz="1300" b="0">
+                <a:solidFill>
+                  <a:srgbClr val="0F172A"/>
+                </a:solidFill>
+                <a:latin typeface="맑은 고딕"/>
+                <a:ea typeface="맑은 고딕"/>
+                <a:cs typeface="맑은 고딕"/>
+              </a:rPr>
+              <a:t>• CSRF / ALLOWED_HOSTS https 허용</a:t>
+            </a:r>
+          </a:p>
+        </p:txBody>
+      </p:sp>
+      <p:sp>
+        <p:nvSpPr>
+          <p:cNvPr id="5" name="Rounded Rectangle 4"/>
+          <p:cNvSpPr/>
+          <p:nvPr/>
+        </p:nvSpPr>
+        <p:spPr>
+          <a:xfrm>
+            <a:off x="6217920" y="1051560"/>
+            <a:ext cx="5623560" cy="5029200"/>
+          </a:xfrm>
+          <a:prstGeom prst="roundRect">
+            <a:avLst/>
+          </a:prstGeom>
+          <a:solidFill>
+            <a:srgbClr val="FEF2F2"/>
+          </a:solidFill>
+          <a:ln w="19050">
+            <a:solidFill>
+              <a:srgbClr val="DC2626"/>
+            </a:solidFill>
+          </a:ln>
+        </p:spPr>
+        <p:style>
+          <a:lnRef idx="1">
+            <a:schemeClr val="accent1"/>
+          </a:lnRef>
+          <a:fillRef idx="3">
+            <a:schemeClr val="accent1"/>
+          </a:fillRef>
+          <a:effectRef idx="2">
+            <a:schemeClr val="accent1"/>
+          </a:effectRef>
+          <a:fontRef idx="minor">
+            <a:schemeClr val="lt1"/>
+          </a:fontRef>
+        </p:style>
+        <p:txBody>
+          <a:bodyPr rtlCol="0" anchor="ctr" wrap="square"/>
+          <a:lstStyle/>
+          <a:p>
+            <a:pPr algn="ctr"/>
+            <a:r>
+              <a:rPr sz="1800" b="1">
+                <a:solidFill>
+                  <a:srgbClr val="DC2626"/>
+                </a:solidFill>
+                <a:latin typeface="맑은 고딕"/>
+                <a:ea typeface="맑은 고딕"/>
+                <a:cs typeface="맑은 고딕"/>
+              </a:rPr>
+              <a:t>WAF — ALB Web ACL</a:t>
+            </a:r>
+          </a:p>
+          <a:p>
+            <a:pPr>
+              <a:spcBef>
+                <a:spcPts val="400"/>
+              </a:spcBef>
+            </a:pPr>
+            <a:r>
+              <a:rPr sz="1300" b="0">
+                <a:solidFill>
+                  <a:srgbClr val="0F172A"/>
+                </a:solidFill>
+                <a:latin typeface="맑은 고딕"/>
+                <a:ea typeface="맑은 고딕"/>
+                <a:cs typeface="맑은 고딕"/>
+              </a:rPr>
+              <a:t>modules/waf → aniverse-alb-waf</a:t>
+            </a:r>
+          </a:p>
+          <a:p>
+            <a:pPr>
+              <a:spcBef>
+                <a:spcPts val="400"/>
+              </a:spcBef>
+            </a:pPr>
+            <a:r>
+              <a:rPr sz="1300" b="0">
+                <a:solidFill>
+                  <a:srgbClr val="0F172A"/>
+                </a:solidFill>
+                <a:latin typeface="맑은 고딕"/>
+                <a:ea typeface="맑은 고딕"/>
+                <a:cs typeface="맑은 고딕"/>
+              </a:rPr>
+              <a:t>• scope: REGIONAL (ALB 전용)</a:t>
+            </a:r>
+          </a:p>
+          <a:p>
+            <a:pPr>
+              <a:spcBef>
+                <a:spcPts val="400"/>
+              </a:spcBef>
+            </a:pPr>
+            <a:r>
+              <a:rPr sz="1300" b="0">
+                <a:solidFill>
+                  <a:srgbClr val="0F172A"/>
+                </a:solidFill>
+                <a:latin typeface="맑은 고딕"/>
+                <a:ea typeface="맑은 고딕"/>
+                <a:cs typeface="맑은 고딕"/>
+              </a:rPr>
+              <a:t/>
+            </a:r>
+          </a:p>
+          <a:p>
+            <a:pPr>
+              <a:spcBef>
+                <a:spcPts val="400"/>
+              </a:spcBef>
+            </a:pPr>
+            <a:r>
+              <a:rPr sz="1300" b="0">
+                <a:solidFill>
+                  <a:srgbClr val="0F172A"/>
+                </a:solidFill>
+                <a:latin typeface="맑은 고딕"/>
+                <a:ea typeface="맑은 고딕"/>
+                <a:cs typeface="맑은 고딕"/>
+              </a:rPr>
+              <a:t>관리형 규칙</a:t>
+            </a:r>
+          </a:p>
+          <a:p>
+            <a:pPr>
+              <a:spcBef>
+                <a:spcPts val="400"/>
+              </a:spcBef>
+            </a:pPr>
+            <a:r>
+              <a:rPr sz="1300" b="0">
+                <a:solidFill>
+                  <a:srgbClr val="0F172A"/>
+                </a:solidFill>
+                <a:latin typeface="맑은 고딕"/>
+                <a:ea typeface="맑은 고딕"/>
+                <a:cs typeface="맑은 고딕"/>
+              </a:rPr>
+              <a:t>• CommonRuleSet (일반 웹 공격)</a:t>
+            </a:r>
+          </a:p>
+          <a:p>
+            <a:pPr>
+              <a:spcBef>
+                <a:spcPts val="400"/>
+              </a:spcBef>
+            </a:pPr>
+            <a:r>
+              <a:rPr sz="1300" b="0">
+                <a:solidFill>
+                  <a:srgbClr val="0F172A"/>
+                </a:solidFill>
+                <a:latin typeface="맑은 고딕"/>
+                <a:ea typeface="맑은 고딕"/>
+                <a:cs typeface="맑은 고딕"/>
+              </a:rPr>
+              <a:t>• KnownBadInputs</a:t>
+            </a:r>
+          </a:p>
+          <a:p>
+            <a:pPr>
+              <a:spcBef>
+                <a:spcPts val="400"/>
+              </a:spcBef>
+            </a:pPr>
+            <a:r>
+              <a:rPr sz="1300" b="0">
+                <a:solidFill>
+                  <a:srgbClr val="0F172A"/>
+                </a:solidFill>
+                <a:latin typeface="맑은 고딕"/>
+                <a:ea typeface="맑은 고딕"/>
+                <a:cs typeface="맑은 고딕"/>
+              </a:rPr>
+              <a:t>• SQLi RuleSet</a:t>
+            </a:r>
+          </a:p>
+          <a:p>
+            <a:pPr>
+              <a:spcBef>
+                <a:spcPts val="400"/>
+              </a:spcBef>
+            </a:pPr>
+            <a:r>
+              <a:rPr sz="1300" b="0">
+                <a:solidFill>
+                  <a:srgbClr val="0F172A"/>
+                </a:solidFill>
+                <a:latin typeface="맑은 고딕"/>
+                <a:ea typeface="맑은 고딕"/>
+                <a:cs typeface="맑은 고딕"/>
+              </a:rPr>
+              <a:t/>
+            </a:r>
+          </a:p>
+          <a:p>
+            <a:pPr>
+              <a:spcBef>
+                <a:spcPts val="400"/>
+              </a:spcBef>
+            </a:pPr>
+            <a:r>
+              <a:rPr sz="1300" b="0">
+                <a:solidFill>
+                  <a:srgbClr val="0F172A"/>
+                </a:solidFill>
+                <a:latin typeface="맑은 고딕"/>
+                <a:ea typeface="맑은 고딕"/>
+                <a:cs typeface="맑은 고딕"/>
+              </a:rPr>
+              <a:t>커스텀</a:t>
+            </a:r>
+          </a:p>
+          <a:p>
+            <a:pPr>
+              <a:spcBef>
+                <a:spcPts val="400"/>
+              </a:spcBef>
+            </a:pPr>
+            <a:r>
+              <a:rPr sz="1300" b="0">
+                <a:solidFill>
+                  <a:srgbClr val="0F172A"/>
+                </a:solidFill>
+                <a:latin typeface="맑은 고딕"/>
+                <a:ea typeface="맑은 고딕"/>
+                <a:cs typeface="맑은 고딕"/>
+              </a:rPr>
+              <a:t>• RateLimitPerIP → Block</a:t>
+            </a:r>
+          </a:p>
+          <a:p>
+            <a:pPr>
+              <a:spcBef>
+                <a:spcPts val="400"/>
+              </a:spcBef>
+            </a:pPr>
+            <a:r>
+              <a:rPr sz="1300" b="0">
+                <a:solidFill>
+                  <a:srgbClr val="0F172A"/>
+                </a:solidFill>
+                <a:latin typeface="맑은 고딕"/>
+                <a:ea typeface="맑은 고딕"/>
+                <a:cs typeface="맑은 고딕"/>
+              </a:rPr>
+              <a:t/>
+            </a:r>
+          </a:p>
+          <a:p>
+            <a:pPr>
+              <a:spcBef>
+                <a:spcPts val="400"/>
+              </a:spcBef>
+            </a:pPr>
+            <a:r>
+              <a:rPr sz="1300" b="0">
+                <a:solidFill>
+                  <a:srgbClr val="0F172A"/>
+                </a:solidFill>
+                <a:latin typeface="맑은 고딕"/>
+                <a:ea typeface="맑은 고딕"/>
+                <a:cs typeface="맑은 고딕"/>
+              </a:rPr>
+              <a:t>연결</a:t>
+            </a:r>
+          </a:p>
+          <a:p>
+            <a:pPr>
+              <a:spcBef>
+                <a:spcPts val="400"/>
+              </a:spcBef>
+            </a:pPr>
+            <a:r>
+              <a:rPr sz="1300" b="0">
+                <a:solidFill>
+                  <a:srgbClr val="0F172A"/>
+                </a:solidFill>
+                <a:latin typeface="맑은 고딕"/>
+                <a:ea typeface="맑은 고딕"/>
+                <a:cs typeface="맑은 고딕"/>
+              </a:rPr>
+              <a:t>• web_acl_association → ALB ARN</a:t>
+            </a:r>
+          </a:p>
+          <a:p>
+            <a:pPr>
+              <a:spcBef>
+                <a:spcPts val="400"/>
+              </a:spcBef>
+            </a:pPr>
+            <a:r>
+              <a:rPr sz="1300" b="0">
+                <a:solidFill>
+                  <a:srgbClr val="0F172A"/>
+                </a:solidFill>
+                <a:latin typeface="맑은 고딕"/>
+                <a:ea typeface="맑은 고딕"/>
+                <a:cs typeface="맑은 고딕"/>
+              </a:rPr>
+              <a:t>• CloudWatch metrics / sampled req</a:t>
+            </a:r>
+          </a:p>
+        </p:txBody>
+      </p:sp>
+      <p:sp>
+        <p:nvSpPr>
+          <p:cNvPr id="6" name="TextBox 5"/>
+          <p:cNvSpPr txBox="1"/>
+          <p:nvPr/>
+        </p:nvSpPr>
+        <p:spPr>
+          <a:xfrm>
+            <a:off x="411480" y="6446520"/>
+            <a:ext cx="11338560" cy="274320"/>
+          </a:xfrm>
+          <a:prstGeom prst="rect">
+            <a:avLst/>
+          </a:prstGeom>
+          <a:noFill/>
+        </p:spPr>
+        <p:txBody>
+          <a:bodyPr wrap="none">
+            <a:spAutoFit/>
+          </a:bodyPr>
+          <a:lstStyle/>
+          <a:p>
+            <a:pPr algn="r"/>
+            <a:r>
+              <a:rPr sz="1000" b="0">
+                <a:solidFill>
+                  <a:srgbClr val="475569"/>
+                </a:solidFill>
+                <a:latin typeface="맑은 고딕"/>
+                <a:ea typeface="맑은 고딕"/>
+                <a:cs typeface="맑은 고딕"/>
+              </a:rPr>
+              <a:t>Aniverse · 온프레미스 3-tier → AWS   |   14/14</a:t>
+            </a:r>
+          </a:p>
+        </p:txBody>
+      </p:sp>
+    </p:spTree>
+  </p:cSld>
+  <p:clrMapOvr>
+    <a:masterClrMapping/>
+  </p:clrMapOvr>
+</p:sld>
+</file>
+
+<file path=ppt/slides/slide15.xml><?xml version="1.0" encoding="utf-8"?>
+<p:sld xmlns:a="http://schemas.openxmlformats.org/drawingml/2006/main" xmlns:p="http://schemas.openxmlformats.org/presentationml/2006/main" xmlns:r="http://schemas.openxmlformats.org/officeDocument/2006/relationships">
+  <p:cSld>
+    <p:spTree>
+      <p:nvGrpSpPr>
+        <p:cNvPr id="1" name=""/>
+        <p:cNvGrpSpPr/>
+        <p:nvPr/>
+      </p:nvGrpSpPr>
+      <p:grpSpPr/>
+      <p:sp>
+        <p:nvSpPr>
+          <p:cNvPr id="2" name="Rectangle 1"/>
+          <p:cNvSpPr/>
+          <p:nvPr/>
+        </p:nvSpPr>
+        <p:spPr>
+          <a:xfrm>
+            <a:off x="0" y="0"/>
+            <a:ext cx="12191695" cy="6858000"/>
+          </a:xfrm>
+          <a:prstGeom prst="rect">
+            <a:avLst/>
+          </a:prstGeom>
+          <a:solidFill>
+            <a:srgbClr val="0F172A"/>
+          </a:solidFill>
+          <a:ln>
+            <a:noFill/>
+          </a:ln>
+        </p:spPr>
+        <p:style>
+          <a:lnRef idx="1">
+            <a:schemeClr val="accent1"/>
+          </a:lnRef>
+          <a:fillRef idx="3">
+            <a:schemeClr val="accent1"/>
+          </a:fillRef>
+          <a:effectRef idx="2">
+            <a:schemeClr val="accent1"/>
+          </a:effectRef>
+          <a:fontRef idx="minor">
+            <a:schemeClr val="lt1"/>
+          </a:fontRef>
+        </p:style>
+        <p:txBody>
+          <a:bodyPr rtlCol="0" anchor="ctr"/>
+          <a:lstStyle/>
+          <a:p>
+            <a:pPr algn="ctr"/>
+          </a:p>
+        </p:txBody>
+      </p:sp>
+      <p:sp>
+        <p:nvSpPr>
+          <p:cNvPr id="3" name="TextBox 2"/>
+          <p:cNvSpPr txBox="1"/>
+          <p:nvPr/>
+        </p:nvSpPr>
+        <p:spPr>
+          <a:xfrm>
+            <a:off x="731520" y="1645920"/>
+            <a:ext cx="10698480" cy="3657600"/>
+          </a:xfrm>
+          <a:prstGeom prst="rect">
+            <a:avLst/>
+          </a:prstGeom>
+          <a:noFill/>
+        </p:spPr>
+        <p:txBody>
+          <a:bodyPr wrap="square">
+            <a:spAutoFit/>
+          </a:bodyPr>
+          <a:lstStyle/>
+          <a:p>
+            <a:r>
               <a:rPr sz="2000" b="1">
                 <a:solidFill>
                   <a:srgbClr val="93C5FD"/>
@@ -4573,7 +5483,7 @@
                 <a:ea typeface="맑은 고딕"/>
                 <a:cs typeface="맑은 고딕"/>
               </a:rPr>
-              <a:t>서이(망) · 유민(트래픽) · 윤주(데이터) · 현우(자동화)</a:t>
+              <a:t>서이(망) · 유민(트래픽) · 윤주(데이터) · 현우(자동화·HTTPS·WAF)</a:t>
             </a:r>
           </a:p>
           <a:p>
@@ -4701,8 +5611,8 @@
         </p:nvSpPr>
         <p:spPr>
           <a:xfrm>
-            <a:off x="640080" y="1097280"/>
-            <a:ext cx="10881360" cy="777240"/>
+            <a:off x="640080" y="1051560"/>
+            <a:ext cx="10881360" cy="685800"/>
           </a:xfrm>
           <a:prstGeom prst="roundRect">
             <a:avLst/>
@@ -4736,7 +5646,7 @@
           <a:p>
             <a:pPr algn="ctr"/>
             <a:r>
-              <a:rPr sz="2000" b="1">
+              <a:rPr sz="1800" b="1">
                 <a:solidFill>
                   <a:srgbClr val="0F172A"/>
                 </a:solidFill>
@@ -4757,8 +5667,8 @@
         </p:nvSpPr>
         <p:spPr>
           <a:xfrm>
-            <a:off x="640080" y="2011680"/>
-            <a:ext cx="10881360" cy="777240"/>
+            <a:off x="640080" y="1856232"/>
+            <a:ext cx="10881360" cy="685800"/>
           </a:xfrm>
           <a:prstGeom prst="roundRect">
             <a:avLst/>
@@ -4792,7 +5702,7 @@
           <a:p>
             <a:pPr algn="ctr"/>
             <a:r>
-              <a:rPr sz="2000" b="1">
+              <a:rPr sz="1800" b="1">
                 <a:solidFill>
                   <a:srgbClr val="0F172A"/>
                 </a:solidFill>
@@ -4813,8 +5723,8 @@
         </p:nvSpPr>
         <p:spPr>
           <a:xfrm>
-            <a:off x="640080" y="2926080"/>
-            <a:ext cx="10881360" cy="777240"/>
+            <a:off x="640080" y="2660904"/>
+            <a:ext cx="10881360" cy="685800"/>
           </a:xfrm>
           <a:prstGeom prst="roundRect">
             <a:avLst/>
@@ -4848,7 +5758,7 @@
           <a:p>
             <a:pPr algn="ctr"/>
             <a:r>
-              <a:rPr sz="2000" b="1">
+              <a:rPr sz="1800" b="1">
                 <a:solidFill>
                   <a:srgbClr val="0F172A"/>
                 </a:solidFill>
@@ -4869,8 +5779,8 @@
         </p:nvSpPr>
         <p:spPr>
           <a:xfrm>
-            <a:off x="640080" y="3840480"/>
-            <a:ext cx="10881360" cy="777240"/>
+            <a:off x="640080" y="3465576"/>
+            <a:ext cx="10881360" cy="685800"/>
           </a:xfrm>
           <a:prstGeom prst="roundRect">
             <a:avLst/>
@@ -4904,7 +5814,7 @@
           <a:p>
             <a:pPr algn="ctr"/>
             <a:r>
-              <a:rPr sz="2000" b="1">
+              <a:rPr sz="1800" b="1">
                 <a:solidFill>
                   <a:srgbClr val="0F172A"/>
                 </a:solidFill>
@@ -4925,8 +5835,8 @@
         </p:nvSpPr>
         <p:spPr>
           <a:xfrm>
-            <a:off x="640080" y="4754880"/>
-            <a:ext cx="10881360" cy="777240"/>
+            <a:off x="640080" y="4270248"/>
+            <a:ext cx="10881360" cy="685800"/>
           </a:xfrm>
           <a:prstGeom prst="roundRect">
             <a:avLst/>
@@ -4960,7 +5870,7 @@
           <a:p>
             <a:pPr algn="ctr"/>
             <a:r>
-              <a:rPr sz="2000" b="1">
+              <a:rPr sz="1800" b="1">
                 <a:solidFill>
                   <a:srgbClr val="0F172A"/>
                 </a:solidFill>
@@ -4975,7 +5885,63 @@
       </p:sp>
       <p:sp>
         <p:nvSpPr>
-          <p:cNvPr id="9" name="TextBox 8"/>
+          <p:cNvPr id="9" name="Rounded Rectangle 8"/>
+          <p:cNvSpPr/>
+          <p:nvPr/>
+        </p:nvSpPr>
+        <p:spPr>
+          <a:xfrm>
+            <a:off x="640080" y="5074920"/>
+            <a:ext cx="10881360" cy="685800"/>
+          </a:xfrm>
+          <a:prstGeom prst="roundRect">
+            <a:avLst/>
+          </a:prstGeom>
+          <a:solidFill>
+            <a:srgbClr val="F8FAFC"/>
+          </a:solidFill>
+          <a:ln w="19050">
+            <a:solidFill>
+              <a:srgbClr val="2563EB"/>
+            </a:solidFill>
+          </a:ln>
+        </p:spPr>
+        <p:style>
+          <a:lnRef idx="1">
+            <a:schemeClr val="accent1"/>
+          </a:lnRef>
+          <a:fillRef idx="3">
+            <a:schemeClr val="accent1"/>
+          </a:fillRef>
+          <a:effectRef idx="2">
+            <a:schemeClr val="accent1"/>
+          </a:effectRef>
+          <a:fontRef idx="minor">
+            <a:schemeClr val="lt1"/>
+          </a:fontRef>
+        </p:style>
+        <p:txBody>
+          <a:bodyPr rtlCol="0" anchor="ctr" wrap="square"/>
+          <a:lstStyle/>
+          <a:p>
+            <a:pPr algn="ctr"/>
+            <a:r>
+              <a:rPr sz="1800" b="1">
+                <a:solidFill>
+                  <a:srgbClr val="0F172A"/>
+                </a:solidFill>
+                <a:latin typeface="맑은 고딕"/>
+                <a:ea typeface="맑은 고딕"/>
+                <a:cs typeface="맑은 고딕"/>
+              </a:rPr>
+              <a:t>06  HTTPS · WAF</a:t>
+            </a:r>
+          </a:p>
+        </p:txBody>
+      </p:sp>
+      <p:sp>
+        <p:nvSpPr>
+          <p:cNvPr id="10" name="TextBox 9"/>
           <p:cNvSpPr txBox="1"/>
           <p:nvPr/>
         </p:nvSpPr>
@@ -5005,7 +5971,7 @@
                 <a:ea typeface="맑은 고딕"/>
                 <a:cs typeface="맑은 고딕"/>
               </a:rPr>
-              <a:t>Aniverse · 온프레미스 3-tier → AWS   |   2/12</a:t>
+              <a:t>Aniverse · 온프레미스 3-tier → AWS   |   2/14</a:t>
             </a:r>
           </a:p>
         </p:txBody>
@@ -5681,7 +6647,7 @@
                 <a:ea typeface="맑은 고딕"/>
                 <a:cs typeface="맑은 고딕"/>
               </a:rPr>
-              <a:t>Aniverse · 온프레미스 3-tier → AWS   |   3/12</a:t>
+              <a:t>Aniverse · 온프레미스 3-tier → AWS   |   3/14</a:t>
             </a:r>
           </a:p>
         </p:txBody>
@@ -5857,7 +6823,7 @@
                 <a:ea typeface="맑은 고딕"/>
                 <a:cs typeface="맑은 고딕"/>
               </a:rPr>
-              <a:t>Aniverse · 온프레미스 3-tier → AWS   |   4/12</a:t>
+              <a:t>Aniverse · 온프레미스 3-tier → AWS   |   4/14</a:t>
             </a:r>
           </a:p>
         </p:txBody>
@@ -6449,7 +7415,7 @@
                 <a:ea typeface="맑은 고딕"/>
                 <a:cs typeface="맑은 고딕"/>
               </a:rPr>
-              <a:t>Aniverse · 온프레미스 3-tier → AWS   |   5/12</a:t>
+              <a:t>Aniverse · 온프레미스 3-tier → AWS   |   5/14</a:t>
             </a:r>
           </a:p>
         </p:txBody>
@@ -6625,7 +7591,7 @@
                 <a:ea typeface="맑은 고딕"/>
                 <a:cs typeface="맑은 고딕"/>
               </a:rPr>
-              <a:t>Aniverse · 온프레미스 3-tier → AWS   |   6/12</a:t>
+              <a:t>Aniverse · 온프레미스 3-tier → AWS   |   6/14</a:t>
             </a:r>
           </a:p>
         </p:txBody>
@@ -6801,7 +7767,7 @@
                 <a:ea typeface="맑은 고딕"/>
                 <a:cs typeface="맑은 고딕"/>
               </a:rPr>
-              <a:t>Aniverse · 온프레미스 3-tier → AWS   |   7/12</a:t>
+              <a:t>Aniverse · 온프레미스 3-tier → AWS   |   7/14</a:t>
             </a:r>
           </a:p>
         </p:txBody>
@@ -7317,7 +8283,7 @@
                 <a:ea typeface="맑은 고딕"/>
                 <a:cs typeface="맑은 고딕"/>
               </a:rPr>
-              <a:t>Aniverse · 온프레미스 3-tier → AWS   |   8/12</a:t>
+              <a:t>Aniverse · 온프레미스 3-tier → AWS   |   8/14</a:t>
             </a:r>
           </a:p>
         </p:txBody>
@@ -7493,7 +8459,7 @@
                 <a:ea typeface="맑은 고딕"/>
                 <a:cs typeface="맑은 고딕"/>
               </a:rPr>
-              <a:t>Aniverse · 온프레미스 3-tier → AWS   |   9/12</a:t>
+              <a:t>Aniverse · 온프레미스 3-tier → AWS   |   9/14</a:t>
             </a:r>
           </a:p>
         </p:txBody>

</xml_diff>

<commit_message>
docs: add data/storage slides and Remote State to assembly
Expand instructor PPT with RDS/EFS/S3+DynamoDB/CORS+Lifecycle, and
update slide 8 assembly steps with Remote State bootstrap plus State Lock.

Co-authored-by: ho0215 <ho0215@users.noreply.github.com>
</commit_message>
<xml_diff>
--- a/docs/presentation/ppt/Aniverse_발표_강사용.pptx
+++ b/docs/presentation/ppt/Aniverse_발표_강사용.pptx
@@ -20,6 +20,7 @@
     <p:sldId id="268" r:id="rId19"/>
     <p:sldId id="269" r:id="rId20"/>
     <p:sldId id="270" r:id="rId21"/>
+    <p:sldId id="271" r:id="rId22"/>
   </p:sldIdLst>
   <p:sldSz cx="12191695" cy="6858000" type="screen4x3"/>
   <p:notesSz cx="6858000" cy="9144000"/>
@@ -3327,7 +3328,7 @@
                 <a:ea typeface="맑은 고딕"/>
                 <a:cs typeface="맑은 고딕"/>
               </a:rPr>
-              <a:t>4. GitHub Actions (2)</a:t>
+              <a:t>4. GitHub Actions (1)</a:t>
             </a:r>
           </a:p>
           <a:p>
@@ -3345,306 +3346,38 @@
                 <a:ea typeface="맑은 고딕"/>
                 <a:cs typeface="맑은 고딕"/>
               </a:rPr>
-              <a:t>실제로 돌아가는 파이프라인</a:t>
-            </a:r>
-          </a:p>
-        </p:txBody>
-      </p:sp>
-      <p:sp>
-        <p:nvSpPr>
-          <p:cNvPr id="4" name="Rounded Rectangle 3"/>
-          <p:cNvSpPr/>
+              <a:t>인프라 저장소 / 앱 저장소를 나눠 자동화</a:t>
+            </a:r>
+          </a:p>
+        </p:txBody>
+      </p:sp>
+      <p:pic>
+        <p:nvPicPr>
+          <p:cNvPr id="4" name="Picture 3" descr="04_github_actions.png"/>
+          <p:cNvPicPr>
+            <a:picLocks noChangeAspect="1"/>
+          </p:cNvPicPr>
           <p:nvPr/>
-        </p:nvSpPr>
-        <p:spPr>
-          <a:xfrm>
-            <a:off x="365760" y="1097280"/>
-            <a:ext cx="5669280" cy="4846320"/>
-          </a:xfrm>
-          <a:prstGeom prst="roundRect">
+        </p:nvPicPr>
+        <p:blipFill>
+          <a:blip r:embed="rId2"/>
+          <a:stretch>
+            <a:fillRect/>
+          </a:stretch>
+        </p:blipFill>
+        <p:spPr>
+          <a:xfrm>
+            <a:off x="274320" y="960120"/>
+            <a:ext cx="11612880" cy="6532245"/>
+          </a:xfrm>
+          <a:prstGeom prst="rect">
             <a:avLst/>
           </a:prstGeom>
-          <a:solidFill>
-            <a:srgbClr val="EFF6FF"/>
-          </a:solidFill>
-          <a:ln w="19050">
-            <a:solidFill>
-              <a:srgbClr val="2563EB"/>
-            </a:solidFill>
-          </a:ln>
-        </p:spPr>
-        <p:style>
-          <a:lnRef idx="1">
-            <a:schemeClr val="accent1"/>
-          </a:lnRef>
-          <a:fillRef idx="3">
-            <a:schemeClr val="accent1"/>
-          </a:fillRef>
-          <a:effectRef idx="2">
-            <a:schemeClr val="accent1"/>
-          </a:effectRef>
-          <a:fontRef idx="minor">
-            <a:schemeClr val="lt1"/>
-          </a:fontRef>
-        </p:style>
-        <p:txBody>
-          <a:bodyPr rtlCol="0" anchor="ctr" wrap="square"/>
-          <a:lstStyle/>
-          <a:p>
-            <a:pPr algn="ctr"/>
-            <a:r>
-              <a:rPr sz="1600" b="1">
-                <a:solidFill>
-                  <a:srgbClr val="2563EB"/>
-                </a:solidFill>
-                <a:latin typeface="맑은 고딕"/>
-                <a:ea typeface="맑은 고딕"/>
-                <a:cs typeface="맑은 고딕"/>
-              </a:rPr>
-              <a:t>anime-project-infra</a:t>
-            </a:r>
-          </a:p>
-          <a:p>
-            <a:pPr>
-              <a:spcBef>
-                <a:spcPts val="800"/>
-              </a:spcBef>
-            </a:pPr>
-            <a:r>
-              <a:rPr sz="1300" b="0">
-                <a:solidFill>
-                  <a:srgbClr val="0F172A"/>
-                </a:solidFill>
-                <a:latin typeface="맑은 고딕"/>
-                <a:ea typeface="맑은 고딕"/>
-                <a:cs typeface="맑은 고딕"/>
-              </a:rPr>
-              <a:t>• trigger: main push / workflow_dispatch</a:t>
-            </a:r>
-          </a:p>
-          <a:p>
-            <a:pPr>
-              <a:spcBef>
-                <a:spcPts val="800"/>
-              </a:spcBef>
-            </a:pPr>
-            <a:r>
-              <a:rPr sz="1300" b="0">
-                <a:solidFill>
-                  <a:srgbClr val="0F172A"/>
-                </a:solidFill>
-                <a:latin typeface="맑은 고딕"/>
-                <a:ea typeface="맑은 고딕"/>
-                <a:cs typeface="맑은 고딕"/>
-              </a:rPr>
-              <a:t>• steps: checkout → setup TF → fmt</a:t>
-            </a:r>
-          </a:p>
-          <a:p>
-            <a:pPr>
-              <a:spcBef>
-                <a:spcPts val="800"/>
-              </a:spcBef>
-            </a:pPr>
-            <a:r>
-              <a:rPr sz="1300" b="0">
-                <a:solidFill>
-                  <a:srgbClr val="0F172A"/>
-                </a:solidFill>
-                <a:latin typeface="맑은 고딕"/>
-                <a:ea typeface="맑은 고딕"/>
-                <a:cs typeface="맑은 고딕"/>
-              </a:rPr>
-              <a:t>•         validate → plan → apply</a:t>
-            </a:r>
-          </a:p>
-          <a:p>
-            <a:pPr>
-              <a:spcBef>
-                <a:spcPts val="800"/>
-              </a:spcBef>
-            </a:pPr>
-            <a:r>
-              <a:rPr sz="1300" b="0">
-                <a:solidFill>
-                  <a:srgbClr val="0F172A"/>
-                </a:solidFill>
-                <a:latin typeface="맑은 고딕"/>
-                <a:ea typeface="맑은 고딕"/>
-                <a:cs typeface="맑은 고딕"/>
-              </a:rPr>
-              <a:t>• 결과: VPC/ALB/ASG/RDS/S3/WAF 갱신</a:t>
-            </a:r>
-          </a:p>
-          <a:p>
-            <a:pPr>
-              <a:spcBef>
-                <a:spcPts val="800"/>
-              </a:spcBef>
-            </a:pPr>
-            <a:r>
-              <a:rPr sz="1300" b="0">
-                <a:solidFill>
-                  <a:srgbClr val="0F172A"/>
-                </a:solidFill>
-                <a:latin typeface="맑은 고딕"/>
-                <a:ea typeface="맑은 고딕"/>
-                <a:cs typeface="맑은 고딕"/>
-              </a:rPr>
-              <a:t>• Secrets: AWS 자격증명, TF_VAR_*</a:t>
-            </a:r>
-          </a:p>
-        </p:txBody>
-      </p:sp>
-      <p:sp>
-        <p:nvSpPr>
-          <p:cNvPr id="5" name="Rounded Rectangle 4"/>
-          <p:cNvSpPr/>
-          <p:nvPr/>
-        </p:nvSpPr>
-        <p:spPr>
-          <a:xfrm>
-            <a:off x="6309360" y="1097280"/>
-            <a:ext cx="5394960" cy="4846320"/>
-          </a:xfrm>
-          <a:prstGeom prst="roundRect">
-            <a:avLst/>
-          </a:prstGeom>
-          <a:solidFill>
-            <a:srgbClr val="FFF7ED"/>
-          </a:solidFill>
-          <a:ln w="19050">
-            <a:solidFill>
-              <a:srgbClr val="EA580C"/>
-            </a:solidFill>
-          </a:ln>
-        </p:spPr>
-        <p:style>
-          <a:lnRef idx="1">
-            <a:schemeClr val="accent1"/>
-          </a:lnRef>
-          <a:fillRef idx="3">
-            <a:schemeClr val="accent1"/>
-          </a:fillRef>
-          <a:effectRef idx="2">
-            <a:schemeClr val="accent1"/>
-          </a:effectRef>
-          <a:fontRef idx="minor">
-            <a:schemeClr val="lt1"/>
-          </a:fontRef>
-        </p:style>
-        <p:txBody>
-          <a:bodyPr rtlCol="0" anchor="ctr" wrap="square"/>
-          <a:lstStyle/>
-          <a:p>
-            <a:pPr algn="ctr"/>
-            <a:r>
-              <a:rPr sz="1600" b="1">
-                <a:solidFill>
-                  <a:srgbClr val="EA580C"/>
-                </a:solidFill>
-                <a:latin typeface="맑은 고딕"/>
-                <a:ea typeface="맑은 고딕"/>
-                <a:cs typeface="맑은 고딕"/>
-              </a:rPr>
-              <a:t>anime-project</a:t>
-            </a:r>
-          </a:p>
-          <a:p>
-            <a:pPr>
-              <a:spcBef>
-                <a:spcPts val="800"/>
-              </a:spcBef>
-            </a:pPr>
-            <a:r>
-              <a:rPr sz="1300" b="0">
-                <a:solidFill>
-                  <a:srgbClr val="0F172A"/>
-                </a:solidFill>
-                <a:latin typeface="맑은 고딕"/>
-                <a:ea typeface="맑은 고딕"/>
-                <a:cs typeface="맑은 고딕"/>
-              </a:rPr>
-              <a:t>• trigger: main push / workflow_dispatch</a:t>
-            </a:r>
-          </a:p>
-          <a:p>
-            <a:pPr>
-              <a:spcBef>
-                <a:spcPts val="800"/>
-              </a:spcBef>
-            </a:pPr>
-            <a:r>
-              <a:rPr sz="1300" b="0">
-                <a:solidFill>
-                  <a:srgbClr val="0F172A"/>
-                </a:solidFill>
-                <a:latin typeface="맑은 고딕"/>
-                <a:ea typeface="맑은 고딕"/>
-                <a:cs typeface="맑은 고딕"/>
-              </a:rPr>
-              <a:t>• steps: media → S3 sync</a:t>
-            </a:r>
-          </a:p>
-          <a:p>
-            <a:pPr>
-              <a:spcBef>
-                <a:spcPts val="800"/>
-              </a:spcBef>
-            </a:pPr>
-            <a:r>
-              <a:rPr sz="1300" b="0">
-                <a:solidFill>
-                  <a:srgbClr val="0F172A"/>
-                </a:solidFill>
-                <a:latin typeface="맑은 고딕"/>
-                <a:ea typeface="맑은 고딕"/>
-                <a:cs typeface="맑은 고딕"/>
-              </a:rPr>
-              <a:t>•         앱 zip 패키징 → deploy S3</a:t>
-            </a:r>
-          </a:p>
-          <a:p>
-            <a:pPr>
-              <a:spcBef>
-                <a:spcPts val="800"/>
-              </a:spcBef>
-            </a:pPr>
-            <a:r>
-              <a:rPr sz="1300" b="0">
-                <a:solidFill>
-                  <a:srgbClr val="0F172A"/>
-                </a:solidFill>
-                <a:latin typeface="맑은 고딕"/>
-                <a:ea typeface="맑은 고딕"/>
-                <a:cs typeface="맑은 고딕"/>
-              </a:rPr>
-              <a:t>•         CodeDeploy → ASG 배포</a:t>
-            </a:r>
-          </a:p>
-          <a:p>
-            <a:pPr>
-              <a:spcBef>
-                <a:spcPts val="800"/>
-              </a:spcBef>
-            </a:pPr>
-            <a:r>
-              <a:rPr sz="1300" b="0">
-                <a:solidFill>
-                  <a:srgbClr val="0F172A"/>
-                </a:solidFill>
-                <a:latin typeface="맑은 고딕"/>
-                <a:ea typeface="맑은 고딕"/>
-                <a:cs typeface="맑은 고딕"/>
-              </a:rPr>
-              <a:t>• hooks: install → migrate → Daphne 기동</a:t>
-            </a:r>
-          </a:p>
-        </p:txBody>
-      </p:sp>
-      <p:sp>
-        <p:nvSpPr>
-          <p:cNvPr id="6" name="TextBox 5"/>
+        </p:spPr>
+      </p:pic>
+      <p:sp>
+        <p:nvSpPr>
+          <p:cNvPr id="5" name="TextBox 4"/>
           <p:cNvSpPr txBox="1"/>
           <p:nvPr/>
         </p:nvSpPr>
@@ -3674,7 +3407,7 @@
                 <a:ea typeface="맑은 고딕"/>
                 <a:cs typeface="맑은 고딕"/>
               </a:rPr>
-              <a:t>Aniverse · 온프레미스 3-tier → AWS   |   10/14</a:t>
+              <a:t>Aniverse · 온프레미스 3-tier → AWS   |   10/15</a:t>
             </a:r>
           </a:p>
         </p:txBody>
@@ -3771,7 +3504,7 @@
                 <a:ea typeface="맑은 고딕"/>
                 <a:cs typeface="맑은 고딕"/>
               </a:rPr>
-              <a:t>5. CI/CD · HA · 모니터링 · 보안</a:t>
+              <a:t>4. GitHub Actions (2)</a:t>
             </a:r>
           </a:p>
           <a:p>
@@ -3789,38 +3522,306 @@
                 <a:ea typeface="맑은 고딕"/>
                 <a:cs typeface="맑은 고딕"/>
               </a:rPr>
-              <a:t>배포·가용성·관측·보안을 한 장으로</a:t>
-            </a:r>
-          </a:p>
-        </p:txBody>
-      </p:sp>
-      <p:pic>
-        <p:nvPicPr>
-          <p:cNvPr id="4" name="Picture 3" descr="05_ops_security.png"/>
-          <p:cNvPicPr>
-            <a:picLocks noChangeAspect="1"/>
-          </p:cNvPicPr>
+              <a:t>실제로 돌아가는 파이프라인</a:t>
+            </a:r>
+          </a:p>
+        </p:txBody>
+      </p:sp>
+      <p:sp>
+        <p:nvSpPr>
+          <p:cNvPr id="4" name="Rounded Rectangle 3"/>
+          <p:cNvSpPr/>
           <p:nvPr/>
-        </p:nvPicPr>
-        <p:blipFill>
-          <a:blip r:embed="rId2"/>
-          <a:stretch>
-            <a:fillRect/>
-          </a:stretch>
-        </p:blipFill>
-        <p:spPr>
-          <a:xfrm>
-            <a:off x="411480" y="1051560"/>
-            <a:ext cx="11338560" cy="4960620"/>
-          </a:xfrm>
-          <a:prstGeom prst="rect">
+        </p:nvSpPr>
+        <p:spPr>
+          <a:xfrm>
+            <a:off x="365760" y="1097280"/>
+            <a:ext cx="5669280" cy="4846320"/>
+          </a:xfrm>
+          <a:prstGeom prst="roundRect">
             <a:avLst/>
           </a:prstGeom>
-        </p:spPr>
-      </p:pic>
-      <p:sp>
-        <p:nvSpPr>
-          <p:cNvPr id="5" name="TextBox 4"/>
+          <a:solidFill>
+            <a:srgbClr val="EFF6FF"/>
+          </a:solidFill>
+          <a:ln w="19050">
+            <a:solidFill>
+              <a:srgbClr val="2563EB"/>
+            </a:solidFill>
+          </a:ln>
+        </p:spPr>
+        <p:style>
+          <a:lnRef idx="1">
+            <a:schemeClr val="accent1"/>
+          </a:lnRef>
+          <a:fillRef idx="3">
+            <a:schemeClr val="accent1"/>
+          </a:fillRef>
+          <a:effectRef idx="2">
+            <a:schemeClr val="accent1"/>
+          </a:effectRef>
+          <a:fontRef idx="minor">
+            <a:schemeClr val="lt1"/>
+          </a:fontRef>
+        </p:style>
+        <p:txBody>
+          <a:bodyPr rtlCol="0" anchor="ctr" wrap="square"/>
+          <a:lstStyle/>
+          <a:p>
+            <a:pPr algn="ctr"/>
+            <a:r>
+              <a:rPr sz="1600" b="1">
+                <a:solidFill>
+                  <a:srgbClr val="2563EB"/>
+                </a:solidFill>
+                <a:latin typeface="맑은 고딕"/>
+                <a:ea typeface="맑은 고딕"/>
+                <a:cs typeface="맑은 고딕"/>
+              </a:rPr>
+              <a:t>anime-project-infra</a:t>
+            </a:r>
+          </a:p>
+          <a:p>
+            <a:pPr>
+              <a:spcBef>
+                <a:spcPts val="800"/>
+              </a:spcBef>
+            </a:pPr>
+            <a:r>
+              <a:rPr sz="1300" b="0">
+                <a:solidFill>
+                  <a:srgbClr val="0F172A"/>
+                </a:solidFill>
+                <a:latin typeface="맑은 고딕"/>
+                <a:ea typeface="맑은 고딕"/>
+                <a:cs typeface="맑은 고딕"/>
+              </a:rPr>
+              <a:t>• trigger: main push / workflow_dispatch</a:t>
+            </a:r>
+          </a:p>
+          <a:p>
+            <a:pPr>
+              <a:spcBef>
+                <a:spcPts val="800"/>
+              </a:spcBef>
+            </a:pPr>
+            <a:r>
+              <a:rPr sz="1300" b="0">
+                <a:solidFill>
+                  <a:srgbClr val="0F172A"/>
+                </a:solidFill>
+                <a:latin typeface="맑은 고딕"/>
+                <a:ea typeface="맑은 고딕"/>
+                <a:cs typeface="맑은 고딕"/>
+              </a:rPr>
+              <a:t>• steps: checkout → setup TF → fmt</a:t>
+            </a:r>
+          </a:p>
+          <a:p>
+            <a:pPr>
+              <a:spcBef>
+                <a:spcPts val="800"/>
+              </a:spcBef>
+            </a:pPr>
+            <a:r>
+              <a:rPr sz="1300" b="0">
+                <a:solidFill>
+                  <a:srgbClr val="0F172A"/>
+                </a:solidFill>
+                <a:latin typeface="맑은 고딕"/>
+                <a:ea typeface="맑은 고딕"/>
+                <a:cs typeface="맑은 고딕"/>
+              </a:rPr>
+              <a:t>•         validate → plan → apply</a:t>
+            </a:r>
+          </a:p>
+          <a:p>
+            <a:pPr>
+              <a:spcBef>
+                <a:spcPts val="800"/>
+              </a:spcBef>
+            </a:pPr>
+            <a:r>
+              <a:rPr sz="1300" b="0">
+                <a:solidFill>
+                  <a:srgbClr val="0F172A"/>
+                </a:solidFill>
+                <a:latin typeface="맑은 고딕"/>
+                <a:ea typeface="맑은 고딕"/>
+                <a:cs typeface="맑은 고딕"/>
+              </a:rPr>
+              <a:t>• 결과: VPC/ALB/ASG/RDS/S3/WAF 갱신</a:t>
+            </a:r>
+          </a:p>
+          <a:p>
+            <a:pPr>
+              <a:spcBef>
+                <a:spcPts val="800"/>
+              </a:spcBef>
+            </a:pPr>
+            <a:r>
+              <a:rPr sz="1300" b="0">
+                <a:solidFill>
+                  <a:srgbClr val="0F172A"/>
+                </a:solidFill>
+                <a:latin typeface="맑은 고딕"/>
+                <a:ea typeface="맑은 고딕"/>
+                <a:cs typeface="맑은 고딕"/>
+              </a:rPr>
+              <a:t>• Secrets: AWS 자격증명, TF_VAR_*</a:t>
+            </a:r>
+          </a:p>
+        </p:txBody>
+      </p:sp>
+      <p:sp>
+        <p:nvSpPr>
+          <p:cNvPr id="5" name="Rounded Rectangle 4"/>
+          <p:cNvSpPr/>
+          <p:nvPr/>
+        </p:nvSpPr>
+        <p:spPr>
+          <a:xfrm>
+            <a:off x="6309360" y="1097280"/>
+            <a:ext cx="5394960" cy="4846320"/>
+          </a:xfrm>
+          <a:prstGeom prst="roundRect">
+            <a:avLst/>
+          </a:prstGeom>
+          <a:solidFill>
+            <a:srgbClr val="FFF7ED"/>
+          </a:solidFill>
+          <a:ln w="19050">
+            <a:solidFill>
+              <a:srgbClr val="EA580C"/>
+            </a:solidFill>
+          </a:ln>
+        </p:spPr>
+        <p:style>
+          <a:lnRef idx="1">
+            <a:schemeClr val="accent1"/>
+          </a:lnRef>
+          <a:fillRef idx="3">
+            <a:schemeClr val="accent1"/>
+          </a:fillRef>
+          <a:effectRef idx="2">
+            <a:schemeClr val="accent1"/>
+          </a:effectRef>
+          <a:fontRef idx="minor">
+            <a:schemeClr val="lt1"/>
+          </a:fontRef>
+        </p:style>
+        <p:txBody>
+          <a:bodyPr rtlCol="0" anchor="ctr" wrap="square"/>
+          <a:lstStyle/>
+          <a:p>
+            <a:pPr algn="ctr"/>
+            <a:r>
+              <a:rPr sz="1600" b="1">
+                <a:solidFill>
+                  <a:srgbClr val="EA580C"/>
+                </a:solidFill>
+                <a:latin typeface="맑은 고딕"/>
+                <a:ea typeface="맑은 고딕"/>
+                <a:cs typeface="맑은 고딕"/>
+              </a:rPr>
+              <a:t>anime-project</a:t>
+            </a:r>
+          </a:p>
+          <a:p>
+            <a:pPr>
+              <a:spcBef>
+                <a:spcPts val="800"/>
+              </a:spcBef>
+            </a:pPr>
+            <a:r>
+              <a:rPr sz="1300" b="0">
+                <a:solidFill>
+                  <a:srgbClr val="0F172A"/>
+                </a:solidFill>
+                <a:latin typeface="맑은 고딕"/>
+                <a:ea typeface="맑은 고딕"/>
+                <a:cs typeface="맑은 고딕"/>
+              </a:rPr>
+              <a:t>• trigger: main push / workflow_dispatch</a:t>
+            </a:r>
+          </a:p>
+          <a:p>
+            <a:pPr>
+              <a:spcBef>
+                <a:spcPts val="800"/>
+              </a:spcBef>
+            </a:pPr>
+            <a:r>
+              <a:rPr sz="1300" b="0">
+                <a:solidFill>
+                  <a:srgbClr val="0F172A"/>
+                </a:solidFill>
+                <a:latin typeface="맑은 고딕"/>
+                <a:ea typeface="맑은 고딕"/>
+                <a:cs typeface="맑은 고딕"/>
+              </a:rPr>
+              <a:t>• steps: media → S3 sync</a:t>
+            </a:r>
+          </a:p>
+          <a:p>
+            <a:pPr>
+              <a:spcBef>
+                <a:spcPts val="800"/>
+              </a:spcBef>
+            </a:pPr>
+            <a:r>
+              <a:rPr sz="1300" b="0">
+                <a:solidFill>
+                  <a:srgbClr val="0F172A"/>
+                </a:solidFill>
+                <a:latin typeface="맑은 고딕"/>
+                <a:ea typeface="맑은 고딕"/>
+                <a:cs typeface="맑은 고딕"/>
+              </a:rPr>
+              <a:t>•         앱 zip 패키징 → deploy S3</a:t>
+            </a:r>
+          </a:p>
+          <a:p>
+            <a:pPr>
+              <a:spcBef>
+                <a:spcPts val="800"/>
+              </a:spcBef>
+            </a:pPr>
+            <a:r>
+              <a:rPr sz="1300" b="0">
+                <a:solidFill>
+                  <a:srgbClr val="0F172A"/>
+                </a:solidFill>
+                <a:latin typeface="맑은 고딕"/>
+                <a:ea typeface="맑은 고딕"/>
+                <a:cs typeface="맑은 고딕"/>
+              </a:rPr>
+              <a:t>•         CodeDeploy → ASG 배포</a:t>
+            </a:r>
+          </a:p>
+          <a:p>
+            <a:pPr>
+              <a:spcBef>
+                <a:spcPts val="800"/>
+              </a:spcBef>
+            </a:pPr>
+            <a:r>
+              <a:rPr sz="1300" b="0">
+                <a:solidFill>
+                  <a:srgbClr val="0F172A"/>
+                </a:solidFill>
+                <a:latin typeface="맑은 고딕"/>
+                <a:ea typeface="맑은 고딕"/>
+                <a:cs typeface="맑은 고딕"/>
+              </a:rPr>
+              <a:t>• hooks: install → migrate → Daphne 기동</a:t>
+            </a:r>
+          </a:p>
+        </p:txBody>
+      </p:sp>
+      <p:sp>
+        <p:nvSpPr>
+          <p:cNvPr id="6" name="TextBox 5"/>
           <p:cNvSpPr txBox="1"/>
           <p:nvPr/>
         </p:nvSpPr>
@@ -3850,7 +3851,7 @@
                 <a:ea typeface="맑은 고딕"/>
                 <a:cs typeface="맑은 고딕"/>
               </a:rPr>
-              <a:t>Aniverse · 온프레미스 3-tier → AWS   |   11/14</a:t>
+              <a:t>Aniverse · 온프레미스 3-tier → AWS   |   11/15</a:t>
             </a:r>
           </a:p>
         </p:txBody>
@@ -3947,7 +3948,7 @@
                 <a:ea typeface="맑은 고딕"/>
                 <a:cs typeface="맑은 고딕"/>
               </a:rPr>
-              <a:t>5. 적용 내용 상세</a:t>
+              <a:t>5. CI/CD · HA · 모니터링 · 보안</a:t>
             </a:r>
           </a:p>
           <a:p>
@@ -3965,454 +3966,38 @@
                 <a:ea typeface="맑은 고딕"/>
                 <a:cs typeface="맑은 고딕"/>
               </a:rPr>
-              <a:t>서비스가 실제로 어떻게 버티는지</a:t>
-            </a:r>
-          </a:p>
-        </p:txBody>
-      </p:sp>
-      <p:sp>
-        <p:nvSpPr>
-          <p:cNvPr id="4" name="Rounded Rectangle 3"/>
-          <p:cNvSpPr/>
+              <a:t>배포·가용성·관측·보안을 한 장으로</a:t>
+            </a:r>
+          </a:p>
+        </p:txBody>
+      </p:sp>
+      <p:pic>
+        <p:nvPicPr>
+          <p:cNvPr id="4" name="Picture 3" descr="05_ops_security.png"/>
+          <p:cNvPicPr>
+            <a:picLocks noChangeAspect="1"/>
+          </p:cNvPicPr>
           <p:nvPr/>
-        </p:nvSpPr>
-        <p:spPr>
-          <a:xfrm>
-            <a:off x="274320" y="1051560"/>
-            <a:ext cx="5669280" cy="2331720"/>
-          </a:xfrm>
-          <a:prstGeom prst="roundRect">
+        </p:nvPicPr>
+        <p:blipFill>
+          <a:blip r:embed="rId2"/>
+          <a:stretch>
+            <a:fillRect/>
+          </a:stretch>
+        </p:blipFill>
+        <p:spPr>
+          <a:xfrm>
+            <a:off x="411480" y="1051560"/>
+            <a:ext cx="11338560" cy="4960620"/>
+          </a:xfrm>
+          <a:prstGeom prst="rect">
             <a:avLst/>
           </a:prstGeom>
-          <a:solidFill>
-            <a:srgbClr val="F8FAFC"/>
-          </a:solidFill>
-          <a:ln w="19050">
-            <a:solidFill>
-              <a:srgbClr val="2563EB"/>
-            </a:solidFill>
-          </a:ln>
-        </p:spPr>
-        <p:style>
-          <a:lnRef idx="1">
-            <a:schemeClr val="accent1"/>
-          </a:lnRef>
-          <a:fillRef idx="3">
-            <a:schemeClr val="accent1"/>
-          </a:fillRef>
-          <a:effectRef idx="2">
-            <a:schemeClr val="accent1"/>
-          </a:effectRef>
-          <a:fontRef idx="minor">
-            <a:schemeClr val="lt1"/>
-          </a:fontRef>
-        </p:style>
-        <p:txBody>
-          <a:bodyPr rtlCol="0" anchor="ctr" wrap="square"/>
-          <a:lstStyle/>
-          <a:p>
-            <a:pPr algn="ctr"/>
-            <a:r>
-              <a:rPr sz="1700" b="1">
-                <a:solidFill>
-                  <a:srgbClr val="2563EB"/>
-                </a:solidFill>
-                <a:latin typeface="맑은 고딕"/>
-                <a:ea typeface="맑은 고딕"/>
-                <a:cs typeface="맑은 고딕"/>
-              </a:rPr>
-              <a:t>CI/CD</a:t>
-            </a:r>
-          </a:p>
-          <a:p>
-            <a:pPr>
-              <a:spcBef>
-                <a:spcPts val="700"/>
-              </a:spcBef>
-            </a:pPr>
-            <a:r>
-              <a:rPr sz="1300" b="0">
-                <a:solidFill>
-                  <a:srgbClr val="0F172A"/>
-                </a:solidFill>
-                <a:latin typeface="맑은 고딕"/>
-                <a:ea typeface="맑은 고딕"/>
-                <a:cs typeface="맑은 고딕"/>
-              </a:rPr>
-              <a:t>• Actions + CodeDeploy로 배포 경로 고정</a:t>
-            </a:r>
-          </a:p>
-          <a:p>
-            <a:pPr>
-              <a:spcBef>
-                <a:spcPts val="700"/>
-              </a:spcBef>
-            </a:pPr>
-            <a:r>
-              <a:rPr sz="1300" b="0">
-                <a:solidFill>
-                  <a:srgbClr val="0F172A"/>
-                </a:solidFill>
-                <a:latin typeface="맑은 고딕"/>
-                <a:ea typeface="맑은 고딕"/>
-                <a:cs typeface="맑은 고딕"/>
-              </a:rPr>
-              <a:t>• ALB /health/ 로 배포 성공 판정</a:t>
-            </a:r>
-          </a:p>
-          <a:p>
-            <a:pPr>
-              <a:spcBef>
-                <a:spcPts val="700"/>
-              </a:spcBef>
-            </a:pPr>
-            <a:r>
-              <a:rPr sz="1300" b="0">
-                <a:solidFill>
-                  <a:srgbClr val="0F172A"/>
-                </a:solidFill>
-                <a:latin typeface="맑은 고딕"/>
-                <a:ea typeface="맑은 고딕"/>
-                <a:cs typeface="맑은 고딕"/>
-              </a:rPr>
-              <a:t>• 실패 시 Actions·배포 로그로 추적</a:t>
-            </a:r>
-          </a:p>
-        </p:txBody>
-      </p:sp>
-      <p:sp>
-        <p:nvSpPr>
-          <p:cNvPr id="5" name="Rounded Rectangle 4"/>
-          <p:cNvSpPr/>
-          <p:nvPr/>
-        </p:nvSpPr>
-        <p:spPr>
-          <a:xfrm>
-            <a:off x="6172200" y="1051560"/>
-            <a:ext cx="5669280" cy="2331720"/>
-          </a:xfrm>
-          <a:prstGeom prst="roundRect">
-            <a:avLst/>
-          </a:prstGeom>
-          <a:solidFill>
-            <a:srgbClr val="F8FAFC"/>
-          </a:solidFill>
-          <a:ln w="19050">
-            <a:solidFill>
-              <a:srgbClr val="EA580C"/>
-            </a:solidFill>
-          </a:ln>
-        </p:spPr>
-        <p:style>
-          <a:lnRef idx="1">
-            <a:schemeClr val="accent1"/>
-          </a:lnRef>
-          <a:fillRef idx="3">
-            <a:schemeClr val="accent1"/>
-          </a:fillRef>
-          <a:effectRef idx="2">
-            <a:schemeClr val="accent1"/>
-          </a:effectRef>
-          <a:fontRef idx="minor">
-            <a:schemeClr val="lt1"/>
-          </a:fontRef>
-        </p:style>
-        <p:txBody>
-          <a:bodyPr rtlCol="0" anchor="ctr" wrap="square"/>
-          <a:lstStyle/>
-          <a:p>
-            <a:pPr algn="ctr"/>
-            <a:r>
-              <a:rPr sz="1700" b="1">
-                <a:solidFill>
-                  <a:srgbClr val="EA580C"/>
-                </a:solidFill>
-                <a:latin typeface="맑은 고딕"/>
-                <a:ea typeface="맑은 고딕"/>
-                <a:cs typeface="맑은 고딕"/>
-              </a:rPr>
-              <a:t>고가용성</a:t>
-            </a:r>
-          </a:p>
-          <a:p>
-            <a:pPr>
-              <a:spcBef>
-                <a:spcPts val="700"/>
-              </a:spcBef>
-            </a:pPr>
-            <a:r>
-              <a:rPr sz="1300" b="0">
-                <a:solidFill>
-                  <a:srgbClr val="0F172A"/>
-                </a:solidFill>
-                <a:latin typeface="맑은 고딕"/>
-                <a:ea typeface="맑은 고딕"/>
-                <a:cs typeface="맑은 고딕"/>
-              </a:rPr>
-              <a:t>• ALB로 트래픽 분산</a:t>
-            </a:r>
-          </a:p>
-          <a:p>
-            <a:pPr>
-              <a:spcBef>
-                <a:spcPts val="700"/>
-              </a:spcBef>
-            </a:pPr>
-            <a:r>
-              <a:rPr sz="1300" b="0">
-                <a:solidFill>
-                  <a:srgbClr val="0F172A"/>
-                </a:solidFill>
-                <a:latin typeface="맑은 고딕"/>
-                <a:ea typeface="맑은 고딕"/>
-                <a:cs typeface="맑은 고딕"/>
-              </a:rPr>
-              <a:t>• ASG로 인스턴스 교체·확장</a:t>
-            </a:r>
-          </a:p>
-          <a:p>
-            <a:pPr>
-              <a:spcBef>
-                <a:spcPts val="700"/>
-              </a:spcBef>
-            </a:pPr>
-            <a:r>
-              <a:rPr sz="1300" b="0">
-                <a:solidFill>
-                  <a:srgbClr val="0F172A"/>
-                </a:solidFill>
-                <a:latin typeface="맑은 고딕"/>
-                <a:ea typeface="맑은 고딕"/>
-                <a:cs typeface="맑은 고딕"/>
-              </a:rPr>
-              <a:t>• App/DB 서브넷 분리 배치</a:t>
-            </a:r>
-          </a:p>
-        </p:txBody>
-      </p:sp>
-      <p:sp>
-        <p:nvSpPr>
-          <p:cNvPr id="6" name="Rounded Rectangle 5"/>
-          <p:cNvSpPr/>
-          <p:nvPr/>
-        </p:nvSpPr>
-        <p:spPr>
-          <a:xfrm>
-            <a:off x="274320" y="3566160"/>
-            <a:ext cx="5669280" cy="2331720"/>
-          </a:xfrm>
-          <a:prstGeom prst="roundRect">
-            <a:avLst/>
-          </a:prstGeom>
-          <a:solidFill>
-            <a:srgbClr val="F8FAFC"/>
-          </a:solidFill>
-          <a:ln w="19050">
-            <a:solidFill>
-              <a:srgbClr val="0D9488"/>
-            </a:solidFill>
-          </a:ln>
-        </p:spPr>
-        <p:style>
-          <a:lnRef idx="1">
-            <a:schemeClr val="accent1"/>
-          </a:lnRef>
-          <a:fillRef idx="3">
-            <a:schemeClr val="accent1"/>
-          </a:fillRef>
-          <a:effectRef idx="2">
-            <a:schemeClr val="accent1"/>
-          </a:effectRef>
-          <a:fontRef idx="minor">
-            <a:schemeClr val="lt1"/>
-          </a:fontRef>
-        </p:style>
-        <p:txBody>
-          <a:bodyPr rtlCol="0" anchor="ctr" wrap="square"/>
-          <a:lstStyle/>
-          <a:p>
-            <a:pPr algn="ctr"/>
-            <a:r>
-              <a:rPr sz="1700" b="1">
-                <a:solidFill>
-                  <a:srgbClr val="0D9488"/>
-                </a:solidFill>
-                <a:latin typeface="맑은 고딕"/>
-                <a:ea typeface="맑은 고딕"/>
-                <a:cs typeface="맑은 고딕"/>
-              </a:rPr>
-              <a:t>모니터링</a:t>
-            </a:r>
-          </a:p>
-          <a:p>
-            <a:pPr>
-              <a:spcBef>
-                <a:spcPts val="700"/>
-              </a:spcBef>
-            </a:pPr>
-            <a:r>
-              <a:rPr sz="1300" b="0">
-                <a:solidFill>
-                  <a:srgbClr val="0F172A"/>
-                </a:solidFill>
-                <a:latin typeface="맑은 고딕"/>
-                <a:ea typeface="맑은 고딕"/>
-                <a:cs typeface="맑은 고딕"/>
-              </a:rPr>
-              <a:t>• CloudWatch 알람</a:t>
-            </a:r>
-          </a:p>
-          <a:p>
-            <a:pPr>
-              <a:spcBef>
-                <a:spcPts val="700"/>
-              </a:spcBef>
-            </a:pPr>
-            <a:r>
-              <a:rPr sz="1300" b="0">
-                <a:solidFill>
-                  <a:srgbClr val="0F172A"/>
-                </a:solidFill>
-                <a:latin typeface="맑은 고딕"/>
-                <a:ea typeface="맑은 고딕"/>
-                <a:cs typeface="맑은 고딕"/>
-              </a:rPr>
-              <a:t>• Target Group health 확인</a:t>
-            </a:r>
-          </a:p>
-          <a:p>
-            <a:pPr>
-              <a:spcBef>
-                <a:spcPts val="700"/>
-              </a:spcBef>
-            </a:pPr>
-            <a:r>
-              <a:rPr sz="1300" b="0">
-                <a:solidFill>
-                  <a:srgbClr val="0F172A"/>
-                </a:solidFill>
-                <a:latin typeface="맑은 고딕"/>
-                <a:ea typeface="맑은 고딕"/>
-                <a:cs typeface="맑은 고딕"/>
-              </a:rPr>
-              <a:t>• SSM으로 서버 점검</a:t>
-            </a:r>
-          </a:p>
-        </p:txBody>
-      </p:sp>
-      <p:sp>
-        <p:nvSpPr>
-          <p:cNvPr id="7" name="Rounded Rectangle 6"/>
-          <p:cNvSpPr/>
-          <p:nvPr/>
-        </p:nvSpPr>
-        <p:spPr>
-          <a:xfrm>
-            <a:off x="6172200" y="3566160"/>
-            <a:ext cx="5669280" cy="2331720"/>
-          </a:xfrm>
-          <a:prstGeom prst="roundRect">
-            <a:avLst/>
-          </a:prstGeom>
-          <a:solidFill>
-            <a:srgbClr val="F8FAFC"/>
-          </a:solidFill>
-          <a:ln w="19050">
-            <a:solidFill>
-              <a:srgbClr val="DC2626"/>
-            </a:solidFill>
-          </a:ln>
-        </p:spPr>
-        <p:style>
-          <a:lnRef idx="1">
-            <a:schemeClr val="accent1"/>
-          </a:lnRef>
-          <a:fillRef idx="3">
-            <a:schemeClr val="accent1"/>
-          </a:fillRef>
-          <a:effectRef idx="2">
-            <a:schemeClr val="accent1"/>
-          </a:effectRef>
-          <a:fontRef idx="minor">
-            <a:schemeClr val="lt1"/>
-          </a:fontRef>
-        </p:style>
-        <p:txBody>
-          <a:bodyPr rtlCol="0" anchor="ctr" wrap="square"/>
-          <a:lstStyle/>
-          <a:p>
-            <a:pPr algn="ctr"/>
-            <a:r>
-              <a:rPr sz="1700" b="1">
-                <a:solidFill>
-                  <a:srgbClr val="DC2626"/>
-                </a:solidFill>
-                <a:latin typeface="맑은 고딕"/>
-                <a:ea typeface="맑은 고딕"/>
-                <a:cs typeface="맑은 고딕"/>
-              </a:rPr>
-              <a:t>보안</a:t>
-            </a:r>
-          </a:p>
-          <a:p>
-            <a:pPr>
-              <a:spcBef>
-                <a:spcPts val="700"/>
-              </a:spcBef>
-            </a:pPr>
-            <a:r>
-              <a:rPr sz="1300" b="0">
-                <a:solidFill>
-                  <a:srgbClr val="0F172A"/>
-                </a:solidFill>
-                <a:latin typeface="맑은 고딕"/>
-                <a:ea typeface="맑은 고딕"/>
-                <a:cs typeface="맑은 고딕"/>
-              </a:rPr>
-              <a:t>• SG 최소 포트 개방</a:t>
-            </a:r>
-          </a:p>
-          <a:p>
-            <a:pPr>
-              <a:spcBef>
-                <a:spcPts val="700"/>
-              </a:spcBef>
-            </a:pPr>
-            <a:r>
-              <a:rPr sz="1300" b="0">
-                <a:solidFill>
-                  <a:srgbClr val="0F172A"/>
-                </a:solidFill>
-                <a:latin typeface="맑은 고딕"/>
-                <a:ea typeface="맑은 고딕"/>
-                <a:cs typeface="맑은 고딕"/>
-              </a:rPr>
-              <a:t>• Secrets Manager로 키 주입</a:t>
-            </a:r>
-          </a:p>
-          <a:p>
-            <a:pPr>
-              <a:spcBef>
-                <a:spcPts val="700"/>
-              </a:spcBef>
-            </a:pPr>
-            <a:r>
-              <a:rPr sz="1300" b="0">
-                <a:solidFill>
-                  <a:srgbClr val="0F172A"/>
-                </a:solidFill>
-                <a:latin typeface="맑은 고딕"/>
-                <a:ea typeface="맑은 고딕"/>
-                <a:cs typeface="맑은 고딕"/>
-              </a:rPr>
-              <a:t>• ACM HTTPS + WAF(SQLi/Rate)</a:t>
-            </a:r>
-          </a:p>
-        </p:txBody>
-      </p:sp>
-      <p:sp>
-        <p:nvSpPr>
-          <p:cNvPr id="8" name="TextBox 7"/>
+        </p:spPr>
+      </p:pic>
+      <p:sp>
+        <p:nvSpPr>
+          <p:cNvPr id="5" name="TextBox 4"/>
           <p:cNvSpPr txBox="1"/>
           <p:nvPr/>
         </p:nvSpPr>
@@ -4442,7 +4027,7 @@
                 <a:ea typeface="맑은 고딕"/>
                 <a:cs typeface="맑은 고딕"/>
               </a:rPr>
-              <a:t>Aniverse · 온프레미스 3-tier → AWS   |   12/14</a:t>
+              <a:t>Aniverse · 온프레미스 3-tier → AWS   |   12/15</a:t>
             </a:r>
           </a:p>
         </p:txBody>
@@ -4539,7 +4124,7 @@
                 <a:ea typeface="맑은 고딕"/>
                 <a:cs typeface="맑은 고딕"/>
               </a:rPr>
-              <a:t>6. HTTPS · WAF (1)</a:t>
+              <a:t>5. 적용 내용 상세</a:t>
             </a:r>
           </a:p>
           <a:p>
@@ -4557,38 +4142,454 @@
                 <a:ea typeface="맑은 고딕"/>
                 <a:cs typeface="맑은 고딕"/>
               </a:rPr>
-              <a:t>도메인부터 ALB까지 암호화·필터링 경로</a:t>
-            </a:r>
-          </a:p>
-        </p:txBody>
-      </p:sp>
-      <p:pic>
-        <p:nvPicPr>
-          <p:cNvPr id="4" name="Picture 3" descr="06_https_waf.png"/>
-          <p:cNvPicPr>
-            <a:picLocks noChangeAspect="1"/>
-          </p:cNvPicPr>
+              <a:t>서비스가 실제로 어떻게 버티는지</a:t>
+            </a:r>
+          </a:p>
+        </p:txBody>
+      </p:sp>
+      <p:sp>
+        <p:nvSpPr>
+          <p:cNvPr id="4" name="Rounded Rectangle 3"/>
+          <p:cNvSpPr/>
           <p:nvPr/>
-        </p:nvPicPr>
-        <p:blipFill>
-          <a:blip r:embed="rId2"/>
-          <a:stretch>
-            <a:fillRect/>
-          </a:stretch>
-        </p:blipFill>
-        <p:spPr>
-          <a:xfrm>
-            <a:off x="320040" y="914400"/>
-            <a:ext cx="11521440" cy="6480810"/>
-          </a:xfrm>
-          <a:prstGeom prst="rect">
+        </p:nvSpPr>
+        <p:spPr>
+          <a:xfrm>
+            <a:off x="274320" y="1051560"/>
+            <a:ext cx="5669280" cy="2331720"/>
+          </a:xfrm>
+          <a:prstGeom prst="roundRect">
             <a:avLst/>
           </a:prstGeom>
-        </p:spPr>
-      </p:pic>
-      <p:sp>
-        <p:nvSpPr>
-          <p:cNvPr id="5" name="TextBox 4"/>
+          <a:solidFill>
+            <a:srgbClr val="F8FAFC"/>
+          </a:solidFill>
+          <a:ln w="19050">
+            <a:solidFill>
+              <a:srgbClr val="2563EB"/>
+            </a:solidFill>
+          </a:ln>
+        </p:spPr>
+        <p:style>
+          <a:lnRef idx="1">
+            <a:schemeClr val="accent1"/>
+          </a:lnRef>
+          <a:fillRef idx="3">
+            <a:schemeClr val="accent1"/>
+          </a:fillRef>
+          <a:effectRef idx="2">
+            <a:schemeClr val="accent1"/>
+          </a:effectRef>
+          <a:fontRef idx="minor">
+            <a:schemeClr val="lt1"/>
+          </a:fontRef>
+        </p:style>
+        <p:txBody>
+          <a:bodyPr rtlCol="0" anchor="ctr" wrap="square"/>
+          <a:lstStyle/>
+          <a:p>
+            <a:pPr algn="ctr"/>
+            <a:r>
+              <a:rPr sz="1700" b="1">
+                <a:solidFill>
+                  <a:srgbClr val="2563EB"/>
+                </a:solidFill>
+                <a:latin typeface="맑은 고딕"/>
+                <a:ea typeface="맑은 고딕"/>
+                <a:cs typeface="맑은 고딕"/>
+              </a:rPr>
+              <a:t>CI/CD</a:t>
+            </a:r>
+          </a:p>
+          <a:p>
+            <a:pPr>
+              <a:spcBef>
+                <a:spcPts val="700"/>
+              </a:spcBef>
+            </a:pPr>
+            <a:r>
+              <a:rPr sz="1300" b="0">
+                <a:solidFill>
+                  <a:srgbClr val="0F172A"/>
+                </a:solidFill>
+                <a:latin typeface="맑은 고딕"/>
+                <a:ea typeface="맑은 고딕"/>
+                <a:cs typeface="맑은 고딕"/>
+              </a:rPr>
+              <a:t>• Actions + CodeDeploy로 배포 경로 고정</a:t>
+            </a:r>
+          </a:p>
+          <a:p>
+            <a:pPr>
+              <a:spcBef>
+                <a:spcPts val="700"/>
+              </a:spcBef>
+            </a:pPr>
+            <a:r>
+              <a:rPr sz="1300" b="0">
+                <a:solidFill>
+                  <a:srgbClr val="0F172A"/>
+                </a:solidFill>
+                <a:latin typeface="맑은 고딕"/>
+                <a:ea typeface="맑은 고딕"/>
+                <a:cs typeface="맑은 고딕"/>
+              </a:rPr>
+              <a:t>• ALB /health/ 로 배포 성공 판정</a:t>
+            </a:r>
+          </a:p>
+          <a:p>
+            <a:pPr>
+              <a:spcBef>
+                <a:spcPts val="700"/>
+              </a:spcBef>
+            </a:pPr>
+            <a:r>
+              <a:rPr sz="1300" b="0">
+                <a:solidFill>
+                  <a:srgbClr val="0F172A"/>
+                </a:solidFill>
+                <a:latin typeface="맑은 고딕"/>
+                <a:ea typeface="맑은 고딕"/>
+                <a:cs typeface="맑은 고딕"/>
+              </a:rPr>
+              <a:t>• 실패 시 Actions·배포 로그로 추적</a:t>
+            </a:r>
+          </a:p>
+        </p:txBody>
+      </p:sp>
+      <p:sp>
+        <p:nvSpPr>
+          <p:cNvPr id="5" name="Rounded Rectangle 4"/>
+          <p:cNvSpPr/>
+          <p:nvPr/>
+        </p:nvSpPr>
+        <p:spPr>
+          <a:xfrm>
+            <a:off x="6172200" y="1051560"/>
+            <a:ext cx="5669280" cy="2331720"/>
+          </a:xfrm>
+          <a:prstGeom prst="roundRect">
+            <a:avLst/>
+          </a:prstGeom>
+          <a:solidFill>
+            <a:srgbClr val="F8FAFC"/>
+          </a:solidFill>
+          <a:ln w="19050">
+            <a:solidFill>
+              <a:srgbClr val="EA580C"/>
+            </a:solidFill>
+          </a:ln>
+        </p:spPr>
+        <p:style>
+          <a:lnRef idx="1">
+            <a:schemeClr val="accent1"/>
+          </a:lnRef>
+          <a:fillRef idx="3">
+            <a:schemeClr val="accent1"/>
+          </a:fillRef>
+          <a:effectRef idx="2">
+            <a:schemeClr val="accent1"/>
+          </a:effectRef>
+          <a:fontRef idx="minor">
+            <a:schemeClr val="lt1"/>
+          </a:fontRef>
+        </p:style>
+        <p:txBody>
+          <a:bodyPr rtlCol="0" anchor="ctr" wrap="square"/>
+          <a:lstStyle/>
+          <a:p>
+            <a:pPr algn="ctr"/>
+            <a:r>
+              <a:rPr sz="1700" b="1">
+                <a:solidFill>
+                  <a:srgbClr val="EA580C"/>
+                </a:solidFill>
+                <a:latin typeface="맑은 고딕"/>
+                <a:ea typeface="맑은 고딕"/>
+                <a:cs typeface="맑은 고딕"/>
+              </a:rPr>
+              <a:t>고가용성</a:t>
+            </a:r>
+          </a:p>
+          <a:p>
+            <a:pPr>
+              <a:spcBef>
+                <a:spcPts val="700"/>
+              </a:spcBef>
+            </a:pPr>
+            <a:r>
+              <a:rPr sz="1300" b="0">
+                <a:solidFill>
+                  <a:srgbClr val="0F172A"/>
+                </a:solidFill>
+                <a:latin typeface="맑은 고딕"/>
+                <a:ea typeface="맑은 고딕"/>
+                <a:cs typeface="맑은 고딕"/>
+              </a:rPr>
+              <a:t>• ALB로 트래픽 분산</a:t>
+            </a:r>
+          </a:p>
+          <a:p>
+            <a:pPr>
+              <a:spcBef>
+                <a:spcPts val="700"/>
+              </a:spcBef>
+            </a:pPr>
+            <a:r>
+              <a:rPr sz="1300" b="0">
+                <a:solidFill>
+                  <a:srgbClr val="0F172A"/>
+                </a:solidFill>
+                <a:latin typeface="맑은 고딕"/>
+                <a:ea typeface="맑은 고딕"/>
+                <a:cs typeface="맑은 고딕"/>
+              </a:rPr>
+              <a:t>• ASG로 인스턴스 교체·확장</a:t>
+            </a:r>
+          </a:p>
+          <a:p>
+            <a:pPr>
+              <a:spcBef>
+                <a:spcPts val="700"/>
+              </a:spcBef>
+            </a:pPr>
+            <a:r>
+              <a:rPr sz="1300" b="0">
+                <a:solidFill>
+                  <a:srgbClr val="0F172A"/>
+                </a:solidFill>
+                <a:latin typeface="맑은 고딕"/>
+                <a:ea typeface="맑은 고딕"/>
+                <a:cs typeface="맑은 고딕"/>
+              </a:rPr>
+              <a:t>• App/DB 서브넷 분리 배치</a:t>
+            </a:r>
+          </a:p>
+        </p:txBody>
+      </p:sp>
+      <p:sp>
+        <p:nvSpPr>
+          <p:cNvPr id="6" name="Rounded Rectangle 5"/>
+          <p:cNvSpPr/>
+          <p:nvPr/>
+        </p:nvSpPr>
+        <p:spPr>
+          <a:xfrm>
+            <a:off x="274320" y="3566160"/>
+            <a:ext cx="5669280" cy="2331720"/>
+          </a:xfrm>
+          <a:prstGeom prst="roundRect">
+            <a:avLst/>
+          </a:prstGeom>
+          <a:solidFill>
+            <a:srgbClr val="F8FAFC"/>
+          </a:solidFill>
+          <a:ln w="19050">
+            <a:solidFill>
+              <a:srgbClr val="0D9488"/>
+            </a:solidFill>
+          </a:ln>
+        </p:spPr>
+        <p:style>
+          <a:lnRef idx="1">
+            <a:schemeClr val="accent1"/>
+          </a:lnRef>
+          <a:fillRef idx="3">
+            <a:schemeClr val="accent1"/>
+          </a:fillRef>
+          <a:effectRef idx="2">
+            <a:schemeClr val="accent1"/>
+          </a:effectRef>
+          <a:fontRef idx="minor">
+            <a:schemeClr val="lt1"/>
+          </a:fontRef>
+        </p:style>
+        <p:txBody>
+          <a:bodyPr rtlCol="0" anchor="ctr" wrap="square"/>
+          <a:lstStyle/>
+          <a:p>
+            <a:pPr algn="ctr"/>
+            <a:r>
+              <a:rPr sz="1700" b="1">
+                <a:solidFill>
+                  <a:srgbClr val="0D9488"/>
+                </a:solidFill>
+                <a:latin typeface="맑은 고딕"/>
+                <a:ea typeface="맑은 고딕"/>
+                <a:cs typeface="맑은 고딕"/>
+              </a:rPr>
+              <a:t>모니터링</a:t>
+            </a:r>
+          </a:p>
+          <a:p>
+            <a:pPr>
+              <a:spcBef>
+                <a:spcPts val="700"/>
+              </a:spcBef>
+            </a:pPr>
+            <a:r>
+              <a:rPr sz="1300" b="0">
+                <a:solidFill>
+                  <a:srgbClr val="0F172A"/>
+                </a:solidFill>
+                <a:latin typeface="맑은 고딕"/>
+                <a:ea typeface="맑은 고딕"/>
+                <a:cs typeface="맑은 고딕"/>
+              </a:rPr>
+              <a:t>• CloudWatch 알람</a:t>
+            </a:r>
+          </a:p>
+          <a:p>
+            <a:pPr>
+              <a:spcBef>
+                <a:spcPts val="700"/>
+              </a:spcBef>
+            </a:pPr>
+            <a:r>
+              <a:rPr sz="1300" b="0">
+                <a:solidFill>
+                  <a:srgbClr val="0F172A"/>
+                </a:solidFill>
+                <a:latin typeface="맑은 고딕"/>
+                <a:ea typeface="맑은 고딕"/>
+                <a:cs typeface="맑은 고딕"/>
+              </a:rPr>
+              <a:t>• Target Group health 확인</a:t>
+            </a:r>
+          </a:p>
+          <a:p>
+            <a:pPr>
+              <a:spcBef>
+                <a:spcPts val="700"/>
+              </a:spcBef>
+            </a:pPr>
+            <a:r>
+              <a:rPr sz="1300" b="0">
+                <a:solidFill>
+                  <a:srgbClr val="0F172A"/>
+                </a:solidFill>
+                <a:latin typeface="맑은 고딕"/>
+                <a:ea typeface="맑은 고딕"/>
+                <a:cs typeface="맑은 고딕"/>
+              </a:rPr>
+              <a:t>• SSM으로 서버 점검</a:t>
+            </a:r>
+          </a:p>
+        </p:txBody>
+      </p:sp>
+      <p:sp>
+        <p:nvSpPr>
+          <p:cNvPr id="7" name="Rounded Rectangle 6"/>
+          <p:cNvSpPr/>
+          <p:nvPr/>
+        </p:nvSpPr>
+        <p:spPr>
+          <a:xfrm>
+            <a:off x="6172200" y="3566160"/>
+            <a:ext cx="5669280" cy="2331720"/>
+          </a:xfrm>
+          <a:prstGeom prst="roundRect">
+            <a:avLst/>
+          </a:prstGeom>
+          <a:solidFill>
+            <a:srgbClr val="F8FAFC"/>
+          </a:solidFill>
+          <a:ln w="19050">
+            <a:solidFill>
+              <a:srgbClr val="DC2626"/>
+            </a:solidFill>
+          </a:ln>
+        </p:spPr>
+        <p:style>
+          <a:lnRef idx="1">
+            <a:schemeClr val="accent1"/>
+          </a:lnRef>
+          <a:fillRef idx="3">
+            <a:schemeClr val="accent1"/>
+          </a:fillRef>
+          <a:effectRef idx="2">
+            <a:schemeClr val="accent1"/>
+          </a:effectRef>
+          <a:fontRef idx="minor">
+            <a:schemeClr val="lt1"/>
+          </a:fontRef>
+        </p:style>
+        <p:txBody>
+          <a:bodyPr rtlCol="0" anchor="ctr" wrap="square"/>
+          <a:lstStyle/>
+          <a:p>
+            <a:pPr algn="ctr"/>
+            <a:r>
+              <a:rPr sz="1700" b="1">
+                <a:solidFill>
+                  <a:srgbClr val="DC2626"/>
+                </a:solidFill>
+                <a:latin typeface="맑은 고딕"/>
+                <a:ea typeface="맑은 고딕"/>
+                <a:cs typeface="맑은 고딕"/>
+              </a:rPr>
+              <a:t>보안</a:t>
+            </a:r>
+          </a:p>
+          <a:p>
+            <a:pPr>
+              <a:spcBef>
+                <a:spcPts val="700"/>
+              </a:spcBef>
+            </a:pPr>
+            <a:r>
+              <a:rPr sz="1300" b="0">
+                <a:solidFill>
+                  <a:srgbClr val="0F172A"/>
+                </a:solidFill>
+                <a:latin typeface="맑은 고딕"/>
+                <a:ea typeface="맑은 고딕"/>
+                <a:cs typeface="맑은 고딕"/>
+              </a:rPr>
+              <a:t>• SG 최소 포트 개방</a:t>
+            </a:r>
+          </a:p>
+          <a:p>
+            <a:pPr>
+              <a:spcBef>
+                <a:spcPts val="700"/>
+              </a:spcBef>
+            </a:pPr>
+            <a:r>
+              <a:rPr sz="1300" b="0">
+                <a:solidFill>
+                  <a:srgbClr val="0F172A"/>
+                </a:solidFill>
+                <a:latin typeface="맑은 고딕"/>
+                <a:ea typeface="맑은 고딕"/>
+                <a:cs typeface="맑은 고딕"/>
+              </a:rPr>
+              <a:t>• Secrets Manager로 키 주입</a:t>
+            </a:r>
+          </a:p>
+          <a:p>
+            <a:pPr>
+              <a:spcBef>
+                <a:spcPts val="700"/>
+              </a:spcBef>
+            </a:pPr>
+            <a:r>
+              <a:rPr sz="1300" b="0">
+                <a:solidFill>
+                  <a:srgbClr val="0F172A"/>
+                </a:solidFill>
+                <a:latin typeface="맑은 고딕"/>
+                <a:ea typeface="맑은 고딕"/>
+                <a:cs typeface="맑은 고딕"/>
+              </a:rPr>
+              <a:t>• ACM HTTPS + WAF(SQLi/Rate)</a:t>
+            </a:r>
+          </a:p>
+        </p:txBody>
+      </p:sp>
+      <p:sp>
+        <p:nvSpPr>
+          <p:cNvPr id="8" name="TextBox 7"/>
           <p:cNvSpPr txBox="1"/>
           <p:nvPr/>
         </p:nvSpPr>
@@ -4618,7 +4619,7 @@
                 <a:ea typeface="맑은 고딕"/>
                 <a:cs typeface="맑은 고딕"/>
               </a:rPr>
-              <a:t>Aniverse · 온프레미스 3-tier → AWS   |   13/14</a:t>
+              <a:t>Aniverse · 온프레미스 3-tier → AWS   |   13/15</a:t>
             </a:r>
           </a:p>
         </p:txBody>
@@ -4715,7 +4716,7 @@
                 <a:ea typeface="맑은 고딕"/>
                 <a:cs typeface="맑은 고딕"/>
               </a:rPr>
-              <a:t>6. HTTPS · WAF (2)</a:t>
+              <a:t>6. HTTPS · WAF (1)</a:t>
             </a:r>
           </a:p>
           <a:p>
@@ -4733,594 +4734,38 @@
                 <a:ea typeface="맑은 고딕"/>
                 <a:cs typeface="맑은 고딕"/>
               </a:rPr>
-              <a:t>Terraform으로 고정한 보안 엣지</a:t>
-            </a:r>
-          </a:p>
-        </p:txBody>
-      </p:sp>
-      <p:sp>
-        <p:nvSpPr>
-          <p:cNvPr id="4" name="Rounded Rectangle 3"/>
-          <p:cNvSpPr/>
+              <a:t>도메인부터 ALB까지 암호화·필터링 경로</a:t>
+            </a:r>
+          </a:p>
+        </p:txBody>
+      </p:sp>
+      <p:pic>
+        <p:nvPicPr>
+          <p:cNvPr id="4" name="Picture 3" descr="06_https_waf.png"/>
+          <p:cNvPicPr>
+            <a:picLocks noChangeAspect="1"/>
+          </p:cNvPicPr>
           <p:nvPr/>
-        </p:nvSpPr>
-        <p:spPr>
-          <a:xfrm>
-            <a:off x="320040" y="1051560"/>
-            <a:ext cx="5669280" cy="5029200"/>
-          </a:xfrm>
-          <a:prstGeom prst="roundRect">
+        </p:nvPicPr>
+        <p:blipFill>
+          <a:blip r:embed="rId2"/>
+          <a:stretch>
+            <a:fillRect/>
+          </a:stretch>
+        </p:blipFill>
+        <p:spPr>
+          <a:xfrm>
+            <a:off x="320040" y="914400"/>
+            <a:ext cx="11521440" cy="6480810"/>
+          </a:xfrm>
+          <a:prstGeom prst="rect">
             <a:avLst/>
           </a:prstGeom>
-          <a:solidFill>
-            <a:srgbClr val="EFF6FF"/>
-          </a:solidFill>
-          <a:ln w="19050">
-            <a:solidFill>
-              <a:srgbClr val="0D9488"/>
-            </a:solidFill>
-          </a:ln>
-        </p:spPr>
-        <p:style>
-          <a:lnRef idx="1">
-            <a:schemeClr val="accent1"/>
-          </a:lnRef>
-          <a:fillRef idx="3">
-            <a:schemeClr val="accent1"/>
-          </a:fillRef>
-          <a:effectRef idx="2">
-            <a:schemeClr val="accent1"/>
-          </a:effectRef>
-          <a:fontRef idx="minor">
-            <a:schemeClr val="lt1"/>
-          </a:fontRef>
-        </p:style>
-        <p:txBody>
-          <a:bodyPr rtlCol="0" anchor="ctr" wrap="square"/>
-          <a:lstStyle/>
-          <a:p>
-            <a:pPr algn="ctr"/>
-            <a:r>
-              <a:rPr sz="1800" b="1">
-                <a:solidFill>
-                  <a:srgbClr val="0D9488"/>
-                </a:solidFill>
-                <a:latin typeface="맑은 고딕"/>
-                <a:ea typeface="맑은 고딕"/>
-                <a:cs typeface="맑은 고딕"/>
-              </a:rPr>
-              <a:t>HTTPS — ACM + ALB</a:t>
-            </a:r>
-          </a:p>
-          <a:p>
-            <a:pPr>
-              <a:spcBef>
-                <a:spcPts val="500"/>
-              </a:spcBef>
-            </a:pPr>
-            <a:r>
-              <a:rPr sz="1300" b="0">
-                <a:solidFill>
-                  <a:srgbClr val="0F172A"/>
-                </a:solidFill>
-                <a:latin typeface="맑은 고딕"/>
-                <a:ea typeface="맑은 고딕"/>
-                <a:cs typeface="맑은 고딕"/>
-              </a:rPr>
-              <a:t>modules/acm</a:t>
-            </a:r>
-          </a:p>
-          <a:p>
-            <a:pPr>
-              <a:spcBef>
-                <a:spcPts val="500"/>
-              </a:spcBef>
-            </a:pPr>
-            <a:r>
-              <a:rPr sz="1300" b="0">
-                <a:solidFill>
-                  <a:srgbClr val="0F172A"/>
-                </a:solidFill>
-                <a:latin typeface="맑은 고딕"/>
-                <a:ea typeface="맑은 고딕"/>
-                <a:cs typeface="맑은 고딕"/>
-              </a:rPr>
-              <a:t>• aniverse.my DNS 검증 인증서</a:t>
-            </a:r>
-          </a:p>
-          <a:p>
-            <a:pPr>
-              <a:spcBef>
-                <a:spcPts val="500"/>
-              </a:spcBef>
-            </a:pPr>
-            <a:r>
-              <a:rPr sz="1300" b="0">
-                <a:solidFill>
-                  <a:srgbClr val="0F172A"/>
-                </a:solidFill>
-                <a:latin typeface="맑은 고딕"/>
-                <a:ea typeface="맑은 고딕"/>
-                <a:cs typeface="맑은 고딕"/>
-              </a:rPr>
-              <a:t>• www SAN 포함 · Route53 검증 레코드</a:t>
-            </a:r>
-          </a:p>
-          <a:p>
-            <a:pPr>
-              <a:spcBef>
-                <a:spcPts val="500"/>
-              </a:spcBef>
-            </a:pPr>
-            <a:r>
-              <a:rPr sz="1300" b="0">
-                <a:solidFill>
-                  <a:srgbClr val="0F172A"/>
-                </a:solidFill>
-                <a:latin typeface="맑은 고딕"/>
-                <a:ea typeface="맑은 고딕"/>
-                <a:cs typeface="맑은 고딕"/>
-              </a:rPr>
-              <a:t/>
-            </a:r>
-          </a:p>
-          <a:p>
-            <a:pPr>
-              <a:spcBef>
-                <a:spcPts val="500"/>
-              </a:spcBef>
-            </a:pPr>
-            <a:r>
-              <a:rPr sz="1300" b="0">
-                <a:solidFill>
-                  <a:srgbClr val="0F172A"/>
-                </a:solidFill>
-                <a:latin typeface="맑은 고딕"/>
-                <a:ea typeface="맑은 고딕"/>
-                <a:cs typeface="맑은 고딕"/>
-              </a:rPr>
-              <a:t>modules/alb</a:t>
-            </a:r>
-          </a:p>
-          <a:p>
-            <a:pPr>
-              <a:spcBef>
-                <a:spcPts val="500"/>
-              </a:spcBef>
-            </a:pPr>
-            <a:r>
-              <a:rPr sz="1300" b="0">
-                <a:solidFill>
-                  <a:srgbClr val="0F172A"/>
-                </a:solidFill>
-                <a:latin typeface="맑은 고딕"/>
-                <a:ea typeface="맑은 고딕"/>
-                <a:cs typeface="맑은 고딕"/>
-              </a:rPr>
-              <a:t>• 443 HTTPS Listener (TLS 1.3)</a:t>
-            </a:r>
-          </a:p>
-          <a:p>
-            <a:pPr>
-              <a:spcBef>
-                <a:spcPts val="500"/>
-              </a:spcBef>
-            </a:pPr>
-            <a:r>
-              <a:rPr sz="1300" b="0">
-                <a:solidFill>
-                  <a:srgbClr val="0F172A"/>
-                </a:solidFill>
-                <a:latin typeface="맑은 고딕"/>
-                <a:ea typeface="맑은 고딕"/>
-                <a:cs typeface="맑은 고딕"/>
-              </a:rPr>
-              <a:t>• 80 → 443 HTTP 301 redirect</a:t>
-            </a:r>
-          </a:p>
-          <a:p>
-            <a:pPr>
-              <a:spcBef>
-                <a:spcPts val="500"/>
-              </a:spcBef>
-            </a:pPr>
-            <a:r>
-              <a:rPr sz="1300" b="0">
-                <a:solidFill>
-                  <a:srgbClr val="0F172A"/>
-                </a:solidFill>
-                <a:latin typeface="맑은 고딕"/>
-                <a:ea typeface="맑은 고딕"/>
-                <a:cs typeface="맑은 고딕"/>
-              </a:rPr>
-              <a:t>• Target Group → ASG/EC2</a:t>
-            </a:r>
-          </a:p>
-          <a:p>
-            <a:pPr>
-              <a:spcBef>
-                <a:spcPts val="500"/>
-              </a:spcBef>
-            </a:pPr>
-            <a:r>
-              <a:rPr sz="1300" b="0">
-                <a:solidFill>
-                  <a:srgbClr val="0F172A"/>
-                </a:solidFill>
-                <a:latin typeface="맑은 고딕"/>
-                <a:ea typeface="맑은 고딕"/>
-                <a:cs typeface="맑은 고딕"/>
-              </a:rPr>
-              <a:t/>
-            </a:r>
-          </a:p>
-          <a:p>
-            <a:pPr>
-              <a:spcBef>
-                <a:spcPts val="500"/>
-              </a:spcBef>
-            </a:pPr>
-            <a:r>
-              <a:rPr sz="1300" b="0">
-                <a:solidFill>
-                  <a:srgbClr val="0F172A"/>
-                </a:solidFill>
-                <a:latin typeface="맑은 고딕"/>
-                <a:ea typeface="맑은 고딕"/>
-                <a:cs typeface="맑은 고딕"/>
-              </a:rPr>
-              <a:t>앱 연동</a:t>
-            </a:r>
-          </a:p>
-          <a:p>
-            <a:pPr>
-              <a:spcBef>
-                <a:spcPts val="500"/>
-              </a:spcBef>
-            </a:pPr>
-            <a:r>
-              <a:rPr sz="1300" b="0">
-                <a:solidFill>
-                  <a:srgbClr val="0F172A"/>
-                </a:solidFill>
-                <a:latin typeface="맑은 고딕"/>
-                <a:ea typeface="맑은 고딕"/>
-                <a:cs typeface="맑은 고딕"/>
-              </a:rPr>
-              <a:t>• Secrets: USE_HTTPS=True</a:t>
-            </a:r>
-          </a:p>
-          <a:p>
-            <a:pPr>
-              <a:spcBef>
-                <a:spcPts val="500"/>
-              </a:spcBef>
-            </a:pPr>
-            <a:r>
-              <a:rPr sz="1300" b="0">
-                <a:solidFill>
-                  <a:srgbClr val="0F172A"/>
-                </a:solidFill>
-                <a:latin typeface="맑은 고딕"/>
-                <a:ea typeface="맑은 고딕"/>
-                <a:cs typeface="맑은 고딕"/>
-              </a:rPr>
-              <a:t>• CSRF / ALLOWED_HOSTS https 허용</a:t>
-            </a:r>
-          </a:p>
-        </p:txBody>
-      </p:sp>
-      <p:sp>
-        <p:nvSpPr>
-          <p:cNvPr id="5" name="Rounded Rectangle 4"/>
-          <p:cNvSpPr/>
-          <p:nvPr/>
-        </p:nvSpPr>
-        <p:spPr>
-          <a:xfrm>
-            <a:off x="6217920" y="1051560"/>
-            <a:ext cx="5623560" cy="5029200"/>
-          </a:xfrm>
-          <a:prstGeom prst="roundRect">
-            <a:avLst/>
-          </a:prstGeom>
-          <a:solidFill>
-            <a:srgbClr val="FEF2F2"/>
-          </a:solidFill>
-          <a:ln w="19050">
-            <a:solidFill>
-              <a:srgbClr val="DC2626"/>
-            </a:solidFill>
-          </a:ln>
-        </p:spPr>
-        <p:style>
-          <a:lnRef idx="1">
-            <a:schemeClr val="accent1"/>
-          </a:lnRef>
-          <a:fillRef idx="3">
-            <a:schemeClr val="accent1"/>
-          </a:fillRef>
-          <a:effectRef idx="2">
-            <a:schemeClr val="accent1"/>
-          </a:effectRef>
-          <a:fontRef idx="minor">
-            <a:schemeClr val="lt1"/>
-          </a:fontRef>
-        </p:style>
-        <p:txBody>
-          <a:bodyPr rtlCol="0" anchor="ctr" wrap="square"/>
-          <a:lstStyle/>
-          <a:p>
-            <a:pPr algn="ctr"/>
-            <a:r>
-              <a:rPr sz="1800" b="1">
-                <a:solidFill>
-                  <a:srgbClr val="DC2626"/>
-                </a:solidFill>
-                <a:latin typeface="맑은 고딕"/>
-                <a:ea typeface="맑은 고딕"/>
-                <a:cs typeface="맑은 고딕"/>
-              </a:rPr>
-              <a:t>WAF — ALB Web ACL</a:t>
-            </a:r>
-          </a:p>
-          <a:p>
-            <a:pPr>
-              <a:spcBef>
-                <a:spcPts val="400"/>
-              </a:spcBef>
-            </a:pPr>
-            <a:r>
-              <a:rPr sz="1300" b="0">
-                <a:solidFill>
-                  <a:srgbClr val="0F172A"/>
-                </a:solidFill>
-                <a:latin typeface="맑은 고딕"/>
-                <a:ea typeface="맑은 고딕"/>
-                <a:cs typeface="맑은 고딕"/>
-              </a:rPr>
-              <a:t>modules/waf → aniverse-alb-waf</a:t>
-            </a:r>
-          </a:p>
-          <a:p>
-            <a:pPr>
-              <a:spcBef>
-                <a:spcPts val="400"/>
-              </a:spcBef>
-            </a:pPr>
-            <a:r>
-              <a:rPr sz="1300" b="0">
-                <a:solidFill>
-                  <a:srgbClr val="0F172A"/>
-                </a:solidFill>
-                <a:latin typeface="맑은 고딕"/>
-                <a:ea typeface="맑은 고딕"/>
-                <a:cs typeface="맑은 고딕"/>
-              </a:rPr>
-              <a:t>• scope: REGIONAL (ALB 전용)</a:t>
-            </a:r>
-          </a:p>
-          <a:p>
-            <a:pPr>
-              <a:spcBef>
-                <a:spcPts val="400"/>
-              </a:spcBef>
-            </a:pPr>
-            <a:r>
-              <a:rPr sz="1300" b="0">
-                <a:solidFill>
-                  <a:srgbClr val="0F172A"/>
-                </a:solidFill>
-                <a:latin typeface="맑은 고딕"/>
-                <a:ea typeface="맑은 고딕"/>
-                <a:cs typeface="맑은 고딕"/>
-              </a:rPr>
-              <a:t/>
-            </a:r>
-          </a:p>
-          <a:p>
-            <a:pPr>
-              <a:spcBef>
-                <a:spcPts val="400"/>
-              </a:spcBef>
-            </a:pPr>
-            <a:r>
-              <a:rPr sz="1300" b="0">
-                <a:solidFill>
-                  <a:srgbClr val="0F172A"/>
-                </a:solidFill>
-                <a:latin typeface="맑은 고딕"/>
-                <a:ea typeface="맑은 고딕"/>
-                <a:cs typeface="맑은 고딕"/>
-              </a:rPr>
-              <a:t>관리형 규칙</a:t>
-            </a:r>
-          </a:p>
-          <a:p>
-            <a:pPr>
-              <a:spcBef>
-                <a:spcPts val="400"/>
-              </a:spcBef>
-            </a:pPr>
-            <a:r>
-              <a:rPr sz="1300" b="0">
-                <a:solidFill>
-                  <a:srgbClr val="0F172A"/>
-                </a:solidFill>
-                <a:latin typeface="맑은 고딕"/>
-                <a:ea typeface="맑은 고딕"/>
-                <a:cs typeface="맑은 고딕"/>
-              </a:rPr>
-              <a:t>• CommonRuleSet (일반 웹 공격)</a:t>
-            </a:r>
-          </a:p>
-          <a:p>
-            <a:pPr>
-              <a:spcBef>
-                <a:spcPts val="400"/>
-              </a:spcBef>
-            </a:pPr>
-            <a:r>
-              <a:rPr sz="1300" b="0">
-                <a:solidFill>
-                  <a:srgbClr val="0F172A"/>
-                </a:solidFill>
-                <a:latin typeface="맑은 고딕"/>
-                <a:ea typeface="맑은 고딕"/>
-                <a:cs typeface="맑은 고딕"/>
-              </a:rPr>
-              <a:t>• KnownBadInputs</a:t>
-            </a:r>
-          </a:p>
-          <a:p>
-            <a:pPr>
-              <a:spcBef>
-                <a:spcPts val="400"/>
-              </a:spcBef>
-            </a:pPr>
-            <a:r>
-              <a:rPr sz="1300" b="0">
-                <a:solidFill>
-                  <a:srgbClr val="0F172A"/>
-                </a:solidFill>
-                <a:latin typeface="맑은 고딕"/>
-                <a:ea typeface="맑은 고딕"/>
-                <a:cs typeface="맑은 고딕"/>
-              </a:rPr>
-              <a:t>• SQLi RuleSet</a:t>
-            </a:r>
-          </a:p>
-          <a:p>
-            <a:pPr>
-              <a:spcBef>
-                <a:spcPts val="400"/>
-              </a:spcBef>
-            </a:pPr>
-            <a:r>
-              <a:rPr sz="1300" b="0">
-                <a:solidFill>
-                  <a:srgbClr val="0F172A"/>
-                </a:solidFill>
-                <a:latin typeface="맑은 고딕"/>
-                <a:ea typeface="맑은 고딕"/>
-                <a:cs typeface="맑은 고딕"/>
-              </a:rPr>
-              <a:t/>
-            </a:r>
-          </a:p>
-          <a:p>
-            <a:pPr>
-              <a:spcBef>
-                <a:spcPts val="400"/>
-              </a:spcBef>
-            </a:pPr>
-            <a:r>
-              <a:rPr sz="1300" b="0">
-                <a:solidFill>
-                  <a:srgbClr val="0F172A"/>
-                </a:solidFill>
-                <a:latin typeface="맑은 고딕"/>
-                <a:ea typeface="맑은 고딕"/>
-                <a:cs typeface="맑은 고딕"/>
-              </a:rPr>
-              <a:t>커스텀</a:t>
-            </a:r>
-          </a:p>
-          <a:p>
-            <a:pPr>
-              <a:spcBef>
-                <a:spcPts val="400"/>
-              </a:spcBef>
-            </a:pPr>
-            <a:r>
-              <a:rPr sz="1300" b="0">
-                <a:solidFill>
-                  <a:srgbClr val="0F172A"/>
-                </a:solidFill>
-                <a:latin typeface="맑은 고딕"/>
-                <a:ea typeface="맑은 고딕"/>
-                <a:cs typeface="맑은 고딕"/>
-              </a:rPr>
-              <a:t>• RateLimitPerIP → Block</a:t>
-            </a:r>
-          </a:p>
-          <a:p>
-            <a:pPr>
-              <a:spcBef>
-                <a:spcPts val="400"/>
-              </a:spcBef>
-            </a:pPr>
-            <a:r>
-              <a:rPr sz="1300" b="0">
-                <a:solidFill>
-                  <a:srgbClr val="0F172A"/>
-                </a:solidFill>
-                <a:latin typeface="맑은 고딕"/>
-                <a:ea typeface="맑은 고딕"/>
-                <a:cs typeface="맑은 고딕"/>
-              </a:rPr>
-              <a:t/>
-            </a:r>
-          </a:p>
-          <a:p>
-            <a:pPr>
-              <a:spcBef>
-                <a:spcPts val="400"/>
-              </a:spcBef>
-            </a:pPr>
-            <a:r>
-              <a:rPr sz="1300" b="0">
-                <a:solidFill>
-                  <a:srgbClr val="0F172A"/>
-                </a:solidFill>
-                <a:latin typeface="맑은 고딕"/>
-                <a:ea typeface="맑은 고딕"/>
-                <a:cs typeface="맑은 고딕"/>
-              </a:rPr>
-              <a:t>연결</a:t>
-            </a:r>
-          </a:p>
-          <a:p>
-            <a:pPr>
-              <a:spcBef>
-                <a:spcPts val="400"/>
-              </a:spcBef>
-            </a:pPr>
-            <a:r>
-              <a:rPr sz="1300" b="0">
-                <a:solidFill>
-                  <a:srgbClr val="0F172A"/>
-                </a:solidFill>
-                <a:latin typeface="맑은 고딕"/>
-                <a:ea typeface="맑은 고딕"/>
-                <a:cs typeface="맑은 고딕"/>
-              </a:rPr>
-              <a:t>• web_acl_association → ALB ARN</a:t>
-            </a:r>
-          </a:p>
-          <a:p>
-            <a:pPr>
-              <a:spcBef>
-                <a:spcPts val="400"/>
-              </a:spcBef>
-            </a:pPr>
-            <a:r>
-              <a:rPr sz="1300" b="0">
-                <a:solidFill>
-                  <a:srgbClr val="0F172A"/>
-                </a:solidFill>
-                <a:latin typeface="맑은 고딕"/>
-                <a:ea typeface="맑은 고딕"/>
-                <a:cs typeface="맑은 고딕"/>
-              </a:rPr>
-              <a:t>• CloudWatch metrics / sampled req</a:t>
-            </a:r>
-          </a:p>
-        </p:txBody>
-      </p:sp>
-      <p:sp>
-        <p:nvSpPr>
-          <p:cNvPr id="6" name="TextBox 5"/>
+        </p:spPr>
+      </p:pic>
+      <p:sp>
+        <p:nvSpPr>
+          <p:cNvPr id="5" name="TextBox 4"/>
           <p:cNvSpPr txBox="1"/>
           <p:nvPr/>
         </p:nvSpPr>
@@ -5350,7 +4795,7 @@
                 <a:ea typeface="맑은 고딕"/>
                 <a:cs typeface="맑은 고딕"/>
               </a:rPr>
-              <a:t>Aniverse · 온프레미스 3-tier → AWS   |   14/14</a:t>
+              <a:t>Aniverse · 온프레미스 3-tier → AWS   |   14/15</a:t>
             </a:r>
           </a:p>
         </p:txBody>
@@ -5382,6 +4827,738 @@
         <p:spPr>
           <a:xfrm>
             <a:off x="0" y="0"/>
+            <a:ext cx="12191695" cy="777240"/>
+          </a:xfrm>
+          <a:prstGeom prst="rect">
+            <a:avLst/>
+          </a:prstGeom>
+          <a:solidFill>
+            <a:srgbClr val="0F172A"/>
+          </a:solidFill>
+          <a:ln>
+            <a:noFill/>
+          </a:ln>
+        </p:spPr>
+        <p:style>
+          <a:lnRef idx="1">
+            <a:schemeClr val="accent1"/>
+          </a:lnRef>
+          <a:fillRef idx="3">
+            <a:schemeClr val="accent1"/>
+          </a:fillRef>
+          <a:effectRef idx="2">
+            <a:schemeClr val="accent1"/>
+          </a:effectRef>
+          <a:fontRef idx="minor">
+            <a:schemeClr val="lt1"/>
+          </a:fontRef>
+        </p:style>
+        <p:txBody>
+          <a:bodyPr rtlCol="0" anchor="ctr"/>
+          <a:lstStyle/>
+          <a:p>
+            <a:pPr algn="ctr"/>
+          </a:p>
+        </p:txBody>
+      </p:sp>
+      <p:sp>
+        <p:nvSpPr>
+          <p:cNvPr id="3" name="TextBox 2"/>
+          <p:cNvSpPr txBox="1"/>
+          <p:nvPr/>
+        </p:nvSpPr>
+        <p:spPr>
+          <a:xfrm>
+            <a:off x="411480" y="109728"/>
+            <a:ext cx="11338560" cy="594360"/>
+          </a:xfrm>
+          <a:prstGeom prst="rect">
+            <a:avLst/>
+          </a:prstGeom>
+          <a:noFill/>
+        </p:spPr>
+        <p:txBody>
+          <a:bodyPr wrap="square">
+            <a:spAutoFit/>
+          </a:bodyPr>
+          <a:lstStyle/>
+          <a:p>
+            <a:r>
+              <a:rPr sz="2200" b="1">
+                <a:solidFill>
+                  <a:srgbClr val="FFFFFF"/>
+                </a:solidFill>
+                <a:latin typeface="맑은 고딕"/>
+                <a:ea typeface="맑은 고딕"/>
+                <a:cs typeface="맑은 고딕"/>
+              </a:rPr>
+              <a:t>6. HTTPS · WAF (2)</a:t>
+            </a:r>
+          </a:p>
+          <a:p>
+            <a:pPr>
+              <a:spcBef>
+                <a:spcPts val="200"/>
+              </a:spcBef>
+            </a:pPr>
+            <a:r>
+              <a:rPr sz="1200" b="0">
+                <a:solidFill>
+                  <a:srgbClr val="93C5FD"/>
+                </a:solidFill>
+                <a:latin typeface="맑은 고딕"/>
+                <a:ea typeface="맑은 고딕"/>
+                <a:cs typeface="맑은 고딕"/>
+              </a:rPr>
+              <a:t>Terraform으로 고정한 보안 엣지</a:t>
+            </a:r>
+          </a:p>
+        </p:txBody>
+      </p:sp>
+      <p:sp>
+        <p:nvSpPr>
+          <p:cNvPr id="4" name="Rounded Rectangle 3"/>
+          <p:cNvSpPr/>
+          <p:nvPr/>
+        </p:nvSpPr>
+        <p:spPr>
+          <a:xfrm>
+            <a:off x="320040" y="1051560"/>
+            <a:ext cx="5669280" cy="5029200"/>
+          </a:xfrm>
+          <a:prstGeom prst="roundRect">
+            <a:avLst/>
+          </a:prstGeom>
+          <a:solidFill>
+            <a:srgbClr val="EFF6FF"/>
+          </a:solidFill>
+          <a:ln w="19050">
+            <a:solidFill>
+              <a:srgbClr val="0D9488"/>
+            </a:solidFill>
+          </a:ln>
+        </p:spPr>
+        <p:style>
+          <a:lnRef idx="1">
+            <a:schemeClr val="accent1"/>
+          </a:lnRef>
+          <a:fillRef idx="3">
+            <a:schemeClr val="accent1"/>
+          </a:fillRef>
+          <a:effectRef idx="2">
+            <a:schemeClr val="accent1"/>
+          </a:effectRef>
+          <a:fontRef idx="minor">
+            <a:schemeClr val="lt1"/>
+          </a:fontRef>
+        </p:style>
+        <p:txBody>
+          <a:bodyPr rtlCol="0" anchor="ctr" wrap="square"/>
+          <a:lstStyle/>
+          <a:p>
+            <a:pPr algn="ctr"/>
+            <a:r>
+              <a:rPr sz="1800" b="1">
+                <a:solidFill>
+                  <a:srgbClr val="0D9488"/>
+                </a:solidFill>
+                <a:latin typeface="맑은 고딕"/>
+                <a:ea typeface="맑은 고딕"/>
+                <a:cs typeface="맑은 고딕"/>
+              </a:rPr>
+              <a:t>HTTPS — ACM + ALB</a:t>
+            </a:r>
+          </a:p>
+          <a:p>
+            <a:pPr>
+              <a:spcBef>
+                <a:spcPts val="500"/>
+              </a:spcBef>
+            </a:pPr>
+            <a:r>
+              <a:rPr sz="1300" b="0">
+                <a:solidFill>
+                  <a:srgbClr val="0F172A"/>
+                </a:solidFill>
+                <a:latin typeface="맑은 고딕"/>
+                <a:ea typeface="맑은 고딕"/>
+                <a:cs typeface="맑은 고딕"/>
+              </a:rPr>
+              <a:t>modules/acm</a:t>
+            </a:r>
+          </a:p>
+          <a:p>
+            <a:pPr>
+              <a:spcBef>
+                <a:spcPts val="500"/>
+              </a:spcBef>
+            </a:pPr>
+            <a:r>
+              <a:rPr sz="1300" b="0">
+                <a:solidFill>
+                  <a:srgbClr val="0F172A"/>
+                </a:solidFill>
+                <a:latin typeface="맑은 고딕"/>
+                <a:ea typeface="맑은 고딕"/>
+                <a:cs typeface="맑은 고딕"/>
+              </a:rPr>
+              <a:t>• aniverse.my DNS 검증 인증서</a:t>
+            </a:r>
+          </a:p>
+          <a:p>
+            <a:pPr>
+              <a:spcBef>
+                <a:spcPts val="500"/>
+              </a:spcBef>
+            </a:pPr>
+            <a:r>
+              <a:rPr sz="1300" b="0">
+                <a:solidFill>
+                  <a:srgbClr val="0F172A"/>
+                </a:solidFill>
+                <a:latin typeface="맑은 고딕"/>
+                <a:ea typeface="맑은 고딕"/>
+                <a:cs typeface="맑은 고딕"/>
+              </a:rPr>
+              <a:t>• www SAN 포함 · Route53 검증 레코드</a:t>
+            </a:r>
+          </a:p>
+          <a:p>
+            <a:pPr>
+              <a:spcBef>
+                <a:spcPts val="500"/>
+              </a:spcBef>
+            </a:pPr>
+            <a:r>
+              <a:rPr sz="1300" b="0">
+                <a:solidFill>
+                  <a:srgbClr val="0F172A"/>
+                </a:solidFill>
+                <a:latin typeface="맑은 고딕"/>
+                <a:ea typeface="맑은 고딕"/>
+                <a:cs typeface="맑은 고딕"/>
+              </a:rPr>
+              <a:t/>
+            </a:r>
+          </a:p>
+          <a:p>
+            <a:pPr>
+              <a:spcBef>
+                <a:spcPts val="500"/>
+              </a:spcBef>
+            </a:pPr>
+            <a:r>
+              <a:rPr sz="1300" b="0">
+                <a:solidFill>
+                  <a:srgbClr val="0F172A"/>
+                </a:solidFill>
+                <a:latin typeface="맑은 고딕"/>
+                <a:ea typeface="맑은 고딕"/>
+                <a:cs typeface="맑은 고딕"/>
+              </a:rPr>
+              <a:t>modules/alb</a:t>
+            </a:r>
+          </a:p>
+          <a:p>
+            <a:pPr>
+              <a:spcBef>
+                <a:spcPts val="500"/>
+              </a:spcBef>
+            </a:pPr>
+            <a:r>
+              <a:rPr sz="1300" b="0">
+                <a:solidFill>
+                  <a:srgbClr val="0F172A"/>
+                </a:solidFill>
+                <a:latin typeface="맑은 고딕"/>
+                <a:ea typeface="맑은 고딕"/>
+                <a:cs typeface="맑은 고딕"/>
+              </a:rPr>
+              <a:t>• 443 HTTPS Listener (TLS 1.3)</a:t>
+            </a:r>
+          </a:p>
+          <a:p>
+            <a:pPr>
+              <a:spcBef>
+                <a:spcPts val="500"/>
+              </a:spcBef>
+            </a:pPr>
+            <a:r>
+              <a:rPr sz="1300" b="0">
+                <a:solidFill>
+                  <a:srgbClr val="0F172A"/>
+                </a:solidFill>
+                <a:latin typeface="맑은 고딕"/>
+                <a:ea typeface="맑은 고딕"/>
+                <a:cs typeface="맑은 고딕"/>
+              </a:rPr>
+              <a:t>• 80 → 443 HTTP 301 redirect</a:t>
+            </a:r>
+          </a:p>
+          <a:p>
+            <a:pPr>
+              <a:spcBef>
+                <a:spcPts val="500"/>
+              </a:spcBef>
+            </a:pPr>
+            <a:r>
+              <a:rPr sz="1300" b="0">
+                <a:solidFill>
+                  <a:srgbClr val="0F172A"/>
+                </a:solidFill>
+                <a:latin typeface="맑은 고딕"/>
+                <a:ea typeface="맑은 고딕"/>
+                <a:cs typeface="맑은 고딕"/>
+              </a:rPr>
+              <a:t>• Target Group → ASG/EC2</a:t>
+            </a:r>
+          </a:p>
+          <a:p>
+            <a:pPr>
+              <a:spcBef>
+                <a:spcPts val="500"/>
+              </a:spcBef>
+            </a:pPr>
+            <a:r>
+              <a:rPr sz="1300" b="0">
+                <a:solidFill>
+                  <a:srgbClr val="0F172A"/>
+                </a:solidFill>
+                <a:latin typeface="맑은 고딕"/>
+                <a:ea typeface="맑은 고딕"/>
+                <a:cs typeface="맑은 고딕"/>
+              </a:rPr>
+              <a:t/>
+            </a:r>
+          </a:p>
+          <a:p>
+            <a:pPr>
+              <a:spcBef>
+                <a:spcPts val="500"/>
+              </a:spcBef>
+            </a:pPr>
+            <a:r>
+              <a:rPr sz="1300" b="0">
+                <a:solidFill>
+                  <a:srgbClr val="0F172A"/>
+                </a:solidFill>
+                <a:latin typeface="맑은 고딕"/>
+                <a:ea typeface="맑은 고딕"/>
+                <a:cs typeface="맑은 고딕"/>
+              </a:rPr>
+              <a:t>앱 연동</a:t>
+            </a:r>
+          </a:p>
+          <a:p>
+            <a:pPr>
+              <a:spcBef>
+                <a:spcPts val="500"/>
+              </a:spcBef>
+            </a:pPr>
+            <a:r>
+              <a:rPr sz="1300" b="0">
+                <a:solidFill>
+                  <a:srgbClr val="0F172A"/>
+                </a:solidFill>
+                <a:latin typeface="맑은 고딕"/>
+                <a:ea typeface="맑은 고딕"/>
+                <a:cs typeface="맑은 고딕"/>
+              </a:rPr>
+              <a:t>• Secrets: USE_HTTPS=True</a:t>
+            </a:r>
+          </a:p>
+          <a:p>
+            <a:pPr>
+              <a:spcBef>
+                <a:spcPts val="500"/>
+              </a:spcBef>
+            </a:pPr>
+            <a:r>
+              <a:rPr sz="1300" b="0">
+                <a:solidFill>
+                  <a:srgbClr val="0F172A"/>
+                </a:solidFill>
+                <a:latin typeface="맑은 고딕"/>
+                <a:ea typeface="맑은 고딕"/>
+                <a:cs typeface="맑은 고딕"/>
+              </a:rPr>
+              <a:t>• CSRF / ALLOWED_HOSTS https 허용</a:t>
+            </a:r>
+          </a:p>
+        </p:txBody>
+      </p:sp>
+      <p:sp>
+        <p:nvSpPr>
+          <p:cNvPr id="5" name="Rounded Rectangle 4"/>
+          <p:cNvSpPr/>
+          <p:nvPr/>
+        </p:nvSpPr>
+        <p:spPr>
+          <a:xfrm>
+            <a:off x="6217920" y="1051560"/>
+            <a:ext cx="5623560" cy="5029200"/>
+          </a:xfrm>
+          <a:prstGeom prst="roundRect">
+            <a:avLst/>
+          </a:prstGeom>
+          <a:solidFill>
+            <a:srgbClr val="FEF2F2"/>
+          </a:solidFill>
+          <a:ln w="19050">
+            <a:solidFill>
+              <a:srgbClr val="DC2626"/>
+            </a:solidFill>
+          </a:ln>
+        </p:spPr>
+        <p:style>
+          <a:lnRef idx="1">
+            <a:schemeClr val="accent1"/>
+          </a:lnRef>
+          <a:fillRef idx="3">
+            <a:schemeClr val="accent1"/>
+          </a:fillRef>
+          <a:effectRef idx="2">
+            <a:schemeClr val="accent1"/>
+          </a:effectRef>
+          <a:fontRef idx="minor">
+            <a:schemeClr val="lt1"/>
+          </a:fontRef>
+        </p:style>
+        <p:txBody>
+          <a:bodyPr rtlCol="0" anchor="ctr" wrap="square"/>
+          <a:lstStyle/>
+          <a:p>
+            <a:pPr algn="ctr"/>
+            <a:r>
+              <a:rPr sz="1800" b="1">
+                <a:solidFill>
+                  <a:srgbClr val="DC2626"/>
+                </a:solidFill>
+                <a:latin typeface="맑은 고딕"/>
+                <a:ea typeface="맑은 고딕"/>
+                <a:cs typeface="맑은 고딕"/>
+              </a:rPr>
+              <a:t>WAF — ALB Web ACL</a:t>
+            </a:r>
+          </a:p>
+          <a:p>
+            <a:pPr>
+              <a:spcBef>
+                <a:spcPts val="400"/>
+              </a:spcBef>
+            </a:pPr>
+            <a:r>
+              <a:rPr sz="1300" b="0">
+                <a:solidFill>
+                  <a:srgbClr val="0F172A"/>
+                </a:solidFill>
+                <a:latin typeface="맑은 고딕"/>
+                <a:ea typeface="맑은 고딕"/>
+                <a:cs typeface="맑은 고딕"/>
+              </a:rPr>
+              <a:t>modules/waf → aniverse-alb-waf</a:t>
+            </a:r>
+          </a:p>
+          <a:p>
+            <a:pPr>
+              <a:spcBef>
+                <a:spcPts val="400"/>
+              </a:spcBef>
+            </a:pPr>
+            <a:r>
+              <a:rPr sz="1300" b="0">
+                <a:solidFill>
+                  <a:srgbClr val="0F172A"/>
+                </a:solidFill>
+                <a:latin typeface="맑은 고딕"/>
+                <a:ea typeface="맑은 고딕"/>
+                <a:cs typeface="맑은 고딕"/>
+              </a:rPr>
+              <a:t>• scope: REGIONAL (ALB 전용)</a:t>
+            </a:r>
+          </a:p>
+          <a:p>
+            <a:pPr>
+              <a:spcBef>
+                <a:spcPts val="400"/>
+              </a:spcBef>
+            </a:pPr>
+            <a:r>
+              <a:rPr sz="1300" b="0">
+                <a:solidFill>
+                  <a:srgbClr val="0F172A"/>
+                </a:solidFill>
+                <a:latin typeface="맑은 고딕"/>
+                <a:ea typeface="맑은 고딕"/>
+                <a:cs typeface="맑은 고딕"/>
+              </a:rPr>
+              <a:t/>
+            </a:r>
+          </a:p>
+          <a:p>
+            <a:pPr>
+              <a:spcBef>
+                <a:spcPts val="400"/>
+              </a:spcBef>
+            </a:pPr>
+            <a:r>
+              <a:rPr sz="1300" b="0">
+                <a:solidFill>
+                  <a:srgbClr val="0F172A"/>
+                </a:solidFill>
+                <a:latin typeface="맑은 고딕"/>
+                <a:ea typeface="맑은 고딕"/>
+                <a:cs typeface="맑은 고딕"/>
+              </a:rPr>
+              <a:t>관리형 규칙</a:t>
+            </a:r>
+          </a:p>
+          <a:p>
+            <a:pPr>
+              <a:spcBef>
+                <a:spcPts val="400"/>
+              </a:spcBef>
+            </a:pPr>
+            <a:r>
+              <a:rPr sz="1300" b="0">
+                <a:solidFill>
+                  <a:srgbClr val="0F172A"/>
+                </a:solidFill>
+                <a:latin typeface="맑은 고딕"/>
+                <a:ea typeface="맑은 고딕"/>
+                <a:cs typeface="맑은 고딕"/>
+              </a:rPr>
+              <a:t>• CommonRuleSet (일반 웹 공격)</a:t>
+            </a:r>
+          </a:p>
+          <a:p>
+            <a:pPr>
+              <a:spcBef>
+                <a:spcPts val="400"/>
+              </a:spcBef>
+            </a:pPr>
+            <a:r>
+              <a:rPr sz="1300" b="0">
+                <a:solidFill>
+                  <a:srgbClr val="0F172A"/>
+                </a:solidFill>
+                <a:latin typeface="맑은 고딕"/>
+                <a:ea typeface="맑은 고딕"/>
+                <a:cs typeface="맑은 고딕"/>
+              </a:rPr>
+              <a:t>• KnownBadInputs</a:t>
+            </a:r>
+          </a:p>
+          <a:p>
+            <a:pPr>
+              <a:spcBef>
+                <a:spcPts val="400"/>
+              </a:spcBef>
+            </a:pPr>
+            <a:r>
+              <a:rPr sz="1300" b="0">
+                <a:solidFill>
+                  <a:srgbClr val="0F172A"/>
+                </a:solidFill>
+                <a:latin typeface="맑은 고딕"/>
+                <a:ea typeface="맑은 고딕"/>
+                <a:cs typeface="맑은 고딕"/>
+              </a:rPr>
+              <a:t>• SQLi RuleSet</a:t>
+            </a:r>
+          </a:p>
+          <a:p>
+            <a:pPr>
+              <a:spcBef>
+                <a:spcPts val="400"/>
+              </a:spcBef>
+            </a:pPr>
+            <a:r>
+              <a:rPr sz="1300" b="0">
+                <a:solidFill>
+                  <a:srgbClr val="0F172A"/>
+                </a:solidFill>
+                <a:latin typeface="맑은 고딕"/>
+                <a:ea typeface="맑은 고딕"/>
+                <a:cs typeface="맑은 고딕"/>
+              </a:rPr>
+              <a:t/>
+            </a:r>
+          </a:p>
+          <a:p>
+            <a:pPr>
+              <a:spcBef>
+                <a:spcPts val="400"/>
+              </a:spcBef>
+            </a:pPr>
+            <a:r>
+              <a:rPr sz="1300" b="0">
+                <a:solidFill>
+                  <a:srgbClr val="0F172A"/>
+                </a:solidFill>
+                <a:latin typeface="맑은 고딕"/>
+                <a:ea typeface="맑은 고딕"/>
+                <a:cs typeface="맑은 고딕"/>
+              </a:rPr>
+              <a:t>커스텀</a:t>
+            </a:r>
+          </a:p>
+          <a:p>
+            <a:pPr>
+              <a:spcBef>
+                <a:spcPts val="400"/>
+              </a:spcBef>
+            </a:pPr>
+            <a:r>
+              <a:rPr sz="1300" b="0">
+                <a:solidFill>
+                  <a:srgbClr val="0F172A"/>
+                </a:solidFill>
+                <a:latin typeface="맑은 고딕"/>
+                <a:ea typeface="맑은 고딕"/>
+                <a:cs typeface="맑은 고딕"/>
+              </a:rPr>
+              <a:t>• RateLimitPerIP → Block</a:t>
+            </a:r>
+          </a:p>
+          <a:p>
+            <a:pPr>
+              <a:spcBef>
+                <a:spcPts val="400"/>
+              </a:spcBef>
+            </a:pPr>
+            <a:r>
+              <a:rPr sz="1300" b="0">
+                <a:solidFill>
+                  <a:srgbClr val="0F172A"/>
+                </a:solidFill>
+                <a:latin typeface="맑은 고딕"/>
+                <a:ea typeface="맑은 고딕"/>
+                <a:cs typeface="맑은 고딕"/>
+              </a:rPr>
+              <a:t/>
+            </a:r>
+          </a:p>
+          <a:p>
+            <a:pPr>
+              <a:spcBef>
+                <a:spcPts val="400"/>
+              </a:spcBef>
+            </a:pPr>
+            <a:r>
+              <a:rPr sz="1300" b="0">
+                <a:solidFill>
+                  <a:srgbClr val="0F172A"/>
+                </a:solidFill>
+                <a:latin typeface="맑은 고딕"/>
+                <a:ea typeface="맑은 고딕"/>
+                <a:cs typeface="맑은 고딕"/>
+              </a:rPr>
+              <a:t>연결</a:t>
+            </a:r>
+          </a:p>
+          <a:p>
+            <a:pPr>
+              <a:spcBef>
+                <a:spcPts val="400"/>
+              </a:spcBef>
+            </a:pPr>
+            <a:r>
+              <a:rPr sz="1300" b="0">
+                <a:solidFill>
+                  <a:srgbClr val="0F172A"/>
+                </a:solidFill>
+                <a:latin typeface="맑은 고딕"/>
+                <a:ea typeface="맑은 고딕"/>
+                <a:cs typeface="맑은 고딕"/>
+              </a:rPr>
+              <a:t>• web_acl_association → ALB ARN</a:t>
+            </a:r>
+          </a:p>
+          <a:p>
+            <a:pPr>
+              <a:spcBef>
+                <a:spcPts val="400"/>
+              </a:spcBef>
+            </a:pPr>
+            <a:r>
+              <a:rPr sz="1300" b="0">
+                <a:solidFill>
+                  <a:srgbClr val="0F172A"/>
+                </a:solidFill>
+                <a:latin typeface="맑은 고딕"/>
+                <a:ea typeface="맑은 고딕"/>
+                <a:cs typeface="맑은 고딕"/>
+              </a:rPr>
+              <a:t>• CloudWatch metrics / sampled req</a:t>
+            </a:r>
+          </a:p>
+        </p:txBody>
+      </p:sp>
+      <p:sp>
+        <p:nvSpPr>
+          <p:cNvPr id="6" name="TextBox 5"/>
+          <p:cNvSpPr txBox="1"/>
+          <p:nvPr/>
+        </p:nvSpPr>
+        <p:spPr>
+          <a:xfrm>
+            <a:off x="411480" y="6446520"/>
+            <a:ext cx="11338560" cy="274320"/>
+          </a:xfrm>
+          <a:prstGeom prst="rect">
+            <a:avLst/>
+          </a:prstGeom>
+          <a:noFill/>
+        </p:spPr>
+        <p:txBody>
+          <a:bodyPr wrap="none">
+            <a:spAutoFit/>
+          </a:bodyPr>
+          <a:lstStyle/>
+          <a:p>
+            <a:pPr algn="r"/>
+            <a:r>
+              <a:rPr sz="1000" b="0">
+                <a:solidFill>
+                  <a:srgbClr val="475569"/>
+                </a:solidFill>
+                <a:latin typeface="맑은 고딕"/>
+                <a:ea typeface="맑은 고딕"/>
+                <a:cs typeface="맑은 고딕"/>
+              </a:rPr>
+              <a:t>Aniverse · 온프레미스 3-tier → AWS   |   15/15</a:t>
+            </a:r>
+          </a:p>
+        </p:txBody>
+      </p:sp>
+    </p:spTree>
+  </p:cSld>
+  <p:clrMapOvr>
+    <a:masterClrMapping/>
+  </p:clrMapOvr>
+</p:sld>
+</file>
+
+<file path=ppt/slides/slide16.xml><?xml version="1.0" encoding="utf-8"?>
+<p:sld xmlns:a="http://schemas.openxmlformats.org/drawingml/2006/main" xmlns:p="http://schemas.openxmlformats.org/presentationml/2006/main" xmlns:r="http://schemas.openxmlformats.org/officeDocument/2006/relationships">
+  <p:cSld>
+    <p:spTree>
+      <p:nvGrpSpPr>
+        <p:cNvPr id="1" name=""/>
+        <p:cNvGrpSpPr/>
+        <p:nvPr/>
+      </p:nvGrpSpPr>
+      <p:grpSpPr/>
+      <p:sp>
+        <p:nvSpPr>
+          <p:cNvPr id="2" name="Rectangle 1"/>
+          <p:cNvSpPr/>
+          <p:nvPr/>
+        </p:nvSpPr>
+        <p:spPr>
+          <a:xfrm>
+            <a:off x="0" y="0"/>
             <a:ext cx="12191695" cy="6858000"/>
           </a:xfrm>
           <a:prstGeom prst="rect">
@@ -5971,7 +6148,7 @@
                 <a:ea typeface="맑은 고딕"/>
                 <a:cs typeface="맑은 고딕"/>
               </a:rPr>
-              <a:t>Aniverse · 온프레미스 3-tier → AWS   |   2/14</a:t>
+              <a:t>Aniverse · 온프레미스 3-tier → AWS   |   2/15</a:t>
             </a:r>
           </a:p>
         </p:txBody>
@@ -6647,7 +6824,7 @@
                 <a:ea typeface="맑은 고딕"/>
                 <a:cs typeface="맑은 고딕"/>
               </a:rPr>
-              <a:t>Aniverse · 온프레미스 3-tier → AWS   |   3/14</a:t>
+              <a:t>Aniverse · 온프레미스 3-tier → AWS   |   3/15</a:t>
             </a:r>
           </a:p>
         </p:txBody>
@@ -6823,7 +7000,7 @@
                 <a:ea typeface="맑은 고딕"/>
                 <a:cs typeface="맑은 고딕"/>
               </a:rPr>
-              <a:t>Aniverse · 온프레미스 3-tier → AWS   |   4/14</a:t>
+              <a:t>Aniverse · 온프레미스 3-tier → AWS   |   4/15</a:t>
             </a:r>
           </a:p>
         </p:txBody>
@@ -7415,7 +7592,7 @@
                 <a:ea typeface="맑은 고딕"/>
                 <a:cs typeface="맑은 고딕"/>
               </a:rPr>
-              <a:t>Aniverse · 온프레미스 3-tier → AWS   |   5/14</a:t>
+              <a:t>Aniverse · 온프레미스 3-tier → AWS   |   5/15</a:t>
             </a:r>
           </a:p>
         </p:txBody>
@@ -7591,7 +7768,7 @@
                 <a:ea typeface="맑은 고딕"/>
                 <a:cs typeface="맑은 고딕"/>
               </a:rPr>
-              <a:t>Aniverse · 온프레미스 3-tier → AWS   |   6/14</a:t>
+              <a:t>Aniverse · 온프레미스 3-tier → AWS   |   6/15</a:t>
             </a:r>
           </a:p>
         </p:txBody>
@@ -7767,7 +7944,7 @@
                 <a:ea typeface="맑은 고딕"/>
                 <a:cs typeface="맑은 고딕"/>
               </a:rPr>
-              <a:t>Aniverse · 온프레미스 3-tier → AWS   |   7/14</a:t>
+              <a:t>Aniverse · 온프레미스 3-tier → AWS   |   7/15</a:t>
             </a:r>
           </a:p>
         </p:txBody>
@@ -8108,83 +8285,101 @@
           <a:p>
             <a:pPr>
               <a:spcBef>
-                <a:spcPts val="700"/>
-              </a:spcBef>
-            </a:pPr>
-            <a:r>
-              <a:rPr sz="1300" b="0">
-                <a:solidFill>
-                  <a:srgbClr val="0F172A"/>
-                </a:solidFill>
-                <a:latin typeface="맑은 고딕"/>
-                <a:ea typeface="맑은 고딕"/>
-                <a:cs typeface="맑은 고딕"/>
-              </a:rPr>
-              <a:t>1) 팀원이 모듈 PR로 기능 단위 작성</a:t>
+                <a:spcPts val="500"/>
+              </a:spcBef>
+            </a:pPr>
+            <a:r>
+              <a:rPr sz="1200" b="0">
+                <a:solidFill>
+                  <a:srgbClr val="0F172A"/>
+                </a:solidFill>
+                <a:latin typeface="맑은 고딕"/>
+                <a:ea typeface="맑은 고딕"/>
+                <a:cs typeface="맑은 고딕"/>
+              </a:rPr>
+              <a:t>1) S3 + DynamoDB로 Remote State 환경 선구축</a:t>
             </a:r>
           </a:p>
           <a:p>
             <a:pPr>
               <a:spcBef>
-                <a:spcPts val="700"/>
-              </a:spcBef>
-            </a:pPr>
-            <a:r>
-              <a:rPr sz="1300" b="0">
-                <a:solidFill>
-                  <a:srgbClr val="0F172A"/>
-                </a:solidFill>
-                <a:latin typeface="맑은 고딕"/>
-                <a:ea typeface="맑은 고딕"/>
-                <a:cs typeface="맑은 고딕"/>
-              </a:rPr>
-              <a:t>2) outputs.tf 로 vpc_id, sg_id 등 연결</a:t>
+                <a:spcPts val="500"/>
+              </a:spcBef>
+            </a:pPr>
+            <a:r>
+              <a:rPr sz="1200" b="0">
+                <a:solidFill>
+                  <a:srgbClr val="0F172A"/>
+                </a:solidFill>
+                <a:latin typeface="맑은 고딕"/>
+                <a:ea typeface="맑은 고딕"/>
+                <a:cs typeface="맑은 고딕"/>
+              </a:rPr>
+              <a:t>2) 팀원이 모듈 PR로 기능 단위 작성</a:t>
             </a:r>
           </a:p>
           <a:p>
             <a:pPr>
               <a:spcBef>
-                <a:spcPts val="700"/>
-              </a:spcBef>
-            </a:pPr>
-            <a:r>
-              <a:rPr sz="1300" b="0">
-                <a:solidFill>
-                  <a:srgbClr val="0F172A"/>
-                </a:solidFill>
-                <a:latin typeface="맑은 고딕"/>
-                <a:ea typeface="맑은 고딕"/>
-                <a:cs typeface="맑은 고딕"/>
-              </a:rPr>
-              <a:t>3) environments/dev/main.tf 에서 module 호출</a:t>
+                <a:spcPts val="500"/>
+              </a:spcBef>
+            </a:pPr>
+            <a:r>
+              <a:rPr sz="1200" b="0">
+                <a:solidFill>
+                  <a:srgbClr val="0F172A"/>
+                </a:solidFill>
+                <a:latin typeface="맑은 고딕"/>
+                <a:ea typeface="맑은 고딕"/>
+                <a:cs typeface="맑은 고딕"/>
+              </a:rPr>
+              <a:t>3) outputs.tf 로 vpc_id, sg_id 등 연결</a:t>
             </a:r>
           </a:p>
           <a:p>
             <a:pPr>
               <a:spcBef>
-                <a:spcPts val="700"/>
-              </a:spcBef>
-            </a:pPr>
-            <a:r>
-              <a:rPr sz="1300" b="0">
-                <a:solidFill>
-                  <a:srgbClr val="0F172A"/>
-                </a:solidFill>
-                <a:latin typeface="맑은 고딕"/>
-                <a:ea typeface="맑은 고딕"/>
-                <a:cs typeface="맑은 고딕"/>
-              </a:rPr>
-              <a:t>4) terraform plan / apply 로 한 번에 반영</a:t>
+                <a:spcPts val="500"/>
+              </a:spcBef>
+            </a:pPr>
+            <a:r>
+              <a:rPr sz="1200" b="0">
+                <a:solidFill>
+                  <a:srgbClr val="0F172A"/>
+                </a:solidFill>
+                <a:latin typeface="맑은 고딕"/>
+                <a:ea typeface="맑은 고딕"/>
+                <a:cs typeface="맑은 고딕"/>
+              </a:rPr>
+              <a:t>4) environments/dev/main.tf 에서 module 호출</a:t>
             </a:r>
           </a:p>
           <a:p>
             <a:pPr>
               <a:spcBef>
-                <a:spcPts val="700"/>
-              </a:spcBef>
-            </a:pPr>
-            <a:r>
-              <a:rPr sz="1300" b="0">
+                <a:spcPts val="500"/>
+              </a:spcBef>
+            </a:pPr>
+            <a:r>
+              <a:rPr sz="1200" b="0">
+                <a:solidFill>
+                  <a:srgbClr val="0F172A"/>
+                </a:solidFill>
+                <a:latin typeface="맑은 고딕"/>
+                <a:ea typeface="맑은 고딕"/>
+                <a:cs typeface="맑은 고딕"/>
+              </a:rPr>
+              <a:t>5) terraform plan / apply 로 한 번에 반영</a:t>
+            </a:r>
+          </a:p>
+          <a:p>
+            <a:pPr>
+              <a:spcBef>
+                <a:spcPts val="500"/>
+              </a:spcBef>
+            </a:pPr>
+            <a:r>
+              <a:rPr sz="1200" b="0">
                 <a:solidFill>
                   <a:srgbClr val="0F172A"/>
                 </a:solidFill>
@@ -8198,11 +8393,11 @@
           <a:p>
             <a:pPr>
               <a:spcBef>
-                <a:spcPts val="700"/>
-              </a:spcBef>
-            </a:pPr>
-            <a:r>
-              <a:rPr sz="1300" b="0">
+                <a:spcPts val="500"/>
+              </a:spcBef>
+            </a:pPr>
+            <a:r>
+              <a:rPr sz="1200" b="0">
                 <a:solidFill>
                   <a:srgbClr val="0F172A"/>
                 </a:solidFill>
@@ -8216,11 +8411,11 @@
           <a:p>
             <a:pPr>
               <a:spcBef>
-                <a:spcPts val="700"/>
-              </a:spcBef>
-            </a:pPr>
-            <a:r>
-              <a:rPr sz="1300" b="0">
+                <a:spcPts val="500"/>
+              </a:spcBef>
+            </a:pPr>
+            <a:r>
+              <a:rPr sz="1200" b="0">
                 <a:solidFill>
                   <a:srgbClr val="0F172A"/>
                 </a:solidFill>
@@ -8234,11 +8429,11 @@
           <a:p>
             <a:pPr>
               <a:spcBef>
-                <a:spcPts val="700"/>
-              </a:spcBef>
-            </a:pPr>
-            <a:r>
-              <a:rPr sz="1300" b="0">
+                <a:spcPts val="500"/>
+              </a:spcBef>
+            </a:pPr>
+            <a:r>
+              <a:rPr sz="1200" b="0">
                 <a:solidFill>
                   <a:srgbClr val="0F172A"/>
                 </a:solidFill>
@@ -8247,6 +8442,24 @@
                 <a:cs typeface="맑은 고딕"/>
               </a:rPr>
               <a:t>• 서버 ‘기억 의존’ 감소</a:t>
+            </a:r>
+          </a:p>
+          <a:p>
+            <a:pPr>
+              <a:spcBef>
+                <a:spcPts val="500"/>
+              </a:spcBef>
+            </a:pPr>
+            <a:r>
+              <a:rPr sz="1200" b="0">
+                <a:solidFill>
+                  <a:srgbClr val="0F172A"/>
+                </a:solidFill>
+                <a:latin typeface="맑은 고딕"/>
+                <a:ea typeface="맑은 고딕"/>
+                <a:cs typeface="맑은 고딕"/>
+              </a:rPr>
+              <a:t>• 팀 전체가 충돌 없이 동시 작업 가능 (State Lock)</a:t>
             </a:r>
           </a:p>
         </p:txBody>
@@ -8283,7 +8496,7 @@
                 <a:ea typeface="맑은 고딕"/>
                 <a:cs typeface="맑은 고딕"/>
               </a:rPr>
-              <a:t>Aniverse · 온프레미스 3-tier → AWS   |   8/14</a:t>
+              <a:t>Aniverse · 온프레미스 3-tier → AWS   |   8/15</a:t>
             </a:r>
           </a:p>
         </p:txBody>
@@ -8380,7 +8593,7 @@
                 <a:ea typeface="맑은 고딕"/>
                 <a:cs typeface="맑은 고딕"/>
               </a:rPr>
-              <a:t>4. GitHub Actions (1)</a:t>
+              <a:t>3. 데이터베이스·스토리지 구성</a:t>
             </a:r>
           </a:p>
           <a:p>
@@ -8398,38 +8611,526 @@
                 <a:ea typeface="맑은 고딕"/>
                 <a:cs typeface="맑은 고딕"/>
               </a:rPr>
-              <a:t>인프라 저장소 / 앱 저장소를 나눠 자동화</a:t>
-            </a:r>
-          </a:p>
-        </p:txBody>
-      </p:sp>
-      <p:pic>
-        <p:nvPicPr>
-          <p:cNvPr id="4" name="Picture 3" descr="04_github_actions.png"/>
-          <p:cNvPicPr>
-            <a:picLocks noChangeAspect="1"/>
-          </p:cNvPicPr>
+              <a:t>김윤주 Data &amp; Storage — RDS · EFS · S3 · Remote State</a:t>
+            </a:r>
+          </a:p>
+        </p:txBody>
+      </p:sp>
+      <p:sp>
+        <p:nvSpPr>
+          <p:cNvPr id="4" name="Rounded Rectangle 3"/>
+          <p:cNvSpPr/>
           <p:nvPr/>
-        </p:nvPicPr>
-        <p:blipFill>
-          <a:blip r:embed="rId2"/>
-          <a:stretch>
-            <a:fillRect/>
-          </a:stretch>
-        </p:blipFill>
-        <p:spPr>
-          <a:xfrm>
-            <a:off x="274320" y="960120"/>
-            <a:ext cx="11612880" cy="6532245"/>
-          </a:xfrm>
-          <a:prstGeom prst="rect">
+        </p:nvSpPr>
+        <p:spPr>
+          <a:xfrm>
+            <a:off x="274320" y="1097280"/>
+            <a:ext cx="2788920" cy="4846320"/>
+          </a:xfrm>
+          <a:prstGeom prst="roundRect">
             <a:avLst/>
           </a:prstGeom>
-        </p:spPr>
-      </p:pic>
-      <p:sp>
-        <p:nvSpPr>
-          <p:cNvPr id="5" name="TextBox 4"/>
+          <a:solidFill>
+            <a:srgbClr val="F8FAFC"/>
+          </a:solidFill>
+          <a:ln w="19050">
+            <a:solidFill>
+              <a:srgbClr val="16A34A"/>
+            </a:solidFill>
+          </a:ln>
+        </p:spPr>
+        <p:style>
+          <a:lnRef idx="1">
+            <a:schemeClr val="accent1"/>
+          </a:lnRef>
+          <a:fillRef idx="3">
+            <a:schemeClr val="accent1"/>
+          </a:fillRef>
+          <a:effectRef idx="2">
+            <a:schemeClr val="accent1"/>
+          </a:effectRef>
+          <a:fontRef idx="minor">
+            <a:schemeClr val="lt1"/>
+          </a:fontRef>
+        </p:style>
+        <p:txBody>
+          <a:bodyPr rtlCol="0" anchor="ctr" wrap="square"/>
+          <a:lstStyle/>
+          <a:p>
+            <a:pPr algn="ctr"/>
+            <a:r>
+              <a:rPr sz="1600" b="1">
+                <a:solidFill>
+                  <a:srgbClr val="16A34A"/>
+                </a:solidFill>
+                <a:latin typeface="맑은 고딕"/>
+                <a:ea typeface="맑은 고딕"/>
+                <a:cs typeface="맑은 고딕"/>
+              </a:rPr>
+              <a:t>RDS (MariaDB)</a:t>
+            </a:r>
+          </a:p>
+          <a:p>
+            <a:pPr algn="ctr">
+              <a:spcBef>
+                <a:spcPts val="1000"/>
+              </a:spcBef>
+            </a:pPr>
+            <a:r>
+              <a:rPr sz="1300" b="0">
+                <a:solidFill>
+                  <a:srgbClr val="0F172A"/>
+                </a:solidFill>
+                <a:latin typeface="맑은 고딕"/>
+                <a:ea typeface="맑은 고딕"/>
+                <a:cs typeface="맑은 고딕"/>
+              </a:rPr>
+              <a:t>• modules/database</a:t>
+            </a:r>
+          </a:p>
+          <a:p>
+            <a:pPr algn="ctr">
+              <a:spcBef>
+                <a:spcPts val="1000"/>
+              </a:spcBef>
+            </a:pPr>
+            <a:r>
+              <a:rPr sz="1300" b="0">
+                <a:solidFill>
+                  <a:srgbClr val="0F172A"/>
+                </a:solidFill>
+                <a:latin typeface="맑은 고딕"/>
+                <a:ea typeface="맑은 고딕"/>
+                <a:cs typeface="맑은 고딕"/>
+              </a:rPr>
+              <a:t>• 앱 DB를 관리형으로 이전</a:t>
+            </a:r>
+          </a:p>
+          <a:p>
+            <a:pPr algn="ctr">
+              <a:spcBef>
+                <a:spcPts val="1000"/>
+              </a:spcBef>
+            </a:pPr>
+            <a:r>
+              <a:rPr sz="1300" b="0">
+                <a:solidFill>
+                  <a:srgbClr val="0F172A"/>
+                </a:solidFill>
+                <a:latin typeface="맑은 고딕"/>
+                <a:ea typeface="맑은 고딕"/>
+                <a:cs typeface="맑은 고딕"/>
+              </a:rPr>
+              <a:t>• Private subnet 배치</a:t>
+            </a:r>
+          </a:p>
+          <a:p>
+            <a:pPr algn="ctr">
+              <a:spcBef>
+                <a:spcPts val="1000"/>
+              </a:spcBef>
+            </a:pPr>
+            <a:r>
+              <a:rPr sz="1300" b="0">
+                <a:solidFill>
+                  <a:srgbClr val="0F172A"/>
+                </a:solidFill>
+                <a:latin typeface="맑은 고딕"/>
+                <a:ea typeface="맑은 고딕"/>
+                <a:cs typeface="맑은 고딕"/>
+              </a:rPr>
+              <a:t>• 스냅샷 · Secrets 연동</a:t>
+            </a:r>
+          </a:p>
+        </p:txBody>
+      </p:sp>
+      <p:sp>
+        <p:nvSpPr>
+          <p:cNvPr id="5" name="Rounded Rectangle 4"/>
+          <p:cNvSpPr/>
+          <p:nvPr/>
+        </p:nvSpPr>
+        <p:spPr>
+          <a:xfrm>
+            <a:off x="3200400" y="1097280"/>
+            <a:ext cx="2788920" cy="4846320"/>
+          </a:xfrm>
+          <a:prstGeom prst="roundRect">
+            <a:avLst/>
+          </a:prstGeom>
+          <a:solidFill>
+            <a:srgbClr val="F8FAFC"/>
+          </a:solidFill>
+          <a:ln w="19050">
+            <a:solidFill>
+              <a:srgbClr val="0D9488"/>
+            </a:solidFill>
+          </a:ln>
+        </p:spPr>
+        <p:style>
+          <a:lnRef idx="1">
+            <a:schemeClr val="accent1"/>
+          </a:lnRef>
+          <a:fillRef idx="3">
+            <a:schemeClr val="accent1"/>
+          </a:fillRef>
+          <a:effectRef idx="2">
+            <a:schemeClr val="accent1"/>
+          </a:effectRef>
+          <a:fontRef idx="minor">
+            <a:schemeClr val="lt1"/>
+          </a:fontRef>
+        </p:style>
+        <p:txBody>
+          <a:bodyPr rtlCol="0" anchor="ctr" wrap="square"/>
+          <a:lstStyle/>
+          <a:p>
+            <a:pPr algn="ctr"/>
+            <a:r>
+              <a:rPr sz="1600" b="1">
+                <a:solidFill>
+                  <a:srgbClr val="0D9488"/>
+                </a:solidFill>
+                <a:latin typeface="맑은 고딕"/>
+                <a:ea typeface="맑은 고딕"/>
+                <a:cs typeface="맑은 고딕"/>
+              </a:rPr>
+              <a:t>EFS</a:t>
+            </a:r>
+          </a:p>
+          <a:p>
+            <a:pPr algn="ctr">
+              <a:spcBef>
+                <a:spcPts val="1000"/>
+              </a:spcBef>
+            </a:pPr>
+            <a:r>
+              <a:rPr sz="1300" b="0">
+                <a:solidFill>
+                  <a:srgbClr val="0F172A"/>
+                </a:solidFill>
+                <a:latin typeface="맑은 고딕"/>
+                <a:ea typeface="맑은 고딕"/>
+                <a:cs typeface="맑은 고딕"/>
+              </a:rPr>
+              <a:t>• modules/storage</a:t>
+            </a:r>
+          </a:p>
+          <a:p>
+            <a:pPr algn="ctr">
+              <a:spcBef>
+                <a:spcPts val="1000"/>
+              </a:spcBef>
+            </a:pPr>
+            <a:r>
+              <a:rPr sz="1300" b="0">
+                <a:solidFill>
+                  <a:srgbClr val="0F172A"/>
+                </a:solidFill>
+                <a:latin typeface="맑은 고딕"/>
+                <a:ea typeface="맑은 고딕"/>
+                <a:cs typeface="맑은 고딕"/>
+              </a:rPr>
+              <a:t>• 온프렘 NFS 대체</a:t>
+            </a:r>
+          </a:p>
+          <a:p>
+            <a:pPr algn="ctr">
+              <a:spcBef>
+                <a:spcPts val="1000"/>
+              </a:spcBef>
+            </a:pPr>
+            <a:r>
+              <a:rPr sz="1300" b="0">
+                <a:solidFill>
+                  <a:srgbClr val="0F172A"/>
+                </a:solidFill>
+                <a:latin typeface="맑은 고딕"/>
+                <a:ea typeface="맑은 고딕"/>
+                <a:cs typeface="맑은 고딕"/>
+              </a:rPr>
+              <a:t>• ASG EC2 간 공유 마운트</a:t>
+            </a:r>
+          </a:p>
+          <a:p>
+            <a:pPr algn="ctr">
+              <a:spcBef>
+                <a:spcPts val="1000"/>
+              </a:spcBef>
+            </a:pPr>
+            <a:r>
+              <a:rPr sz="1300" b="0">
+                <a:solidFill>
+                  <a:srgbClr val="0F172A"/>
+                </a:solidFill>
+                <a:latin typeface="맑은 고딕"/>
+                <a:ea typeface="맑은 고딕"/>
+                <a:cs typeface="맑은 고딕"/>
+              </a:rPr>
+              <a:t>• 미디어·업로드 파일 공유</a:t>
+            </a:r>
+          </a:p>
+        </p:txBody>
+      </p:sp>
+      <p:sp>
+        <p:nvSpPr>
+          <p:cNvPr id="6" name="Rounded Rectangle 5"/>
+          <p:cNvSpPr/>
+          <p:nvPr/>
+        </p:nvSpPr>
+        <p:spPr>
+          <a:xfrm>
+            <a:off x="6126480" y="1097280"/>
+            <a:ext cx="2788920" cy="4846320"/>
+          </a:xfrm>
+          <a:prstGeom prst="roundRect">
+            <a:avLst/>
+          </a:prstGeom>
+          <a:solidFill>
+            <a:srgbClr val="F8FAFC"/>
+          </a:solidFill>
+          <a:ln w="19050">
+            <a:solidFill>
+              <a:srgbClr val="2563EB"/>
+            </a:solidFill>
+          </a:ln>
+        </p:spPr>
+        <p:style>
+          <a:lnRef idx="1">
+            <a:schemeClr val="accent1"/>
+          </a:lnRef>
+          <a:fillRef idx="3">
+            <a:schemeClr val="accent1"/>
+          </a:fillRef>
+          <a:effectRef idx="2">
+            <a:schemeClr val="accent1"/>
+          </a:effectRef>
+          <a:fontRef idx="minor">
+            <a:schemeClr val="lt1"/>
+          </a:fontRef>
+        </p:style>
+        <p:txBody>
+          <a:bodyPr rtlCol="0" anchor="ctr" wrap="square"/>
+          <a:lstStyle/>
+          <a:p>
+            <a:pPr algn="ctr"/>
+            <a:r>
+              <a:rPr sz="1600" b="1">
+                <a:solidFill>
+                  <a:srgbClr val="2563EB"/>
+                </a:solidFill>
+                <a:latin typeface="맑은 고딕"/>
+                <a:ea typeface="맑은 고딕"/>
+                <a:cs typeface="맑은 고딕"/>
+              </a:rPr>
+              <a:t>S3 + DynamoDB</a:t>
+            </a:r>
+          </a:p>
+          <a:p>
+            <a:pPr algn="ctr">
+              <a:spcBef>
+                <a:spcPts val="1000"/>
+              </a:spcBef>
+            </a:pPr>
+            <a:r>
+              <a:rPr sz="1300" b="0">
+                <a:solidFill>
+                  <a:srgbClr val="0F172A"/>
+                </a:solidFill>
+                <a:latin typeface="맑은 고딕"/>
+                <a:ea typeface="맑은 고딕"/>
+                <a:cs typeface="맑은 고딕"/>
+              </a:rPr>
+              <a:t>• Remote State 선구축</a:t>
+            </a:r>
+          </a:p>
+          <a:p>
+            <a:pPr algn="ctr">
+              <a:spcBef>
+                <a:spcPts val="1000"/>
+              </a:spcBef>
+            </a:pPr>
+            <a:r>
+              <a:rPr sz="1300" b="0">
+                <a:solidFill>
+                  <a:srgbClr val="0F172A"/>
+                </a:solidFill>
+                <a:latin typeface="맑은 고딕"/>
+                <a:ea typeface="맑은 고딕"/>
+                <a:cs typeface="맑은 고딕"/>
+              </a:rPr>
+              <a:t>• S3: tfstate 저장</a:t>
+            </a:r>
+          </a:p>
+          <a:p>
+            <a:pPr algn="ctr">
+              <a:spcBef>
+                <a:spcPts val="1000"/>
+              </a:spcBef>
+            </a:pPr>
+            <a:r>
+              <a:rPr sz="1300" b="0">
+                <a:solidFill>
+                  <a:srgbClr val="0F172A"/>
+                </a:solidFill>
+                <a:latin typeface="맑은 고딕"/>
+                <a:ea typeface="맑은 고딕"/>
+                <a:cs typeface="맑은 고딕"/>
+              </a:rPr>
+              <a:t>• DynamoDB: State Lock</a:t>
+            </a:r>
+          </a:p>
+          <a:p>
+            <a:pPr algn="ctr">
+              <a:spcBef>
+                <a:spcPts val="1000"/>
+              </a:spcBef>
+            </a:pPr>
+            <a:r>
+              <a:rPr sz="1300" b="0">
+                <a:solidFill>
+                  <a:srgbClr val="0F172A"/>
+                </a:solidFill>
+                <a:latin typeface="맑은 고딕"/>
+                <a:ea typeface="맑은 고딕"/>
+                <a:cs typeface="맑은 고딕"/>
+              </a:rPr>
+              <a:t>• 팀 동시 apply 충돌 방지</a:t>
+            </a:r>
+          </a:p>
+        </p:txBody>
+      </p:sp>
+      <p:sp>
+        <p:nvSpPr>
+          <p:cNvPr id="7" name="Rounded Rectangle 6"/>
+          <p:cNvSpPr/>
+          <p:nvPr/>
+        </p:nvSpPr>
+        <p:spPr>
+          <a:xfrm>
+            <a:off x="9052560" y="1097280"/>
+            <a:ext cx="2788920" cy="4846320"/>
+          </a:xfrm>
+          <a:prstGeom prst="roundRect">
+            <a:avLst/>
+          </a:prstGeom>
+          <a:solidFill>
+            <a:srgbClr val="F8FAFC"/>
+          </a:solidFill>
+          <a:ln w="19050">
+            <a:solidFill>
+              <a:srgbClr val="EA580C"/>
+            </a:solidFill>
+          </a:ln>
+        </p:spPr>
+        <p:style>
+          <a:lnRef idx="1">
+            <a:schemeClr val="accent1"/>
+          </a:lnRef>
+          <a:fillRef idx="3">
+            <a:schemeClr val="accent1"/>
+          </a:fillRef>
+          <a:effectRef idx="2">
+            <a:schemeClr val="accent1"/>
+          </a:effectRef>
+          <a:fontRef idx="minor">
+            <a:schemeClr val="lt1"/>
+          </a:fontRef>
+        </p:style>
+        <p:txBody>
+          <a:bodyPr rtlCol="0" anchor="ctr" wrap="square"/>
+          <a:lstStyle/>
+          <a:p>
+            <a:pPr algn="ctr"/>
+            <a:r>
+              <a:rPr sz="1600" b="1">
+                <a:solidFill>
+                  <a:srgbClr val="EA580C"/>
+                </a:solidFill>
+                <a:latin typeface="맑은 고딕"/>
+                <a:ea typeface="맑은 고딕"/>
+                <a:cs typeface="맑은 고딕"/>
+              </a:rPr>
+              <a:t>S3 CORS + Lifecycle</a:t>
+            </a:r>
+          </a:p>
+          <a:p>
+            <a:pPr algn="ctr">
+              <a:spcBef>
+                <a:spcPts val="1000"/>
+              </a:spcBef>
+            </a:pPr>
+            <a:r>
+              <a:rPr sz="1300" b="0">
+                <a:solidFill>
+                  <a:srgbClr val="0F172A"/>
+                </a:solidFill>
+                <a:latin typeface="맑은 고딕"/>
+                <a:ea typeface="맑은 고딕"/>
+                <a:cs typeface="맑은 고딕"/>
+              </a:rPr>
+              <a:t>• 정적/미디어 버킷 정책</a:t>
+            </a:r>
+          </a:p>
+          <a:p>
+            <a:pPr algn="ctr">
+              <a:spcBef>
+                <a:spcPts val="1000"/>
+              </a:spcBef>
+            </a:pPr>
+            <a:r>
+              <a:rPr sz="1300" b="0">
+                <a:solidFill>
+                  <a:srgbClr val="0F172A"/>
+                </a:solidFill>
+                <a:latin typeface="맑은 고딕"/>
+                <a:ea typeface="맑은 고딕"/>
+                <a:cs typeface="맑은 고딕"/>
+              </a:rPr>
+              <a:t>• CORS: 브라우저 GET 허용</a:t>
+            </a:r>
+          </a:p>
+          <a:p>
+            <a:pPr algn="ctr">
+              <a:spcBef>
+                <a:spcPts val="1000"/>
+              </a:spcBef>
+            </a:pPr>
+            <a:r>
+              <a:rPr sz="1300" b="0">
+                <a:solidFill>
+                  <a:srgbClr val="0F172A"/>
+                </a:solidFill>
+                <a:latin typeface="맑은 고딕"/>
+                <a:ea typeface="맑은 고딕"/>
+                <a:cs typeface="맑은 고딕"/>
+              </a:rPr>
+              <a:t>• Lifecycle: 오래된 객체 정리</a:t>
+            </a:r>
+          </a:p>
+          <a:p>
+            <a:pPr algn="ctr">
+              <a:spcBef>
+                <a:spcPts val="1000"/>
+              </a:spcBef>
+            </a:pPr>
+            <a:r>
+              <a:rPr sz="1300" b="0">
+                <a:solidFill>
+                  <a:srgbClr val="0F172A"/>
+                </a:solidFill>
+                <a:latin typeface="맑은 고딕"/>
+                <a:ea typeface="맑은 고딕"/>
+                <a:cs typeface="맑은 고딕"/>
+              </a:rPr>
+              <a:t>• 비용·운영 부담 감소</a:t>
+            </a:r>
+          </a:p>
+        </p:txBody>
+      </p:sp>
+      <p:sp>
+        <p:nvSpPr>
+          <p:cNvPr id="8" name="TextBox 7"/>
           <p:cNvSpPr txBox="1"/>
           <p:nvPr/>
         </p:nvSpPr>
@@ -8459,7 +9160,7 @@
                 <a:ea typeface="맑은 고딕"/>
                 <a:cs typeface="맑은 고딕"/>
               </a:rPr>
-              <a:t>Aniverse · 온프레미스 3-tier → AWS   |   9/14</a:t>
+              <a:t>Aniverse · 온프레미스 3-tier → AWS   |   9/15</a:t>
             </a:r>
           </a:p>
         </p:txBody>

</xml_diff>

<commit_message>
docs: add S3/EFS/RDS storage-roles slide to instructor PPT
Clarify what each store holds (DB rows vs shared media mount vs object/deploy files) after the data/storage overview.

Co-authored-by: ho0215 <ho0215@users.noreply.github.com>
</commit_message>
<xml_diff>
--- a/docs/presentation/ppt/Aniverse_발표_강사용.pptx
+++ b/docs/presentation/ppt/Aniverse_발표_강사용.pptx
@@ -21,6 +21,7 @@
     <p:sldId id="269" r:id="rId20"/>
     <p:sldId id="270" r:id="rId21"/>
     <p:sldId id="271" r:id="rId22"/>
+    <p:sldId id="272" r:id="rId23"/>
   </p:sldIdLst>
   <p:sldSz cx="12191695" cy="6858000" type="screen4x3"/>
   <p:notesSz cx="6858000" cy="9144000"/>
@@ -3328,7 +3329,7 @@
                 <a:ea typeface="맑은 고딕"/>
                 <a:cs typeface="맑은 고딕"/>
               </a:rPr>
-              <a:t>4. GitHub Actions (1)</a:t>
+              <a:t>3. S3 · EFS · RDS — 저장 역할 정리</a:t>
             </a:r>
           </a:p>
           <a:p>
@@ -3346,45 +3347,513 @@
                 <a:ea typeface="맑은 고딕"/>
                 <a:cs typeface="맑은 고딕"/>
               </a:rPr>
-              <a:t>인프라 저장소 / 앱 저장소를 나눠 자동화</a:t>
-            </a:r>
-          </a:p>
-        </p:txBody>
-      </p:sp>
-      <p:pic>
-        <p:nvPicPr>
-          <p:cNvPr id="4" name="Picture 3" descr="04_github_actions.png"/>
-          <p:cNvPicPr>
-            <a:picLocks noChangeAspect="1"/>
-          </p:cNvPicPr>
+              <a:t>같은 ‘데이터’라도 성격에 따라 저장소를 나눔</a:t>
+            </a:r>
+          </a:p>
+        </p:txBody>
+      </p:sp>
+      <p:sp>
+        <p:nvSpPr>
+          <p:cNvPr id="4" name="Rounded Rectangle 3"/>
+          <p:cNvSpPr/>
           <p:nvPr/>
-        </p:nvPicPr>
-        <p:blipFill>
-          <a:blip r:embed="rId2"/>
-          <a:stretch>
-            <a:fillRect/>
-          </a:stretch>
-        </p:blipFill>
-        <p:spPr>
-          <a:xfrm>
-            <a:off x="274320" y="960120"/>
-            <a:ext cx="11612880" cy="6532245"/>
-          </a:xfrm>
-          <a:prstGeom prst="rect">
+        </p:nvSpPr>
+        <p:spPr>
+          <a:xfrm>
+            <a:off x="320040" y="1051560"/>
+            <a:ext cx="3703320" cy="4709160"/>
+          </a:xfrm>
+          <a:prstGeom prst="roundRect">
             <a:avLst/>
           </a:prstGeom>
-        </p:spPr>
-      </p:pic>
-      <p:sp>
-        <p:nvSpPr>
-          <p:cNvPr id="5" name="TextBox 4"/>
+          <a:solidFill>
+            <a:srgbClr val="F8FAFC"/>
+          </a:solidFill>
+          <a:ln w="19050">
+            <a:solidFill>
+              <a:srgbClr val="16A34A"/>
+            </a:solidFill>
+          </a:ln>
+        </p:spPr>
+        <p:style>
+          <a:lnRef idx="1">
+            <a:schemeClr val="accent1"/>
+          </a:lnRef>
+          <a:fillRef idx="3">
+            <a:schemeClr val="accent1"/>
+          </a:fillRef>
+          <a:effectRef idx="2">
+            <a:schemeClr val="accent1"/>
+          </a:effectRef>
+          <a:fontRef idx="minor">
+            <a:schemeClr val="lt1"/>
+          </a:fontRef>
+        </p:style>
+        <p:txBody>
+          <a:bodyPr rtlCol="0" anchor="ctr" wrap="square"/>
+          <a:lstStyle/>
+          <a:p>
+            <a:pPr algn="ctr"/>
+            <a:r>
+              <a:rPr sz="1800" b="1">
+                <a:solidFill>
+                  <a:srgbClr val="16A34A"/>
+                </a:solidFill>
+                <a:latin typeface="맑은 고딕"/>
+                <a:ea typeface="맑은 고딕"/>
+                <a:cs typeface="맑은 고딕"/>
+              </a:rPr>
+              <a:t>RDS (MariaDB)</a:t>
+            </a:r>
+          </a:p>
+          <a:p>
+            <a:pPr algn="ctr">
+              <a:spcBef>
+                <a:spcPts val="800"/>
+              </a:spcBef>
+            </a:pPr>
+            <a:r>
+              <a:rPr sz="1300" b="1">
+                <a:solidFill>
+                  <a:srgbClr val="475569"/>
+                </a:solidFill>
+                <a:latin typeface="맑은 고딕"/>
+                <a:ea typeface="맑은 고딕"/>
+                <a:cs typeface="맑은 고딕"/>
+              </a:rPr>
+              <a:t>구조화된 DB 데이터</a:t>
+            </a:r>
+          </a:p>
+          <a:p>
+            <a:pPr algn="ctr">
+              <a:spcBef>
+                <a:spcPts val="800"/>
+              </a:spcBef>
+            </a:pPr>
+            <a:r>
+              <a:rPr sz="1300" b="0">
+                <a:solidFill>
+                  <a:srgbClr val="0F172A"/>
+                </a:solidFill>
+                <a:latin typeface="맑은 고딕"/>
+                <a:ea typeface="맑은 고딕"/>
+                <a:cs typeface="맑은 고딕"/>
+              </a:rPr>
+              <a:t>• 회원 · 로그인 계정</a:t>
+            </a:r>
+          </a:p>
+          <a:p>
+            <a:pPr algn="ctr">
+              <a:spcBef>
+                <a:spcPts val="800"/>
+              </a:spcBef>
+            </a:pPr>
+            <a:r>
+              <a:rPr sz="1300" b="0">
+                <a:solidFill>
+                  <a:srgbClr val="0F172A"/>
+                </a:solidFill>
+                <a:latin typeface="맑은 고딕"/>
+                <a:ea typeface="맑은 고딕"/>
+                <a:cs typeface="맑은 고딕"/>
+              </a:rPr>
+              <a:t>• 커뮤니티 글 · 댓글 · 좋아요</a:t>
+            </a:r>
+          </a:p>
+          <a:p>
+            <a:pPr algn="ctr">
+              <a:spcBef>
+                <a:spcPts val="800"/>
+              </a:spcBef>
+            </a:pPr>
+            <a:r>
+              <a:rPr sz="1300" b="0">
+                <a:solidFill>
+                  <a:srgbClr val="0F172A"/>
+                </a:solidFill>
+                <a:latin typeface="맑은 고딕"/>
+                <a:ea typeface="맑은 고딕"/>
+                <a:cs typeface="맑은 고딕"/>
+              </a:rPr>
+              <a:t>• 거래 상품 정보 · 채팅 메타</a:t>
+            </a:r>
+          </a:p>
+          <a:p>
+            <a:pPr algn="ctr">
+              <a:spcBef>
+                <a:spcPts val="800"/>
+              </a:spcBef>
+            </a:pPr>
+            <a:r>
+              <a:rPr sz="1300" b="0">
+                <a:solidFill>
+                  <a:srgbClr val="0F172A"/>
+                </a:solidFill>
+                <a:latin typeface="맑은 고딕"/>
+                <a:ea typeface="맑은 고딕"/>
+                <a:cs typeface="맑은 고딕"/>
+              </a:rPr>
+              <a:t>• 창작물 제목·본문·상태</a:t>
+            </a:r>
+          </a:p>
+          <a:p>
+            <a:pPr algn="ctr">
+              <a:spcBef>
+                <a:spcPts val="800"/>
+              </a:spcBef>
+            </a:pPr>
+            <a:r>
+              <a:rPr sz="1300" b="0">
+                <a:solidFill>
+                  <a:srgbClr val="0F172A"/>
+                </a:solidFill>
+                <a:latin typeface="맑은 고딕"/>
+                <a:ea typeface="맑은 고딕"/>
+                <a:cs typeface="맑은 고딕"/>
+              </a:rPr>
+              <a:t>• 관계·검색·트랜잭션이 필요한 값</a:t>
+            </a:r>
+          </a:p>
+        </p:txBody>
+      </p:sp>
+      <p:sp>
+        <p:nvSpPr>
+          <p:cNvPr id="5" name="Rounded Rectangle 4"/>
+          <p:cNvSpPr/>
+          <p:nvPr/>
+        </p:nvSpPr>
+        <p:spPr>
+          <a:xfrm>
+            <a:off x="4206240" y="1051560"/>
+            <a:ext cx="3703320" cy="4709160"/>
+          </a:xfrm>
+          <a:prstGeom prst="roundRect">
+            <a:avLst/>
+          </a:prstGeom>
+          <a:solidFill>
+            <a:srgbClr val="F8FAFC"/>
+          </a:solidFill>
+          <a:ln w="19050">
+            <a:solidFill>
+              <a:srgbClr val="0D9488"/>
+            </a:solidFill>
+          </a:ln>
+        </p:spPr>
+        <p:style>
+          <a:lnRef idx="1">
+            <a:schemeClr val="accent1"/>
+          </a:lnRef>
+          <a:fillRef idx="3">
+            <a:schemeClr val="accent1"/>
+          </a:fillRef>
+          <a:effectRef idx="2">
+            <a:schemeClr val="accent1"/>
+          </a:effectRef>
+          <a:fontRef idx="minor">
+            <a:schemeClr val="lt1"/>
+          </a:fontRef>
+        </p:style>
+        <p:txBody>
+          <a:bodyPr rtlCol="0" anchor="ctr" wrap="square"/>
+          <a:lstStyle/>
+          <a:p>
+            <a:pPr algn="ctr"/>
+            <a:r>
+              <a:rPr sz="1800" b="1">
+                <a:solidFill>
+                  <a:srgbClr val="0D9488"/>
+                </a:solidFill>
+                <a:latin typeface="맑은 고딕"/>
+                <a:ea typeface="맑은 고딕"/>
+                <a:cs typeface="맑은 고딕"/>
+              </a:rPr>
+              <a:t>EFS</a:t>
+            </a:r>
+          </a:p>
+          <a:p>
+            <a:pPr algn="ctr">
+              <a:spcBef>
+                <a:spcPts val="800"/>
+              </a:spcBef>
+            </a:pPr>
+            <a:r>
+              <a:rPr sz="1300" b="1">
+                <a:solidFill>
+                  <a:srgbClr val="475569"/>
+                </a:solidFill>
+                <a:latin typeface="맑은 고딕"/>
+                <a:ea typeface="맑은 고딕"/>
+                <a:cs typeface="맑은 고딕"/>
+              </a:rPr>
+              <a:t>ASG가 공유하는 파일 공간</a:t>
+            </a:r>
+          </a:p>
+          <a:p>
+            <a:pPr algn="ctr">
+              <a:spcBef>
+                <a:spcPts val="800"/>
+              </a:spcBef>
+            </a:pPr>
+            <a:r>
+              <a:rPr sz="1300" b="0">
+                <a:solidFill>
+                  <a:srgbClr val="0F172A"/>
+                </a:solidFill>
+                <a:latin typeface="맑은 고딕"/>
+                <a:ea typeface="맑은 고딕"/>
+                <a:cs typeface="맑은 고딕"/>
+              </a:rPr>
+              <a:t>• EC2 media/ 경로에 NFS 마운트</a:t>
+            </a:r>
+          </a:p>
+          <a:p>
+            <a:pPr algn="ctr">
+              <a:spcBef>
+                <a:spcPts val="800"/>
+              </a:spcBef>
+            </a:pPr>
+            <a:r>
+              <a:rPr sz="1300" b="0">
+                <a:solidFill>
+                  <a:srgbClr val="0F172A"/>
+                </a:solidFill>
+                <a:latin typeface="맑은 고딕"/>
+                <a:ea typeface="맑은 고딕"/>
+                <a:cs typeface="맑은 고딕"/>
+              </a:rPr>
+              <a:t>• 인스턴스 교체돼도 파일 유지</a:t>
+            </a:r>
+          </a:p>
+          <a:p>
+            <a:pPr algn="ctr">
+              <a:spcBef>
+                <a:spcPts val="800"/>
+              </a:spcBef>
+            </a:pPr>
+            <a:r>
+              <a:rPr sz="1300" b="0">
+                <a:solidFill>
+                  <a:srgbClr val="0F172A"/>
+                </a:solidFill>
+                <a:latin typeface="맑은 고딕"/>
+                <a:ea typeface="맑은 고딕"/>
+                <a:cs typeface="맑은 고딕"/>
+              </a:rPr>
+              <a:t>• 여러 대 EC2가 같은 media 공유</a:t>
+            </a:r>
+          </a:p>
+          <a:p>
+            <a:pPr algn="ctr">
+              <a:spcBef>
+                <a:spcPts val="800"/>
+              </a:spcBef>
+            </a:pPr>
+            <a:r>
+              <a:rPr sz="1300" b="0">
+                <a:solidFill>
+                  <a:srgbClr val="0F172A"/>
+                </a:solidFill>
+                <a:latin typeface="맑은 고딕"/>
+                <a:ea typeface="맑은 고딕"/>
+                <a:cs typeface="맑은 고딕"/>
+              </a:rPr>
+              <a:t>• 온프렘 NFS 역할을 AWS에서 대체</a:t>
+            </a:r>
+          </a:p>
+          <a:p>
+            <a:pPr algn="ctr">
+              <a:spcBef>
+                <a:spcPts val="800"/>
+              </a:spcBef>
+            </a:pPr>
+            <a:r>
+              <a:rPr sz="1300" b="0">
+                <a:solidFill>
+                  <a:srgbClr val="0F172A"/>
+                </a:solidFill>
+                <a:latin typeface="맑은 고딕"/>
+                <a:ea typeface="맑은 고딕"/>
+                <a:cs typeface="맑은 고딕"/>
+              </a:rPr>
+              <a:t>• Nginx /media 로컬·fallback 서빙</a:t>
+            </a:r>
+          </a:p>
+        </p:txBody>
+      </p:sp>
+      <p:sp>
+        <p:nvSpPr>
+          <p:cNvPr id="6" name="Rounded Rectangle 5"/>
+          <p:cNvSpPr/>
+          <p:nvPr/>
+        </p:nvSpPr>
+        <p:spPr>
+          <a:xfrm>
+            <a:off x="8092440" y="1051560"/>
+            <a:ext cx="3703320" cy="4709160"/>
+          </a:xfrm>
+          <a:prstGeom prst="roundRect">
+            <a:avLst/>
+          </a:prstGeom>
+          <a:solidFill>
+            <a:srgbClr val="F8FAFC"/>
+          </a:solidFill>
+          <a:ln w="19050">
+            <a:solidFill>
+              <a:srgbClr val="EA580C"/>
+            </a:solidFill>
+          </a:ln>
+        </p:spPr>
+        <p:style>
+          <a:lnRef idx="1">
+            <a:schemeClr val="accent1"/>
+          </a:lnRef>
+          <a:fillRef idx="3">
+            <a:schemeClr val="accent1"/>
+          </a:fillRef>
+          <a:effectRef idx="2">
+            <a:schemeClr val="accent1"/>
+          </a:effectRef>
+          <a:fontRef idx="minor">
+            <a:schemeClr val="lt1"/>
+          </a:fontRef>
+        </p:style>
+        <p:txBody>
+          <a:bodyPr rtlCol="0" anchor="ctr" wrap="square"/>
+          <a:lstStyle/>
+          <a:p>
+            <a:pPr algn="ctr"/>
+            <a:r>
+              <a:rPr sz="1800" b="1">
+                <a:solidFill>
+                  <a:srgbClr val="EA580C"/>
+                </a:solidFill>
+                <a:latin typeface="맑은 고딕"/>
+                <a:ea typeface="맑은 고딕"/>
+                <a:cs typeface="맑은 고딕"/>
+              </a:rPr>
+              <a:t>S3</a:t>
+            </a:r>
+          </a:p>
+          <a:p>
+            <a:pPr algn="ctr">
+              <a:spcBef>
+                <a:spcPts val="800"/>
+              </a:spcBef>
+            </a:pPr>
+            <a:r>
+              <a:rPr sz="1300" b="1">
+                <a:solidFill>
+                  <a:srgbClr val="475569"/>
+                </a:solidFill>
+                <a:latin typeface="맑은 고딕"/>
+                <a:ea typeface="맑은 고딕"/>
+                <a:cs typeface="맑은 고딕"/>
+              </a:rPr>
+              <a:t>객체 스토리지 (파일·배포)</a:t>
+            </a:r>
+          </a:p>
+          <a:p>
+            <a:pPr algn="ctr">
+              <a:spcBef>
+                <a:spcPts val="800"/>
+              </a:spcBef>
+            </a:pPr>
+            <a:r>
+              <a:rPr sz="1300" b="0">
+                <a:solidFill>
+                  <a:srgbClr val="0F172A"/>
+                </a:solidFill>
+                <a:latin typeface="맑은 고딕"/>
+                <a:ea typeface="맑은 고딕"/>
+                <a:cs typeface="맑은 고딕"/>
+              </a:rPr>
+              <a:t>• 업로드 이미지 원본</a:t>
+            </a:r>
+          </a:p>
+          <a:p>
+            <a:pPr algn="ctr">
+              <a:spcBef>
+                <a:spcPts val="800"/>
+              </a:spcBef>
+            </a:pPr>
+            <a:r>
+              <a:rPr sz="1300" b="0">
+                <a:solidFill>
+                  <a:srgbClr val="0F172A"/>
+                </a:solidFill>
+                <a:latin typeface="맑은 고딕"/>
+                <a:ea typeface="맑은 고딕"/>
+                <a:cs typeface="맑은 고딕"/>
+              </a:rPr>
+              <a:t>• community/ · goods_images/</a:t>
+            </a:r>
+          </a:p>
+          <a:p>
+            <a:pPr algn="ctr">
+              <a:spcBef>
+                <a:spcPts val="800"/>
+              </a:spcBef>
+            </a:pPr>
+            <a:r>
+              <a:rPr sz="1300" b="0">
+                <a:solidFill>
+                  <a:srgbClr val="0F172A"/>
+                </a:solidFill>
+                <a:latin typeface="맑은 고딕"/>
+                <a:ea typeface="맑은 고딕"/>
+                <a:cs typeface="맑은 고딕"/>
+              </a:rPr>
+              <a:t>• works_images/</a:t>
+            </a:r>
+          </a:p>
+          <a:p>
+            <a:pPr algn="ctr">
+              <a:spcBef>
+                <a:spcPts val="800"/>
+              </a:spcBef>
+            </a:pPr>
+            <a:r>
+              <a:rPr sz="1300" b="0">
+                <a:solidFill>
+                  <a:srgbClr val="0F172A"/>
+                </a:solidFill>
+                <a:latin typeface="맑은 고딕"/>
+                <a:ea typeface="맑은 고딕"/>
+                <a:cs typeface="맑은 고딕"/>
+              </a:rPr>
+              <a:t>• 공개 URL로 브라우저 제공</a:t>
+            </a:r>
+          </a:p>
+          <a:p>
+            <a:pPr algn="ctr">
+              <a:spcBef>
+                <a:spcPts val="800"/>
+              </a:spcBef>
+            </a:pPr>
+            <a:r>
+              <a:rPr sz="1300" b="0">
+                <a:solidFill>
+                  <a:srgbClr val="0F172A"/>
+                </a:solidFill>
+                <a:latin typeface="맑은 고딕"/>
+                <a:ea typeface="맑은 고딕"/>
+                <a:cs typeface="맑은 고딕"/>
+              </a:rPr>
+              <a:t>• 배포 zip · (별도) tfstate 버킷</a:t>
+            </a:r>
+          </a:p>
+        </p:txBody>
+      </p:sp>
+      <p:sp>
+        <p:nvSpPr>
+          <p:cNvPr id="7" name="TextBox 6"/>
           <p:cNvSpPr txBox="1"/>
           <p:nvPr/>
         </p:nvSpPr>
         <p:spPr>
           <a:xfrm>
-            <a:off x="411480" y="6446520"/>
-            <a:ext cx="11338560" cy="274320"/>
+            <a:off x="365760" y="5852160"/>
+            <a:ext cx="11430000" cy="411480"/>
           </a:xfrm>
           <a:prstGeom prst="rect">
             <a:avLst/>
@@ -3392,6 +3861,43 @@
           <a:noFill/>
         </p:spPr>
         <p:txBody>
+          <a:bodyPr wrap="square">
+            <a:spAutoFit/>
+          </a:bodyPr>
+          <a:lstStyle/>
+          <a:p>
+            <a:pPr algn="ctr"/>
+            <a:r>
+              <a:rPr sz="1400" b="1">
+                <a:solidFill>
+                  <a:srgbClr val="0D9488"/>
+                </a:solidFill>
+                <a:latin typeface="맑은 고딕"/>
+                <a:ea typeface="맑은 고딕"/>
+                <a:cs typeface="맑은 고딕"/>
+              </a:rPr>
+              <a:t>한 줄:  RDS = ‘무슨 글인지’  ·  S3 = ‘사진 파일’  ·  EFS = ‘여러 EC2가 같이 쓰는 폴더’</a:t>
+            </a:r>
+          </a:p>
+        </p:txBody>
+      </p:sp>
+      <p:sp>
+        <p:nvSpPr>
+          <p:cNvPr id="8" name="TextBox 7"/>
+          <p:cNvSpPr txBox="1"/>
+          <p:nvPr/>
+        </p:nvSpPr>
+        <p:spPr>
+          <a:xfrm>
+            <a:off x="411480" y="6446520"/>
+            <a:ext cx="11338560" cy="274320"/>
+          </a:xfrm>
+          <a:prstGeom prst="rect">
+            <a:avLst/>
+          </a:prstGeom>
+          <a:noFill/>
+        </p:spPr>
+        <p:txBody>
           <a:bodyPr wrap="none">
             <a:spAutoFit/>
           </a:bodyPr>
@@ -3407,7 +3913,7 @@
                 <a:ea typeface="맑은 고딕"/>
                 <a:cs typeface="맑은 고딕"/>
               </a:rPr>
-              <a:t>Aniverse · 온프레미스 3-tier → AWS   |   10/15</a:t>
+              <a:t>Aniverse · 온프레미스 3-tier → AWS   |   10/17</a:t>
             </a:r>
           </a:p>
         </p:txBody>
@@ -3504,7 +4010,7 @@
                 <a:ea typeface="맑은 고딕"/>
                 <a:cs typeface="맑은 고딕"/>
               </a:rPr>
-              <a:t>4. GitHub Actions (2)</a:t>
+              <a:t>4. GitHub Actions (1)</a:t>
             </a:r>
           </a:p>
           <a:p>
@@ -3522,306 +4028,38 @@
                 <a:ea typeface="맑은 고딕"/>
                 <a:cs typeface="맑은 고딕"/>
               </a:rPr>
-              <a:t>실제로 돌아가는 파이프라인</a:t>
-            </a:r>
-          </a:p>
-        </p:txBody>
-      </p:sp>
-      <p:sp>
-        <p:nvSpPr>
-          <p:cNvPr id="4" name="Rounded Rectangle 3"/>
-          <p:cNvSpPr/>
+              <a:t>인프라 저장소 / 앱 저장소를 나눠 자동화</a:t>
+            </a:r>
+          </a:p>
+        </p:txBody>
+      </p:sp>
+      <p:pic>
+        <p:nvPicPr>
+          <p:cNvPr id="4" name="Picture 3" descr="04_github_actions.png"/>
+          <p:cNvPicPr>
+            <a:picLocks noChangeAspect="1"/>
+          </p:cNvPicPr>
           <p:nvPr/>
-        </p:nvSpPr>
-        <p:spPr>
-          <a:xfrm>
-            <a:off x="365760" y="1097280"/>
-            <a:ext cx="5669280" cy="4846320"/>
-          </a:xfrm>
-          <a:prstGeom prst="roundRect">
+        </p:nvPicPr>
+        <p:blipFill>
+          <a:blip r:embed="rId2"/>
+          <a:stretch>
+            <a:fillRect/>
+          </a:stretch>
+        </p:blipFill>
+        <p:spPr>
+          <a:xfrm>
+            <a:off x="274320" y="960120"/>
+            <a:ext cx="11612880" cy="6532245"/>
+          </a:xfrm>
+          <a:prstGeom prst="rect">
             <a:avLst/>
           </a:prstGeom>
-          <a:solidFill>
-            <a:srgbClr val="EFF6FF"/>
-          </a:solidFill>
-          <a:ln w="19050">
-            <a:solidFill>
-              <a:srgbClr val="2563EB"/>
-            </a:solidFill>
-          </a:ln>
-        </p:spPr>
-        <p:style>
-          <a:lnRef idx="1">
-            <a:schemeClr val="accent1"/>
-          </a:lnRef>
-          <a:fillRef idx="3">
-            <a:schemeClr val="accent1"/>
-          </a:fillRef>
-          <a:effectRef idx="2">
-            <a:schemeClr val="accent1"/>
-          </a:effectRef>
-          <a:fontRef idx="minor">
-            <a:schemeClr val="lt1"/>
-          </a:fontRef>
-        </p:style>
-        <p:txBody>
-          <a:bodyPr rtlCol="0" anchor="ctr" wrap="square"/>
-          <a:lstStyle/>
-          <a:p>
-            <a:pPr algn="ctr"/>
-            <a:r>
-              <a:rPr sz="1600" b="1">
-                <a:solidFill>
-                  <a:srgbClr val="2563EB"/>
-                </a:solidFill>
-                <a:latin typeface="맑은 고딕"/>
-                <a:ea typeface="맑은 고딕"/>
-                <a:cs typeface="맑은 고딕"/>
-              </a:rPr>
-              <a:t>anime-project-infra</a:t>
-            </a:r>
-          </a:p>
-          <a:p>
-            <a:pPr>
-              <a:spcBef>
-                <a:spcPts val="800"/>
-              </a:spcBef>
-            </a:pPr>
-            <a:r>
-              <a:rPr sz="1300" b="0">
-                <a:solidFill>
-                  <a:srgbClr val="0F172A"/>
-                </a:solidFill>
-                <a:latin typeface="맑은 고딕"/>
-                <a:ea typeface="맑은 고딕"/>
-                <a:cs typeface="맑은 고딕"/>
-              </a:rPr>
-              <a:t>• trigger: main push / workflow_dispatch</a:t>
-            </a:r>
-          </a:p>
-          <a:p>
-            <a:pPr>
-              <a:spcBef>
-                <a:spcPts val="800"/>
-              </a:spcBef>
-            </a:pPr>
-            <a:r>
-              <a:rPr sz="1300" b="0">
-                <a:solidFill>
-                  <a:srgbClr val="0F172A"/>
-                </a:solidFill>
-                <a:latin typeface="맑은 고딕"/>
-                <a:ea typeface="맑은 고딕"/>
-                <a:cs typeface="맑은 고딕"/>
-              </a:rPr>
-              <a:t>• steps: checkout → setup TF → fmt</a:t>
-            </a:r>
-          </a:p>
-          <a:p>
-            <a:pPr>
-              <a:spcBef>
-                <a:spcPts val="800"/>
-              </a:spcBef>
-            </a:pPr>
-            <a:r>
-              <a:rPr sz="1300" b="0">
-                <a:solidFill>
-                  <a:srgbClr val="0F172A"/>
-                </a:solidFill>
-                <a:latin typeface="맑은 고딕"/>
-                <a:ea typeface="맑은 고딕"/>
-                <a:cs typeface="맑은 고딕"/>
-              </a:rPr>
-              <a:t>•         validate → plan → apply</a:t>
-            </a:r>
-          </a:p>
-          <a:p>
-            <a:pPr>
-              <a:spcBef>
-                <a:spcPts val="800"/>
-              </a:spcBef>
-            </a:pPr>
-            <a:r>
-              <a:rPr sz="1300" b="0">
-                <a:solidFill>
-                  <a:srgbClr val="0F172A"/>
-                </a:solidFill>
-                <a:latin typeface="맑은 고딕"/>
-                <a:ea typeface="맑은 고딕"/>
-                <a:cs typeface="맑은 고딕"/>
-              </a:rPr>
-              <a:t>• 결과: VPC/ALB/ASG/RDS/S3/WAF 갱신</a:t>
-            </a:r>
-          </a:p>
-          <a:p>
-            <a:pPr>
-              <a:spcBef>
-                <a:spcPts val="800"/>
-              </a:spcBef>
-            </a:pPr>
-            <a:r>
-              <a:rPr sz="1300" b="0">
-                <a:solidFill>
-                  <a:srgbClr val="0F172A"/>
-                </a:solidFill>
-                <a:latin typeface="맑은 고딕"/>
-                <a:ea typeface="맑은 고딕"/>
-                <a:cs typeface="맑은 고딕"/>
-              </a:rPr>
-              <a:t>• Secrets: AWS 자격증명, TF_VAR_*</a:t>
-            </a:r>
-          </a:p>
-        </p:txBody>
-      </p:sp>
-      <p:sp>
-        <p:nvSpPr>
-          <p:cNvPr id="5" name="Rounded Rectangle 4"/>
-          <p:cNvSpPr/>
-          <p:nvPr/>
-        </p:nvSpPr>
-        <p:spPr>
-          <a:xfrm>
-            <a:off x="6309360" y="1097280"/>
-            <a:ext cx="5394960" cy="4846320"/>
-          </a:xfrm>
-          <a:prstGeom prst="roundRect">
-            <a:avLst/>
-          </a:prstGeom>
-          <a:solidFill>
-            <a:srgbClr val="FFF7ED"/>
-          </a:solidFill>
-          <a:ln w="19050">
-            <a:solidFill>
-              <a:srgbClr val="EA580C"/>
-            </a:solidFill>
-          </a:ln>
-        </p:spPr>
-        <p:style>
-          <a:lnRef idx="1">
-            <a:schemeClr val="accent1"/>
-          </a:lnRef>
-          <a:fillRef idx="3">
-            <a:schemeClr val="accent1"/>
-          </a:fillRef>
-          <a:effectRef idx="2">
-            <a:schemeClr val="accent1"/>
-          </a:effectRef>
-          <a:fontRef idx="minor">
-            <a:schemeClr val="lt1"/>
-          </a:fontRef>
-        </p:style>
-        <p:txBody>
-          <a:bodyPr rtlCol="0" anchor="ctr" wrap="square"/>
-          <a:lstStyle/>
-          <a:p>
-            <a:pPr algn="ctr"/>
-            <a:r>
-              <a:rPr sz="1600" b="1">
-                <a:solidFill>
-                  <a:srgbClr val="EA580C"/>
-                </a:solidFill>
-                <a:latin typeface="맑은 고딕"/>
-                <a:ea typeface="맑은 고딕"/>
-                <a:cs typeface="맑은 고딕"/>
-              </a:rPr>
-              <a:t>anime-project</a:t>
-            </a:r>
-          </a:p>
-          <a:p>
-            <a:pPr>
-              <a:spcBef>
-                <a:spcPts val="800"/>
-              </a:spcBef>
-            </a:pPr>
-            <a:r>
-              <a:rPr sz="1300" b="0">
-                <a:solidFill>
-                  <a:srgbClr val="0F172A"/>
-                </a:solidFill>
-                <a:latin typeface="맑은 고딕"/>
-                <a:ea typeface="맑은 고딕"/>
-                <a:cs typeface="맑은 고딕"/>
-              </a:rPr>
-              <a:t>• trigger: main push / workflow_dispatch</a:t>
-            </a:r>
-          </a:p>
-          <a:p>
-            <a:pPr>
-              <a:spcBef>
-                <a:spcPts val="800"/>
-              </a:spcBef>
-            </a:pPr>
-            <a:r>
-              <a:rPr sz="1300" b="0">
-                <a:solidFill>
-                  <a:srgbClr val="0F172A"/>
-                </a:solidFill>
-                <a:latin typeface="맑은 고딕"/>
-                <a:ea typeface="맑은 고딕"/>
-                <a:cs typeface="맑은 고딕"/>
-              </a:rPr>
-              <a:t>• steps: media → S3 sync</a:t>
-            </a:r>
-          </a:p>
-          <a:p>
-            <a:pPr>
-              <a:spcBef>
-                <a:spcPts val="800"/>
-              </a:spcBef>
-            </a:pPr>
-            <a:r>
-              <a:rPr sz="1300" b="0">
-                <a:solidFill>
-                  <a:srgbClr val="0F172A"/>
-                </a:solidFill>
-                <a:latin typeface="맑은 고딕"/>
-                <a:ea typeface="맑은 고딕"/>
-                <a:cs typeface="맑은 고딕"/>
-              </a:rPr>
-              <a:t>•         앱 zip 패키징 → deploy S3</a:t>
-            </a:r>
-          </a:p>
-          <a:p>
-            <a:pPr>
-              <a:spcBef>
-                <a:spcPts val="800"/>
-              </a:spcBef>
-            </a:pPr>
-            <a:r>
-              <a:rPr sz="1300" b="0">
-                <a:solidFill>
-                  <a:srgbClr val="0F172A"/>
-                </a:solidFill>
-                <a:latin typeface="맑은 고딕"/>
-                <a:ea typeface="맑은 고딕"/>
-                <a:cs typeface="맑은 고딕"/>
-              </a:rPr>
-              <a:t>•         CodeDeploy → ASG 배포</a:t>
-            </a:r>
-          </a:p>
-          <a:p>
-            <a:pPr>
-              <a:spcBef>
-                <a:spcPts val="800"/>
-              </a:spcBef>
-            </a:pPr>
-            <a:r>
-              <a:rPr sz="1300" b="0">
-                <a:solidFill>
-                  <a:srgbClr val="0F172A"/>
-                </a:solidFill>
-                <a:latin typeface="맑은 고딕"/>
-                <a:ea typeface="맑은 고딕"/>
-                <a:cs typeface="맑은 고딕"/>
-              </a:rPr>
-              <a:t>• hooks: install → migrate → Daphne 기동</a:t>
-            </a:r>
-          </a:p>
-        </p:txBody>
-      </p:sp>
-      <p:sp>
-        <p:nvSpPr>
-          <p:cNvPr id="6" name="TextBox 5"/>
+        </p:spPr>
+      </p:pic>
+      <p:sp>
+        <p:nvSpPr>
+          <p:cNvPr id="5" name="TextBox 4"/>
           <p:cNvSpPr txBox="1"/>
           <p:nvPr/>
         </p:nvSpPr>
@@ -3851,7 +4089,7 @@
                 <a:ea typeface="맑은 고딕"/>
                 <a:cs typeface="맑은 고딕"/>
               </a:rPr>
-              <a:t>Aniverse · 온프레미스 3-tier → AWS   |   11/15</a:t>
+              <a:t>Aniverse · 온프레미스 3-tier → AWS   |   11/17</a:t>
             </a:r>
           </a:p>
         </p:txBody>
@@ -3948,7 +4186,7 @@
                 <a:ea typeface="맑은 고딕"/>
                 <a:cs typeface="맑은 고딕"/>
               </a:rPr>
-              <a:t>5. CI/CD · HA · 모니터링 · 보안</a:t>
+              <a:t>4. GitHub Actions (2)</a:t>
             </a:r>
           </a:p>
           <a:p>
@@ -3966,38 +4204,306 @@
                 <a:ea typeface="맑은 고딕"/>
                 <a:cs typeface="맑은 고딕"/>
               </a:rPr>
-              <a:t>배포·가용성·관측·보안을 한 장으로</a:t>
-            </a:r>
-          </a:p>
-        </p:txBody>
-      </p:sp>
-      <p:pic>
-        <p:nvPicPr>
-          <p:cNvPr id="4" name="Picture 3" descr="05_ops_security.png"/>
-          <p:cNvPicPr>
-            <a:picLocks noChangeAspect="1"/>
-          </p:cNvPicPr>
+              <a:t>실제로 돌아가는 파이프라인</a:t>
+            </a:r>
+          </a:p>
+        </p:txBody>
+      </p:sp>
+      <p:sp>
+        <p:nvSpPr>
+          <p:cNvPr id="4" name="Rounded Rectangle 3"/>
+          <p:cNvSpPr/>
           <p:nvPr/>
-        </p:nvPicPr>
-        <p:blipFill>
-          <a:blip r:embed="rId2"/>
-          <a:stretch>
-            <a:fillRect/>
-          </a:stretch>
-        </p:blipFill>
-        <p:spPr>
-          <a:xfrm>
-            <a:off x="411480" y="1051560"/>
-            <a:ext cx="11338560" cy="4960620"/>
-          </a:xfrm>
-          <a:prstGeom prst="rect">
+        </p:nvSpPr>
+        <p:spPr>
+          <a:xfrm>
+            <a:off x="365760" y="1097280"/>
+            <a:ext cx="5669280" cy="4846320"/>
+          </a:xfrm>
+          <a:prstGeom prst="roundRect">
             <a:avLst/>
           </a:prstGeom>
-        </p:spPr>
-      </p:pic>
-      <p:sp>
-        <p:nvSpPr>
-          <p:cNvPr id="5" name="TextBox 4"/>
+          <a:solidFill>
+            <a:srgbClr val="EFF6FF"/>
+          </a:solidFill>
+          <a:ln w="19050">
+            <a:solidFill>
+              <a:srgbClr val="2563EB"/>
+            </a:solidFill>
+          </a:ln>
+        </p:spPr>
+        <p:style>
+          <a:lnRef idx="1">
+            <a:schemeClr val="accent1"/>
+          </a:lnRef>
+          <a:fillRef idx="3">
+            <a:schemeClr val="accent1"/>
+          </a:fillRef>
+          <a:effectRef idx="2">
+            <a:schemeClr val="accent1"/>
+          </a:effectRef>
+          <a:fontRef idx="minor">
+            <a:schemeClr val="lt1"/>
+          </a:fontRef>
+        </p:style>
+        <p:txBody>
+          <a:bodyPr rtlCol="0" anchor="ctr" wrap="square"/>
+          <a:lstStyle/>
+          <a:p>
+            <a:pPr algn="ctr"/>
+            <a:r>
+              <a:rPr sz="1600" b="1">
+                <a:solidFill>
+                  <a:srgbClr val="2563EB"/>
+                </a:solidFill>
+                <a:latin typeface="맑은 고딕"/>
+                <a:ea typeface="맑은 고딕"/>
+                <a:cs typeface="맑은 고딕"/>
+              </a:rPr>
+              <a:t>anime-project-infra</a:t>
+            </a:r>
+          </a:p>
+          <a:p>
+            <a:pPr>
+              <a:spcBef>
+                <a:spcPts val="800"/>
+              </a:spcBef>
+            </a:pPr>
+            <a:r>
+              <a:rPr sz="1300" b="0">
+                <a:solidFill>
+                  <a:srgbClr val="0F172A"/>
+                </a:solidFill>
+                <a:latin typeface="맑은 고딕"/>
+                <a:ea typeface="맑은 고딕"/>
+                <a:cs typeface="맑은 고딕"/>
+              </a:rPr>
+              <a:t>• trigger: main push / workflow_dispatch</a:t>
+            </a:r>
+          </a:p>
+          <a:p>
+            <a:pPr>
+              <a:spcBef>
+                <a:spcPts val="800"/>
+              </a:spcBef>
+            </a:pPr>
+            <a:r>
+              <a:rPr sz="1300" b="0">
+                <a:solidFill>
+                  <a:srgbClr val="0F172A"/>
+                </a:solidFill>
+                <a:latin typeface="맑은 고딕"/>
+                <a:ea typeface="맑은 고딕"/>
+                <a:cs typeface="맑은 고딕"/>
+              </a:rPr>
+              <a:t>• steps: checkout → setup TF → fmt</a:t>
+            </a:r>
+          </a:p>
+          <a:p>
+            <a:pPr>
+              <a:spcBef>
+                <a:spcPts val="800"/>
+              </a:spcBef>
+            </a:pPr>
+            <a:r>
+              <a:rPr sz="1300" b="0">
+                <a:solidFill>
+                  <a:srgbClr val="0F172A"/>
+                </a:solidFill>
+                <a:latin typeface="맑은 고딕"/>
+                <a:ea typeface="맑은 고딕"/>
+                <a:cs typeface="맑은 고딕"/>
+              </a:rPr>
+              <a:t>•         validate → plan → apply</a:t>
+            </a:r>
+          </a:p>
+          <a:p>
+            <a:pPr>
+              <a:spcBef>
+                <a:spcPts val="800"/>
+              </a:spcBef>
+            </a:pPr>
+            <a:r>
+              <a:rPr sz="1300" b="0">
+                <a:solidFill>
+                  <a:srgbClr val="0F172A"/>
+                </a:solidFill>
+                <a:latin typeface="맑은 고딕"/>
+                <a:ea typeface="맑은 고딕"/>
+                <a:cs typeface="맑은 고딕"/>
+              </a:rPr>
+              <a:t>• 결과: VPC/ALB/ASG/RDS/S3/WAF 갱신</a:t>
+            </a:r>
+          </a:p>
+          <a:p>
+            <a:pPr>
+              <a:spcBef>
+                <a:spcPts val="800"/>
+              </a:spcBef>
+            </a:pPr>
+            <a:r>
+              <a:rPr sz="1300" b="0">
+                <a:solidFill>
+                  <a:srgbClr val="0F172A"/>
+                </a:solidFill>
+                <a:latin typeface="맑은 고딕"/>
+                <a:ea typeface="맑은 고딕"/>
+                <a:cs typeface="맑은 고딕"/>
+              </a:rPr>
+              <a:t>• Secrets: AWS 자격증명, TF_VAR_*</a:t>
+            </a:r>
+          </a:p>
+        </p:txBody>
+      </p:sp>
+      <p:sp>
+        <p:nvSpPr>
+          <p:cNvPr id="5" name="Rounded Rectangle 4"/>
+          <p:cNvSpPr/>
+          <p:nvPr/>
+        </p:nvSpPr>
+        <p:spPr>
+          <a:xfrm>
+            <a:off x="6309360" y="1097280"/>
+            <a:ext cx="5394960" cy="4846320"/>
+          </a:xfrm>
+          <a:prstGeom prst="roundRect">
+            <a:avLst/>
+          </a:prstGeom>
+          <a:solidFill>
+            <a:srgbClr val="FFF7ED"/>
+          </a:solidFill>
+          <a:ln w="19050">
+            <a:solidFill>
+              <a:srgbClr val="EA580C"/>
+            </a:solidFill>
+          </a:ln>
+        </p:spPr>
+        <p:style>
+          <a:lnRef idx="1">
+            <a:schemeClr val="accent1"/>
+          </a:lnRef>
+          <a:fillRef idx="3">
+            <a:schemeClr val="accent1"/>
+          </a:fillRef>
+          <a:effectRef idx="2">
+            <a:schemeClr val="accent1"/>
+          </a:effectRef>
+          <a:fontRef idx="minor">
+            <a:schemeClr val="lt1"/>
+          </a:fontRef>
+        </p:style>
+        <p:txBody>
+          <a:bodyPr rtlCol="0" anchor="ctr" wrap="square"/>
+          <a:lstStyle/>
+          <a:p>
+            <a:pPr algn="ctr"/>
+            <a:r>
+              <a:rPr sz="1600" b="1">
+                <a:solidFill>
+                  <a:srgbClr val="EA580C"/>
+                </a:solidFill>
+                <a:latin typeface="맑은 고딕"/>
+                <a:ea typeface="맑은 고딕"/>
+                <a:cs typeface="맑은 고딕"/>
+              </a:rPr>
+              <a:t>anime-project</a:t>
+            </a:r>
+          </a:p>
+          <a:p>
+            <a:pPr>
+              <a:spcBef>
+                <a:spcPts val="800"/>
+              </a:spcBef>
+            </a:pPr>
+            <a:r>
+              <a:rPr sz="1300" b="0">
+                <a:solidFill>
+                  <a:srgbClr val="0F172A"/>
+                </a:solidFill>
+                <a:latin typeface="맑은 고딕"/>
+                <a:ea typeface="맑은 고딕"/>
+                <a:cs typeface="맑은 고딕"/>
+              </a:rPr>
+              <a:t>• trigger: main push / workflow_dispatch</a:t>
+            </a:r>
+          </a:p>
+          <a:p>
+            <a:pPr>
+              <a:spcBef>
+                <a:spcPts val="800"/>
+              </a:spcBef>
+            </a:pPr>
+            <a:r>
+              <a:rPr sz="1300" b="0">
+                <a:solidFill>
+                  <a:srgbClr val="0F172A"/>
+                </a:solidFill>
+                <a:latin typeface="맑은 고딕"/>
+                <a:ea typeface="맑은 고딕"/>
+                <a:cs typeface="맑은 고딕"/>
+              </a:rPr>
+              <a:t>• steps: media → S3 sync</a:t>
+            </a:r>
+          </a:p>
+          <a:p>
+            <a:pPr>
+              <a:spcBef>
+                <a:spcPts val="800"/>
+              </a:spcBef>
+            </a:pPr>
+            <a:r>
+              <a:rPr sz="1300" b="0">
+                <a:solidFill>
+                  <a:srgbClr val="0F172A"/>
+                </a:solidFill>
+                <a:latin typeface="맑은 고딕"/>
+                <a:ea typeface="맑은 고딕"/>
+                <a:cs typeface="맑은 고딕"/>
+              </a:rPr>
+              <a:t>•         앱 zip 패키징 → deploy S3</a:t>
+            </a:r>
+          </a:p>
+          <a:p>
+            <a:pPr>
+              <a:spcBef>
+                <a:spcPts val="800"/>
+              </a:spcBef>
+            </a:pPr>
+            <a:r>
+              <a:rPr sz="1300" b="0">
+                <a:solidFill>
+                  <a:srgbClr val="0F172A"/>
+                </a:solidFill>
+                <a:latin typeface="맑은 고딕"/>
+                <a:ea typeface="맑은 고딕"/>
+                <a:cs typeface="맑은 고딕"/>
+              </a:rPr>
+              <a:t>•         CodeDeploy → ASG 배포</a:t>
+            </a:r>
+          </a:p>
+          <a:p>
+            <a:pPr>
+              <a:spcBef>
+                <a:spcPts val="800"/>
+              </a:spcBef>
+            </a:pPr>
+            <a:r>
+              <a:rPr sz="1300" b="0">
+                <a:solidFill>
+                  <a:srgbClr val="0F172A"/>
+                </a:solidFill>
+                <a:latin typeface="맑은 고딕"/>
+                <a:ea typeface="맑은 고딕"/>
+                <a:cs typeface="맑은 고딕"/>
+              </a:rPr>
+              <a:t>• hooks: install → migrate → Daphne 기동</a:t>
+            </a:r>
+          </a:p>
+        </p:txBody>
+      </p:sp>
+      <p:sp>
+        <p:nvSpPr>
+          <p:cNvPr id="6" name="TextBox 5"/>
           <p:cNvSpPr txBox="1"/>
           <p:nvPr/>
         </p:nvSpPr>
@@ -4027,7 +4533,7 @@
                 <a:ea typeface="맑은 고딕"/>
                 <a:cs typeface="맑은 고딕"/>
               </a:rPr>
-              <a:t>Aniverse · 온프레미스 3-tier → AWS   |   12/15</a:t>
+              <a:t>Aniverse · 온프레미스 3-tier → AWS   |   12/17</a:t>
             </a:r>
           </a:p>
         </p:txBody>
@@ -4124,7 +4630,7 @@
                 <a:ea typeface="맑은 고딕"/>
                 <a:cs typeface="맑은 고딕"/>
               </a:rPr>
-              <a:t>5. 적용 내용 상세</a:t>
+              <a:t>5. CI/CD · HA · 모니터링 · 보안</a:t>
             </a:r>
           </a:p>
           <a:p>
@@ -4142,454 +4648,38 @@
                 <a:ea typeface="맑은 고딕"/>
                 <a:cs typeface="맑은 고딕"/>
               </a:rPr>
-              <a:t>서비스가 실제로 어떻게 버티는지</a:t>
-            </a:r>
-          </a:p>
-        </p:txBody>
-      </p:sp>
-      <p:sp>
-        <p:nvSpPr>
-          <p:cNvPr id="4" name="Rounded Rectangle 3"/>
-          <p:cNvSpPr/>
+              <a:t>배포·가용성·관측·보안을 한 장으로</a:t>
+            </a:r>
+          </a:p>
+        </p:txBody>
+      </p:sp>
+      <p:pic>
+        <p:nvPicPr>
+          <p:cNvPr id="4" name="Picture 3" descr="05_ops_security.png"/>
+          <p:cNvPicPr>
+            <a:picLocks noChangeAspect="1"/>
+          </p:cNvPicPr>
           <p:nvPr/>
-        </p:nvSpPr>
-        <p:spPr>
-          <a:xfrm>
-            <a:off x="274320" y="1051560"/>
-            <a:ext cx="5669280" cy="2331720"/>
-          </a:xfrm>
-          <a:prstGeom prst="roundRect">
+        </p:nvPicPr>
+        <p:blipFill>
+          <a:blip r:embed="rId2"/>
+          <a:stretch>
+            <a:fillRect/>
+          </a:stretch>
+        </p:blipFill>
+        <p:spPr>
+          <a:xfrm>
+            <a:off x="411480" y="1051560"/>
+            <a:ext cx="11338560" cy="4960620"/>
+          </a:xfrm>
+          <a:prstGeom prst="rect">
             <a:avLst/>
           </a:prstGeom>
-          <a:solidFill>
-            <a:srgbClr val="F8FAFC"/>
-          </a:solidFill>
-          <a:ln w="19050">
-            <a:solidFill>
-              <a:srgbClr val="2563EB"/>
-            </a:solidFill>
-          </a:ln>
-        </p:spPr>
-        <p:style>
-          <a:lnRef idx="1">
-            <a:schemeClr val="accent1"/>
-          </a:lnRef>
-          <a:fillRef idx="3">
-            <a:schemeClr val="accent1"/>
-          </a:fillRef>
-          <a:effectRef idx="2">
-            <a:schemeClr val="accent1"/>
-          </a:effectRef>
-          <a:fontRef idx="minor">
-            <a:schemeClr val="lt1"/>
-          </a:fontRef>
-        </p:style>
-        <p:txBody>
-          <a:bodyPr rtlCol="0" anchor="ctr" wrap="square"/>
-          <a:lstStyle/>
-          <a:p>
-            <a:pPr algn="ctr"/>
-            <a:r>
-              <a:rPr sz="1700" b="1">
-                <a:solidFill>
-                  <a:srgbClr val="2563EB"/>
-                </a:solidFill>
-                <a:latin typeface="맑은 고딕"/>
-                <a:ea typeface="맑은 고딕"/>
-                <a:cs typeface="맑은 고딕"/>
-              </a:rPr>
-              <a:t>CI/CD</a:t>
-            </a:r>
-          </a:p>
-          <a:p>
-            <a:pPr>
-              <a:spcBef>
-                <a:spcPts val="700"/>
-              </a:spcBef>
-            </a:pPr>
-            <a:r>
-              <a:rPr sz="1300" b="0">
-                <a:solidFill>
-                  <a:srgbClr val="0F172A"/>
-                </a:solidFill>
-                <a:latin typeface="맑은 고딕"/>
-                <a:ea typeface="맑은 고딕"/>
-                <a:cs typeface="맑은 고딕"/>
-              </a:rPr>
-              <a:t>• Actions + CodeDeploy로 배포 경로 고정</a:t>
-            </a:r>
-          </a:p>
-          <a:p>
-            <a:pPr>
-              <a:spcBef>
-                <a:spcPts val="700"/>
-              </a:spcBef>
-            </a:pPr>
-            <a:r>
-              <a:rPr sz="1300" b="0">
-                <a:solidFill>
-                  <a:srgbClr val="0F172A"/>
-                </a:solidFill>
-                <a:latin typeface="맑은 고딕"/>
-                <a:ea typeface="맑은 고딕"/>
-                <a:cs typeface="맑은 고딕"/>
-              </a:rPr>
-              <a:t>• ALB /health/ 로 배포 성공 판정</a:t>
-            </a:r>
-          </a:p>
-          <a:p>
-            <a:pPr>
-              <a:spcBef>
-                <a:spcPts val="700"/>
-              </a:spcBef>
-            </a:pPr>
-            <a:r>
-              <a:rPr sz="1300" b="0">
-                <a:solidFill>
-                  <a:srgbClr val="0F172A"/>
-                </a:solidFill>
-                <a:latin typeface="맑은 고딕"/>
-                <a:ea typeface="맑은 고딕"/>
-                <a:cs typeface="맑은 고딕"/>
-              </a:rPr>
-              <a:t>• 실패 시 Actions·배포 로그로 추적</a:t>
-            </a:r>
-          </a:p>
-        </p:txBody>
-      </p:sp>
-      <p:sp>
-        <p:nvSpPr>
-          <p:cNvPr id="5" name="Rounded Rectangle 4"/>
-          <p:cNvSpPr/>
-          <p:nvPr/>
-        </p:nvSpPr>
-        <p:spPr>
-          <a:xfrm>
-            <a:off x="6172200" y="1051560"/>
-            <a:ext cx="5669280" cy="2331720"/>
-          </a:xfrm>
-          <a:prstGeom prst="roundRect">
-            <a:avLst/>
-          </a:prstGeom>
-          <a:solidFill>
-            <a:srgbClr val="F8FAFC"/>
-          </a:solidFill>
-          <a:ln w="19050">
-            <a:solidFill>
-              <a:srgbClr val="EA580C"/>
-            </a:solidFill>
-          </a:ln>
-        </p:spPr>
-        <p:style>
-          <a:lnRef idx="1">
-            <a:schemeClr val="accent1"/>
-          </a:lnRef>
-          <a:fillRef idx="3">
-            <a:schemeClr val="accent1"/>
-          </a:fillRef>
-          <a:effectRef idx="2">
-            <a:schemeClr val="accent1"/>
-          </a:effectRef>
-          <a:fontRef idx="minor">
-            <a:schemeClr val="lt1"/>
-          </a:fontRef>
-        </p:style>
-        <p:txBody>
-          <a:bodyPr rtlCol="0" anchor="ctr" wrap="square"/>
-          <a:lstStyle/>
-          <a:p>
-            <a:pPr algn="ctr"/>
-            <a:r>
-              <a:rPr sz="1700" b="1">
-                <a:solidFill>
-                  <a:srgbClr val="EA580C"/>
-                </a:solidFill>
-                <a:latin typeface="맑은 고딕"/>
-                <a:ea typeface="맑은 고딕"/>
-                <a:cs typeface="맑은 고딕"/>
-              </a:rPr>
-              <a:t>고가용성</a:t>
-            </a:r>
-          </a:p>
-          <a:p>
-            <a:pPr>
-              <a:spcBef>
-                <a:spcPts val="700"/>
-              </a:spcBef>
-            </a:pPr>
-            <a:r>
-              <a:rPr sz="1300" b="0">
-                <a:solidFill>
-                  <a:srgbClr val="0F172A"/>
-                </a:solidFill>
-                <a:latin typeface="맑은 고딕"/>
-                <a:ea typeface="맑은 고딕"/>
-                <a:cs typeface="맑은 고딕"/>
-              </a:rPr>
-              <a:t>• ALB로 트래픽 분산</a:t>
-            </a:r>
-          </a:p>
-          <a:p>
-            <a:pPr>
-              <a:spcBef>
-                <a:spcPts val="700"/>
-              </a:spcBef>
-            </a:pPr>
-            <a:r>
-              <a:rPr sz="1300" b="0">
-                <a:solidFill>
-                  <a:srgbClr val="0F172A"/>
-                </a:solidFill>
-                <a:latin typeface="맑은 고딕"/>
-                <a:ea typeface="맑은 고딕"/>
-                <a:cs typeface="맑은 고딕"/>
-              </a:rPr>
-              <a:t>• ASG로 인스턴스 교체·확장</a:t>
-            </a:r>
-          </a:p>
-          <a:p>
-            <a:pPr>
-              <a:spcBef>
-                <a:spcPts val="700"/>
-              </a:spcBef>
-            </a:pPr>
-            <a:r>
-              <a:rPr sz="1300" b="0">
-                <a:solidFill>
-                  <a:srgbClr val="0F172A"/>
-                </a:solidFill>
-                <a:latin typeface="맑은 고딕"/>
-                <a:ea typeface="맑은 고딕"/>
-                <a:cs typeface="맑은 고딕"/>
-              </a:rPr>
-              <a:t>• App/DB 서브넷 분리 배치</a:t>
-            </a:r>
-          </a:p>
-        </p:txBody>
-      </p:sp>
-      <p:sp>
-        <p:nvSpPr>
-          <p:cNvPr id="6" name="Rounded Rectangle 5"/>
-          <p:cNvSpPr/>
-          <p:nvPr/>
-        </p:nvSpPr>
-        <p:spPr>
-          <a:xfrm>
-            <a:off x="274320" y="3566160"/>
-            <a:ext cx="5669280" cy="2331720"/>
-          </a:xfrm>
-          <a:prstGeom prst="roundRect">
-            <a:avLst/>
-          </a:prstGeom>
-          <a:solidFill>
-            <a:srgbClr val="F8FAFC"/>
-          </a:solidFill>
-          <a:ln w="19050">
-            <a:solidFill>
-              <a:srgbClr val="0D9488"/>
-            </a:solidFill>
-          </a:ln>
-        </p:spPr>
-        <p:style>
-          <a:lnRef idx="1">
-            <a:schemeClr val="accent1"/>
-          </a:lnRef>
-          <a:fillRef idx="3">
-            <a:schemeClr val="accent1"/>
-          </a:fillRef>
-          <a:effectRef idx="2">
-            <a:schemeClr val="accent1"/>
-          </a:effectRef>
-          <a:fontRef idx="minor">
-            <a:schemeClr val="lt1"/>
-          </a:fontRef>
-        </p:style>
-        <p:txBody>
-          <a:bodyPr rtlCol="0" anchor="ctr" wrap="square"/>
-          <a:lstStyle/>
-          <a:p>
-            <a:pPr algn="ctr"/>
-            <a:r>
-              <a:rPr sz="1700" b="1">
-                <a:solidFill>
-                  <a:srgbClr val="0D9488"/>
-                </a:solidFill>
-                <a:latin typeface="맑은 고딕"/>
-                <a:ea typeface="맑은 고딕"/>
-                <a:cs typeface="맑은 고딕"/>
-              </a:rPr>
-              <a:t>모니터링</a:t>
-            </a:r>
-          </a:p>
-          <a:p>
-            <a:pPr>
-              <a:spcBef>
-                <a:spcPts val="700"/>
-              </a:spcBef>
-            </a:pPr>
-            <a:r>
-              <a:rPr sz="1300" b="0">
-                <a:solidFill>
-                  <a:srgbClr val="0F172A"/>
-                </a:solidFill>
-                <a:latin typeface="맑은 고딕"/>
-                <a:ea typeface="맑은 고딕"/>
-                <a:cs typeface="맑은 고딕"/>
-              </a:rPr>
-              <a:t>• CloudWatch 알람</a:t>
-            </a:r>
-          </a:p>
-          <a:p>
-            <a:pPr>
-              <a:spcBef>
-                <a:spcPts val="700"/>
-              </a:spcBef>
-            </a:pPr>
-            <a:r>
-              <a:rPr sz="1300" b="0">
-                <a:solidFill>
-                  <a:srgbClr val="0F172A"/>
-                </a:solidFill>
-                <a:latin typeface="맑은 고딕"/>
-                <a:ea typeface="맑은 고딕"/>
-                <a:cs typeface="맑은 고딕"/>
-              </a:rPr>
-              <a:t>• Target Group health 확인</a:t>
-            </a:r>
-          </a:p>
-          <a:p>
-            <a:pPr>
-              <a:spcBef>
-                <a:spcPts val="700"/>
-              </a:spcBef>
-            </a:pPr>
-            <a:r>
-              <a:rPr sz="1300" b="0">
-                <a:solidFill>
-                  <a:srgbClr val="0F172A"/>
-                </a:solidFill>
-                <a:latin typeface="맑은 고딕"/>
-                <a:ea typeface="맑은 고딕"/>
-                <a:cs typeface="맑은 고딕"/>
-              </a:rPr>
-              <a:t>• SSM으로 서버 점검</a:t>
-            </a:r>
-          </a:p>
-        </p:txBody>
-      </p:sp>
-      <p:sp>
-        <p:nvSpPr>
-          <p:cNvPr id="7" name="Rounded Rectangle 6"/>
-          <p:cNvSpPr/>
-          <p:nvPr/>
-        </p:nvSpPr>
-        <p:spPr>
-          <a:xfrm>
-            <a:off x="6172200" y="3566160"/>
-            <a:ext cx="5669280" cy="2331720"/>
-          </a:xfrm>
-          <a:prstGeom prst="roundRect">
-            <a:avLst/>
-          </a:prstGeom>
-          <a:solidFill>
-            <a:srgbClr val="F8FAFC"/>
-          </a:solidFill>
-          <a:ln w="19050">
-            <a:solidFill>
-              <a:srgbClr val="DC2626"/>
-            </a:solidFill>
-          </a:ln>
-        </p:spPr>
-        <p:style>
-          <a:lnRef idx="1">
-            <a:schemeClr val="accent1"/>
-          </a:lnRef>
-          <a:fillRef idx="3">
-            <a:schemeClr val="accent1"/>
-          </a:fillRef>
-          <a:effectRef idx="2">
-            <a:schemeClr val="accent1"/>
-          </a:effectRef>
-          <a:fontRef idx="minor">
-            <a:schemeClr val="lt1"/>
-          </a:fontRef>
-        </p:style>
-        <p:txBody>
-          <a:bodyPr rtlCol="0" anchor="ctr" wrap="square"/>
-          <a:lstStyle/>
-          <a:p>
-            <a:pPr algn="ctr"/>
-            <a:r>
-              <a:rPr sz="1700" b="1">
-                <a:solidFill>
-                  <a:srgbClr val="DC2626"/>
-                </a:solidFill>
-                <a:latin typeface="맑은 고딕"/>
-                <a:ea typeface="맑은 고딕"/>
-                <a:cs typeface="맑은 고딕"/>
-              </a:rPr>
-              <a:t>보안</a:t>
-            </a:r>
-          </a:p>
-          <a:p>
-            <a:pPr>
-              <a:spcBef>
-                <a:spcPts val="700"/>
-              </a:spcBef>
-            </a:pPr>
-            <a:r>
-              <a:rPr sz="1300" b="0">
-                <a:solidFill>
-                  <a:srgbClr val="0F172A"/>
-                </a:solidFill>
-                <a:latin typeface="맑은 고딕"/>
-                <a:ea typeface="맑은 고딕"/>
-                <a:cs typeface="맑은 고딕"/>
-              </a:rPr>
-              <a:t>• SG 최소 포트 개방</a:t>
-            </a:r>
-          </a:p>
-          <a:p>
-            <a:pPr>
-              <a:spcBef>
-                <a:spcPts val="700"/>
-              </a:spcBef>
-            </a:pPr>
-            <a:r>
-              <a:rPr sz="1300" b="0">
-                <a:solidFill>
-                  <a:srgbClr val="0F172A"/>
-                </a:solidFill>
-                <a:latin typeface="맑은 고딕"/>
-                <a:ea typeface="맑은 고딕"/>
-                <a:cs typeface="맑은 고딕"/>
-              </a:rPr>
-              <a:t>• Secrets Manager로 키 주입</a:t>
-            </a:r>
-          </a:p>
-          <a:p>
-            <a:pPr>
-              <a:spcBef>
-                <a:spcPts val="700"/>
-              </a:spcBef>
-            </a:pPr>
-            <a:r>
-              <a:rPr sz="1300" b="0">
-                <a:solidFill>
-                  <a:srgbClr val="0F172A"/>
-                </a:solidFill>
-                <a:latin typeface="맑은 고딕"/>
-                <a:ea typeface="맑은 고딕"/>
-                <a:cs typeface="맑은 고딕"/>
-              </a:rPr>
-              <a:t>• ACM HTTPS + WAF(SQLi/Rate)</a:t>
-            </a:r>
-          </a:p>
-        </p:txBody>
-      </p:sp>
-      <p:sp>
-        <p:nvSpPr>
-          <p:cNvPr id="8" name="TextBox 7"/>
+        </p:spPr>
+      </p:pic>
+      <p:sp>
+        <p:nvSpPr>
+          <p:cNvPr id="5" name="TextBox 4"/>
           <p:cNvSpPr txBox="1"/>
           <p:nvPr/>
         </p:nvSpPr>
@@ -4619,7 +4709,7 @@
                 <a:ea typeface="맑은 고딕"/>
                 <a:cs typeface="맑은 고딕"/>
               </a:rPr>
-              <a:t>Aniverse · 온프레미스 3-tier → AWS   |   13/15</a:t>
+              <a:t>Aniverse · 온프레미스 3-tier → AWS   |   13/17</a:t>
             </a:r>
           </a:p>
         </p:txBody>
@@ -4716,7 +4806,7 @@
                 <a:ea typeface="맑은 고딕"/>
                 <a:cs typeface="맑은 고딕"/>
               </a:rPr>
-              <a:t>6. HTTPS · WAF (1)</a:t>
+              <a:t>5. 적용 내용 상세</a:t>
             </a:r>
           </a:p>
           <a:p>
@@ -4734,38 +4824,454 @@
                 <a:ea typeface="맑은 고딕"/>
                 <a:cs typeface="맑은 고딕"/>
               </a:rPr>
-              <a:t>도메인부터 ALB까지 암호화·필터링 경로</a:t>
-            </a:r>
-          </a:p>
-        </p:txBody>
-      </p:sp>
-      <p:pic>
-        <p:nvPicPr>
-          <p:cNvPr id="4" name="Picture 3" descr="06_https_waf.png"/>
-          <p:cNvPicPr>
-            <a:picLocks noChangeAspect="1"/>
-          </p:cNvPicPr>
+              <a:t>서비스가 실제로 어떻게 버티는지</a:t>
+            </a:r>
+          </a:p>
+        </p:txBody>
+      </p:sp>
+      <p:sp>
+        <p:nvSpPr>
+          <p:cNvPr id="4" name="Rounded Rectangle 3"/>
+          <p:cNvSpPr/>
           <p:nvPr/>
-        </p:nvPicPr>
-        <p:blipFill>
-          <a:blip r:embed="rId2"/>
-          <a:stretch>
-            <a:fillRect/>
-          </a:stretch>
-        </p:blipFill>
-        <p:spPr>
-          <a:xfrm>
-            <a:off x="320040" y="914400"/>
-            <a:ext cx="11521440" cy="6480810"/>
-          </a:xfrm>
-          <a:prstGeom prst="rect">
+        </p:nvSpPr>
+        <p:spPr>
+          <a:xfrm>
+            <a:off x="274320" y="1051560"/>
+            <a:ext cx="5669280" cy="2331720"/>
+          </a:xfrm>
+          <a:prstGeom prst="roundRect">
             <a:avLst/>
           </a:prstGeom>
-        </p:spPr>
-      </p:pic>
-      <p:sp>
-        <p:nvSpPr>
-          <p:cNvPr id="5" name="TextBox 4"/>
+          <a:solidFill>
+            <a:srgbClr val="F8FAFC"/>
+          </a:solidFill>
+          <a:ln w="19050">
+            <a:solidFill>
+              <a:srgbClr val="2563EB"/>
+            </a:solidFill>
+          </a:ln>
+        </p:spPr>
+        <p:style>
+          <a:lnRef idx="1">
+            <a:schemeClr val="accent1"/>
+          </a:lnRef>
+          <a:fillRef idx="3">
+            <a:schemeClr val="accent1"/>
+          </a:fillRef>
+          <a:effectRef idx="2">
+            <a:schemeClr val="accent1"/>
+          </a:effectRef>
+          <a:fontRef idx="minor">
+            <a:schemeClr val="lt1"/>
+          </a:fontRef>
+        </p:style>
+        <p:txBody>
+          <a:bodyPr rtlCol="0" anchor="ctr" wrap="square"/>
+          <a:lstStyle/>
+          <a:p>
+            <a:pPr algn="ctr"/>
+            <a:r>
+              <a:rPr sz="1700" b="1">
+                <a:solidFill>
+                  <a:srgbClr val="2563EB"/>
+                </a:solidFill>
+                <a:latin typeface="맑은 고딕"/>
+                <a:ea typeface="맑은 고딕"/>
+                <a:cs typeface="맑은 고딕"/>
+              </a:rPr>
+              <a:t>CI/CD</a:t>
+            </a:r>
+          </a:p>
+          <a:p>
+            <a:pPr>
+              <a:spcBef>
+                <a:spcPts val="700"/>
+              </a:spcBef>
+            </a:pPr>
+            <a:r>
+              <a:rPr sz="1300" b="0">
+                <a:solidFill>
+                  <a:srgbClr val="0F172A"/>
+                </a:solidFill>
+                <a:latin typeface="맑은 고딕"/>
+                <a:ea typeface="맑은 고딕"/>
+                <a:cs typeface="맑은 고딕"/>
+              </a:rPr>
+              <a:t>• Actions + CodeDeploy로 배포 경로 고정</a:t>
+            </a:r>
+          </a:p>
+          <a:p>
+            <a:pPr>
+              <a:spcBef>
+                <a:spcPts val="700"/>
+              </a:spcBef>
+            </a:pPr>
+            <a:r>
+              <a:rPr sz="1300" b="0">
+                <a:solidFill>
+                  <a:srgbClr val="0F172A"/>
+                </a:solidFill>
+                <a:latin typeface="맑은 고딕"/>
+                <a:ea typeface="맑은 고딕"/>
+                <a:cs typeface="맑은 고딕"/>
+              </a:rPr>
+              <a:t>• ALB /health/ 로 배포 성공 판정</a:t>
+            </a:r>
+          </a:p>
+          <a:p>
+            <a:pPr>
+              <a:spcBef>
+                <a:spcPts val="700"/>
+              </a:spcBef>
+            </a:pPr>
+            <a:r>
+              <a:rPr sz="1300" b="0">
+                <a:solidFill>
+                  <a:srgbClr val="0F172A"/>
+                </a:solidFill>
+                <a:latin typeface="맑은 고딕"/>
+                <a:ea typeface="맑은 고딕"/>
+                <a:cs typeface="맑은 고딕"/>
+              </a:rPr>
+              <a:t>• 실패 시 Actions·배포 로그로 추적</a:t>
+            </a:r>
+          </a:p>
+        </p:txBody>
+      </p:sp>
+      <p:sp>
+        <p:nvSpPr>
+          <p:cNvPr id="5" name="Rounded Rectangle 4"/>
+          <p:cNvSpPr/>
+          <p:nvPr/>
+        </p:nvSpPr>
+        <p:spPr>
+          <a:xfrm>
+            <a:off x="6172200" y="1051560"/>
+            <a:ext cx="5669280" cy="2331720"/>
+          </a:xfrm>
+          <a:prstGeom prst="roundRect">
+            <a:avLst/>
+          </a:prstGeom>
+          <a:solidFill>
+            <a:srgbClr val="F8FAFC"/>
+          </a:solidFill>
+          <a:ln w="19050">
+            <a:solidFill>
+              <a:srgbClr val="EA580C"/>
+            </a:solidFill>
+          </a:ln>
+        </p:spPr>
+        <p:style>
+          <a:lnRef idx="1">
+            <a:schemeClr val="accent1"/>
+          </a:lnRef>
+          <a:fillRef idx="3">
+            <a:schemeClr val="accent1"/>
+          </a:fillRef>
+          <a:effectRef idx="2">
+            <a:schemeClr val="accent1"/>
+          </a:effectRef>
+          <a:fontRef idx="minor">
+            <a:schemeClr val="lt1"/>
+          </a:fontRef>
+        </p:style>
+        <p:txBody>
+          <a:bodyPr rtlCol="0" anchor="ctr" wrap="square"/>
+          <a:lstStyle/>
+          <a:p>
+            <a:pPr algn="ctr"/>
+            <a:r>
+              <a:rPr sz="1700" b="1">
+                <a:solidFill>
+                  <a:srgbClr val="EA580C"/>
+                </a:solidFill>
+                <a:latin typeface="맑은 고딕"/>
+                <a:ea typeface="맑은 고딕"/>
+                <a:cs typeface="맑은 고딕"/>
+              </a:rPr>
+              <a:t>고가용성</a:t>
+            </a:r>
+          </a:p>
+          <a:p>
+            <a:pPr>
+              <a:spcBef>
+                <a:spcPts val="700"/>
+              </a:spcBef>
+            </a:pPr>
+            <a:r>
+              <a:rPr sz="1300" b="0">
+                <a:solidFill>
+                  <a:srgbClr val="0F172A"/>
+                </a:solidFill>
+                <a:latin typeface="맑은 고딕"/>
+                <a:ea typeface="맑은 고딕"/>
+                <a:cs typeface="맑은 고딕"/>
+              </a:rPr>
+              <a:t>• ALB로 트래픽 분산</a:t>
+            </a:r>
+          </a:p>
+          <a:p>
+            <a:pPr>
+              <a:spcBef>
+                <a:spcPts val="700"/>
+              </a:spcBef>
+            </a:pPr>
+            <a:r>
+              <a:rPr sz="1300" b="0">
+                <a:solidFill>
+                  <a:srgbClr val="0F172A"/>
+                </a:solidFill>
+                <a:latin typeface="맑은 고딕"/>
+                <a:ea typeface="맑은 고딕"/>
+                <a:cs typeface="맑은 고딕"/>
+              </a:rPr>
+              <a:t>• ASG로 인스턴스 교체·확장</a:t>
+            </a:r>
+          </a:p>
+          <a:p>
+            <a:pPr>
+              <a:spcBef>
+                <a:spcPts val="700"/>
+              </a:spcBef>
+            </a:pPr>
+            <a:r>
+              <a:rPr sz="1300" b="0">
+                <a:solidFill>
+                  <a:srgbClr val="0F172A"/>
+                </a:solidFill>
+                <a:latin typeface="맑은 고딕"/>
+                <a:ea typeface="맑은 고딕"/>
+                <a:cs typeface="맑은 고딕"/>
+              </a:rPr>
+              <a:t>• App/DB 서브넷 분리 배치</a:t>
+            </a:r>
+          </a:p>
+        </p:txBody>
+      </p:sp>
+      <p:sp>
+        <p:nvSpPr>
+          <p:cNvPr id="6" name="Rounded Rectangle 5"/>
+          <p:cNvSpPr/>
+          <p:nvPr/>
+        </p:nvSpPr>
+        <p:spPr>
+          <a:xfrm>
+            <a:off x="274320" y="3566160"/>
+            <a:ext cx="5669280" cy="2331720"/>
+          </a:xfrm>
+          <a:prstGeom prst="roundRect">
+            <a:avLst/>
+          </a:prstGeom>
+          <a:solidFill>
+            <a:srgbClr val="F8FAFC"/>
+          </a:solidFill>
+          <a:ln w="19050">
+            <a:solidFill>
+              <a:srgbClr val="0D9488"/>
+            </a:solidFill>
+          </a:ln>
+        </p:spPr>
+        <p:style>
+          <a:lnRef idx="1">
+            <a:schemeClr val="accent1"/>
+          </a:lnRef>
+          <a:fillRef idx="3">
+            <a:schemeClr val="accent1"/>
+          </a:fillRef>
+          <a:effectRef idx="2">
+            <a:schemeClr val="accent1"/>
+          </a:effectRef>
+          <a:fontRef idx="minor">
+            <a:schemeClr val="lt1"/>
+          </a:fontRef>
+        </p:style>
+        <p:txBody>
+          <a:bodyPr rtlCol="0" anchor="ctr" wrap="square"/>
+          <a:lstStyle/>
+          <a:p>
+            <a:pPr algn="ctr"/>
+            <a:r>
+              <a:rPr sz="1700" b="1">
+                <a:solidFill>
+                  <a:srgbClr val="0D9488"/>
+                </a:solidFill>
+                <a:latin typeface="맑은 고딕"/>
+                <a:ea typeface="맑은 고딕"/>
+                <a:cs typeface="맑은 고딕"/>
+              </a:rPr>
+              <a:t>모니터링</a:t>
+            </a:r>
+          </a:p>
+          <a:p>
+            <a:pPr>
+              <a:spcBef>
+                <a:spcPts val="700"/>
+              </a:spcBef>
+            </a:pPr>
+            <a:r>
+              <a:rPr sz="1300" b="0">
+                <a:solidFill>
+                  <a:srgbClr val="0F172A"/>
+                </a:solidFill>
+                <a:latin typeface="맑은 고딕"/>
+                <a:ea typeface="맑은 고딕"/>
+                <a:cs typeface="맑은 고딕"/>
+              </a:rPr>
+              <a:t>• CloudWatch 알람</a:t>
+            </a:r>
+          </a:p>
+          <a:p>
+            <a:pPr>
+              <a:spcBef>
+                <a:spcPts val="700"/>
+              </a:spcBef>
+            </a:pPr>
+            <a:r>
+              <a:rPr sz="1300" b="0">
+                <a:solidFill>
+                  <a:srgbClr val="0F172A"/>
+                </a:solidFill>
+                <a:latin typeface="맑은 고딕"/>
+                <a:ea typeface="맑은 고딕"/>
+                <a:cs typeface="맑은 고딕"/>
+              </a:rPr>
+              <a:t>• Target Group health 확인</a:t>
+            </a:r>
+          </a:p>
+          <a:p>
+            <a:pPr>
+              <a:spcBef>
+                <a:spcPts val="700"/>
+              </a:spcBef>
+            </a:pPr>
+            <a:r>
+              <a:rPr sz="1300" b="0">
+                <a:solidFill>
+                  <a:srgbClr val="0F172A"/>
+                </a:solidFill>
+                <a:latin typeface="맑은 고딕"/>
+                <a:ea typeface="맑은 고딕"/>
+                <a:cs typeface="맑은 고딕"/>
+              </a:rPr>
+              <a:t>• SSM으로 서버 점검</a:t>
+            </a:r>
+          </a:p>
+        </p:txBody>
+      </p:sp>
+      <p:sp>
+        <p:nvSpPr>
+          <p:cNvPr id="7" name="Rounded Rectangle 6"/>
+          <p:cNvSpPr/>
+          <p:nvPr/>
+        </p:nvSpPr>
+        <p:spPr>
+          <a:xfrm>
+            <a:off x="6172200" y="3566160"/>
+            <a:ext cx="5669280" cy="2331720"/>
+          </a:xfrm>
+          <a:prstGeom prst="roundRect">
+            <a:avLst/>
+          </a:prstGeom>
+          <a:solidFill>
+            <a:srgbClr val="F8FAFC"/>
+          </a:solidFill>
+          <a:ln w="19050">
+            <a:solidFill>
+              <a:srgbClr val="DC2626"/>
+            </a:solidFill>
+          </a:ln>
+        </p:spPr>
+        <p:style>
+          <a:lnRef idx="1">
+            <a:schemeClr val="accent1"/>
+          </a:lnRef>
+          <a:fillRef idx="3">
+            <a:schemeClr val="accent1"/>
+          </a:fillRef>
+          <a:effectRef idx="2">
+            <a:schemeClr val="accent1"/>
+          </a:effectRef>
+          <a:fontRef idx="minor">
+            <a:schemeClr val="lt1"/>
+          </a:fontRef>
+        </p:style>
+        <p:txBody>
+          <a:bodyPr rtlCol="0" anchor="ctr" wrap="square"/>
+          <a:lstStyle/>
+          <a:p>
+            <a:pPr algn="ctr"/>
+            <a:r>
+              <a:rPr sz="1700" b="1">
+                <a:solidFill>
+                  <a:srgbClr val="DC2626"/>
+                </a:solidFill>
+                <a:latin typeface="맑은 고딕"/>
+                <a:ea typeface="맑은 고딕"/>
+                <a:cs typeface="맑은 고딕"/>
+              </a:rPr>
+              <a:t>보안</a:t>
+            </a:r>
+          </a:p>
+          <a:p>
+            <a:pPr>
+              <a:spcBef>
+                <a:spcPts val="700"/>
+              </a:spcBef>
+            </a:pPr>
+            <a:r>
+              <a:rPr sz="1300" b="0">
+                <a:solidFill>
+                  <a:srgbClr val="0F172A"/>
+                </a:solidFill>
+                <a:latin typeface="맑은 고딕"/>
+                <a:ea typeface="맑은 고딕"/>
+                <a:cs typeface="맑은 고딕"/>
+              </a:rPr>
+              <a:t>• SG 최소 포트 개방</a:t>
+            </a:r>
+          </a:p>
+          <a:p>
+            <a:pPr>
+              <a:spcBef>
+                <a:spcPts val="700"/>
+              </a:spcBef>
+            </a:pPr>
+            <a:r>
+              <a:rPr sz="1300" b="0">
+                <a:solidFill>
+                  <a:srgbClr val="0F172A"/>
+                </a:solidFill>
+                <a:latin typeface="맑은 고딕"/>
+                <a:ea typeface="맑은 고딕"/>
+                <a:cs typeface="맑은 고딕"/>
+              </a:rPr>
+              <a:t>• Secrets Manager로 키 주입</a:t>
+            </a:r>
+          </a:p>
+          <a:p>
+            <a:pPr>
+              <a:spcBef>
+                <a:spcPts val="700"/>
+              </a:spcBef>
+            </a:pPr>
+            <a:r>
+              <a:rPr sz="1300" b="0">
+                <a:solidFill>
+                  <a:srgbClr val="0F172A"/>
+                </a:solidFill>
+                <a:latin typeface="맑은 고딕"/>
+                <a:ea typeface="맑은 고딕"/>
+                <a:cs typeface="맑은 고딕"/>
+              </a:rPr>
+              <a:t>• ACM HTTPS + WAF(SQLi/Rate)</a:t>
+            </a:r>
+          </a:p>
+        </p:txBody>
+      </p:sp>
+      <p:sp>
+        <p:nvSpPr>
+          <p:cNvPr id="8" name="TextBox 7"/>
           <p:cNvSpPr txBox="1"/>
           <p:nvPr/>
         </p:nvSpPr>
@@ -4795,7 +5301,7 @@
                 <a:ea typeface="맑은 고딕"/>
                 <a:cs typeface="맑은 고딕"/>
               </a:rPr>
-              <a:t>Aniverse · 온프레미스 3-tier → AWS   |   14/15</a:t>
+              <a:t>Aniverse · 온프레미스 3-tier → AWS   |   14/17</a:t>
             </a:r>
           </a:p>
         </p:txBody>
@@ -4892,7 +5398,7 @@
                 <a:ea typeface="맑은 고딕"/>
                 <a:cs typeface="맑은 고딕"/>
               </a:rPr>
-              <a:t>6. HTTPS · WAF (2)</a:t>
+              <a:t>6. HTTPS · WAF (1)</a:t>
             </a:r>
           </a:p>
           <a:p>
@@ -4910,594 +5416,38 @@
                 <a:ea typeface="맑은 고딕"/>
                 <a:cs typeface="맑은 고딕"/>
               </a:rPr>
-              <a:t>Terraform으로 고정한 보안 엣지</a:t>
-            </a:r>
-          </a:p>
-        </p:txBody>
-      </p:sp>
-      <p:sp>
-        <p:nvSpPr>
-          <p:cNvPr id="4" name="Rounded Rectangle 3"/>
-          <p:cNvSpPr/>
+              <a:t>도메인부터 ALB까지 암호화·필터링 경로</a:t>
+            </a:r>
+          </a:p>
+        </p:txBody>
+      </p:sp>
+      <p:pic>
+        <p:nvPicPr>
+          <p:cNvPr id="4" name="Picture 3" descr="06_https_waf.png"/>
+          <p:cNvPicPr>
+            <a:picLocks noChangeAspect="1"/>
+          </p:cNvPicPr>
           <p:nvPr/>
-        </p:nvSpPr>
-        <p:spPr>
-          <a:xfrm>
-            <a:off x="320040" y="1051560"/>
-            <a:ext cx="5669280" cy="5029200"/>
-          </a:xfrm>
-          <a:prstGeom prst="roundRect">
+        </p:nvPicPr>
+        <p:blipFill>
+          <a:blip r:embed="rId2"/>
+          <a:stretch>
+            <a:fillRect/>
+          </a:stretch>
+        </p:blipFill>
+        <p:spPr>
+          <a:xfrm>
+            <a:off x="320040" y="914400"/>
+            <a:ext cx="11521440" cy="6480810"/>
+          </a:xfrm>
+          <a:prstGeom prst="rect">
             <a:avLst/>
           </a:prstGeom>
-          <a:solidFill>
-            <a:srgbClr val="EFF6FF"/>
-          </a:solidFill>
-          <a:ln w="19050">
-            <a:solidFill>
-              <a:srgbClr val="0D9488"/>
-            </a:solidFill>
-          </a:ln>
-        </p:spPr>
-        <p:style>
-          <a:lnRef idx="1">
-            <a:schemeClr val="accent1"/>
-          </a:lnRef>
-          <a:fillRef idx="3">
-            <a:schemeClr val="accent1"/>
-          </a:fillRef>
-          <a:effectRef idx="2">
-            <a:schemeClr val="accent1"/>
-          </a:effectRef>
-          <a:fontRef idx="minor">
-            <a:schemeClr val="lt1"/>
-          </a:fontRef>
-        </p:style>
-        <p:txBody>
-          <a:bodyPr rtlCol="0" anchor="ctr" wrap="square"/>
-          <a:lstStyle/>
-          <a:p>
-            <a:pPr algn="ctr"/>
-            <a:r>
-              <a:rPr sz="1800" b="1">
-                <a:solidFill>
-                  <a:srgbClr val="0D9488"/>
-                </a:solidFill>
-                <a:latin typeface="맑은 고딕"/>
-                <a:ea typeface="맑은 고딕"/>
-                <a:cs typeface="맑은 고딕"/>
-              </a:rPr>
-              <a:t>HTTPS — ACM + ALB</a:t>
-            </a:r>
-          </a:p>
-          <a:p>
-            <a:pPr>
-              <a:spcBef>
-                <a:spcPts val="500"/>
-              </a:spcBef>
-            </a:pPr>
-            <a:r>
-              <a:rPr sz="1300" b="0">
-                <a:solidFill>
-                  <a:srgbClr val="0F172A"/>
-                </a:solidFill>
-                <a:latin typeface="맑은 고딕"/>
-                <a:ea typeface="맑은 고딕"/>
-                <a:cs typeface="맑은 고딕"/>
-              </a:rPr>
-              <a:t>modules/acm</a:t>
-            </a:r>
-          </a:p>
-          <a:p>
-            <a:pPr>
-              <a:spcBef>
-                <a:spcPts val="500"/>
-              </a:spcBef>
-            </a:pPr>
-            <a:r>
-              <a:rPr sz="1300" b="0">
-                <a:solidFill>
-                  <a:srgbClr val="0F172A"/>
-                </a:solidFill>
-                <a:latin typeface="맑은 고딕"/>
-                <a:ea typeface="맑은 고딕"/>
-                <a:cs typeface="맑은 고딕"/>
-              </a:rPr>
-              <a:t>• aniverse.my DNS 검증 인증서</a:t>
-            </a:r>
-          </a:p>
-          <a:p>
-            <a:pPr>
-              <a:spcBef>
-                <a:spcPts val="500"/>
-              </a:spcBef>
-            </a:pPr>
-            <a:r>
-              <a:rPr sz="1300" b="0">
-                <a:solidFill>
-                  <a:srgbClr val="0F172A"/>
-                </a:solidFill>
-                <a:latin typeface="맑은 고딕"/>
-                <a:ea typeface="맑은 고딕"/>
-                <a:cs typeface="맑은 고딕"/>
-              </a:rPr>
-              <a:t>• www SAN 포함 · Route53 검증 레코드</a:t>
-            </a:r>
-          </a:p>
-          <a:p>
-            <a:pPr>
-              <a:spcBef>
-                <a:spcPts val="500"/>
-              </a:spcBef>
-            </a:pPr>
-            <a:r>
-              <a:rPr sz="1300" b="0">
-                <a:solidFill>
-                  <a:srgbClr val="0F172A"/>
-                </a:solidFill>
-                <a:latin typeface="맑은 고딕"/>
-                <a:ea typeface="맑은 고딕"/>
-                <a:cs typeface="맑은 고딕"/>
-              </a:rPr>
-              <a:t/>
-            </a:r>
-          </a:p>
-          <a:p>
-            <a:pPr>
-              <a:spcBef>
-                <a:spcPts val="500"/>
-              </a:spcBef>
-            </a:pPr>
-            <a:r>
-              <a:rPr sz="1300" b="0">
-                <a:solidFill>
-                  <a:srgbClr val="0F172A"/>
-                </a:solidFill>
-                <a:latin typeface="맑은 고딕"/>
-                <a:ea typeface="맑은 고딕"/>
-                <a:cs typeface="맑은 고딕"/>
-              </a:rPr>
-              <a:t>modules/alb</a:t>
-            </a:r>
-          </a:p>
-          <a:p>
-            <a:pPr>
-              <a:spcBef>
-                <a:spcPts val="500"/>
-              </a:spcBef>
-            </a:pPr>
-            <a:r>
-              <a:rPr sz="1300" b="0">
-                <a:solidFill>
-                  <a:srgbClr val="0F172A"/>
-                </a:solidFill>
-                <a:latin typeface="맑은 고딕"/>
-                <a:ea typeface="맑은 고딕"/>
-                <a:cs typeface="맑은 고딕"/>
-              </a:rPr>
-              <a:t>• 443 HTTPS Listener (TLS 1.3)</a:t>
-            </a:r>
-          </a:p>
-          <a:p>
-            <a:pPr>
-              <a:spcBef>
-                <a:spcPts val="500"/>
-              </a:spcBef>
-            </a:pPr>
-            <a:r>
-              <a:rPr sz="1300" b="0">
-                <a:solidFill>
-                  <a:srgbClr val="0F172A"/>
-                </a:solidFill>
-                <a:latin typeface="맑은 고딕"/>
-                <a:ea typeface="맑은 고딕"/>
-                <a:cs typeface="맑은 고딕"/>
-              </a:rPr>
-              <a:t>• 80 → 443 HTTP 301 redirect</a:t>
-            </a:r>
-          </a:p>
-          <a:p>
-            <a:pPr>
-              <a:spcBef>
-                <a:spcPts val="500"/>
-              </a:spcBef>
-            </a:pPr>
-            <a:r>
-              <a:rPr sz="1300" b="0">
-                <a:solidFill>
-                  <a:srgbClr val="0F172A"/>
-                </a:solidFill>
-                <a:latin typeface="맑은 고딕"/>
-                <a:ea typeface="맑은 고딕"/>
-                <a:cs typeface="맑은 고딕"/>
-              </a:rPr>
-              <a:t>• Target Group → ASG/EC2</a:t>
-            </a:r>
-          </a:p>
-          <a:p>
-            <a:pPr>
-              <a:spcBef>
-                <a:spcPts val="500"/>
-              </a:spcBef>
-            </a:pPr>
-            <a:r>
-              <a:rPr sz="1300" b="0">
-                <a:solidFill>
-                  <a:srgbClr val="0F172A"/>
-                </a:solidFill>
-                <a:latin typeface="맑은 고딕"/>
-                <a:ea typeface="맑은 고딕"/>
-                <a:cs typeface="맑은 고딕"/>
-              </a:rPr>
-              <a:t/>
-            </a:r>
-          </a:p>
-          <a:p>
-            <a:pPr>
-              <a:spcBef>
-                <a:spcPts val="500"/>
-              </a:spcBef>
-            </a:pPr>
-            <a:r>
-              <a:rPr sz="1300" b="0">
-                <a:solidFill>
-                  <a:srgbClr val="0F172A"/>
-                </a:solidFill>
-                <a:latin typeface="맑은 고딕"/>
-                <a:ea typeface="맑은 고딕"/>
-                <a:cs typeface="맑은 고딕"/>
-              </a:rPr>
-              <a:t>앱 연동</a:t>
-            </a:r>
-          </a:p>
-          <a:p>
-            <a:pPr>
-              <a:spcBef>
-                <a:spcPts val="500"/>
-              </a:spcBef>
-            </a:pPr>
-            <a:r>
-              <a:rPr sz="1300" b="0">
-                <a:solidFill>
-                  <a:srgbClr val="0F172A"/>
-                </a:solidFill>
-                <a:latin typeface="맑은 고딕"/>
-                <a:ea typeface="맑은 고딕"/>
-                <a:cs typeface="맑은 고딕"/>
-              </a:rPr>
-              <a:t>• Secrets: USE_HTTPS=True</a:t>
-            </a:r>
-          </a:p>
-          <a:p>
-            <a:pPr>
-              <a:spcBef>
-                <a:spcPts val="500"/>
-              </a:spcBef>
-            </a:pPr>
-            <a:r>
-              <a:rPr sz="1300" b="0">
-                <a:solidFill>
-                  <a:srgbClr val="0F172A"/>
-                </a:solidFill>
-                <a:latin typeface="맑은 고딕"/>
-                <a:ea typeface="맑은 고딕"/>
-                <a:cs typeface="맑은 고딕"/>
-              </a:rPr>
-              <a:t>• CSRF / ALLOWED_HOSTS https 허용</a:t>
-            </a:r>
-          </a:p>
-        </p:txBody>
-      </p:sp>
-      <p:sp>
-        <p:nvSpPr>
-          <p:cNvPr id="5" name="Rounded Rectangle 4"/>
-          <p:cNvSpPr/>
-          <p:nvPr/>
-        </p:nvSpPr>
-        <p:spPr>
-          <a:xfrm>
-            <a:off x="6217920" y="1051560"/>
-            <a:ext cx="5623560" cy="5029200"/>
-          </a:xfrm>
-          <a:prstGeom prst="roundRect">
-            <a:avLst/>
-          </a:prstGeom>
-          <a:solidFill>
-            <a:srgbClr val="FEF2F2"/>
-          </a:solidFill>
-          <a:ln w="19050">
-            <a:solidFill>
-              <a:srgbClr val="DC2626"/>
-            </a:solidFill>
-          </a:ln>
-        </p:spPr>
-        <p:style>
-          <a:lnRef idx="1">
-            <a:schemeClr val="accent1"/>
-          </a:lnRef>
-          <a:fillRef idx="3">
-            <a:schemeClr val="accent1"/>
-          </a:fillRef>
-          <a:effectRef idx="2">
-            <a:schemeClr val="accent1"/>
-          </a:effectRef>
-          <a:fontRef idx="minor">
-            <a:schemeClr val="lt1"/>
-          </a:fontRef>
-        </p:style>
-        <p:txBody>
-          <a:bodyPr rtlCol="0" anchor="ctr" wrap="square"/>
-          <a:lstStyle/>
-          <a:p>
-            <a:pPr algn="ctr"/>
-            <a:r>
-              <a:rPr sz="1800" b="1">
-                <a:solidFill>
-                  <a:srgbClr val="DC2626"/>
-                </a:solidFill>
-                <a:latin typeface="맑은 고딕"/>
-                <a:ea typeface="맑은 고딕"/>
-                <a:cs typeface="맑은 고딕"/>
-              </a:rPr>
-              <a:t>WAF — ALB Web ACL</a:t>
-            </a:r>
-          </a:p>
-          <a:p>
-            <a:pPr>
-              <a:spcBef>
-                <a:spcPts val="400"/>
-              </a:spcBef>
-            </a:pPr>
-            <a:r>
-              <a:rPr sz="1300" b="0">
-                <a:solidFill>
-                  <a:srgbClr val="0F172A"/>
-                </a:solidFill>
-                <a:latin typeface="맑은 고딕"/>
-                <a:ea typeface="맑은 고딕"/>
-                <a:cs typeface="맑은 고딕"/>
-              </a:rPr>
-              <a:t>modules/waf → aniverse-alb-waf</a:t>
-            </a:r>
-          </a:p>
-          <a:p>
-            <a:pPr>
-              <a:spcBef>
-                <a:spcPts val="400"/>
-              </a:spcBef>
-            </a:pPr>
-            <a:r>
-              <a:rPr sz="1300" b="0">
-                <a:solidFill>
-                  <a:srgbClr val="0F172A"/>
-                </a:solidFill>
-                <a:latin typeface="맑은 고딕"/>
-                <a:ea typeface="맑은 고딕"/>
-                <a:cs typeface="맑은 고딕"/>
-              </a:rPr>
-              <a:t>• scope: REGIONAL (ALB 전용)</a:t>
-            </a:r>
-          </a:p>
-          <a:p>
-            <a:pPr>
-              <a:spcBef>
-                <a:spcPts val="400"/>
-              </a:spcBef>
-            </a:pPr>
-            <a:r>
-              <a:rPr sz="1300" b="0">
-                <a:solidFill>
-                  <a:srgbClr val="0F172A"/>
-                </a:solidFill>
-                <a:latin typeface="맑은 고딕"/>
-                <a:ea typeface="맑은 고딕"/>
-                <a:cs typeface="맑은 고딕"/>
-              </a:rPr>
-              <a:t/>
-            </a:r>
-          </a:p>
-          <a:p>
-            <a:pPr>
-              <a:spcBef>
-                <a:spcPts val="400"/>
-              </a:spcBef>
-            </a:pPr>
-            <a:r>
-              <a:rPr sz="1300" b="0">
-                <a:solidFill>
-                  <a:srgbClr val="0F172A"/>
-                </a:solidFill>
-                <a:latin typeface="맑은 고딕"/>
-                <a:ea typeface="맑은 고딕"/>
-                <a:cs typeface="맑은 고딕"/>
-              </a:rPr>
-              <a:t>관리형 규칙</a:t>
-            </a:r>
-          </a:p>
-          <a:p>
-            <a:pPr>
-              <a:spcBef>
-                <a:spcPts val="400"/>
-              </a:spcBef>
-            </a:pPr>
-            <a:r>
-              <a:rPr sz="1300" b="0">
-                <a:solidFill>
-                  <a:srgbClr val="0F172A"/>
-                </a:solidFill>
-                <a:latin typeface="맑은 고딕"/>
-                <a:ea typeface="맑은 고딕"/>
-                <a:cs typeface="맑은 고딕"/>
-              </a:rPr>
-              <a:t>• CommonRuleSet (일반 웹 공격)</a:t>
-            </a:r>
-          </a:p>
-          <a:p>
-            <a:pPr>
-              <a:spcBef>
-                <a:spcPts val="400"/>
-              </a:spcBef>
-            </a:pPr>
-            <a:r>
-              <a:rPr sz="1300" b="0">
-                <a:solidFill>
-                  <a:srgbClr val="0F172A"/>
-                </a:solidFill>
-                <a:latin typeface="맑은 고딕"/>
-                <a:ea typeface="맑은 고딕"/>
-                <a:cs typeface="맑은 고딕"/>
-              </a:rPr>
-              <a:t>• KnownBadInputs</a:t>
-            </a:r>
-          </a:p>
-          <a:p>
-            <a:pPr>
-              <a:spcBef>
-                <a:spcPts val="400"/>
-              </a:spcBef>
-            </a:pPr>
-            <a:r>
-              <a:rPr sz="1300" b="0">
-                <a:solidFill>
-                  <a:srgbClr val="0F172A"/>
-                </a:solidFill>
-                <a:latin typeface="맑은 고딕"/>
-                <a:ea typeface="맑은 고딕"/>
-                <a:cs typeface="맑은 고딕"/>
-              </a:rPr>
-              <a:t>• SQLi RuleSet</a:t>
-            </a:r>
-          </a:p>
-          <a:p>
-            <a:pPr>
-              <a:spcBef>
-                <a:spcPts val="400"/>
-              </a:spcBef>
-            </a:pPr>
-            <a:r>
-              <a:rPr sz="1300" b="0">
-                <a:solidFill>
-                  <a:srgbClr val="0F172A"/>
-                </a:solidFill>
-                <a:latin typeface="맑은 고딕"/>
-                <a:ea typeface="맑은 고딕"/>
-                <a:cs typeface="맑은 고딕"/>
-              </a:rPr>
-              <a:t/>
-            </a:r>
-          </a:p>
-          <a:p>
-            <a:pPr>
-              <a:spcBef>
-                <a:spcPts val="400"/>
-              </a:spcBef>
-            </a:pPr>
-            <a:r>
-              <a:rPr sz="1300" b="0">
-                <a:solidFill>
-                  <a:srgbClr val="0F172A"/>
-                </a:solidFill>
-                <a:latin typeface="맑은 고딕"/>
-                <a:ea typeface="맑은 고딕"/>
-                <a:cs typeface="맑은 고딕"/>
-              </a:rPr>
-              <a:t>커스텀</a:t>
-            </a:r>
-          </a:p>
-          <a:p>
-            <a:pPr>
-              <a:spcBef>
-                <a:spcPts val="400"/>
-              </a:spcBef>
-            </a:pPr>
-            <a:r>
-              <a:rPr sz="1300" b="0">
-                <a:solidFill>
-                  <a:srgbClr val="0F172A"/>
-                </a:solidFill>
-                <a:latin typeface="맑은 고딕"/>
-                <a:ea typeface="맑은 고딕"/>
-                <a:cs typeface="맑은 고딕"/>
-              </a:rPr>
-              <a:t>• RateLimitPerIP → Block</a:t>
-            </a:r>
-          </a:p>
-          <a:p>
-            <a:pPr>
-              <a:spcBef>
-                <a:spcPts val="400"/>
-              </a:spcBef>
-            </a:pPr>
-            <a:r>
-              <a:rPr sz="1300" b="0">
-                <a:solidFill>
-                  <a:srgbClr val="0F172A"/>
-                </a:solidFill>
-                <a:latin typeface="맑은 고딕"/>
-                <a:ea typeface="맑은 고딕"/>
-                <a:cs typeface="맑은 고딕"/>
-              </a:rPr>
-              <a:t/>
-            </a:r>
-          </a:p>
-          <a:p>
-            <a:pPr>
-              <a:spcBef>
-                <a:spcPts val="400"/>
-              </a:spcBef>
-            </a:pPr>
-            <a:r>
-              <a:rPr sz="1300" b="0">
-                <a:solidFill>
-                  <a:srgbClr val="0F172A"/>
-                </a:solidFill>
-                <a:latin typeface="맑은 고딕"/>
-                <a:ea typeface="맑은 고딕"/>
-                <a:cs typeface="맑은 고딕"/>
-              </a:rPr>
-              <a:t>연결</a:t>
-            </a:r>
-          </a:p>
-          <a:p>
-            <a:pPr>
-              <a:spcBef>
-                <a:spcPts val="400"/>
-              </a:spcBef>
-            </a:pPr>
-            <a:r>
-              <a:rPr sz="1300" b="0">
-                <a:solidFill>
-                  <a:srgbClr val="0F172A"/>
-                </a:solidFill>
-                <a:latin typeface="맑은 고딕"/>
-                <a:ea typeface="맑은 고딕"/>
-                <a:cs typeface="맑은 고딕"/>
-              </a:rPr>
-              <a:t>• web_acl_association → ALB ARN</a:t>
-            </a:r>
-          </a:p>
-          <a:p>
-            <a:pPr>
-              <a:spcBef>
-                <a:spcPts val="400"/>
-              </a:spcBef>
-            </a:pPr>
-            <a:r>
-              <a:rPr sz="1300" b="0">
-                <a:solidFill>
-                  <a:srgbClr val="0F172A"/>
-                </a:solidFill>
-                <a:latin typeface="맑은 고딕"/>
-                <a:ea typeface="맑은 고딕"/>
-                <a:cs typeface="맑은 고딕"/>
-              </a:rPr>
-              <a:t>• CloudWatch metrics / sampled req</a:t>
-            </a:r>
-          </a:p>
-        </p:txBody>
-      </p:sp>
-      <p:sp>
-        <p:nvSpPr>
-          <p:cNvPr id="6" name="TextBox 5"/>
+        </p:spPr>
+      </p:pic>
+      <p:sp>
+        <p:nvSpPr>
+          <p:cNvPr id="5" name="TextBox 4"/>
           <p:cNvSpPr txBox="1"/>
           <p:nvPr/>
         </p:nvSpPr>
@@ -5527,7 +5477,7 @@
                 <a:ea typeface="맑은 고딕"/>
                 <a:cs typeface="맑은 고딕"/>
               </a:rPr>
-              <a:t>Aniverse · 온프레미스 3-tier → AWS   |   15/15</a:t>
+              <a:t>Aniverse · 온프레미스 3-tier → AWS   |   15/17</a:t>
             </a:r>
           </a:p>
         </p:txBody>
@@ -5559,6 +5509,738 @@
         <p:spPr>
           <a:xfrm>
             <a:off x="0" y="0"/>
+            <a:ext cx="12191695" cy="777240"/>
+          </a:xfrm>
+          <a:prstGeom prst="rect">
+            <a:avLst/>
+          </a:prstGeom>
+          <a:solidFill>
+            <a:srgbClr val="0F172A"/>
+          </a:solidFill>
+          <a:ln>
+            <a:noFill/>
+          </a:ln>
+        </p:spPr>
+        <p:style>
+          <a:lnRef idx="1">
+            <a:schemeClr val="accent1"/>
+          </a:lnRef>
+          <a:fillRef idx="3">
+            <a:schemeClr val="accent1"/>
+          </a:fillRef>
+          <a:effectRef idx="2">
+            <a:schemeClr val="accent1"/>
+          </a:effectRef>
+          <a:fontRef idx="minor">
+            <a:schemeClr val="lt1"/>
+          </a:fontRef>
+        </p:style>
+        <p:txBody>
+          <a:bodyPr rtlCol="0" anchor="ctr"/>
+          <a:lstStyle/>
+          <a:p>
+            <a:pPr algn="ctr"/>
+          </a:p>
+        </p:txBody>
+      </p:sp>
+      <p:sp>
+        <p:nvSpPr>
+          <p:cNvPr id="3" name="TextBox 2"/>
+          <p:cNvSpPr txBox="1"/>
+          <p:nvPr/>
+        </p:nvSpPr>
+        <p:spPr>
+          <a:xfrm>
+            <a:off x="411480" y="109728"/>
+            <a:ext cx="11338560" cy="594360"/>
+          </a:xfrm>
+          <a:prstGeom prst="rect">
+            <a:avLst/>
+          </a:prstGeom>
+          <a:noFill/>
+        </p:spPr>
+        <p:txBody>
+          <a:bodyPr wrap="square">
+            <a:spAutoFit/>
+          </a:bodyPr>
+          <a:lstStyle/>
+          <a:p>
+            <a:r>
+              <a:rPr sz="2200" b="1">
+                <a:solidFill>
+                  <a:srgbClr val="FFFFFF"/>
+                </a:solidFill>
+                <a:latin typeface="맑은 고딕"/>
+                <a:ea typeface="맑은 고딕"/>
+                <a:cs typeface="맑은 고딕"/>
+              </a:rPr>
+              <a:t>6. HTTPS · WAF (2)</a:t>
+            </a:r>
+          </a:p>
+          <a:p>
+            <a:pPr>
+              <a:spcBef>
+                <a:spcPts val="200"/>
+              </a:spcBef>
+            </a:pPr>
+            <a:r>
+              <a:rPr sz="1200" b="0">
+                <a:solidFill>
+                  <a:srgbClr val="93C5FD"/>
+                </a:solidFill>
+                <a:latin typeface="맑은 고딕"/>
+                <a:ea typeface="맑은 고딕"/>
+                <a:cs typeface="맑은 고딕"/>
+              </a:rPr>
+              <a:t>Terraform으로 고정한 보안 엣지</a:t>
+            </a:r>
+          </a:p>
+        </p:txBody>
+      </p:sp>
+      <p:sp>
+        <p:nvSpPr>
+          <p:cNvPr id="4" name="Rounded Rectangle 3"/>
+          <p:cNvSpPr/>
+          <p:nvPr/>
+        </p:nvSpPr>
+        <p:spPr>
+          <a:xfrm>
+            <a:off x="320040" y="1051560"/>
+            <a:ext cx="5669280" cy="5029200"/>
+          </a:xfrm>
+          <a:prstGeom prst="roundRect">
+            <a:avLst/>
+          </a:prstGeom>
+          <a:solidFill>
+            <a:srgbClr val="EFF6FF"/>
+          </a:solidFill>
+          <a:ln w="19050">
+            <a:solidFill>
+              <a:srgbClr val="0D9488"/>
+            </a:solidFill>
+          </a:ln>
+        </p:spPr>
+        <p:style>
+          <a:lnRef idx="1">
+            <a:schemeClr val="accent1"/>
+          </a:lnRef>
+          <a:fillRef idx="3">
+            <a:schemeClr val="accent1"/>
+          </a:fillRef>
+          <a:effectRef idx="2">
+            <a:schemeClr val="accent1"/>
+          </a:effectRef>
+          <a:fontRef idx="minor">
+            <a:schemeClr val="lt1"/>
+          </a:fontRef>
+        </p:style>
+        <p:txBody>
+          <a:bodyPr rtlCol="0" anchor="ctr" wrap="square"/>
+          <a:lstStyle/>
+          <a:p>
+            <a:pPr algn="ctr"/>
+            <a:r>
+              <a:rPr sz="1800" b="1">
+                <a:solidFill>
+                  <a:srgbClr val="0D9488"/>
+                </a:solidFill>
+                <a:latin typeface="맑은 고딕"/>
+                <a:ea typeface="맑은 고딕"/>
+                <a:cs typeface="맑은 고딕"/>
+              </a:rPr>
+              <a:t>HTTPS — ACM + ALB</a:t>
+            </a:r>
+          </a:p>
+          <a:p>
+            <a:pPr>
+              <a:spcBef>
+                <a:spcPts val="500"/>
+              </a:spcBef>
+            </a:pPr>
+            <a:r>
+              <a:rPr sz="1300" b="0">
+                <a:solidFill>
+                  <a:srgbClr val="0F172A"/>
+                </a:solidFill>
+                <a:latin typeface="맑은 고딕"/>
+                <a:ea typeface="맑은 고딕"/>
+                <a:cs typeface="맑은 고딕"/>
+              </a:rPr>
+              <a:t>modules/acm</a:t>
+            </a:r>
+          </a:p>
+          <a:p>
+            <a:pPr>
+              <a:spcBef>
+                <a:spcPts val="500"/>
+              </a:spcBef>
+            </a:pPr>
+            <a:r>
+              <a:rPr sz="1300" b="0">
+                <a:solidFill>
+                  <a:srgbClr val="0F172A"/>
+                </a:solidFill>
+                <a:latin typeface="맑은 고딕"/>
+                <a:ea typeface="맑은 고딕"/>
+                <a:cs typeface="맑은 고딕"/>
+              </a:rPr>
+              <a:t>• aniverse.my DNS 검증 인증서</a:t>
+            </a:r>
+          </a:p>
+          <a:p>
+            <a:pPr>
+              <a:spcBef>
+                <a:spcPts val="500"/>
+              </a:spcBef>
+            </a:pPr>
+            <a:r>
+              <a:rPr sz="1300" b="0">
+                <a:solidFill>
+                  <a:srgbClr val="0F172A"/>
+                </a:solidFill>
+                <a:latin typeface="맑은 고딕"/>
+                <a:ea typeface="맑은 고딕"/>
+                <a:cs typeface="맑은 고딕"/>
+              </a:rPr>
+              <a:t>• www SAN 포함 · Route53 검증 레코드</a:t>
+            </a:r>
+          </a:p>
+          <a:p>
+            <a:pPr>
+              <a:spcBef>
+                <a:spcPts val="500"/>
+              </a:spcBef>
+            </a:pPr>
+            <a:r>
+              <a:rPr sz="1300" b="0">
+                <a:solidFill>
+                  <a:srgbClr val="0F172A"/>
+                </a:solidFill>
+                <a:latin typeface="맑은 고딕"/>
+                <a:ea typeface="맑은 고딕"/>
+                <a:cs typeface="맑은 고딕"/>
+              </a:rPr>
+              <a:t/>
+            </a:r>
+          </a:p>
+          <a:p>
+            <a:pPr>
+              <a:spcBef>
+                <a:spcPts val="500"/>
+              </a:spcBef>
+            </a:pPr>
+            <a:r>
+              <a:rPr sz="1300" b="0">
+                <a:solidFill>
+                  <a:srgbClr val="0F172A"/>
+                </a:solidFill>
+                <a:latin typeface="맑은 고딕"/>
+                <a:ea typeface="맑은 고딕"/>
+                <a:cs typeface="맑은 고딕"/>
+              </a:rPr>
+              <a:t>modules/alb</a:t>
+            </a:r>
+          </a:p>
+          <a:p>
+            <a:pPr>
+              <a:spcBef>
+                <a:spcPts val="500"/>
+              </a:spcBef>
+            </a:pPr>
+            <a:r>
+              <a:rPr sz="1300" b="0">
+                <a:solidFill>
+                  <a:srgbClr val="0F172A"/>
+                </a:solidFill>
+                <a:latin typeface="맑은 고딕"/>
+                <a:ea typeface="맑은 고딕"/>
+                <a:cs typeface="맑은 고딕"/>
+              </a:rPr>
+              <a:t>• 443 HTTPS Listener (TLS 1.3)</a:t>
+            </a:r>
+          </a:p>
+          <a:p>
+            <a:pPr>
+              <a:spcBef>
+                <a:spcPts val="500"/>
+              </a:spcBef>
+            </a:pPr>
+            <a:r>
+              <a:rPr sz="1300" b="0">
+                <a:solidFill>
+                  <a:srgbClr val="0F172A"/>
+                </a:solidFill>
+                <a:latin typeface="맑은 고딕"/>
+                <a:ea typeface="맑은 고딕"/>
+                <a:cs typeface="맑은 고딕"/>
+              </a:rPr>
+              <a:t>• 80 → 443 HTTP 301 redirect</a:t>
+            </a:r>
+          </a:p>
+          <a:p>
+            <a:pPr>
+              <a:spcBef>
+                <a:spcPts val="500"/>
+              </a:spcBef>
+            </a:pPr>
+            <a:r>
+              <a:rPr sz="1300" b="0">
+                <a:solidFill>
+                  <a:srgbClr val="0F172A"/>
+                </a:solidFill>
+                <a:latin typeface="맑은 고딕"/>
+                <a:ea typeface="맑은 고딕"/>
+                <a:cs typeface="맑은 고딕"/>
+              </a:rPr>
+              <a:t>• Target Group → ASG/EC2</a:t>
+            </a:r>
+          </a:p>
+          <a:p>
+            <a:pPr>
+              <a:spcBef>
+                <a:spcPts val="500"/>
+              </a:spcBef>
+            </a:pPr>
+            <a:r>
+              <a:rPr sz="1300" b="0">
+                <a:solidFill>
+                  <a:srgbClr val="0F172A"/>
+                </a:solidFill>
+                <a:latin typeface="맑은 고딕"/>
+                <a:ea typeface="맑은 고딕"/>
+                <a:cs typeface="맑은 고딕"/>
+              </a:rPr>
+              <a:t/>
+            </a:r>
+          </a:p>
+          <a:p>
+            <a:pPr>
+              <a:spcBef>
+                <a:spcPts val="500"/>
+              </a:spcBef>
+            </a:pPr>
+            <a:r>
+              <a:rPr sz="1300" b="0">
+                <a:solidFill>
+                  <a:srgbClr val="0F172A"/>
+                </a:solidFill>
+                <a:latin typeface="맑은 고딕"/>
+                <a:ea typeface="맑은 고딕"/>
+                <a:cs typeface="맑은 고딕"/>
+              </a:rPr>
+              <a:t>앱 연동</a:t>
+            </a:r>
+          </a:p>
+          <a:p>
+            <a:pPr>
+              <a:spcBef>
+                <a:spcPts val="500"/>
+              </a:spcBef>
+            </a:pPr>
+            <a:r>
+              <a:rPr sz="1300" b="0">
+                <a:solidFill>
+                  <a:srgbClr val="0F172A"/>
+                </a:solidFill>
+                <a:latin typeface="맑은 고딕"/>
+                <a:ea typeface="맑은 고딕"/>
+                <a:cs typeface="맑은 고딕"/>
+              </a:rPr>
+              <a:t>• Secrets: USE_HTTPS=True</a:t>
+            </a:r>
+          </a:p>
+          <a:p>
+            <a:pPr>
+              <a:spcBef>
+                <a:spcPts val="500"/>
+              </a:spcBef>
+            </a:pPr>
+            <a:r>
+              <a:rPr sz="1300" b="0">
+                <a:solidFill>
+                  <a:srgbClr val="0F172A"/>
+                </a:solidFill>
+                <a:latin typeface="맑은 고딕"/>
+                <a:ea typeface="맑은 고딕"/>
+                <a:cs typeface="맑은 고딕"/>
+              </a:rPr>
+              <a:t>• CSRF / ALLOWED_HOSTS https 허용</a:t>
+            </a:r>
+          </a:p>
+        </p:txBody>
+      </p:sp>
+      <p:sp>
+        <p:nvSpPr>
+          <p:cNvPr id="5" name="Rounded Rectangle 4"/>
+          <p:cNvSpPr/>
+          <p:nvPr/>
+        </p:nvSpPr>
+        <p:spPr>
+          <a:xfrm>
+            <a:off x="6217920" y="1051560"/>
+            <a:ext cx="5623560" cy="5029200"/>
+          </a:xfrm>
+          <a:prstGeom prst="roundRect">
+            <a:avLst/>
+          </a:prstGeom>
+          <a:solidFill>
+            <a:srgbClr val="FEF2F2"/>
+          </a:solidFill>
+          <a:ln w="19050">
+            <a:solidFill>
+              <a:srgbClr val="DC2626"/>
+            </a:solidFill>
+          </a:ln>
+        </p:spPr>
+        <p:style>
+          <a:lnRef idx="1">
+            <a:schemeClr val="accent1"/>
+          </a:lnRef>
+          <a:fillRef idx="3">
+            <a:schemeClr val="accent1"/>
+          </a:fillRef>
+          <a:effectRef idx="2">
+            <a:schemeClr val="accent1"/>
+          </a:effectRef>
+          <a:fontRef idx="minor">
+            <a:schemeClr val="lt1"/>
+          </a:fontRef>
+        </p:style>
+        <p:txBody>
+          <a:bodyPr rtlCol="0" anchor="ctr" wrap="square"/>
+          <a:lstStyle/>
+          <a:p>
+            <a:pPr algn="ctr"/>
+            <a:r>
+              <a:rPr sz="1800" b="1">
+                <a:solidFill>
+                  <a:srgbClr val="DC2626"/>
+                </a:solidFill>
+                <a:latin typeface="맑은 고딕"/>
+                <a:ea typeface="맑은 고딕"/>
+                <a:cs typeface="맑은 고딕"/>
+              </a:rPr>
+              <a:t>WAF — ALB Web ACL</a:t>
+            </a:r>
+          </a:p>
+          <a:p>
+            <a:pPr>
+              <a:spcBef>
+                <a:spcPts val="400"/>
+              </a:spcBef>
+            </a:pPr>
+            <a:r>
+              <a:rPr sz="1300" b="0">
+                <a:solidFill>
+                  <a:srgbClr val="0F172A"/>
+                </a:solidFill>
+                <a:latin typeface="맑은 고딕"/>
+                <a:ea typeface="맑은 고딕"/>
+                <a:cs typeface="맑은 고딕"/>
+              </a:rPr>
+              <a:t>modules/waf → aniverse-alb-waf</a:t>
+            </a:r>
+          </a:p>
+          <a:p>
+            <a:pPr>
+              <a:spcBef>
+                <a:spcPts val="400"/>
+              </a:spcBef>
+            </a:pPr>
+            <a:r>
+              <a:rPr sz="1300" b="0">
+                <a:solidFill>
+                  <a:srgbClr val="0F172A"/>
+                </a:solidFill>
+                <a:latin typeface="맑은 고딕"/>
+                <a:ea typeface="맑은 고딕"/>
+                <a:cs typeface="맑은 고딕"/>
+              </a:rPr>
+              <a:t>• scope: REGIONAL (ALB 전용)</a:t>
+            </a:r>
+          </a:p>
+          <a:p>
+            <a:pPr>
+              <a:spcBef>
+                <a:spcPts val="400"/>
+              </a:spcBef>
+            </a:pPr>
+            <a:r>
+              <a:rPr sz="1300" b="0">
+                <a:solidFill>
+                  <a:srgbClr val="0F172A"/>
+                </a:solidFill>
+                <a:latin typeface="맑은 고딕"/>
+                <a:ea typeface="맑은 고딕"/>
+                <a:cs typeface="맑은 고딕"/>
+              </a:rPr>
+              <a:t/>
+            </a:r>
+          </a:p>
+          <a:p>
+            <a:pPr>
+              <a:spcBef>
+                <a:spcPts val="400"/>
+              </a:spcBef>
+            </a:pPr>
+            <a:r>
+              <a:rPr sz="1300" b="0">
+                <a:solidFill>
+                  <a:srgbClr val="0F172A"/>
+                </a:solidFill>
+                <a:latin typeface="맑은 고딕"/>
+                <a:ea typeface="맑은 고딕"/>
+                <a:cs typeface="맑은 고딕"/>
+              </a:rPr>
+              <a:t>관리형 규칙</a:t>
+            </a:r>
+          </a:p>
+          <a:p>
+            <a:pPr>
+              <a:spcBef>
+                <a:spcPts val="400"/>
+              </a:spcBef>
+            </a:pPr>
+            <a:r>
+              <a:rPr sz="1300" b="0">
+                <a:solidFill>
+                  <a:srgbClr val="0F172A"/>
+                </a:solidFill>
+                <a:latin typeface="맑은 고딕"/>
+                <a:ea typeface="맑은 고딕"/>
+                <a:cs typeface="맑은 고딕"/>
+              </a:rPr>
+              <a:t>• CommonRuleSet (일반 웹 공격)</a:t>
+            </a:r>
+          </a:p>
+          <a:p>
+            <a:pPr>
+              <a:spcBef>
+                <a:spcPts val="400"/>
+              </a:spcBef>
+            </a:pPr>
+            <a:r>
+              <a:rPr sz="1300" b="0">
+                <a:solidFill>
+                  <a:srgbClr val="0F172A"/>
+                </a:solidFill>
+                <a:latin typeface="맑은 고딕"/>
+                <a:ea typeface="맑은 고딕"/>
+                <a:cs typeface="맑은 고딕"/>
+              </a:rPr>
+              <a:t>• KnownBadInputs</a:t>
+            </a:r>
+          </a:p>
+          <a:p>
+            <a:pPr>
+              <a:spcBef>
+                <a:spcPts val="400"/>
+              </a:spcBef>
+            </a:pPr>
+            <a:r>
+              <a:rPr sz="1300" b="0">
+                <a:solidFill>
+                  <a:srgbClr val="0F172A"/>
+                </a:solidFill>
+                <a:latin typeface="맑은 고딕"/>
+                <a:ea typeface="맑은 고딕"/>
+                <a:cs typeface="맑은 고딕"/>
+              </a:rPr>
+              <a:t>• SQLi RuleSet</a:t>
+            </a:r>
+          </a:p>
+          <a:p>
+            <a:pPr>
+              <a:spcBef>
+                <a:spcPts val="400"/>
+              </a:spcBef>
+            </a:pPr>
+            <a:r>
+              <a:rPr sz="1300" b="0">
+                <a:solidFill>
+                  <a:srgbClr val="0F172A"/>
+                </a:solidFill>
+                <a:latin typeface="맑은 고딕"/>
+                <a:ea typeface="맑은 고딕"/>
+                <a:cs typeface="맑은 고딕"/>
+              </a:rPr>
+              <a:t/>
+            </a:r>
+          </a:p>
+          <a:p>
+            <a:pPr>
+              <a:spcBef>
+                <a:spcPts val="400"/>
+              </a:spcBef>
+            </a:pPr>
+            <a:r>
+              <a:rPr sz="1300" b="0">
+                <a:solidFill>
+                  <a:srgbClr val="0F172A"/>
+                </a:solidFill>
+                <a:latin typeface="맑은 고딕"/>
+                <a:ea typeface="맑은 고딕"/>
+                <a:cs typeface="맑은 고딕"/>
+              </a:rPr>
+              <a:t>커스텀</a:t>
+            </a:r>
+          </a:p>
+          <a:p>
+            <a:pPr>
+              <a:spcBef>
+                <a:spcPts val="400"/>
+              </a:spcBef>
+            </a:pPr>
+            <a:r>
+              <a:rPr sz="1300" b="0">
+                <a:solidFill>
+                  <a:srgbClr val="0F172A"/>
+                </a:solidFill>
+                <a:latin typeface="맑은 고딕"/>
+                <a:ea typeface="맑은 고딕"/>
+                <a:cs typeface="맑은 고딕"/>
+              </a:rPr>
+              <a:t>• RateLimitPerIP → Block</a:t>
+            </a:r>
+          </a:p>
+          <a:p>
+            <a:pPr>
+              <a:spcBef>
+                <a:spcPts val="400"/>
+              </a:spcBef>
+            </a:pPr>
+            <a:r>
+              <a:rPr sz="1300" b="0">
+                <a:solidFill>
+                  <a:srgbClr val="0F172A"/>
+                </a:solidFill>
+                <a:latin typeface="맑은 고딕"/>
+                <a:ea typeface="맑은 고딕"/>
+                <a:cs typeface="맑은 고딕"/>
+              </a:rPr>
+              <a:t/>
+            </a:r>
+          </a:p>
+          <a:p>
+            <a:pPr>
+              <a:spcBef>
+                <a:spcPts val="400"/>
+              </a:spcBef>
+            </a:pPr>
+            <a:r>
+              <a:rPr sz="1300" b="0">
+                <a:solidFill>
+                  <a:srgbClr val="0F172A"/>
+                </a:solidFill>
+                <a:latin typeface="맑은 고딕"/>
+                <a:ea typeface="맑은 고딕"/>
+                <a:cs typeface="맑은 고딕"/>
+              </a:rPr>
+              <a:t>연결</a:t>
+            </a:r>
+          </a:p>
+          <a:p>
+            <a:pPr>
+              <a:spcBef>
+                <a:spcPts val="400"/>
+              </a:spcBef>
+            </a:pPr>
+            <a:r>
+              <a:rPr sz="1300" b="0">
+                <a:solidFill>
+                  <a:srgbClr val="0F172A"/>
+                </a:solidFill>
+                <a:latin typeface="맑은 고딕"/>
+                <a:ea typeface="맑은 고딕"/>
+                <a:cs typeface="맑은 고딕"/>
+              </a:rPr>
+              <a:t>• web_acl_association → ALB ARN</a:t>
+            </a:r>
+          </a:p>
+          <a:p>
+            <a:pPr>
+              <a:spcBef>
+                <a:spcPts val="400"/>
+              </a:spcBef>
+            </a:pPr>
+            <a:r>
+              <a:rPr sz="1300" b="0">
+                <a:solidFill>
+                  <a:srgbClr val="0F172A"/>
+                </a:solidFill>
+                <a:latin typeface="맑은 고딕"/>
+                <a:ea typeface="맑은 고딕"/>
+                <a:cs typeface="맑은 고딕"/>
+              </a:rPr>
+              <a:t>• CloudWatch metrics / sampled req</a:t>
+            </a:r>
+          </a:p>
+        </p:txBody>
+      </p:sp>
+      <p:sp>
+        <p:nvSpPr>
+          <p:cNvPr id="6" name="TextBox 5"/>
+          <p:cNvSpPr txBox="1"/>
+          <p:nvPr/>
+        </p:nvSpPr>
+        <p:spPr>
+          <a:xfrm>
+            <a:off x="411480" y="6446520"/>
+            <a:ext cx="11338560" cy="274320"/>
+          </a:xfrm>
+          <a:prstGeom prst="rect">
+            <a:avLst/>
+          </a:prstGeom>
+          <a:noFill/>
+        </p:spPr>
+        <p:txBody>
+          <a:bodyPr wrap="none">
+            <a:spAutoFit/>
+          </a:bodyPr>
+          <a:lstStyle/>
+          <a:p>
+            <a:pPr algn="r"/>
+            <a:r>
+              <a:rPr sz="1000" b="0">
+                <a:solidFill>
+                  <a:srgbClr val="475569"/>
+                </a:solidFill>
+                <a:latin typeface="맑은 고딕"/>
+                <a:ea typeface="맑은 고딕"/>
+                <a:cs typeface="맑은 고딕"/>
+              </a:rPr>
+              <a:t>Aniverse · 온프레미스 3-tier → AWS   |   16/17</a:t>
+            </a:r>
+          </a:p>
+        </p:txBody>
+      </p:sp>
+    </p:spTree>
+  </p:cSld>
+  <p:clrMapOvr>
+    <a:masterClrMapping/>
+  </p:clrMapOvr>
+</p:sld>
+</file>
+
+<file path=ppt/slides/slide17.xml><?xml version="1.0" encoding="utf-8"?>
+<p:sld xmlns:a="http://schemas.openxmlformats.org/drawingml/2006/main" xmlns:p="http://schemas.openxmlformats.org/presentationml/2006/main" xmlns:r="http://schemas.openxmlformats.org/officeDocument/2006/relationships">
+  <p:cSld>
+    <p:spTree>
+      <p:nvGrpSpPr>
+        <p:cNvPr id="1" name=""/>
+        <p:cNvGrpSpPr/>
+        <p:nvPr/>
+      </p:nvGrpSpPr>
+      <p:grpSpPr/>
+      <p:sp>
+        <p:nvSpPr>
+          <p:cNvPr id="2" name="Rectangle 1"/>
+          <p:cNvSpPr/>
+          <p:nvPr/>
+        </p:nvSpPr>
+        <p:spPr>
+          <a:xfrm>
+            <a:off x="0" y="0"/>
             <a:ext cx="12191695" cy="6858000"/>
           </a:xfrm>
           <a:prstGeom prst="rect">
@@ -6148,7 +6830,7 @@
                 <a:ea typeface="맑은 고딕"/>
                 <a:cs typeface="맑은 고딕"/>
               </a:rPr>
-              <a:t>Aniverse · 온프레미스 3-tier → AWS   |   2/15</a:t>
+              <a:t>Aniverse · 온프레미스 3-tier → AWS   |   2/17</a:t>
             </a:r>
           </a:p>
         </p:txBody>
@@ -6824,7 +7506,7 @@
                 <a:ea typeface="맑은 고딕"/>
                 <a:cs typeface="맑은 고딕"/>
               </a:rPr>
-              <a:t>Aniverse · 온프레미스 3-tier → AWS   |   3/15</a:t>
+              <a:t>Aniverse · 온프레미스 3-tier → AWS   |   3/17</a:t>
             </a:r>
           </a:p>
         </p:txBody>
@@ -7000,7 +7682,7 @@
                 <a:ea typeface="맑은 고딕"/>
                 <a:cs typeface="맑은 고딕"/>
               </a:rPr>
-              <a:t>Aniverse · 온프레미스 3-tier → AWS   |   4/15</a:t>
+              <a:t>Aniverse · 온프레미스 3-tier → AWS   |   4/17</a:t>
             </a:r>
           </a:p>
         </p:txBody>
@@ -7592,7 +8274,7 @@
                 <a:ea typeface="맑은 고딕"/>
                 <a:cs typeface="맑은 고딕"/>
               </a:rPr>
-              <a:t>Aniverse · 온프레미스 3-tier → AWS   |   5/15</a:t>
+              <a:t>Aniverse · 온프레미스 3-tier → AWS   |   5/17</a:t>
             </a:r>
           </a:p>
         </p:txBody>
@@ -7768,7 +8450,7 @@
                 <a:ea typeface="맑은 고딕"/>
                 <a:cs typeface="맑은 고딕"/>
               </a:rPr>
-              <a:t>Aniverse · 온프레미스 3-tier → AWS   |   6/15</a:t>
+              <a:t>Aniverse · 온프레미스 3-tier → AWS   |   6/17</a:t>
             </a:r>
           </a:p>
         </p:txBody>
@@ -7944,7 +8626,7 @@
                 <a:ea typeface="맑은 고딕"/>
                 <a:cs typeface="맑은 고딕"/>
               </a:rPr>
-              <a:t>Aniverse · 온프레미스 3-tier → AWS   |   7/15</a:t>
+              <a:t>Aniverse · 온프레미스 3-tier → AWS   |   7/17</a:t>
             </a:r>
           </a:p>
         </p:txBody>
@@ -8496,7 +9178,7 @@
                 <a:ea typeface="맑은 고딕"/>
                 <a:cs typeface="맑은 고딕"/>
               </a:rPr>
-              <a:t>Aniverse · 온프레미스 3-tier → AWS   |   8/15</a:t>
+              <a:t>Aniverse · 온프레미스 3-tier → AWS   |   8/17</a:t>
             </a:r>
           </a:p>
         </p:txBody>
@@ -9160,7 +9842,7 @@
                 <a:ea typeface="맑은 고딕"/>
                 <a:cs typeface="맑은 고딕"/>
               </a:rPr>
-              <a:t>Aniverse · 온프레미스 3-tier → AWS   |   9/15</a:t>
+              <a:t>Aniverse · 온프레미스 3-tier → AWS   |   9/17</a:t>
             </a:r>
           </a:p>
         </p:txBody>

</xml_diff>

<commit_message>
docs: update SG list and add DB subnet NACL on instructor PPT
Expand slide 8 Security SG coverage (NAT/Redis/endpoints) and add DB subnet NACL to the security detail card.

Co-authored-by: ho0215 <ho0215@users.noreply.github.com>
</commit_message>
<xml_diff>
--- a/docs/presentation/ppt/Aniverse_발표_강사용.pptx
+++ b/docs/presentation/ppt/Aniverse_발표_강사용.pptx
@@ -5246,6 +5246,24 @@
                 <a:ea typeface="맑은 고딕"/>
                 <a:cs typeface="맑은 고딕"/>
               </a:rPr>
+              <a:t>• DB subnet NACL 설정</a:t>
+            </a:r>
+          </a:p>
+          <a:p>
+            <a:pPr>
+              <a:spcBef>
+                <a:spcPts val="700"/>
+              </a:spcBef>
+            </a:pPr>
+            <a:r>
+              <a:rPr sz="1300" b="0">
+                <a:solidFill>
+                  <a:srgbClr val="0F172A"/>
+                </a:solidFill>
+                <a:latin typeface="맑은 고딕"/>
+                <a:ea typeface="맑은 고딕"/>
+                <a:cs typeface="맑은 고딕"/>
+              </a:rPr>
               <a:t>• Secrets Manager로 키 주입</a:t>
             </a:r>
           </a:p>
@@ -8833,7 +8851,7 @@
                 <a:ea typeface="맑은 고딕"/>
                 <a:cs typeface="맑은 고딕"/>
               </a:rPr>
-              <a:t>• Security: ALB/App/DB/EFS용 Security Group</a:t>
+              <a:t>• Security: ALB/App/NAT/DB/EFS/Redis/endpoints 용 Security Group</a:t>
             </a:r>
           </a:p>
           <a:p>

</xml_diff>

<commit_message>
docs: fix instructor PPT overflow (images, cards, long SG text)
Clamp diagram images above the footer, tighten card padding/fonts, and wrap the Security SG line so text no longer spills.

Co-authored-by: ho0215 <ho0215@users.noreply.github.com>
</commit_message>
<xml_diff>
--- a/docs/presentation/ppt/Aniverse_발표_강사용.pptx
+++ b/docs/presentation/ppt/Aniverse_발표_강사용.pptx
@@ -3164,7 +3164,7 @@
           <a:noFill/>
         </p:spPr>
         <p:txBody>
-          <a:bodyPr wrap="square">
+          <a:bodyPr wrap="square" lIns="109728" rIns="109728" tIns="73152" bIns="73152">
             <a:spAutoFit/>
           </a:bodyPr>
           <a:lstStyle/>
@@ -3315,7 +3315,7 @@
           <a:noFill/>
         </p:spPr>
         <p:txBody>
-          <a:bodyPr wrap="square">
+          <a:bodyPr wrap="square" lIns="109728" rIns="109728" tIns="73152" bIns="73152">
             <a:spAutoFit/>
           </a:bodyPr>
           <a:lstStyle/>
@@ -3360,8 +3360,8 @@
         </p:nvSpPr>
         <p:spPr>
           <a:xfrm>
-            <a:off x="320040" y="1051560"/>
-            <a:ext cx="3703320" cy="4709160"/>
+            <a:off x="365760" y="1051560"/>
+            <a:ext cx="3657600" cy="4526280"/>
           </a:xfrm>
           <a:prstGeom prst="roundRect">
             <a:avLst/>
@@ -3390,12 +3390,12 @@
           </a:fontRef>
         </p:style>
         <p:txBody>
-          <a:bodyPr rtlCol="0" anchor="ctr" wrap="square"/>
+          <a:bodyPr rtlCol="0" anchor="ctr" wrap="square" lIns="109728" rIns="109728" tIns="73152" bIns="73152"/>
           <a:lstStyle/>
           <a:p>
             <a:pPr algn="ctr"/>
             <a:r>
-              <a:rPr sz="1800" b="1">
+              <a:rPr sz="1700" b="1">
                 <a:solidFill>
                   <a:srgbClr val="16A34A"/>
                 </a:solidFill>
@@ -3409,11 +3409,11 @@
           <a:p>
             <a:pPr algn="ctr">
               <a:spcBef>
-                <a:spcPts val="800"/>
-              </a:spcBef>
-            </a:pPr>
-            <a:r>
-              <a:rPr sz="1300" b="1">
+                <a:spcPts val="600"/>
+              </a:spcBef>
+            </a:pPr>
+            <a:r>
+              <a:rPr sz="1200" b="1">
                 <a:solidFill>
                   <a:srgbClr val="475569"/>
                 </a:solidFill>
@@ -3427,11 +3427,11 @@
           <a:p>
             <a:pPr algn="ctr">
               <a:spcBef>
-                <a:spcPts val="800"/>
-              </a:spcBef>
-            </a:pPr>
-            <a:r>
-              <a:rPr sz="1300" b="0">
+                <a:spcPts val="700"/>
+              </a:spcBef>
+            </a:pPr>
+            <a:r>
+              <a:rPr sz="1200" b="0">
                 <a:solidFill>
                   <a:srgbClr val="0F172A"/>
                 </a:solidFill>
@@ -3445,11 +3445,11 @@
           <a:p>
             <a:pPr algn="ctr">
               <a:spcBef>
-                <a:spcPts val="800"/>
-              </a:spcBef>
-            </a:pPr>
-            <a:r>
-              <a:rPr sz="1300" b="0">
+                <a:spcPts val="700"/>
+              </a:spcBef>
+            </a:pPr>
+            <a:r>
+              <a:rPr sz="1200" b="0">
                 <a:solidFill>
                   <a:srgbClr val="0F172A"/>
                 </a:solidFill>
@@ -3463,11 +3463,11 @@
           <a:p>
             <a:pPr algn="ctr">
               <a:spcBef>
-                <a:spcPts val="800"/>
-              </a:spcBef>
-            </a:pPr>
-            <a:r>
-              <a:rPr sz="1300" b="0">
+                <a:spcPts val="700"/>
+              </a:spcBef>
+            </a:pPr>
+            <a:r>
+              <a:rPr sz="1200" b="0">
                 <a:solidFill>
                   <a:srgbClr val="0F172A"/>
                 </a:solidFill>
@@ -3481,11 +3481,11 @@
           <a:p>
             <a:pPr algn="ctr">
               <a:spcBef>
-                <a:spcPts val="800"/>
-              </a:spcBef>
-            </a:pPr>
-            <a:r>
-              <a:rPr sz="1300" b="0">
+                <a:spcPts val="700"/>
+              </a:spcBef>
+            </a:pPr>
+            <a:r>
+              <a:rPr sz="1200" b="0">
                 <a:solidFill>
                   <a:srgbClr val="0F172A"/>
                 </a:solidFill>
@@ -3499,11 +3499,11 @@
           <a:p>
             <a:pPr algn="ctr">
               <a:spcBef>
-                <a:spcPts val="800"/>
-              </a:spcBef>
-            </a:pPr>
-            <a:r>
-              <a:rPr sz="1300" b="0">
+                <a:spcPts val="700"/>
+              </a:spcBef>
+            </a:pPr>
+            <a:r>
+              <a:rPr sz="1200" b="0">
                 <a:solidFill>
                   <a:srgbClr val="0F172A"/>
                 </a:solidFill>
@@ -3525,7 +3525,7 @@
         <p:spPr>
           <a:xfrm>
             <a:off x="4206240" y="1051560"/>
-            <a:ext cx="3703320" cy="4709160"/>
+            <a:ext cx="3657600" cy="4526280"/>
           </a:xfrm>
           <a:prstGeom prst="roundRect">
             <a:avLst/>
@@ -3554,12 +3554,12 @@
           </a:fontRef>
         </p:style>
         <p:txBody>
-          <a:bodyPr rtlCol="0" anchor="ctr" wrap="square"/>
+          <a:bodyPr rtlCol="0" anchor="ctr" wrap="square" lIns="109728" rIns="109728" tIns="73152" bIns="73152"/>
           <a:lstStyle/>
           <a:p>
             <a:pPr algn="ctr"/>
             <a:r>
-              <a:rPr sz="1800" b="1">
+              <a:rPr sz="1700" b="1">
                 <a:solidFill>
                   <a:srgbClr val="0D9488"/>
                 </a:solidFill>
@@ -3573,11 +3573,11 @@
           <a:p>
             <a:pPr algn="ctr">
               <a:spcBef>
-                <a:spcPts val="800"/>
-              </a:spcBef>
-            </a:pPr>
-            <a:r>
-              <a:rPr sz="1300" b="1">
+                <a:spcPts val="600"/>
+              </a:spcBef>
+            </a:pPr>
+            <a:r>
+              <a:rPr sz="1200" b="1">
                 <a:solidFill>
                   <a:srgbClr val="475569"/>
                 </a:solidFill>
@@ -3591,11 +3591,11 @@
           <a:p>
             <a:pPr algn="ctr">
               <a:spcBef>
-                <a:spcPts val="800"/>
-              </a:spcBef>
-            </a:pPr>
-            <a:r>
-              <a:rPr sz="1300" b="0">
+                <a:spcPts val="700"/>
+              </a:spcBef>
+            </a:pPr>
+            <a:r>
+              <a:rPr sz="1200" b="0">
                 <a:solidFill>
                   <a:srgbClr val="0F172A"/>
                 </a:solidFill>
@@ -3609,11 +3609,11 @@
           <a:p>
             <a:pPr algn="ctr">
               <a:spcBef>
-                <a:spcPts val="800"/>
-              </a:spcBef>
-            </a:pPr>
-            <a:r>
-              <a:rPr sz="1300" b="0">
+                <a:spcPts val="700"/>
+              </a:spcBef>
+            </a:pPr>
+            <a:r>
+              <a:rPr sz="1200" b="0">
                 <a:solidFill>
                   <a:srgbClr val="0F172A"/>
                 </a:solidFill>
@@ -3627,11 +3627,11 @@
           <a:p>
             <a:pPr algn="ctr">
               <a:spcBef>
-                <a:spcPts val="800"/>
-              </a:spcBef>
-            </a:pPr>
-            <a:r>
-              <a:rPr sz="1300" b="0">
+                <a:spcPts val="700"/>
+              </a:spcBef>
+            </a:pPr>
+            <a:r>
+              <a:rPr sz="1200" b="0">
                 <a:solidFill>
                   <a:srgbClr val="0F172A"/>
                 </a:solidFill>
@@ -3645,11 +3645,11 @@
           <a:p>
             <a:pPr algn="ctr">
               <a:spcBef>
-                <a:spcPts val="800"/>
-              </a:spcBef>
-            </a:pPr>
-            <a:r>
-              <a:rPr sz="1300" b="0">
+                <a:spcPts val="700"/>
+              </a:spcBef>
+            </a:pPr>
+            <a:r>
+              <a:rPr sz="1200" b="0">
                 <a:solidFill>
                   <a:srgbClr val="0F172A"/>
                 </a:solidFill>
@@ -3663,11 +3663,11 @@
           <a:p>
             <a:pPr algn="ctr">
               <a:spcBef>
-                <a:spcPts val="800"/>
-              </a:spcBef>
-            </a:pPr>
-            <a:r>
-              <a:rPr sz="1300" b="0">
+                <a:spcPts val="700"/>
+              </a:spcBef>
+            </a:pPr>
+            <a:r>
+              <a:rPr sz="1200" b="0">
                 <a:solidFill>
                   <a:srgbClr val="0F172A"/>
                 </a:solidFill>
@@ -3688,8 +3688,8 @@
         </p:nvSpPr>
         <p:spPr>
           <a:xfrm>
-            <a:off x="8092440" y="1051560"/>
-            <a:ext cx="3703320" cy="4709160"/>
+            <a:off x="8046720" y="1051560"/>
+            <a:ext cx="3657600" cy="4526280"/>
           </a:xfrm>
           <a:prstGeom prst="roundRect">
             <a:avLst/>
@@ -3718,12 +3718,12 @@
           </a:fontRef>
         </p:style>
         <p:txBody>
-          <a:bodyPr rtlCol="0" anchor="ctr" wrap="square"/>
+          <a:bodyPr rtlCol="0" anchor="ctr" wrap="square" lIns="109728" rIns="109728" tIns="73152" bIns="73152"/>
           <a:lstStyle/>
           <a:p>
             <a:pPr algn="ctr"/>
             <a:r>
-              <a:rPr sz="1800" b="1">
+              <a:rPr sz="1700" b="1">
                 <a:solidFill>
                   <a:srgbClr val="EA580C"/>
                 </a:solidFill>
@@ -3737,11 +3737,11 @@
           <a:p>
             <a:pPr algn="ctr">
               <a:spcBef>
-                <a:spcPts val="800"/>
-              </a:spcBef>
-            </a:pPr>
-            <a:r>
-              <a:rPr sz="1300" b="1">
+                <a:spcPts val="600"/>
+              </a:spcBef>
+            </a:pPr>
+            <a:r>
+              <a:rPr sz="1200" b="1">
                 <a:solidFill>
                   <a:srgbClr val="475569"/>
                 </a:solidFill>
@@ -3755,11 +3755,11 @@
           <a:p>
             <a:pPr algn="ctr">
               <a:spcBef>
-                <a:spcPts val="800"/>
-              </a:spcBef>
-            </a:pPr>
-            <a:r>
-              <a:rPr sz="1300" b="0">
+                <a:spcPts val="700"/>
+              </a:spcBef>
+            </a:pPr>
+            <a:r>
+              <a:rPr sz="1200" b="0">
                 <a:solidFill>
                   <a:srgbClr val="0F172A"/>
                 </a:solidFill>
@@ -3773,11 +3773,11 @@
           <a:p>
             <a:pPr algn="ctr">
               <a:spcBef>
-                <a:spcPts val="800"/>
-              </a:spcBef>
-            </a:pPr>
-            <a:r>
-              <a:rPr sz="1300" b="0">
+                <a:spcPts val="700"/>
+              </a:spcBef>
+            </a:pPr>
+            <a:r>
+              <a:rPr sz="1200" b="0">
                 <a:solidFill>
                   <a:srgbClr val="0F172A"/>
                 </a:solidFill>
@@ -3791,11 +3791,11 @@
           <a:p>
             <a:pPr algn="ctr">
               <a:spcBef>
-                <a:spcPts val="800"/>
-              </a:spcBef>
-            </a:pPr>
-            <a:r>
-              <a:rPr sz="1300" b="0">
+                <a:spcPts val="700"/>
+              </a:spcBef>
+            </a:pPr>
+            <a:r>
+              <a:rPr sz="1200" b="0">
                 <a:solidFill>
                   <a:srgbClr val="0F172A"/>
                 </a:solidFill>
@@ -3809,11 +3809,11 @@
           <a:p>
             <a:pPr algn="ctr">
               <a:spcBef>
-                <a:spcPts val="800"/>
-              </a:spcBef>
-            </a:pPr>
-            <a:r>
-              <a:rPr sz="1300" b="0">
+                <a:spcPts val="700"/>
+              </a:spcBef>
+            </a:pPr>
+            <a:r>
+              <a:rPr sz="1200" b="0">
                 <a:solidFill>
                   <a:srgbClr val="0F172A"/>
                 </a:solidFill>
@@ -3827,11 +3827,11 @@
           <a:p>
             <a:pPr algn="ctr">
               <a:spcBef>
-                <a:spcPts val="800"/>
-              </a:spcBef>
-            </a:pPr>
-            <a:r>
-              <a:rPr sz="1300" b="0">
+                <a:spcPts val="700"/>
+              </a:spcBef>
+            </a:pPr>
+            <a:r>
+              <a:rPr sz="1200" b="0">
                 <a:solidFill>
                   <a:srgbClr val="0F172A"/>
                 </a:solidFill>
@@ -3852,8 +3852,8 @@
         </p:nvSpPr>
         <p:spPr>
           <a:xfrm>
-            <a:off x="365760" y="5852160"/>
-            <a:ext cx="11430000" cy="411480"/>
+            <a:off x="365760" y="5715000"/>
+            <a:ext cx="11430000" cy="457200"/>
           </a:xfrm>
           <a:prstGeom prst="rect">
             <a:avLst/>
@@ -3861,14 +3861,14 @@
           <a:noFill/>
         </p:spPr>
         <p:txBody>
-          <a:bodyPr wrap="square">
+          <a:bodyPr wrap="square" lIns="109728" rIns="109728" tIns="73152" bIns="73152">
             <a:spAutoFit/>
           </a:bodyPr>
           <a:lstStyle/>
           <a:p>
             <a:pPr algn="ctr"/>
             <a:r>
-              <a:rPr sz="1400" b="1">
+              <a:rPr sz="1300" b="1">
                 <a:solidFill>
                   <a:srgbClr val="0D9488"/>
                 </a:solidFill>
@@ -3996,7 +3996,7 @@
           <a:noFill/>
         </p:spPr>
         <p:txBody>
-          <a:bodyPr wrap="square">
+          <a:bodyPr wrap="square" lIns="109728" rIns="109728" tIns="73152" bIns="73152">
             <a:spAutoFit/>
           </a:bodyPr>
           <a:lstStyle/>
@@ -4049,8 +4049,8 @@
         </p:blipFill>
         <p:spPr>
           <a:xfrm>
-            <a:off x="274320" y="960120"/>
-            <a:ext cx="11612880" cy="6532245"/>
+            <a:off x="1285239" y="960120"/>
+            <a:ext cx="9591040" cy="5394960"/>
           </a:xfrm>
           <a:prstGeom prst="rect">
             <a:avLst/>
@@ -4172,7 +4172,7 @@
           <a:noFill/>
         </p:spPr>
         <p:txBody>
-          <a:bodyPr wrap="square">
+          <a:bodyPr wrap="square" lIns="109728" rIns="109728" tIns="73152" bIns="73152">
             <a:spAutoFit/>
           </a:bodyPr>
           <a:lstStyle/>
@@ -4247,7 +4247,7 @@
           </a:fontRef>
         </p:style>
         <p:txBody>
-          <a:bodyPr rtlCol="0" anchor="ctr" wrap="square"/>
+          <a:bodyPr rtlCol="0" anchor="ctr" wrap="square" lIns="109728" rIns="109728" tIns="73152" bIns="73152"/>
           <a:lstStyle/>
           <a:p>
             <a:pPr algn="ctr"/>
@@ -4393,7 +4393,7 @@
           </a:fontRef>
         </p:style>
         <p:txBody>
-          <a:bodyPr rtlCol="0" anchor="ctr" wrap="square"/>
+          <a:bodyPr rtlCol="0" anchor="ctr" wrap="square" lIns="109728" rIns="109728" tIns="73152" bIns="73152"/>
           <a:lstStyle/>
           <a:p>
             <a:pPr algn="ctr"/>
@@ -4616,7 +4616,7 @@
           <a:noFill/>
         </p:spPr>
         <p:txBody>
-          <a:bodyPr wrap="square">
+          <a:bodyPr wrap="square" lIns="109728" rIns="109728" tIns="73152" bIns="73152">
             <a:spAutoFit/>
           </a:bodyPr>
           <a:lstStyle/>
@@ -4792,7 +4792,7 @@
           <a:noFill/>
         </p:spPr>
         <p:txBody>
-          <a:bodyPr wrap="square">
+          <a:bodyPr wrap="square" lIns="109728" rIns="109728" tIns="73152" bIns="73152">
             <a:spAutoFit/>
           </a:bodyPr>
           <a:lstStyle/>
@@ -4837,8 +4837,8 @@
         </p:nvSpPr>
         <p:spPr>
           <a:xfrm>
-            <a:off x="274320" y="1051560"/>
-            <a:ext cx="5669280" cy="2331720"/>
+            <a:off x="320040" y="1051560"/>
+            <a:ext cx="5669280" cy="2468880"/>
           </a:xfrm>
           <a:prstGeom prst="roundRect">
             <a:avLst/>
@@ -4867,12 +4867,12 @@
           </a:fontRef>
         </p:style>
         <p:txBody>
-          <a:bodyPr rtlCol="0" anchor="ctr" wrap="square"/>
+          <a:bodyPr rtlCol="0" anchor="ctr" wrap="square" lIns="109728" rIns="109728" tIns="73152" bIns="73152"/>
           <a:lstStyle/>
           <a:p>
             <a:pPr algn="ctr"/>
             <a:r>
-              <a:rPr sz="1700" b="1">
+              <a:rPr sz="1600" b="1">
                 <a:solidFill>
                   <a:srgbClr val="2563EB"/>
                 </a:solidFill>
@@ -4886,11 +4886,11 @@
           <a:p>
             <a:pPr>
               <a:spcBef>
-                <a:spcPts val="700"/>
-              </a:spcBef>
-            </a:pPr>
-            <a:r>
-              <a:rPr sz="1300" b="0">
+                <a:spcPts val="500"/>
+              </a:spcBef>
+            </a:pPr>
+            <a:r>
+              <a:rPr sz="1200" b="0">
                 <a:solidFill>
                   <a:srgbClr val="0F172A"/>
                 </a:solidFill>
@@ -4904,11 +4904,11 @@
           <a:p>
             <a:pPr>
               <a:spcBef>
-                <a:spcPts val="700"/>
-              </a:spcBef>
-            </a:pPr>
-            <a:r>
-              <a:rPr sz="1300" b="0">
+                <a:spcPts val="500"/>
+              </a:spcBef>
+            </a:pPr>
+            <a:r>
+              <a:rPr sz="1200" b="0">
                 <a:solidFill>
                   <a:srgbClr val="0F172A"/>
                 </a:solidFill>
@@ -4922,11 +4922,11 @@
           <a:p>
             <a:pPr>
               <a:spcBef>
-                <a:spcPts val="700"/>
-              </a:spcBef>
-            </a:pPr>
-            <a:r>
-              <a:rPr sz="1300" b="0">
+                <a:spcPts val="500"/>
+              </a:spcBef>
+            </a:pPr>
+            <a:r>
+              <a:rPr sz="1200" b="0">
                 <a:solidFill>
                   <a:srgbClr val="0F172A"/>
                 </a:solidFill>
@@ -4947,8 +4947,8 @@
         </p:nvSpPr>
         <p:spPr>
           <a:xfrm>
-            <a:off x="6172200" y="1051560"/>
-            <a:ext cx="5669280" cy="2331720"/>
+            <a:off x="6217920" y="1051560"/>
+            <a:ext cx="5669280" cy="2468880"/>
           </a:xfrm>
           <a:prstGeom prst="roundRect">
             <a:avLst/>
@@ -4977,12 +4977,12 @@
           </a:fontRef>
         </p:style>
         <p:txBody>
-          <a:bodyPr rtlCol="0" anchor="ctr" wrap="square"/>
+          <a:bodyPr rtlCol="0" anchor="ctr" wrap="square" lIns="109728" rIns="109728" tIns="73152" bIns="73152"/>
           <a:lstStyle/>
           <a:p>
             <a:pPr algn="ctr"/>
             <a:r>
-              <a:rPr sz="1700" b="1">
+              <a:rPr sz="1600" b="1">
                 <a:solidFill>
                   <a:srgbClr val="EA580C"/>
                 </a:solidFill>
@@ -4996,11 +4996,11 @@
           <a:p>
             <a:pPr>
               <a:spcBef>
-                <a:spcPts val="700"/>
-              </a:spcBef>
-            </a:pPr>
-            <a:r>
-              <a:rPr sz="1300" b="0">
+                <a:spcPts val="500"/>
+              </a:spcBef>
+            </a:pPr>
+            <a:r>
+              <a:rPr sz="1200" b="0">
                 <a:solidFill>
                   <a:srgbClr val="0F172A"/>
                 </a:solidFill>
@@ -5014,11 +5014,11 @@
           <a:p>
             <a:pPr>
               <a:spcBef>
-                <a:spcPts val="700"/>
-              </a:spcBef>
-            </a:pPr>
-            <a:r>
-              <a:rPr sz="1300" b="0">
+                <a:spcPts val="500"/>
+              </a:spcBef>
+            </a:pPr>
+            <a:r>
+              <a:rPr sz="1200" b="0">
                 <a:solidFill>
                   <a:srgbClr val="0F172A"/>
                 </a:solidFill>
@@ -5032,11 +5032,11 @@
           <a:p>
             <a:pPr>
               <a:spcBef>
-                <a:spcPts val="700"/>
-              </a:spcBef>
-            </a:pPr>
-            <a:r>
-              <a:rPr sz="1300" b="0">
+                <a:spcPts val="500"/>
+              </a:spcBef>
+            </a:pPr>
+            <a:r>
+              <a:rPr sz="1200" b="0">
                 <a:solidFill>
                   <a:srgbClr val="0F172A"/>
                 </a:solidFill>
@@ -5057,8 +5057,8 @@
         </p:nvSpPr>
         <p:spPr>
           <a:xfrm>
-            <a:off x="274320" y="3566160"/>
-            <a:ext cx="5669280" cy="2331720"/>
+            <a:off x="320040" y="3657600"/>
+            <a:ext cx="5669280" cy="2468880"/>
           </a:xfrm>
           <a:prstGeom prst="roundRect">
             <a:avLst/>
@@ -5087,12 +5087,12 @@
           </a:fontRef>
         </p:style>
         <p:txBody>
-          <a:bodyPr rtlCol="0" anchor="ctr" wrap="square"/>
+          <a:bodyPr rtlCol="0" anchor="ctr" wrap="square" lIns="109728" rIns="109728" tIns="73152" bIns="73152"/>
           <a:lstStyle/>
           <a:p>
             <a:pPr algn="ctr"/>
             <a:r>
-              <a:rPr sz="1700" b="1">
+              <a:rPr sz="1600" b="1">
                 <a:solidFill>
                   <a:srgbClr val="0D9488"/>
                 </a:solidFill>
@@ -5106,11 +5106,11 @@
           <a:p>
             <a:pPr>
               <a:spcBef>
-                <a:spcPts val="700"/>
-              </a:spcBef>
-            </a:pPr>
-            <a:r>
-              <a:rPr sz="1300" b="0">
+                <a:spcPts val="500"/>
+              </a:spcBef>
+            </a:pPr>
+            <a:r>
+              <a:rPr sz="1200" b="0">
                 <a:solidFill>
                   <a:srgbClr val="0F172A"/>
                 </a:solidFill>
@@ -5124,11 +5124,11 @@
           <a:p>
             <a:pPr>
               <a:spcBef>
-                <a:spcPts val="700"/>
-              </a:spcBef>
-            </a:pPr>
-            <a:r>
-              <a:rPr sz="1300" b="0">
+                <a:spcPts val="500"/>
+              </a:spcBef>
+            </a:pPr>
+            <a:r>
+              <a:rPr sz="1200" b="0">
                 <a:solidFill>
                   <a:srgbClr val="0F172A"/>
                 </a:solidFill>
@@ -5142,11 +5142,11 @@
           <a:p>
             <a:pPr>
               <a:spcBef>
-                <a:spcPts val="700"/>
-              </a:spcBef>
-            </a:pPr>
-            <a:r>
-              <a:rPr sz="1300" b="0">
+                <a:spcPts val="500"/>
+              </a:spcBef>
+            </a:pPr>
+            <a:r>
+              <a:rPr sz="1200" b="0">
                 <a:solidFill>
                   <a:srgbClr val="0F172A"/>
                 </a:solidFill>
@@ -5167,8 +5167,8 @@
         </p:nvSpPr>
         <p:spPr>
           <a:xfrm>
-            <a:off x="6172200" y="3566160"/>
-            <a:ext cx="5669280" cy="2331720"/>
+            <a:off x="6217920" y="3657600"/>
+            <a:ext cx="5669280" cy="2468880"/>
           </a:xfrm>
           <a:prstGeom prst="roundRect">
             <a:avLst/>
@@ -5197,12 +5197,12 @@
           </a:fontRef>
         </p:style>
         <p:txBody>
-          <a:bodyPr rtlCol="0" anchor="ctr" wrap="square"/>
+          <a:bodyPr rtlCol="0" anchor="ctr" wrap="square" lIns="109728" rIns="109728" tIns="73152" bIns="73152"/>
           <a:lstStyle/>
           <a:p>
             <a:pPr algn="ctr"/>
             <a:r>
-              <a:rPr sz="1700" b="1">
+              <a:rPr sz="1600" b="1">
                 <a:solidFill>
                   <a:srgbClr val="DC2626"/>
                 </a:solidFill>
@@ -5216,11 +5216,11 @@
           <a:p>
             <a:pPr>
               <a:spcBef>
-                <a:spcPts val="700"/>
-              </a:spcBef>
-            </a:pPr>
-            <a:r>
-              <a:rPr sz="1300" b="0">
+                <a:spcPts val="500"/>
+              </a:spcBef>
+            </a:pPr>
+            <a:r>
+              <a:rPr sz="1200" b="0">
                 <a:solidFill>
                   <a:srgbClr val="0F172A"/>
                 </a:solidFill>
@@ -5234,11 +5234,11 @@
           <a:p>
             <a:pPr>
               <a:spcBef>
-                <a:spcPts val="700"/>
-              </a:spcBef>
-            </a:pPr>
-            <a:r>
-              <a:rPr sz="1300" b="0">
+                <a:spcPts val="500"/>
+              </a:spcBef>
+            </a:pPr>
+            <a:r>
+              <a:rPr sz="1200" b="0">
                 <a:solidFill>
                   <a:srgbClr val="0F172A"/>
                 </a:solidFill>
@@ -5252,11 +5252,11 @@
           <a:p>
             <a:pPr>
               <a:spcBef>
-                <a:spcPts val="700"/>
-              </a:spcBef>
-            </a:pPr>
-            <a:r>
-              <a:rPr sz="1300" b="0">
+                <a:spcPts val="500"/>
+              </a:spcBef>
+            </a:pPr>
+            <a:r>
+              <a:rPr sz="1200" b="0">
                 <a:solidFill>
                   <a:srgbClr val="0F172A"/>
                 </a:solidFill>
@@ -5270,11 +5270,11 @@
           <a:p>
             <a:pPr>
               <a:spcBef>
-                <a:spcPts val="700"/>
-              </a:spcBef>
-            </a:pPr>
-            <a:r>
-              <a:rPr sz="1300" b="0">
+                <a:spcPts val="500"/>
+              </a:spcBef>
+            </a:pPr>
+            <a:r>
+              <a:rPr sz="1200" b="0">
                 <a:solidFill>
                   <a:srgbClr val="0F172A"/>
                 </a:solidFill>
@@ -5402,7 +5402,7 @@
           <a:noFill/>
         </p:spPr>
         <p:txBody>
-          <a:bodyPr wrap="square">
+          <a:bodyPr wrap="square" lIns="109728" rIns="109728" tIns="73152" bIns="73152">
             <a:spAutoFit/>
           </a:bodyPr>
           <a:lstStyle/>
@@ -5455,8 +5455,8 @@
         </p:blipFill>
         <p:spPr>
           <a:xfrm>
-            <a:off x="320040" y="914400"/>
-            <a:ext cx="11521440" cy="6480810"/>
+            <a:off x="1244600" y="914400"/>
+            <a:ext cx="9672320" cy="5440680"/>
           </a:xfrm>
           <a:prstGeom prst="rect">
             <a:avLst/>
@@ -5578,7 +5578,7 @@
           <a:noFill/>
         </p:spPr>
         <p:txBody>
-          <a:bodyPr wrap="square">
+          <a:bodyPr wrap="square" lIns="109728" rIns="109728" tIns="73152" bIns="73152">
             <a:spAutoFit/>
           </a:bodyPr>
           <a:lstStyle/>
@@ -5624,7 +5624,7 @@
         <p:spPr>
           <a:xfrm>
             <a:off x="320040" y="1051560"/>
-            <a:ext cx="5669280" cy="5029200"/>
+            <a:ext cx="5669280" cy="5074920"/>
           </a:xfrm>
           <a:prstGeom prst="roundRect">
             <a:avLst/>
@@ -5653,12 +5653,12 @@
           </a:fontRef>
         </p:style>
         <p:txBody>
-          <a:bodyPr rtlCol="0" anchor="ctr" wrap="square"/>
+          <a:bodyPr rtlCol="0" anchor="ctr" wrap="square" lIns="109728" rIns="109728" tIns="73152" bIns="73152"/>
           <a:lstStyle/>
           <a:p>
             <a:pPr algn="ctr"/>
             <a:r>
-              <a:rPr sz="1800" b="1">
+              <a:rPr sz="1600" b="1">
                 <a:solidFill>
                   <a:srgbClr val="0D9488"/>
                 </a:solidFill>
@@ -5672,11 +5672,11 @@
           <a:p>
             <a:pPr>
               <a:spcBef>
-                <a:spcPts val="500"/>
-              </a:spcBef>
-            </a:pPr>
-            <a:r>
-              <a:rPr sz="1300" b="0">
+                <a:spcPts val="300"/>
+              </a:spcBef>
+            </a:pPr>
+            <a:r>
+              <a:rPr sz="1200" b="0">
                 <a:solidFill>
                   <a:srgbClr val="0F172A"/>
                 </a:solidFill>
@@ -5690,11 +5690,11 @@
           <a:p>
             <a:pPr>
               <a:spcBef>
-                <a:spcPts val="500"/>
-              </a:spcBef>
-            </a:pPr>
-            <a:r>
-              <a:rPr sz="1300" b="0">
+                <a:spcPts val="300"/>
+              </a:spcBef>
+            </a:pPr>
+            <a:r>
+              <a:rPr sz="1200" b="0">
                 <a:solidFill>
                   <a:srgbClr val="0F172A"/>
                 </a:solidFill>
@@ -5708,11 +5708,11 @@
           <a:p>
             <a:pPr>
               <a:spcBef>
-                <a:spcPts val="500"/>
-              </a:spcBef>
-            </a:pPr>
-            <a:r>
-              <a:rPr sz="1300" b="0">
+                <a:spcPts val="300"/>
+              </a:spcBef>
+            </a:pPr>
+            <a:r>
+              <a:rPr sz="1200" b="0">
                 <a:solidFill>
                   <a:srgbClr val="0F172A"/>
                 </a:solidFill>
@@ -5726,11 +5726,11 @@
           <a:p>
             <a:pPr>
               <a:spcBef>
-                <a:spcPts val="500"/>
-              </a:spcBef>
-            </a:pPr>
-            <a:r>
-              <a:rPr sz="1300" b="0">
+                <a:spcPts val="300"/>
+              </a:spcBef>
+            </a:pPr>
+            <a:r>
+              <a:rPr sz="1200" b="0">
                 <a:solidFill>
                   <a:srgbClr val="0F172A"/>
                 </a:solidFill>
@@ -5744,11 +5744,11 @@
           <a:p>
             <a:pPr>
               <a:spcBef>
-                <a:spcPts val="500"/>
-              </a:spcBef>
-            </a:pPr>
-            <a:r>
-              <a:rPr sz="1300" b="0">
+                <a:spcPts val="300"/>
+              </a:spcBef>
+            </a:pPr>
+            <a:r>
+              <a:rPr sz="1200" b="0">
                 <a:solidFill>
                   <a:srgbClr val="0F172A"/>
                 </a:solidFill>
@@ -5762,11 +5762,11 @@
           <a:p>
             <a:pPr>
               <a:spcBef>
-                <a:spcPts val="500"/>
-              </a:spcBef>
-            </a:pPr>
-            <a:r>
-              <a:rPr sz="1300" b="0">
+                <a:spcPts val="300"/>
+              </a:spcBef>
+            </a:pPr>
+            <a:r>
+              <a:rPr sz="1200" b="0">
                 <a:solidFill>
                   <a:srgbClr val="0F172A"/>
                 </a:solidFill>
@@ -5780,11 +5780,11 @@
           <a:p>
             <a:pPr>
               <a:spcBef>
-                <a:spcPts val="500"/>
-              </a:spcBef>
-            </a:pPr>
-            <a:r>
-              <a:rPr sz="1300" b="0">
+                <a:spcPts val="300"/>
+              </a:spcBef>
+            </a:pPr>
+            <a:r>
+              <a:rPr sz="1200" b="0">
                 <a:solidFill>
                   <a:srgbClr val="0F172A"/>
                 </a:solidFill>
@@ -5798,11 +5798,11 @@
           <a:p>
             <a:pPr>
               <a:spcBef>
-                <a:spcPts val="500"/>
-              </a:spcBef>
-            </a:pPr>
-            <a:r>
-              <a:rPr sz="1300" b="0">
+                <a:spcPts val="300"/>
+              </a:spcBef>
+            </a:pPr>
+            <a:r>
+              <a:rPr sz="1200" b="0">
                 <a:solidFill>
                   <a:srgbClr val="0F172A"/>
                 </a:solidFill>
@@ -5816,11 +5816,11 @@
           <a:p>
             <a:pPr>
               <a:spcBef>
-                <a:spcPts val="500"/>
-              </a:spcBef>
-            </a:pPr>
-            <a:r>
-              <a:rPr sz="1300" b="0">
+                <a:spcPts val="300"/>
+              </a:spcBef>
+            </a:pPr>
+            <a:r>
+              <a:rPr sz="1200" b="0">
                 <a:solidFill>
                   <a:srgbClr val="0F172A"/>
                 </a:solidFill>
@@ -5834,11 +5834,11 @@
           <a:p>
             <a:pPr>
               <a:spcBef>
-                <a:spcPts val="500"/>
-              </a:spcBef>
-            </a:pPr>
-            <a:r>
-              <a:rPr sz="1300" b="0">
+                <a:spcPts val="300"/>
+              </a:spcBef>
+            </a:pPr>
+            <a:r>
+              <a:rPr sz="1200" b="0">
                 <a:solidFill>
                   <a:srgbClr val="0F172A"/>
                 </a:solidFill>
@@ -5852,11 +5852,11 @@
           <a:p>
             <a:pPr>
               <a:spcBef>
-                <a:spcPts val="500"/>
-              </a:spcBef>
-            </a:pPr>
-            <a:r>
-              <a:rPr sz="1300" b="0">
+                <a:spcPts val="300"/>
+              </a:spcBef>
+            </a:pPr>
+            <a:r>
+              <a:rPr sz="1200" b="0">
                 <a:solidFill>
                   <a:srgbClr val="0F172A"/>
                 </a:solidFill>
@@ -5870,11 +5870,11 @@
           <a:p>
             <a:pPr>
               <a:spcBef>
-                <a:spcPts val="500"/>
-              </a:spcBef>
-            </a:pPr>
-            <a:r>
-              <a:rPr sz="1300" b="0">
+                <a:spcPts val="300"/>
+              </a:spcBef>
+            </a:pPr>
+            <a:r>
+              <a:rPr sz="1200" b="0">
                 <a:solidFill>
                   <a:srgbClr val="0F172A"/>
                 </a:solidFill>
@@ -5896,7 +5896,7 @@
         <p:spPr>
           <a:xfrm>
             <a:off x="6217920" y="1051560"/>
-            <a:ext cx="5623560" cy="5029200"/>
+            <a:ext cx="5623560" cy="5074920"/>
           </a:xfrm>
           <a:prstGeom prst="roundRect">
             <a:avLst/>
@@ -5925,12 +5925,12 @@
           </a:fontRef>
         </p:style>
         <p:txBody>
-          <a:bodyPr rtlCol="0" anchor="ctr" wrap="square"/>
+          <a:bodyPr rtlCol="0" anchor="ctr" wrap="square" lIns="109728" rIns="109728" tIns="73152" bIns="73152"/>
           <a:lstStyle/>
           <a:p>
             <a:pPr algn="ctr"/>
             <a:r>
-              <a:rPr sz="1800" b="1">
+              <a:rPr sz="1600" b="1">
                 <a:solidFill>
                   <a:srgbClr val="DC2626"/>
                 </a:solidFill>
@@ -5944,11 +5944,11 @@
           <a:p>
             <a:pPr>
               <a:spcBef>
-                <a:spcPts val="400"/>
-              </a:spcBef>
-            </a:pPr>
-            <a:r>
-              <a:rPr sz="1300" b="0">
+                <a:spcPts val="300"/>
+              </a:spcBef>
+            </a:pPr>
+            <a:r>
+              <a:rPr sz="1200" b="0">
                 <a:solidFill>
                   <a:srgbClr val="0F172A"/>
                 </a:solidFill>
@@ -5962,11 +5962,11 @@
           <a:p>
             <a:pPr>
               <a:spcBef>
-                <a:spcPts val="400"/>
-              </a:spcBef>
-            </a:pPr>
-            <a:r>
-              <a:rPr sz="1300" b="0">
+                <a:spcPts val="300"/>
+              </a:spcBef>
+            </a:pPr>
+            <a:r>
+              <a:rPr sz="1200" b="0">
                 <a:solidFill>
                   <a:srgbClr val="0F172A"/>
                 </a:solidFill>
@@ -5980,11 +5980,11 @@
           <a:p>
             <a:pPr>
               <a:spcBef>
-                <a:spcPts val="400"/>
-              </a:spcBef>
-            </a:pPr>
-            <a:r>
-              <a:rPr sz="1300" b="0">
+                <a:spcPts val="300"/>
+              </a:spcBef>
+            </a:pPr>
+            <a:r>
+              <a:rPr sz="1200" b="0">
                 <a:solidFill>
                   <a:srgbClr val="0F172A"/>
                 </a:solidFill>
@@ -5998,11 +5998,11 @@
           <a:p>
             <a:pPr>
               <a:spcBef>
-                <a:spcPts val="400"/>
-              </a:spcBef>
-            </a:pPr>
-            <a:r>
-              <a:rPr sz="1300" b="0">
+                <a:spcPts val="300"/>
+              </a:spcBef>
+            </a:pPr>
+            <a:r>
+              <a:rPr sz="1200" b="0">
                 <a:solidFill>
                   <a:srgbClr val="0F172A"/>
                 </a:solidFill>
@@ -6016,11 +6016,11 @@
           <a:p>
             <a:pPr>
               <a:spcBef>
-                <a:spcPts val="400"/>
-              </a:spcBef>
-            </a:pPr>
-            <a:r>
-              <a:rPr sz="1300" b="0">
+                <a:spcPts val="300"/>
+              </a:spcBef>
+            </a:pPr>
+            <a:r>
+              <a:rPr sz="1200" b="0">
                 <a:solidFill>
                   <a:srgbClr val="0F172A"/>
                 </a:solidFill>
@@ -6034,11 +6034,11 @@
           <a:p>
             <a:pPr>
               <a:spcBef>
-                <a:spcPts val="400"/>
-              </a:spcBef>
-            </a:pPr>
-            <a:r>
-              <a:rPr sz="1300" b="0">
+                <a:spcPts val="300"/>
+              </a:spcBef>
+            </a:pPr>
+            <a:r>
+              <a:rPr sz="1200" b="0">
                 <a:solidFill>
                   <a:srgbClr val="0F172A"/>
                 </a:solidFill>
@@ -6052,11 +6052,11 @@
           <a:p>
             <a:pPr>
               <a:spcBef>
-                <a:spcPts val="400"/>
-              </a:spcBef>
-            </a:pPr>
-            <a:r>
-              <a:rPr sz="1300" b="0">
+                <a:spcPts val="300"/>
+              </a:spcBef>
+            </a:pPr>
+            <a:r>
+              <a:rPr sz="1200" b="0">
                 <a:solidFill>
                   <a:srgbClr val="0F172A"/>
                 </a:solidFill>
@@ -6070,11 +6070,11 @@
           <a:p>
             <a:pPr>
               <a:spcBef>
-                <a:spcPts val="400"/>
-              </a:spcBef>
-            </a:pPr>
-            <a:r>
-              <a:rPr sz="1300" b="0">
+                <a:spcPts val="300"/>
+              </a:spcBef>
+            </a:pPr>
+            <a:r>
+              <a:rPr sz="1200" b="0">
                 <a:solidFill>
                   <a:srgbClr val="0F172A"/>
                 </a:solidFill>
@@ -6088,11 +6088,11 @@
           <a:p>
             <a:pPr>
               <a:spcBef>
-                <a:spcPts val="400"/>
-              </a:spcBef>
-            </a:pPr>
-            <a:r>
-              <a:rPr sz="1300" b="0">
+                <a:spcPts val="300"/>
+              </a:spcBef>
+            </a:pPr>
+            <a:r>
+              <a:rPr sz="1200" b="0">
                 <a:solidFill>
                   <a:srgbClr val="0F172A"/>
                 </a:solidFill>
@@ -6106,11 +6106,11 @@
           <a:p>
             <a:pPr>
               <a:spcBef>
-                <a:spcPts val="400"/>
-              </a:spcBef>
-            </a:pPr>
-            <a:r>
-              <a:rPr sz="1300" b="0">
+                <a:spcPts val="300"/>
+              </a:spcBef>
+            </a:pPr>
+            <a:r>
+              <a:rPr sz="1200" b="0">
                 <a:solidFill>
                   <a:srgbClr val="0F172A"/>
                 </a:solidFill>
@@ -6124,11 +6124,11 @@
           <a:p>
             <a:pPr>
               <a:spcBef>
-                <a:spcPts val="400"/>
-              </a:spcBef>
-            </a:pPr>
-            <a:r>
-              <a:rPr sz="1300" b="0">
+                <a:spcPts val="300"/>
+              </a:spcBef>
+            </a:pPr>
+            <a:r>
+              <a:rPr sz="1200" b="0">
                 <a:solidFill>
                   <a:srgbClr val="0F172A"/>
                 </a:solidFill>
@@ -6142,11 +6142,11 @@
           <a:p>
             <a:pPr>
               <a:spcBef>
-                <a:spcPts val="400"/>
-              </a:spcBef>
-            </a:pPr>
-            <a:r>
-              <a:rPr sz="1300" b="0">
+                <a:spcPts val="300"/>
+              </a:spcBef>
+            </a:pPr>
+            <a:r>
+              <a:rPr sz="1200" b="0">
                 <a:solidFill>
                   <a:srgbClr val="0F172A"/>
                 </a:solidFill>
@@ -6160,11 +6160,11 @@
           <a:p>
             <a:pPr>
               <a:spcBef>
-                <a:spcPts val="400"/>
-              </a:spcBef>
-            </a:pPr>
-            <a:r>
-              <a:rPr sz="1300" b="0">
+                <a:spcPts val="300"/>
+              </a:spcBef>
+            </a:pPr>
+            <a:r>
+              <a:rPr sz="1200" b="0">
                 <a:solidFill>
                   <a:srgbClr val="0F172A"/>
                 </a:solidFill>
@@ -6178,11 +6178,11 @@
           <a:p>
             <a:pPr>
               <a:spcBef>
-                <a:spcPts val="400"/>
-              </a:spcBef>
-            </a:pPr>
-            <a:r>
-              <a:rPr sz="1300" b="0">
+                <a:spcPts val="300"/>
+              </a:spcBef>
+            </a:pPr>
+            <a:r>
+              <a:rPr sz="1200" b="0">
                 <a:solidFill>
                   <a:srgbClr val="0F172A"/>
                 </a:solidFill>
@@ -6310,7 +6310,7 @@
           <a:noFill/>
         </p:spPr>
         <p:txBody>
-          <a:bodyPr wrap="square">
+          <a:bodyPr wrap="square" lIns="109728" rIns="109728" tIns="73152" bIns="73152">
             <a:spAutoFit/>
           </a:bodyPr>
           <a:lstStyle/>
@@ -6461,7 +6461,7 @@
           <a:noFill/>
         </p:spPr>
         <p:txBody>
-          <a:bodyPr wrap="square">
+          <a:bodyPr wrap="square" lIns="109728" rIns="109728" tIns="73152" bIns="73152">
             <a:spAutoFit/>
           </a:bodyPr>
           <a:lstStyle/>
@@ -6518,7 +6518,7 @@
           </a:fontRef>
         </p:style>
         <p:txBody>
-          <a:bodyPr rtlCol="0" anchor="ctr" wrap="square"/>
+          <a:bodyPr rtlCol="0" anchor="ctr" wrap="square" lIns="109728" rIns="109728" tIns="73152" bIns="73152"/>
           <a:lstStyle/>
           <a:p>
             <a:pPr algn="ctr"/>
@@ -6574,7 +6574,7 @@
           </a:fontRef>
         </p:style>
         <p:txBody>
-          <a:bodyPr rtlCol="0" anchor="ctr" wrap="square"/>
+          <a:bodyPr rtlCol="0" anchor="ctr" wrap="square" lIns="109728" rIns="109728" tIns="73152" bIns="73152"/>
           <a:lstStyle/>
           <a:p>
             <a:pPr algn="ctr"/>
@@ -6630,7 +6630,7 @@
           </a:fontRef>
         </p:style>
         <p:txBody>
-          <a:bodyPr rtlCol="0" anchor="ctr" wrap="square"/>
+          <a:bodyPr rtlCol="0" anchor="ctr" wrap="square" lIns="109728" rIns="109728" tIns="73152" bIns="73152"/>
           <a:lstStyle/>
           <a:p>
             <a:pPr algn="ctr"/>
@@ -6686,7 +6686,7 @@
           </a:fontRef>
         </p:style>
         <p:txBody>
-          <a:bodyPr rtlCol="0" anchor="ctr" wrap="square"/>
+          <a:bodyPr rtlCol="0" anchor="ctr" wrap="square" lIns="109728" rIns="109728" tIns="73152" bIns="73152"/>
           <a:lstStyle/>
           <a:p>
             <a:pPr algn="ctr"/>
@@ -6742,7 +6742,7 @@
           </a:fontRef>
         </p:style>
         <p:txBody>
-          <a:bodyPr rtlCol="0" anchor="ctr" wrap="square"/>
+          <a:bodyPr rtlCol="0" anchor="ctr" wrap="square" lIns="109728" rIns="109728" tIns="73152" bIns="73152"/>
           <a:lstStyle/>
           <a:p>
             <a:pPr algn="ctr"/>
@@ -6798,7 +6798,7 @@
           </a:fontRef>
         </p:style>
         <p:txBody>
-          <a:bodyPr rtlCol="0" anchor="ctr" wrap="square"/>
+          <a:bodyPr rtlCol="0" anchor="ctr" wrap="square" lIns="109728" rIns="109728" tIns="73152" bIns="73152"/>
           <a:lstStyle/>
           <a:p>
             <a:pPr algn="ctr"/>
@@ -6931,7 +6931,7 @@
           <a:noFill/>
         </p:spPr>
         <p:txBody>
-          <a:bodyPr wrap="square">
+          <a:bodyPr wrap="square" lIns="109728" rIns="109728" tIns="73152" bIns="73152">
             <a:spAutoFit/>
           </a:bodyPr>
           <a:lstStyle/>
@@ -6976,8 +6976,8 @@
         </p:nvSpPr>
         <p:spPr>
           <a:xfrm>
-            <a:off x="274320" y="1097280"/>
-            <a:ext cx="2788920" cy="4846320"/>
+            <a:off x="320040" y="1051560"/>
+            <a:ext cx="2788920" cy="5074920"/>
           </a:xfrm>
           <a:prstGeom prst="roundRect">
             <a:avLst/>
@@ -7006,12 +7006,12 @@
           </a:fontRef>
         </p:style>
         <p:txBody>
-          <a:bodyPr rtlCol="0" anchor="ctr" wrap="square"/>
+          <a:bodyPr rtlCol="0" anchor="ctr" wrap="square" lIns="109728" rIns="109728" tIns="73152" bIns="73152"/>
           <a:lstStyle/>
           <a:p>
             <a:pPr algn="ctr"/>
             <a:r>
-              <a:rPr sz="1800" b="1">
+              <a:rPr sz="1700" b="1">
                 <a:solidFill>
                   <a:srgbClr val="7C3AED"/>
                 </a:solidFill>
@@ -7025,11 +7025,11 @@
           <a:p>
             <a:pPr algn="ctr">
               <a:spcBef>
-                <a:spcPts val="800"/>
-              </a:spcBef>
-            </a:pPr>
-            <a:r>
-              <a:rPr sz="1300" b="1">
+                <a:spcPts val="600"/>
+              </a:spcBef>
+            </a:pPr>
+            <a:r>
+              <a:rPr sz="1200" b="1">
                 <a:solidFill>
                   <a:srgbClr val="0F172A"/>
                 </a:solidFill>
@@ -7043,11 +7043,11 @@
           <a:p>
             <a:pPr algn="ctr">
               <a:spcBef>
-                <a:spcPts val="1200"/>
-              </a:spcBef>
-            </a:pPr>
-            <a:r>
-              <a:rPr sz="1200" b="0">
+                <a:spcPts val="1000"/>
+              </a:spcBef>
+            </a:pPr>
+            <a:r>
+              <a:rPr sz="1100" b="0">
                 <a:solidFill>
                   <a:srgbClr val="475569"/>
                 </a:solidFill>
@@ -7062,11 +7062,11 @@
           <a:p>
             <a:pPr algn="ctr">
               <a:spcBef>
-                <a:spcPts val="800"/>
-              </a:spcBef>
-            </a:pPr>
-            <a:r>
-              <a:rPr sz="1100" b="0">
+                <a:spcPts val="600"/>
+              </a:spcBef>
+            </a:pPr>
+            <a:r>
+              <a:rPr sz="1000" b="0">
                 <a:solidFill>
                   <a:srgbClr val="CBD5E1"/>
                 </a:solidFill>
@@ -7084,7 +7084,7 @@
               </a:spcBef>
             </a:pPr>
             <a:r>
-              <a:rPr sz="1300" b="0">
+              <a:rPr sz="1200" b="0">
                 <a:solidFill>
                   <a:srgbClr val="0F172A"/>
                 </a:solidFill>
@@ -7107,8 +7107,8 @@
         </p:nvSpPr>
         <p:spPr>
           <a:xfrm>
-            <a:off x="3200400" y="1097280"/>
-            <a:ext cx="2788920" cy="4846320"/>
+            <a:off x="3246120" y="1051560"/>
+            <a:ext cx="2788920" cy="5074920"/>
           </a:xfrm>
           <a:prstGeom prst="roundRect">
             <a:avLst/>
@@ -7137,12 +7137,12 @@
           </a:fontRef>
         </p:style>
         <p:txBody>
-          <a:bodyPr rtlCol="0" anchor="ctr" wrap="square"/>
+          <a:bodyPr rtlCol="0" anchor="ctr" wrap="square" lIns="109728" rIns="109728" tIns="73152" bIns="73152"/>
           <a:lstStyle/>
           <a:p>
             <a:pPr algn="ctr"/>
             <a:r>
-              <a:rPr sz="1800" b="1">
+              <a:rPr sz="1700" b="1">
                 <a:solidFill>
                   <a:srgbClr val="EA580C"/>
                 </a:solidFill>
@@ -7156,11 +7156,11 @@
           <a:p>
             <a:pPr algn="ctr">
               <a:spcBef>
-                <a:spcPts val="800"/>
-              </a:spcBef>
-            </a:pPr>
-            <a:r>
-              <a:rPr sz="1300" b="1">
+                <a:spcPts val="600"/>
+              </a:spcBef>
+            </a:pPr>
+            <a:r>
+              <a:rPr sz="1200" b="1">
                 <a:solidFill>
                   <a:srgbClr val="0F172A"/>
                 </a:solidFill>
@@ -7174,11 +7174,11 @@
           <a:p>
             <a:pPr algn="ctr">
               <a:spcBef>
-                <a:spcPts val="1200"/>
-              </a:spcBef>
-            </a:pPr>
-            <a:r>
-              <a:rPr sz="1200" b="0">
+                <a:spcPts val="1000"/>
+              </a:spcBef>
+            </a:pPr>
+            <a:r>
+              <a:rPr sz="1100" b="0">
                 <a:solidFill>
                   <a:srgbClr val="475569"/>
                 </a:solidFill>
@@ -7193,11 +7193,11 @@
           <a:p>
             <a:pPr algn="ctr">
               <a:spcBef>
-                <a:spcPts val="800"/>
-              </a:spcBef>
-            </a:pPr>
-            <a:r>
-              <a:rPr sz="1100" b="0">
+                <a:spcPts val="600"/>
+              </a:spcBef>
+            </a:pPr>
+            <a:r>
+              <a:rPr sz="1000" b="0">
                 <a:solidFill>
                   <a:srgbClr val="CBD5E1"/>
                 </a:solidFill>
@@ -7215,7 +7215,7 @@
               </a:spcBef>
             </a:pPr>
             <a:r>
-              <a:rPr sz="1300" b="0">
+              <a:rPr sz="1200" b="0">
                 <a:solidFill>
                   <a:srgbClr val="0F172A"/>
                 </a:solidFill>
@@ -7238,8 +7238,8 @@
         </p:nvSpPr>
         <p:spPr>
           <a:xfrm>
-            <a:off x="6126480" y="1097280"/>
-            <a:ext cx="2788920" cy="4846320"/>
+            <a:off x="6172200" y="1051560"/>
+            <a:ext cx="2788920" cy="5074920"/>
           </a:xfrm>
           <a:prstGeom prst="roundRect">
             <a:avLst/>
@@ -7268,12 +7268,12 @@
           </a:fontRef>
         </p:style>
         <p:txBody>
-          <a:bodyPr rtlCol="0" anchor="ctr" wrap="square"/>
+          <a:bodyPr rtlCol="0" anchor="ctr" wrap="square" lIns="109728" rIns="109728" tIns="73152" bIns="73152"/>
           <a:lstStyle/>
           <a:p>
             <a:pPr algn="ctr"/>
             <a:r>
-              <a:rPr sz="1800" b="1">
+              <a:rPr sz="1700" b="1">
                 <a:solidFill>
                   <a:srgbClr val="16A34A"/>
                 </a:solidFill>
@@ -7287,11 +7287,11 @@
           <a:p>
             <a:pPr algn="ctr">
               <a:spcBef>
-                <a:spcPts val="800"/>
-              </a:spcBef>
-            </a:pPr>
-            <a:r>
-              <a:rPr sz="1300" b="1">
+                <a:spcPts val="600"/>
+              </a:spcBef>
+            </a:pPr>
+            <a:r>
+              <a:rPr sz="1200" b="1">
                 <a:solidFill>
                   <a:srgbClr val="0F172A"/>
                 </a:solidFill>
@@ -7305,11 +7305,11 @@
           <a:p>
             <a:pPr algn="ctr">
               <a:spcBef>
-                <a:spcPts val="1200"/>
-              </a:spcBef>
-            </a:pPr>
-            <a:r>
-              <a:rPr sz="1200" b="0">
+                <a:spcPts val="1000"/>
+              </a:spcBef>
+            </a:pPr>
+            <a:r>
+              <a:rPr sz="1100" b="0">
                 <a:solidFill>
                   <a:srgbClr val="475569"/>
                 </a:solidFill>
@@ -7324,11 +7324,11 @@
           <a:p>
             <a:pPr algn="ctr">
               <a:spcBef>
-                <a:spcPts val="800"/>
-              </a:spcBef>
-            </a:pPr>
-            <a:r>
-              <a:rPr sz="1100" b="0">
+                <a:spcPts val="600"/>
+              </a:spcBef>
+            </a:pPr>
+            <a:r>
+              <a:rPr sz="1000" b="0">
                 <a:solidFill>
                   <a:srgbClr val="CBD5E1"/>
                 </a:solidFill>
@@ -7346,7 +7346,7 @@
               </a:spcBef>
             </a:pPr>
             <a:r>
-              <a:rPr sz="1300" b="0">
+              <a:rPr sz="1200" b="0">
                 <a:solidFill>
                   <a:srgbClr val="0F172A"/>
                 </a:solidFill>
@@ -7369,8 +7369,8 @@
         </p:nvSpPr>
         <p:spPr>
           <a:xfrm>
-            <a:off x="9052560" y="1097280"/>
-            <a:ext cx="2788920" cy="4846320"/>
+            <a:off x="9098280" y="1051560"/>
+            <a:ext cx="2788920" cy="5074920"/>
           </a:xfrm>
           <a:prstGeom prst="roundRect">
             <a:avLst/>
@@ -7399,12 +7399,12 @@
           </a:fontRef>
         </p:style>
         <p:txBody>
-          <a:bodyPr rtlCol="0" anchor="ctr" wrap="square"/>
+          <a:bodyPr rtlCol="0" anchor="ctr" wrap="square" lIns="109728" rIns="109728" tIns="73152" bIns="73152"/>
           <a:lstStyle/>
           <a:p>
             <a:pPr algn="ctr"/>
             <a:r>
-              <a:rPr sz="1800" b="1">
+              <a:rPr sz="1700" b="1">
                 <a:solidFill>
                   <a:srgbClr val="DC2626"/>
                 </a:solidFill>
@@ -7418,11 +7418,11 @@
           <a:p>
             <a:pPr algn="ctr">
               <a:spcBef>
-                <a:spcPts val="800"/>
-              </a:spcBef>
-            </a:pPr>
-            <a:r>
-              <a:rPr sz="1300" b="1">
+                <a:spcPts val="600"/>
+              </a:spcBef>
+            </a:pPr>
+            <a:r>
+              <a:rPr sz="1200" b="1">
                 <a:solidFill>
                   <a:srgbClr val="0F172A"/>
                 </a:solidFill>
@@ -7436,11 +7436,11 @@
           <a:p>
             <a:pPr algn="ctr">
               <a:spcBef>
-                <a:spcPts val="1200"/>
-              </a:spcBef>
-            </a:pPr>
-            <a:r>
-              <a:rPr sz="1200" b="0">
+                <a:spcPts val="1000"/>
+              </a:spcBef>
+            </a:pPr>
+            <a:r>
+              <a:rPr sz="1100" b="0">
                 <a:solidFill>
                   <a:srgbClr val="475569"/>
                 </a:solidFill>
@@ -7455,11 +7455,11 @@
           <a:p>
             <a:pPr algn="ctr">
               <a:spcBef>
-                <a:spcPts val="800"/>
-              </a:spcBef>
-            </a:pPr>
-            <a:r>
-              <a:rPr sz="1100" b="0">
+                <a:spcPts val="600"/>
+              </a:spcBef>
+            </a:pPr>
+            <a:r>
+              <a:rPr sz="1000" b="0">
                 <a:solidFill>
                   <a:srgbClr val="CBD5E1"/>
                 </a:solidFill>
@@ -7477,7 +7477,7 @@
               </a:spcBef>
             </a:pPr>
             <a:r>
-              <a:rPr sz="1300" b="0">
+              <a:rPr sz="1200" b="0">
                 <a:solidFill>
                   <a:srgbClr val="0F172A"/>
                 </a:solidFill>
@@ -7607,7 +7607,7 @@
           <a:noFill/>
         </p:spPr>
         <p:txBody>
-          <a:bodyPr wrap="square">
+          <a:bodyPr wrap="square" lIns="109728" rIns="109728" tIns="73152" bIns="73152">
             <a:spAutoFit/>
           </a:bodyPr>
           <a:lstStyle/>
@@ -7660,8 +7660,8 @@
         </p:blipFill>
         <p:spPr>
           <a:xfrm>
-            <a:off x="365760" y="1005840"/>
-            <a:ext cx="11430000" cy="6429375"/>
+            <a:off x="1325880" y="1005840"/>
+            <a:ext cx="9509759" cy="5349240"/>
           </a:xfrm>
           <a:prstGeom prst="rect">
             <a:avLst/>
@@ -7783,7 +7783,7 @@
           <a:noFill/>
         </p:spPr>
         <p:txBody>
-          <a:bodyPr wrap="square">
+          <a:bodyPr wrap="square" lIns="109728" rIns="109728" tIns="73152" bIns="73152">
             <a:spAutoFit/>
           </a:bodyPr>
           <a:lstStyle/>
@@ -7829,7 +7829,7 @@
         <p:spPr>
           <a:xfrm>
             <a:off x="320040" y="1051560"/>
-            <a:ext cx="5669280" cy="2331720"/>
+            <a:ext cx="5669280" cy="2377440"/>
           </a:xfrm>
           <a:prstGeom prst="roundRect">
             <a:avLst/>
@@ -7858,12 +7858,12 @@
           </a:fontRef>
         </p:style>
         <p:txBody>
-          <a:bodyPr rtlCol="0" anchor="ctr" wrap="square"/>
+          <a:bodyPr rtlCol="0" anchor="ctr" wrap="square" lIns="109728" rIns="109728" tIns="73152" bIns="73152"/>
           <a:lstStyle/>
           <a:p>
             <a:pPr algn="ctr"/>
             <a:r>
-              <a:rPr sz="1600" b="1">
+              <a:rPr sz="1500" b="1">
                 <a:solidFill>
                   <a:srgbClr val="DC2626"/>
                 </a:solidFill>
@@ -7877,11 +7877,11 @@
           <a:p>
             <a:pPr>
               <a:spcBef>
-                <a:spcPts val="600"/>
-              </a:spcBef>
-            </a:pPr>
-            <a:r>
-              <a:rPr sz="1300" b="0">
+                <a:spcPts val="500"/>
+              </a:spcBef>
+            </a:pPr>
+            <a:r>
+              <a:rPr sz="1200" b="0">
                 <a:solidFill>
                   <a:srgbClr val="0F172A"/>
                 </a:solidFill>
@@ -7895,11 +7895,11 @@
           <a:p>
             <a:pPr>
               <a:spcBef>
-                <a:spcPts val="600"/>
-              </a:spcBef>
-            </a:pPr>
-            <a:r>
-              <a:rPr sz="1300" b="0">
+                <a:spcPts val="500"/>
+              </a:spcBef>
+            </a:pPr>
+            <a:r>
+              <a:rPr sz="1200" b="0">
                 <a:solidFill>
                   <a:srgbClr val="0F172A"/>
                 </a:solidFill>
@@ -7913,11 +7913,11 @@
           <a:p>
             <a:pPr>
               <a:spcBef>
-                <a:spcPts val="600"/>
-              </a:spcBef>
-            </a:pPr>
-            <a:r>
-              <a:rPr sz="1300" b="0">
+                <a:spcPts val="500"/>
+              </a:spcBef>
+            </a:pPr>
+            <a:r>
+              <a:rPr sz="1200" b="0">
                 <a:solidFill>
                   <a:srgbClr val="0F172A"/>
                 </a:solidFill>
@@ -7939,7 +7939,7 @@
         <p:spPr>
           <a:xfrm>
             <a:off x="6217920" y="1051560"/>
-            <a:ext cx="5669280" cy="2331720"/>
+            <a:ext cx="5669280" cy="2377440"/>
           </a:xfrm>
           <a:prstGeom prst="roundRect">
             <a:avLst/>
@@ -7968,12 +7968,12 @@
           </a:fontRef>
         </p:style>
         <p:txBody>
-          <a:bodyPr rtlCol="0" anchor="ctr" wrap="square"/>
+          <a:bodyPr rtlCol="0" anchor="ctr" wrap="square" lIns="109728" rIns="109728" tIns="73152" bIns="73152"/>
           <a:lstStyle/>
           <a:p>
             <a:pPr algn="ctr"/>
             <a:r>
-              <a:rPr sz="1600" b="1">
+              <a:rPr sz="1500" b="1">
                 <a:solidFill>
                   <a:srgbClr val="DC2626"/>
                 </a:solidFill>
@@ -7987,11 +7987,11 @@
           <a:p>
             <a:pPr>
               <a:spcBef>
-                <a:spcPts val="600"/>
-              </a:spcBef>
-            </a:pPr>
-            <a:r>
-              <a:rPr sz="1300" b="0">
+                <a:spcPts val="500"/>
+              </a:spcBef>
+            </a:pPr>
+            <a:r>
+              <a:rPr sz="1200" b="0">
                 <a:solidFill>
                   <a:srgbClr val="0F172A"/>
                 </a:solidFill>
@@ -8005,11 +8005,11 @@
           <a:p>
             <a:pPr>
               <a:spcBef>
-                <a:spcPts val="600"/>
-              </a:spcBef>
-            </a:pPr>
-            <a:r>
-              <a:rPr sz="1300" b="0">
+                <a:spcPts val="500"/>
+              </a:spcBef>
+            </a:pPr>
+            <a:r>
+              <a:rPr sz="1200" b="0">
                 <a:solidFill>
                   <a:srgbClr val="0F172A"/>
                 </a:solidFill>
@@ -8023,11 +8023,11 @@
           <a:p>
             <a:pPr>
               <a:spcBef>
-                <a:spcPts val="600"/>
-              </a:spcBef>
-            </a:pPr>
-            <a:r>
-              <a:rPr sz="1300" b="0">
+                <a:spcPts val="500"/>
+              </a:spcBef>
+            </a:pPr>
+            <a:r>
+              <a:rPr sz="1200" b="0">
                 <a:solidFill>
                   <a:srgbClr val="0F172A"/>
                 </a:solidFill>
@@ -8048,8 +8048,8 @@
         </p:nvSpPr>
         <p:spPr>
           <a:xfrm>
-            <a:off x="320040" y="3566160"/>
-            <a:ext cx="5669280" cy="2331720"/>
+            <a:off x="320040" y="3611880"/>
+            <a:ext cx="5669280" cy="2377440"/>
           </a:xfrm>
           <a:prstGeom prst="roundRect">
             <a:avLst/>
@@ -8078,12 +8078,12 @@
           </a:fontRef>
         </p:style>
         <p:txBody>
-          <a:bodyPr rtlCol="0" anchor="ctr" wrap="square"/>
+          <a:bodyPr rtlCol="0" anchor="ctr" wrap="square" lIns="109728" rIns="109728" tIns="73152" bIns="73152"/>
           <a:lstStyle/>
           <a:p>
             <a:pPr algn="ctr"/>
             <a:r>
-              <a:rPr sz="1600" b="1">
+              <a:rPr sz="1500" b="1">
                 <a:solidFill>
                   <a:srgbClr val="DC2626"/>
                 </a:solidFill>
@@ -8097,11 +8097,11 @@
           <a:p>
             <a:pPr>
               <a:spcBef>
-                <a:spcPts val="600"/>
-              </a:spcBef>
-            </a:pPr>
-            <a:r>
-              <a:rPr sz="1300" b="0">
+                <a:spcPts val="500"/>
+              </a:spcBef>
+            </a:pPr>
+            <a:r>
+              <a:rPr sz="1200" b="0">
                 <a:solidFill>
                   <a:srgbClr val="0F172A"/>
                 </a:solidFill>
@@ -8115,11 +8115,11 @@
           <a:p>
             <a:pPr>
               <a:spcBef>
-                <a:spcPts val="600"/>
-              </a:spcBef>
-            </a:pPr>
-            <a:r>
-              <a:rPr sz="1300" b="0">
+                <a:spcPts val="500"/>
+              </a:spcBef>
+            </a:pPr>
+            <a:r>
+              <a:rPr sz="1200" b="0">
                 <a:solidFill>
                   <a:srgbClr val="0F172A"/>
                 </a:solidFill>
@@ -8133,11 +8133,11 @@
           <a:p>
             <a:pPr>
               <a:spcBef>
-                <a:spcPts val="600"/>
-              </a:spcBef>
-            </a:pPr>
-            <a:r>
-              <a:rPr sz="1300" b="0">
+                <a:spcPts val="500"/>
+              </a:spcBef>
+            </a:pPr>
+            <a:r>
+              <a:rPr sz="1200" b="0">
                 <a:solidFill>
                   <a:srgbClr val="0F172A"/>
                 </a:solidFill>
@@ -8158,8 +8158,8 @@
         </p:nvSpPr>
         <p:spPr>
           <a:xfrm>
-            <a:off x="6217920" y="3566160"/>
-            <a:ext cx="5669280" cy="2331720"/>
+            <a:off x="6217920" y="3611880"/>
+            <a:ext cx="5669280" cy="2377440"/>
           </a:xfrm>
           <a:prstGeom prst="roundRect">
             <a:avLst/>
@@ -8188,12 +8188,12 @@
           </a:fontRef>
         </p:style>
         <p:txBody>
-          <a:bodyPr rtlCol="0" anchor="ctr" wrap="square"/>
+          <a:bodyPr rtlCol="0" anchor="ctr" wrap="square" lIns="109728" rIns="109728" tIns="73152" bIns="73152"/>
           <a:lstStyle/>
           <a:p>
             <a:pPr algn="ctr"/>
             <a:r>
-              <a:rPr sz="1600" b="1">
+              <a:rPr sz="1500" b="1">
                 <a:solidFill>
                   <a:srgbClr val="DC2626"/>
                 </a:solidFill>
@@ -8207,11 +8207,11 @@
           <a:p>
             <a:pPr>
               <a:spcBef>
-                <a:spcPts val="600"/>
-              </a:spcBef>
-            </a:pPr>
-            <a:r>
-              <a:rPr sz="1300" b="0">
+                <a:spcPts val="500"/>
+              </a:spcBef>
+            </a:pPr>
+            <a:r>
+              <a:rPr sz="1200" b="0">
                 <a:solidFill>
                   <a:srgbClr val="0F172A"/>
                 </a:solidFill>
@@ -8225,11 +8225,11 @@
           <a:p>
             <a:pPr>
               <a:spcBef>
-                <a:spcPts val="600"/>
-              </a:spcBef>
-            </a:pPr>
-            <a:r>
-              <a:rPr sz="1300" b="0">
+                <a:spcPts val="500"/>
+              </a:spcBef>
+            </a:pPr>
+            <a:r>
+              <a:rPr sz="1200" b="0">
                 <a:solidFill>
                   <a:srgbClr val="0F172A"/>
                 </a:solidFill>
@@ -8243,11 +8243,11 @@
           <a:p>
             <a:pPr>
               <a:spcBef>
-                <a:spcPts val="600"/>
-              </a:spcBef>
-            </a:pPr>
-            <a:r>
-              <a:rPr sz="1300" b="0">
+                <a:spcPts val="500"/>
+              </a:spcBef>
+            </a:pPr>
+            <a:r>
+              <a:rPr sz="1200" b="0">
                 <a:solidFill>
                   <a:srgbClr val="0F172A"/>
                 </a:solidFill>
@@ -8375,7 +8375,7 @@
           <a:noFill/>
         </p:spPr>
         <p:txBody>
-          <a:bodyPr wrap="square">
+          <a:bodyPr wrap="square" lIns="109728" rIns="109728" tIns="73152" bIns="73152">
             <a:spAutoFit/>
           </a:bodyPr>
           <a:lstStyle/>
@@ -8428,8 +8428,8 @@
         </p:blipFill>
         <p:spPr>
           <a:xfrm>
-            <a:off x="320040" y="960120"/>
-            <a:ext cx="11521440" cy="6480810"/>
+            <a:off x="1285240" y="960120"/>
+            <a:ext cx="9591040" cy="5394960"/>
           </a:xfrm>
           <a:prstGeom prst="rect">
             <a:avLst/>
@@ -8551,7 +8551,7 @@
           <a:noFill/>
         </p:spPr>
         <p:txBody>
-          <a:bodyPr wrap="square">
+          <a:bodyPr wrap="square" lIns="109728" rIns="109728" tIns="73152" bIns="73152">
             <a:spAutoFit/>
           </a:bodyPr>
           <a:lstStyle/>
@@ -8604,8 +8604,8 @@
         </p:blipFill>
         <p:spPr>
           <a:xfrm>
-            <a:off x="228600" y="914400"/>
-            <a:ext cx="11704320" cy="6583680"/>
+            <a:off x="1244600" y="914400"/>
+            <a:ext cx="9672320" cy="5440680"/>
           </a:xfrm>
           <a:prstGeom prst="rect">
             <a:avLst/>
@@ -8727,7 +8727,7 @@
           <a:noFill/>
         </p:spPr>
         <p:txBody>
-          <a:bodyPr wrap="square">
+          <a:bodyPr wrap="square" lIns="109728" rIns="109728" tIns="73152" bIns="73152">
             <a:spAutoFit/>
           </a:bodyPr>
           <a:lstStyle/>
@@ -8772,8 +8772,8 @@
         </p:nvSpPr>
         <p:spPr>
           <a:xfrm>
-            <a:off x="365760" y="1097280"/>
-            <a:ext cx="5669280" cy="4846320"/>
+            <a:off x="320040" y="1051560"/>
+            <a:ext cx="5715000" cy="5074920"/>
           </a:xfrm>
           <a:prstGeom prst="roundRect">
             <a:avLst/>
@@ -8802,12 +8802,12 @@
           </a:fontRef>
         </p:style>
         <p:txBody>
-          <a:bodyPr rtlCol="0" anchor="ctr" wrap="square"/>
+          <a:bodyPr rtlCol="0" anchor="ctr" wrap="square" lIns="109728" rIns="109728" tIns="73152" bIns="73152"/>
           <a:lstStyle/>
           <a:p>
             <a:pPr algn="ctr"/>
             <a:r>
-              <a:rPr sz="1700" b="1">
+              <a:rPr sz="1600" b="1">
                 <a:solidFill>
                   <a:srgbClr val="2563EB"/>
                 </a:solidFill>
@@ -8821,11 +8821,11 @@
           <a:p>
             <a:pPr>
               <a:spcBef>
-                <a:spcPts val="800"/>
-              </a:spcBef>
-            </a:pPr>
-            <a:r>
-              <a:rPr sz="1300" b="0">
+                <a:spcPts val="700"/>
+              </a:spcBef>
+            </a:pPr>
+            <a:r>
+              <a:rPr sz="1200" b="0">
                 <a:solidFill>
                   <a:srgbClr val="0F172A"/>
                 </a:solidFill>
@@ -8839,29 +8839,47 @@
           <a:p>
             <a:pPr>
               <a:spcBef>
-                <a:spcPts val="800"/>
-              </a:spcBef>
-            </a:pPr>
-            <a:r>
-              <a:rPr sz="1300" b="0">
-                <a:solidFill>
-                  <a:srgbClr val="0F172A"/>
-                </a:solidFill>
-                <a:latin typeface="맑은 고딕"/>
-                <a:ea typeface="맑은 고딕"/>
-                <a:cs typeface="맑은 고딕"/>
-              </a:rPr>
-              <a:t>• Security: ALB/App/NAT/DB/EFS/Redis/endpoints 용 Security Group</a:t>
+                <a:spcPts val="700"/>
+              </a:spcBef>
+            </a:pPr>
+            <a:r>
+              <a:rPr sz="1200" b="0">
+                <a:solidFill>
+                  <a:srgbClr val="0F172A"/>
+                </a:solidFill>
+                <a:latin typeface="맑은 고딕"/>
+                <a:ea typeface="맑은 고딕"/>
+                <a:cs typeface="맑은 고딕"/>
+              </a:rPr>
+              <a:t>• Security: ALB / App / NAT / DB / EFS</a:t>
             </a:r>
           </a:p>
           <a:p>
             <a:pPr>
               <a:spcBef>
-                <a:spcPts val="800"/>
-              </a:spcBef>
-            </a:pPr>
-            <a:r>
-              <a:rPr sz="1300" b="0">
+                <a:spcPts val="700"/>
+              </a:spcBef>
+            </a:pPr>
+            <a:r>
+              <a:rPr sz="1200" b="0">
+                <a:solidFill>
+                  <a:srgbClr val="0F172A"/>
+                </a:solidFill>
+                <a:latin typeface="맑은 고딕"/>
+                <a:ea typeface="맑은 고딕"/>
+                <a:cs typeface="맑은 고딕"/>
+              </a:rPr>
+              <a:t>  Redis / endpoints 용 Security Group</a:t>
+            </a:r>
+          </a:p>
+          <a:p>
+            <a:pPr>
+              <a:spcBef>
+                <a:spcPts val="700"/>
+              </a:spcBef>
+            </a:pPr>
+            <a:r>
+              <a:rPr sz="1200" b="0">
                 <a:solidFill>
                   <a:srgbClr val="0F172A"/>
                 </a:solidFill>
@@ -8875,11 +8893,11 @@
           <a:p>
             <a:pPr>
               <a:spcBef>
-                <a:spcPts val="800"/>
-              </a:spcBef>
-            </a:pPr>
-            <a:r>
-              <a:rPr sz="1300" b="0">
+                <a:spcPts val="700"/>
+              </a:spcBef>
+            </a:pPr>
+            <a:r>
+              <a:rPr sz="1200" b="0">
                 <a:solidFill>
                   <a:srgbClr val="0F172A"/>
                 </a:solidFill>
@@ -8893,11 +8911,11 @@
           <a:p>
             <a:pPr>
               <a:spcBef>
-                <a:spcPts val="800"/>
-              </a:spcBef>
-            </a:pPr>
-            <a:r>
-              <a:rPr sz="1300" b="0">
+                <a:spcPts val="700"/>
+              </a:spcBef>
+            </a:pPr>
+            <a:r>
+              <a:rPr sz="1200" b="0">
                 <a:solidFill>
                   <a:srgbClr val="0F172A"/>
                 </a:solidFill>
@@ -8911,11 +8929,11 @@
           <a:p>
             <a:pPr>
               <a:spcBef>
-                <a:spcPts val="800"/>
-              </a:spcBef>
-            </a:pPr>
-            <a:r>
-              <a:rPr sz="1300" b="0">
+                <a:spcPts val="700"/>
+              </a:spcBef>
+            </a:pPr>
+            <a:r>
+              <a:rPr sz="1200" b="0">
                 <a:solidFill>
                   <a:srgbClr val="0F172A"/>
                 </a:solidFill>
@@ -8936,8 +8954,8 @@
         </p:nvSpPr>
         <p:spPr>
           <a:xfrm>
-            <a:off x="6309360" y="1097280"/>
-            <a:ext cx="5394960" cy="4846320"/>
+            <a:off x="6263640" y="1051560"/>
+            <a:ext cx="5577840" cy="5074920"/>
           </a:xfrm>
           <a:prstGeom prst="roundRect">
             <a:avLst/>
@@ -8966,12 +8984,12 @@
           </a:fontRef>
         </p:style>
         <p:txBody>
-          <a:bodyPr rtlCol="0" anchor="ctr" wrap="square"/>
+          <a:bodyPr rtlCol="0" anchor="ctr" wrap="square" lIns="109728" rIns="109728" tIns="73152" bIns="73152"/>
           <a:lstStyle/>
           <a:p>
             <a:pPr algn="ctr"/>
             <a:r>
-              <a:rPr sz="1700" b="1">
+              <a:rPr sz="1600" b="1">
                 <a:solidFill>
                   <a:srgbClr val="0D9488"/>
                 </a:solidFill>
@@ -9279,7 +9297,7 @@
           <a:noFill/>
         </p:spPr>
         <p:txBody>
-          <a:bodyPr wrap="square">
+          <a:bodyPr wrap="square" lIns="109728" rIns="109728" tIns="73152" bIns="73152">
             <a:spAutoFit/>
           </a:bodyPr>
           <a:lstStyle/>
@@ -9324,8 +9342,8 @@
         </p:nvSpPr>
         <p:spPr>
           <a:xfrm>
-            <a:off x="274320" y="1097280"/>
-            <a:ext cx="2788920" cy="4846320"/>
+            <a:off x="320040" y="1051560"/>
+            <a:ext cx="2788920" cy="5074920"/>
           </a:xfrm>
           <a:prstGeom prst="roundRect">
             <a:avLst/>
@@ -9354,12 +9372,12 @@
           </a:fontRef>
         </p:style>
         <p:txBody>
-          <a:bodyPr rtlCol="0" anchor="ctr" wrap="square"/>
+          <a:bodyPr rtlCol="0" anchor="ctr" wrap="square" lIns="109728" rIns="109728" tIns="73152" bIns="73152"/>
           <a:lstStyle/>
           <a:p>
             <a:pPr algn="ctr"/>
             <a:r>
-              <a:rPr sz="1600" b="1">
+              <a:rPr sz="1500" b="1">
                 <a:solidFill>
                   <a:srgbClr val="16A34A"/>
                 </a:solidFill>
@@ -9377,7 +9395,7 @@
               </a:spcBef>
             </a:pPr>
             <a:r>
-              <a:rPr sz="1300" b="0">
+              <a:rPr sz="1200" b="0">
                 <a:solidFill>
                   <a:srgbClr val="0F172A"/>
                 </a:solidFill>
@@ -9395,7 +9413,7 @@
               </a:spcBef>
             </a:pPr>
             <a:r>
-              <a:rPr sz="1300" b="0">
+              <a:rPr sz="1200" b="0">
                 <a:solidFill>
                   <a:srgbClr val="0F172A"/>
                 </a:solidFill>
@@ -9413,7 +9431,7 @@
               </a:spcBef>
             </a:pPr>
             <a:r>
-              <a:rPr sz="1300" b="0">
+              <a:rPr sz="1200" b="0">
                 <a:solidFill>
                   <a:srgbClr val="0F172A"/>
                 </a:solidFill>
@@ -9431,7 +9449,7 @@
               </a:spcBef>
             </a:pPr>
             <a:r>
-              <a:rPr sz="1300" b="0">
+              <a:rPr sz="1200" b="0">
                 <a:solidFill>
                   <a:srgbClr val="0F172A"/>
                 </a:solidFill>
@@ -9452,8 +9470,8 @@
         </p:nvSpPr>
         <p:spPr>
           <a:xfrm>
-            <a:off x="3200400" y="1097280"/>
-            <a:ext cx="2788920" cy="4846320"/>
+            <a:off x="3246120" y="1051560"/>
+            <a:ext cx="2788920" cy="5074920"/>
           </a:xfrm>
           <a:prstGeom prst="roundRect">
             <a:avLst/>
@@ -9482,12 +9500,12 @@
           </a:fontRef>
         </p:style>
         <p:txBody>
-          <a:bodyPr rtlCol="0" anchor="ctr" wrap="square"/>
+          <a:bodyPr rtlCol="0" anchor="ctr" wrap="square" lIns="109728" rIns="109728" tIns="73152" bIns="73152"/>
           <a:lstStyle/>
           <a:p>
             <a:pPr algn="ctr"/>
             <a:r>
-              <a:rPr sz="1600" b="1">
+              <a:rPr sz="1500" b="1">
                 <a:solidFill>
                   <a:srgbClr val="0D9488"/>
                 </a:solidFill>
@@ -9505,7 +9523,7 @@
               </a:spcBef>
             </a:pPr>
             <a:r>
-              <a:rPr sz="1300" b="0">
+              <a:rPr sz="1200" b="0">
                 <a:solidFill>
                   <a:srgbClr val="0F172A"/>
                 </a:solidFill>
@@ -9523,7 +9541,7 @@
               </a:spcBef>
             </a:pPr>
             <a:r>
-              <a:rPr sz="1300" b="0">
+              <a:rPr sz="1200" b="0">
                 <a:solidFill>
                   <a:srgbClr val="0F172A"/>
                 </a:solidFill>
@@ -9541,7 +9559,7 @@
               </a:spcBef>
             </a:pPr>
             <a:r>
-              <a:rPr sz="1300" b="0">
+              <a:rPr sz="1200" b="0">
                 <a:solidFill>
                   <a:srgbClr val="0F172A"/>
                 </a:solidFill>
@@ -9559,7 +9577,7 @@
               </a:spcBef>
             </a:pPr>
             <a:r>
-              <a:rPr sz="1300" b="0">
+              <a:rPr sz="1200" b="0">
                 <a:solidFill>
                   <a:srgbClr val="0F172A"/>
                 </a:solidFill>
@@ -9580,8 +9598,8 @@
         </p:nvSpPr>
         <p:spPr>
           <a:xfrm>
-            <a:off x="6126480" y="1097280"/>
-            <a:ext cx="2788920" cy="4846320"/>
+            <a:off x="6172200" y="1051560"/>
+            <a:ext cx="2788920" cy="5074920"/>
           </a:xfrm>
           <a:prstGeom prst="roundRect">
             <a:avLst/>
@@ -9610,12 +9628,12 @@
           </a:fontRef>
         </p:style>
         <p:txBody>
-          <a:bodyPr rtlCol="0" anchor="ctr" wrap="square"/>
+          <a:bodyPr rtlCol="0" anchor="ctr" wrap="square" lIns="109728" rIns="109728" tIns="73152" bIns="73152"/>
           <a:lstStyle/>
           <a:p>
             <a:pPr algn="ctr"/>
             <a:r>
-              <a:rPr sz="1600" b="1">
+              <a:rPr sz="1500" b="1">
                 <a:solidFill>
                   <a:srgbClr val="2563EB"/>
                 </a:solidFill>
@@ -9633,7 +9651,7 @@
               </a:spcBef>
             </a:pPr>
             <a:r>
-              <a:rPr sz="1300" b="0">
+              <a:rPr sz="1200" b="0">
                 <a:solidFill>
                   <a:srgbClr val="0F172A"/>
                 </a:solidFill>
@@ -9651,7 +9669,7 @@
               </a:spcBef>
             </a:pPr>
             <a:r>
-              <a:rPr sz="1300" b="0">
+              <a:rPr sz="1200" b="0">
                 <a:solidFill>
                   <a:srgbClr val="0F172A"/>
                 </a:solidFill>
@@ -9669,7 +9687,7 @@
               </a:spcBef>
             </a:pPr>
             <a:r>
-              <a:rPr sz="1300" b="0">
+              <a:rPr sz="1200" b="0">
                 <a:solidFill>
                   <a:srgbClr val="0F172A"/>
                 </a:solidFill>
@@ -9687,7 +9705,7 @@
               </a:spcBef>
             </a:pPr>
             <a:r>
-              <a:rPr sz="1300" b="0">
+              <a:rPr sz="1200" b="0">
                 <a:solidFill>
                   <a:srgbClr val="0F172A"/>
                 </a:solidFill>
@@ -9708,8 +9726,8 @@
         </p:nvSpPr>
         <p:spPr>
           <a:xfrm>
-            <a:off x="9052560" y="1097280"/>
-            <a:ext cx="2788920" cy="4846320"/>
+            <a:off x="9098280" y="1051560"/>
+            <a:ext cx="2788920" cy="5074920"/>
           </a:xfrm>
           <a:prstGeom prst="roundRect">
             <a:avLst/>
@@ -9738,12 +9756,12 @@
           </a:fontRef>
         </p:style>
         <p:txBody>
-          <a:bodyPr rtlCol="0" anchor="ctr" wrap="square"/>
+          <a:bodyPr rtlCol="0" anchor="ctr" wrap="square" lIns="109728" rIns="109728" tIns="73152" bIns="73152"/>
           <a:lstStyle/>
           <a:p>
             <a:pPr algn="ctr"/>
             <a:r>
-              <a:rPr sz="1600" b="1">
+              <a:rPr sz="1500" b="1">
                 <a:solidFill>
                   <a:srgbClr val="EA580C"/>
                 </a:solidFill>
@@ -9761,7 +9779,7 @@
               </a:spcBef>
             </a:pPr>
             <a:r>
-              <a:rPr sz="1300" b="0">
+              <a:rPr sz="1200" b="0">
                 <a:solidFill>
                   <a:srgbClr val="0F172A"/>
                 </a:solidFill>
@@ -9779,7 +9797,7 @@
               </a:spcBef>
             </a:pPr>
             <a:r>
-              <a:rPr sz="1300" b="0">
+              <a:rPr sz="1200" b="0">
                 <a:solidFill>
                   <a:srgbClr val="0F172A"/>
                 </a:solidFill>
@@ -9797,7 +9815,7 @@
               </a:spcBef>
             </a:pPr>
             <a:r>
-              <a:rPr sz="1300" b="0">
+              <a:rPr sz="1200" b="0">
                 <a:solidFill>
                   <a:srgbClr val="0F172A"/>
                 </a:solidFill>
@@ -9815,7 +9833,7 @@
               </a:spcBef>
             </a:pPr>
             <a:r>
-              <a:rPr sz="1300" b="0">
+              <a:rPr sz="1200" b="0">
                 <a:solidFill>
                   <a:srgbClr val="0F172A"/>
                 </a:solidFill>

</xml_diff>

<commit_message>
docs: simplify HTTPS/WAF slides into plain-language explanations
Replace jargon-heavy ACM/WAF rule names with what HTTPS and WAF do for aniverse.my, and refresh the diagram.

Co-authored-by: ho0215 <ho0215@users.noreply.github.com>
</commit_message>
<xml_diff>
--- a/docs/presentation/ppt/Aniverse_발표_강사용.pptx
+++ b/docs/presentation/ppt/Aniverse_발표_강사용.pptx
@@ -4217,8 +4217,8 @@
         </p:nvSpPr>
         <p:spPr>
           <a:xfrm>
-            <a:off x="365760" y="1097280"/>
-            <a:ext cx="5669280" cy="4846320"/>
+            <a:off x="320040" y="1051560"/>
+            <a:ext cx="5715000" cy="5074920"/>
           </a:xfrm>
           <a:prstGeom prst="roundRect">
             <a:avLst/>
@@ -4252,7 +4252,7 @@
           <a:p>
             <a:pPr algn="ctr"/>
             <a:r>
-              <a:rPr sz="1600" b="1">
+              <a:rPr sz="1500" b="1">
                 <a:solidFill>
                   <a:srgbClr val="2563EB"/>
                 </a:solidFill>
@@ -4270,7 +4270,7 @@
               </a:spcBef>
             </a:pPr>
             <a:r>
-              <a:rPr sz="1300" b="0">
+              <a:rPr sz="1200" b="0">
                 <a:solidFill>
                   <a:srgbClr val="0F172A"/>
                 </a:solidFill>
@@ -4288,7 +4288,7 @@
               </a:spcBef>
             </a:pPr>
             <a:r>
-              <a:rPr sz="1300" b="0">
+              <a:rPr sz="1200" b="0">
                 <a:solidFill>
                   <a:srgbClr val="0F172A"/>
                 </a:solidFill>
@@ -4306,7 +4306,7 @@
               </a:spcBef>
             </a:pPr>
             <a:r>
-              <a:rPr sz="1300" b="0">
+              <a:rPr sz="1200" b="0">
                 <a:solidFill>
                   <a:srgbClr val="0F172A"/>
                 </a:solidFill>
@@ -4324,7 +4324,7 @@
               </a:spcBef>
             </a:pPr>
             <a:r>
-              <a:rPr sz="1300" b="0">
+              <a:rPr sz="1200" b="0">
                 <a:solidFill>
                   <a:srgbClr val="0F172A"/>
                 </a:solidFill>
@@ -4342,7 +4342,7 @@
               </a:spcBef>
             </a:pPr>
             <a:r>
-              <a:rPr sz="1300" b="0">
+              <a:rPr sz="1200" b="0">
                 <a:solidFill>
                   <a:srgbClr val="0F172A"/>
                 </a:solidFill>
@@ -4363,8 +4363,8 @@
         </p:nvSpPr>
         <p:spPr>
           <a:xfrm>
-            <a:off x="6309360" y="1097280"/>
-            <a:ext cx="5394960" cy="4846320"/>
+            <a:off x="6263640" y="1051560"/>
+            <a:ext cx="5577840" cy="5074920"/>
           </a:xfrm>
           <a:prstGeom prst="roundRect">
             <a:avLst/>
@@ -4398,7 +4398,7 @@
           <a:p>
             <a:pPr algn="ctr"/>
             <a:r>
-              <a:rPr sz="1600" b="1">
+              <a:rPr sz="1500" b="1">
                 <a:solidFill>
                   <a:srgbClr val="EA580C"/>
                 </a:solidFill>
@@ -4416,7 +4416,7 @@
               </a:spcBef>
             </a:pPr>
             <a:r>
-              <a:rPr sz="1300" b="0">
+              <a:rPr sz="1200" b="0">
                 <a:solidFill>
                   <a:srgbClr val="0F172A"/>
                 </a:solidFill>
@@ -4434,7 +4434,7 @@
               </a:spcBef>
             </a:pPr>
             <a:r>
-              <a:rPr sz="1300" b="0">
+              <a:rPr sz="1200" b="0">
                 <a:solidFill>
                   <a:srgbClr val="0F172A"/>
                 </a:solidFill>
@@ -4452,7 +4452,7 @@
               </a:spcBef>
             </a:pPr>
             <a:r>
-              <a:rPr sz="1300" b="0">
+              <a:rPr sz="1200" b="0">
                 <a:solidFill>
                   <a:srgbClr val="0F172A"/>
                 </a:solidFill>
@@ -4470,7 +4470,7 @@
               </a:spcBef>
             </a:pPr>
             <a:r>
-              <a:rPr sz="1300" b="0">
+              <a:rPr sz="1200" b="0">
                 <a:solidFill>
                   <a:srgbClr val="0F172A"/>
                 </a:solidFill>
@@ -4488,7 +4488,7 @@
               </a:spcBef>
             </a:pPr>
             <a:r>
-              <a:rPr sz="1300" b="0">
+              <a:rPr sz="1200" b="0">
                 <a:solidFill>
                   <a:srgbClr val="0F172A"/>
                 </a:solidFill>
@@ -5282,7 +5282,7 @@
                 <a:ea typeface="맑은 고딕"/>
                 <a:cs typeface="맑은 고딕"/>
               </a:rPr>
-              <a:t>• ACM HTTPS + WAF(SQLi/Rate)</a:t>
+              <a:t>• HTTPS(암호화) + WAF(공격 차단)</a:t>
             </a:r>
           </a:p>
         </p:txBody>
@@ -5434,7 +5434,7 @@
                 <a:ea typeface="맑은 고딕"/>
                 <a:cs typeface="맑은 고딕"/>
               </a:rPr>
-              <a:t>도메인부터 ALB까지 암호화·필터링 경로</a:t>
+              <a:t>한 줄: 암호화로 보호하고, 앞에서 공격을 걸러낸다</a:t>
             </a:r>
           </a:p>
         </p:txBody>
@@ -5610,7 +5610,7 @@
                 <a:ea typeface="맑은 고딕"/>
                 <a:cs typeface="맑은 고딕"/>
               </a:rPr>
-              <a:t>Terraform으로 고정한 보안 엣지</a:t>
+              <a:t>용어 말고 ‘무엇을 했는지’만</a:t>
             </a:r>
           </a:p>
         </p:txBody>
@@ -5658,7 +5658,7 @@
           <a:p>
             <a:pPr algn="ctr"/>
             <a:r>
-              <a:rPr sz="1600" b="1">
+              <a:rPr sz="1700" b="1">
                 <a:solidFill>
                   <a:srgbClr val="0D9488"/>
                 </a:solidFill>
@@ -5666,223 +5666,115 @@
                 <a:ea typeface="맑은 고딕"/>
                 <a:cs typeface="맑은 고딕"/>
               </a:rPr>
-              <a:t>HTTPS — ACM + ALB</a:t>
+              <a:t>HTTPS — 통신 암호화</a:t>
             </a:r>
           </a:p>
           <a:p>
             <a:pPr>
               <a:spcBef>
-                <a:spcPts val="300"/>
-              </a:spcBef>
-            </a:pPr>
-            <a:r>
-              <a:rPr sz="1200" b="0">
-                <a:solidFill>
-                  <a:srgbClr val="0F172A"/>
-                </a:solidFill>
-                <a:latin typeface="맑은 고딕"/>
-                <a:ea typeface="맑은 고딕"/>
-                <a:cs typeface="맑은 고딕"/>
-              </a:rPr>
-              <a:t>modules/acm</a:t>
+                <a:spcPts val="800"/>
+              </a:spcBef>
+            </a:pPr>
+            <a:r>
+              <a:rPr sz="1200" b="1">
+                <a:solidFill>
+                  <a:srgbClr val="475569"/>
+                </a:solidFill>
+                <a:latin typeface="맑은 고딕"/>
+                <a:ea typeface="맑은 고딕"/>
+                <a:cs typeface="맑은 고딕"/>
+              </a:rPr>
+              <a:t>쉽게: 사이트와 사용자 사이 내용을 남이 못 보게 잠근다</a:t>
             </a:r>
           </a:p>
           <a:p>
             <a:pPr>
               <a:spcBef>
-                <a:spcPts val="300"/>
-              </a:spcBef>
-            </a:pPr>
-            <a:r>
-              <a:rPr sz="1200" b="0">
-                <a:solidFill>
-                  <a:srgbClr val="0F172A"/>
-                </a:solidFill>
-                <a:latin typeface="맑은 고딕"/>
-                <a:ea typeface="맑은 고딕"/>
-                <a:cs typeface="맑은 고딕"/>
-              </a:rPr>
-              <a:t>• aniverse.my DNS 검증 인증서</a:t>
+                <a:spcPts val="1000"/>
+              </a:spcBef>
+            </a:pPr>
+            <a:r>
+              <a:rPr sz="1400" b="0">
+                <a:solidFill>
+                  <a:srgbClr val="0F172A"/>
+                </a:solidFill>
+                <a:latin typeface="맑은 고딕"/>
+                <a:ea typeface="맑은 고딕"/>
+                <a:cs typeface="맑은 고딕"/>
+              </a:rPr>
+              <a:t>• ACM = 인증서(자물쇠) 발급 서비스</a:t>
             </a:r>
           </a:p>
           <a:p>
             <a:pPr>
               <a:spcBef>
-                <a:spcPts val="300"/>
-              </a:spcBef>
-            </a:pPr>
-            <a:r>
-              <a:rPr sz="1200" b="0">
-                <a:solidFill>
-                  <a:srgbClr val="0F172A"/>
-                </a:solidFill>
-                <a:latin typeface="맑은 고딕"/>
-                <a:ea typeface="맑은 고딕"/>
-                <a:cs typeface="맑은 고딕"/>
-              </a:rPr>
-              <a:t>• www SAN 포함 · Route53 검증 레코드</a:t>
+                <a:spcPts val="1000"/>
+              </a:spcBef>
+            </a:pPr>
+            <a:r>
+              <a:rPr sz="1400" b="0">
+                <a:solidFill>
+                  <a:srgbClr val="0F172A"/>
+                </a:solidFill>
+                <a:latin typeface="맑은 고딕"/>
+                <a:ea typeface="맑은 고딕"/>
+                <a:cs typeface="맑은 고딕"/>
+              </a:rPr>
+              <a:t>• aniverse.my 용 인증서를 ALB에 붙임</a:t>
             </a:r>
           </a:p>
           <a:p>
             <a:pPr>
               <a:spcBef>
-                <a:spcPts val="300"/>
-              </a:spcBef>
-            </a:pPr>
-            <a:r>
-              <a:rPr sz="1200" b="0">
-                <a:solidFill>
-                  <a:srgbClr val="0F172A"/>
-                </a:solidFill>
-                <a:latin typeface="맑은 고딕"/>
-                <a:ea typeface="맑은 고딕"/>
-                <a:cs typeface="맑은 고딕"/>
-              </a:rPr>
-              <a:t/>
+                <a:spcPts val="1000"/>
+              </a:spcBef>
+            </a:pPr>
+            <a:r>
+              <a:rPr sz="1400" b="0">
+                <a:solidFill>
+                  <a:srgbClr val="0F172A"/>
+                </a:solidFill>
+                <a:latin typeface="맑은 고딕"/>
+                <a:ea typeface="맑은 고딕"/>
+                <a:cs typeface="맑은 고딕"/>
+              </a:rPr>
+              <a:t>• https(443)로 접속 받기</a:t>
             </a:r>
           </a:p>
           <a:p>
             <a:pPr>
               <a:spcBef>
-                <a:spcPts val="300"/>
-              </a:spcBef>
-            </a:pPr>
-            <a:r>
-              <a:rPr sz="1200" b="0">
-                <a:solidFill>
-                  <a:srgbClr val="0F172A"/>
-                </a:solidFill>
-                <a:latin typeface="맑은 고딕"/>
-                <a:ea typeface="맑은 고딕"/>
-                <a:cs typeface="맑은 고딕"/>
-              </a:rPr>
-              <a:t>modules/alb</a:t>
+                <a:spcPts val="1000"/>
+              </a:spcBef>
+            </a:pPr>
+            <a:r>
+              <a:rPr sz="1400" b="0">
+                <a:solidFill>
+                  <a:srgbClr val="0F172A"/>
+                </a:solidFill>
+                <a:latin typeface="맑은 고딕"/>
+                <a:ea typeface="맑은 고딕"/>
+                <a:cs typeface="맑은 고딕"/>
+              </a:rPr>
+              <a:t>• http로 들어오면 https로 자동 이동</a:t>
             </a:r>
           </a:p>
           <a:p>
             <a:pPr>
               <a:spcBef>
-                <a:spcPts val="300"/>
-              </a:spcBef>
-            </a:pPr>
-            <a:r>
-              <a:rPr sz="1200" b="0">
-                <a:solidFill>
-                  <a:srgbClr val="0F172A"/>
-                </a:solidFill>
-                <a:latin typeface="맑은 고딕"/>
-                <a:ea typeface="맑은 고딕"/>
-                <a:cs typeface="맑은 고딕"/>
-              </a:rPr>
-              <a:t>• 443 HTTPS Listener (TLS 1.3)</a:t>
-            </a:r>
-          </a:p>
-          <a:p>
-            <a:pPr>
-              <a:spcBef>
-                <a:spcPts val="300"/>
-              </a:spcBef>
-            </a:pPr>
-            <a:r>
-              <a:rPr sz="1200" b="0">
-                <a:solidFill>
-                  <a:srgbClr val="0F172A"/>
-                </a:solidFill>
-                <a:latin typeface="맑은 고딕"/>
-                <a:ea typeface="맑은 고딕"/>
-                <a:cs typeface="맑은 고딕"/>
-              </a:rPr>
-              <a:t>• 80 → 443 HTTP 301 redirect</a:t>
-            </a:r>
-          </a:p>
-          <a:p>
-            <a:pPr>
-              <a:spcBef>
-                <a:spcPts val="300"/>
-              </a:spcBef>
-            </a:pPr>
-            <a:r>
-              <a:rPr sz="1200" b="0">
-                <a:solidFill>
-                  <a:srgbClr val="0F172A"/>
-                </a:solidFill>
-                <a:latin typeface="맑은 고딕"/>
-                <a:ea typeface="맑은 고딕"/>
-                <a:cs typeface="맑은 고딕"/>
-              </a:rPr>
-              <a:t>• Target Group → ASG/EC2</a:t>
-            </a:r>
-          </a:p>
-          <a:p>
-            <a:pPr>
-              <a:spcBef>
-                <a:spcPts val="300"/>
-              </a:spcBef>
-            </a:pPr>
-            <a:r>
-              <a:rPr sz="1200" b="0">
-                <a:solidFill>
-                  <a:srgbClr val="0F172A"/>
-                </a:solidFill>
-                <a:latin typeface="맑은 고딕"/>
-                <a:ea typeface="맑은 고딕"/>
-                <a:cs typeface="맑은 고딕"/>
-              </a:rPr>
-              <a:t/>
-            </a:r>
-          </a:p>
-          <a:p>
-            <a:pPr>
-              <a:spcBef>
-                <a:spcPts val="300"/>
-              </a:spcBef>
-            </a:pPr>
-            <a:r>
-              <a:rPr sz="1200" b="0">
-                <a:solidFill>
-                  <a:srgbClr val="0F172A"/>
-                </a:solidFill>
-                <a:latin typeface="맑은 고딕"/>
-                <a:ea typeface="맑은 고딕"/>
-                <a:cs typeface="맑은 고딕"/>
-              </a:rPr>
-              <a:t>앱 연동</a:t>
-            </a:r>
-          </a:p>
-          <a:p>
-            <a:pPr>
-              <a:spcBef>
-                <a:spcPts val="300"/>
-              </a:spcBef>
-            </a:pPr>
-            <a:r>
-              <a:rPr sz="1200" b="0">
-                <a:solidFill>
-                  <a:srgbClr val="0F172A"/>
-                </a:solidFill>
-                <a:latin typeface="맑은 고딕"/>
-                <a:ea typeface="맑은 고딕"/>
-                <a:cs typeface="맑은 고딕"/>
-              </a:rPr>
-              <a:t>• Secrets: USE_HTTPS=True</a:t>
-            </a:r>
-          </a:p>
-          <a:p>
-            <a:pPr>
-              <a:spcBef>
-                <a:spcPts val="300"/>
-              </a:spcBef>
-            </a:pPr>
-            <a:r>
-              <a:rPr sz="1200" b="0">
-                <a:solidFill>
-                  <a:srgbClr val="0F172A"/>
-                </a:solidFill>
-                <a:latin typeface="맑은 고딕"/>
-                <a:ea typeface="맑은 고딕"/>
-                <a:cs typeface="맑은 고딕"/>
-              </a:rPr>
-              <a:t>• CSRF / ALLOWED_HOSTS https 허용</a:t>
+                <a:spcPts val="1000"/>
+              </a:spcBef>
+            </a:pPr>
+            <a:r>
+              <a:rPr sz="1400" b="0">
+                <a:solidFill>
+                  <a:srgbClr val="0F172A"/>
+                </a:solidFill>
+                <a:latin typeface="맑은 고딕"/>
+                <a:ea typeface="맑은 고딕"/>
+                <a:cs typeface="맑은 고딕"/>
+              </a:rPr>
+              <a:t>• 결과: https://aniverse.my + 자물쇠</a:t>
             </a:r>
           </a:p>
         </p:txBody>
@@ -5930,7 +5822,7 @@
           <a:p>
             <a:pPr algn="ctr"/>
             <a:r>
-              <a:rPr sz="1600" b="1">
+              <a:rPr sz="1700" b="1">
                 <a:solidFill>
                   <a:srgbClr val="DC2626"/>
                 </a:solidFill>
@@ -5938,259 +5830,115 @@
                 <a:ea typeface="맑은 고딕"/>
                 <a:cs typeface="맑은 고딕"/>
               </a:rPr>
-              <a:t>WAF — ALB Web ACL</a:t>
+              <a:t>WAF — 앞단 문지기</a:t>
             </a:r>
           </a:p>
           <a:p>
             <a:pPr>
               <a:spcBef>
-                <a:spcPts val="300"/>
-              </a:spcBef>
-            </a:pPr>
-            <a:r>
-              <a:rPr sz="1200" b="0">
-                <a:solidFill>
-                  <a:srgbClr val="0F172A"/>
-                </a:solidFill>
-                <a:latin typeface="맑은 고딕"/>
-                <a:ea typeface="맑은 고딕"/>
-                <a:cs typeface="맑은 고딕"/>
-              </a:rPr>
-              <a:t>modules/waf → aniverse-alb-waf</a:t>
+                <a:spcPts val="800"/>
+              </a:spcBef>
+            </a:pPr>
+            <a:r>
+              <a:rPr sz="1200" b="1">
+                <a:solidFill>
+                  <a:srgbClr val="475569"/>
+                </a:solidFill>
+                <a:latin typeface="맑은 고딕"/>
+                <a:ea typeface="맑은 고딕"/>
+                <a:cs typeface="맑은 고딕"/>
+              </a:rPr>
+              <a:t>쉽게: 서버 들어가기 전에 나쁜 요청을 막는다</a:t>
             </a:r>
           </a:p>
           <a:p>
             <a:pPr>
               <a:spcBef>
-                <a:spcPts val="300"/>
-              </a:spcBef>
-            </a:pPr>
-            <a:r>
-              <a:rPr sz="1200" b="0">
-                <a:solidFill>
-                  <a:srgbClr val="0F172A"/>
-                </a:solidFill>
-                <a:latin typeface="맑은 고딕"/>
-                <a:ea typeface="맑은 고딕"/>
-                <a:cs typeface="맑은 고딕"/>
-              </a:rPr>
-              <a:t>• scope: REGIONAL (ALB 전용)</a:t>
+                <a:spcPts val="1000"/>
+              </a:spcBef>
+            </a:pPr>
+            <a:r>
+              <a:rPr sz="1400" b="0">
+                <a:solidFill>
+                  <a:srgbClr val="0F172A"/>
+                </a:solidFill>
+                <a:latin typeface="맑은 고딕"/>
+                <a:ea typeface="맑은 고딕"/>
+                <a:cs typeface="맑은 고딕"/>
+              </a:rPr>
+              <a:t>• WAF = 웹 방화벽 (ALB 앞)</a:t>
             </a:r>
           </a:p>
           <a:p>
             <a:pPr>
               <a:spcBef>
-                <a:spcPts val="300"/>
-              </a:spcBef>
-            </a:pPr>
-            <a:r>
-              <a:rPr sz="1200" b="0">
-                <a:solidFill>
-                  <a:srgbClr val="0F172A"/>
-                </a:solidFill>
-                <a:latin typeface="맑은 고딕"/>
-                <a:ea typeface="맑은 고딕"/>
-                <a:cs typeface="맑은 고딕"/>
-              </a:rPr>
-              <a:t/>
+                <a:spcPts val="1000"/>
+              </a:spcBef>
+            </a:pPr>
+            <a:r>
+              <a:rPr sz="1400" b="0">
+                <a:solidFill>
+                  <a:srgbClr val="0F172A"/>
+                </a:solidFill>
+                <a:latin typeface="맑은 고딕"/>
+                <a:ea typeface="맑은 고딕"/>
+                <a:cs typeface="맑은 고딕"/>
+              </a:rPr>
+              <a:t>• SQL 삽입·이상한 입력 차단</a:t>
             </a:r>
           </a:p>
           <a:p>
             <a:pPr>
               <a:spcBef>
-                <a:spcPts val="300"/>
-              </a:spcBef>
-            </a:pPr>
-            <a:r>
-              <a:rPr sz="1200" b="0">
-                <a:solidFill>
-                  <a:srgbClr val="0F172A"/>
-                </a:solidFill>
-                <a:latin typeface="맑은 고딕"/>
-                <a:ea typeface="맑은 고딕"/>
-                <a:cs typeface="맑은 고딕"/>
-              </a:rPr>
-              <a:t>관리형 규칙</a:t>
+                <a:spcPts val="1000"/>
+              </a:spcBef>
+            </a:pPr>
+            <a:r>
+              <a:rPr sz="1400" b="0">
+                <a:solidFill>
+                  <a:srgbClr val="0F172A"/>
+                </a:solidFill>
+                <a:latin typeface="맑은 고딕"/>
+                <a:ea typeface="맑은 고딕"/>
+                <a:cs typeface="맑은 고딕"/>
+              </a:rPr>
+              <a:t>• 한 IP가 너무 자주 치면 차단</a:t>
             </a:r>
           </a:p>
           <a:p>
             <a:pPr>
               <a:spcBef>
-                <a:spcPts val="300"/>
-              </a:spcBef>
-            </a:pPr>
-            <a:r>
-              <a:rPr sz="1200" b="0">
-                <a:solidFill>
-                  <a:srgbClr val="0F172A"/>
-                </a:solidFill>
-                <a:latin typeface="맑은 고딕"/>
-                <a:ea typeface="맑은 고딕"/>
-                <a:cs typeface="맑은 고딕"/>
-              </a:rPr>
-              <a:t>• CommonRuleSet (일반 웹 공격)</a:t>
+                <a:spcPts val="1000"/>
+              </a:spcBef>
+            </a:pPr>
+            <a:r>
+              <a:rPr sz="1400" b="0">
+                <a:solidFill>
+                  <a:srgbClr val="0F172A"/>
+                </a:solidFill>
+                <a:latin typeface="맑은 고딕"/>
+                <a:ea typeface="맑은 고딕"/>
+                <a:cs typeface="맑은 고딕"/>
+              </a:rPr>
+              <a:t>• 통과한 요청만 EC2로 전달</a:t>
             </a:r>
           </a:p>
           <a:p>
             <a:pPr>
               <a:spcBef>
-                <a:spcPts val="300"/>
-              </a:spcBef>
-            </a:pPr>
-            <a:r>
-              <a:rPr sz="1200" b="0">
-                <a:solidFill>
-                  <a:srgbClr val="0F172A"/>
-                </a:solidFill>
-                <a:latin typeface="맑은 고딕"/>
-                <a:ea typeface="맑은 고딕"/>
-                <a:cs typeface="맑은 고딕"/>
-              </a:rPr>
-              <a:t>• KnownBadInputs</a:t>
-            </a:r>
-          </a:p>
-          <a:p>
-            <a:pPr>
-              <a:spcBef>
-                <a:spcPts val="300"/>
-              </a:spcBef>
-            </a:pPr>
-            <a:r>
-              <a:rPr sz="1200" b="0">
-                <a:solidFill>
-                  <a:srgbClr val="0F172A"/>
-                </a:solidFill>
-                <a:latin typeface="맑은 고딕"/>
-                <a:ea typeface="맑은 고딕"/>
-                <a:cs typeface="맑은 고딕"/>
-              </a:rPr>
-              <a:t>• SQLi RuleSet</a:t>
-            </a:r>
-          </a:p>
-          <a:p>
-            <a:pPr>
-              <a:spcBef>
-                <a:spcPts val="300"/>
-              </a:spcBef>
-            </a:pPr>
-            <a:r>
-              <a:rPr sz="1200" b="0">
-                <a:solidFill>
-                  <a:srgbClr val="0F172A"/>
-                </a:solidFill>
-                <a:latin typeface="맑은 고딕"/>
-                <a:ea typeface="맑은 고딕"/>
-                <a:cs typeface="맑은 고딕"/>
-              </a:rPr>
-              <a:t/>
-            </a:r>
-          </a:p>
-          <a:p>
-            <a:pPr>
-              <a:spcBef>
-                <a:spcPts val="300"/>
-              </a:spcBef>
-            </a:pPr>
-            <a:r>
-              <a:rPr sz="1200" b="0">
-                <a:solidFill>
-                  <a:srgbClr val="0F172A"/>
-                </a:solidFill>
-                <a:latin typeface="맑은 고딕"/>
-                <a:ea typeface="맑은 고딕"/>
-                <a:cs typeface="맑은 고딕"/>
-              </a:rPr>
-              <a:t>커스텀</a:t>
-            </a:r>
-          </a:p>
-          <a:p>
-            <a:pPr>
-              <a:spcBef>
-                <a:spcPts val="300"/>
-              </a:spcBef>
-            </a:pPr>
-            <a:r>
-              <a:rPr sz="1200" b="0">
-                <a:solidFill>
-                  <a:srgbClr val="0F172A"/>
-                </a:solidFill>
-                <a:latin typeface="맑은 고딕"/>
-                <a:ea typeface="맑은 고딕"/>
-                <a:cs typeface="맑은 고딕"/>
-              </a:rPr>
-              <a:t>• RateLimitPerIP → Block</a:t>
-            </a:r>
-          </a:p>
-          <a:p>
-            <a:pPr>
-              <a:spcBef>
-                <a:spcPts val="300"/>
-              </a:spcBef>
-            </a:pPr>
-            <a:r>
-              <a:rPr sz="1200" b="0">
-                <a:solidFill>
-                  <a:srgbClr val="0F172A"/>
-                </a:solidFill>
-                <a:latin typeface="맑은 고딕"/>
-                <a:ea typeface="맑은 고딕"/>
-                <a:cs typeface="맑은 고딕"/>
-              </a:rPr>
-              <a:t/>
-            </a:r>
-          </a:p>
-          <a:p>
-            <a:pPr>
-              <a:spcBef>
-                <a:spcPts val="300"/>
-              </a:spcBef>
-            </a:pPr>
-            <a:r>
-              <a:rPr sz="1200" b="0">
-                <a:solidFill>
-                  <a:srgbClr val="0F172A"/>
-                </a:solidFill>
-                <a:latin typeface="맑은 고딕"/>
-                <a:ea typeface="맑은 고딕"/>
-                <a:cs typeface="맑은 고딕"/>
-              </a:rPr>
-              <a:t>연결</a:t>
-            </a:r>
-          </a:p>
-          <a:p>
-            <a:pPr>
-              <a:spcBef>
-                <a:spcPts val="300"/>
-              </a:spcBef>
-            </a:pPr>
-            <a:r>
-              <a:rPr sz="1200" b="0">
-                <a:solidFill>
-                  <a:srgbClr val="0F172A"/>
-                </a:solidFill>
-                <a:latin typeface="맑은 고딕"/>
-                <a:ea typeface="맑은 고딕"/>
-                <a:cs typeface="맑은 고딕"/>
-              </a:rPr>
-              <a:t>• web_acl_association → ALB ARN</a:t>
-            </a:r>
-          </a:p>
-          <a:p>
-            <a:pPr>
-              <a:spcBef>
-                <a:spcPts val="300"/>
-              </a:spcBef>
-            </a:pPr>
-            <a:r>
-              <a:rPr sz="1200" b="0">
-                <a:solidFill>
-                  <a:srgbClr val="0F172A"/>
-                </a:solidFill>
-                <a:latin typeface="맑은 고딕"/>
-                <a:ea typeface="맑은 고딕"/>
-                <a:cs typeface="맑은 고딕"/>
-              </a:rPr>
-              <a:t>• CloudWatch metrics / sampled req</a:t>
+                <a:spcPts val="1000"/>
+              </a:spcBef>
+            </a:pPr>
+            <a:r>
+              <a:rPr sz="1400" b="0">
+                <a:solidFill>
+                  <a:srgbClr val="0F172A"/>
+                </a:solidFill>
+                <a:latin typeface="맑은 고딕"/>
+                <a:ea typeface="맑은 고딕"/>
+                <a:cs typeface="맑은 고딕"/>
+              </a:rPr>
+              <a:t>• 결과: 공격성 트래픽을 입구에서 감소</a:t>
             </a:r>
           </a:p>
         </p:txBody>
@@ -8869,7 +8617,7 @@
                 <a:ea typeface="맑은 고딕"/>
                 <a:cs typeface="맑은 고딕"/>
               </a:rPr>
-              <a:t>  Redis / endpoints 용 Security Group</a:t>
+              <a:t>    Redis / endpoints 용 Security Group</a:t>
             </a:r>
           </a:p>
           <a:p>

</xml_diff>

<commit_message>
docs: add one-page AWS vs GitHub stack summary slide
Add a visual summary of AWS services and GitHub features used in the Aniverse migration, plus agenda/notes/VIEW sync.

Co-authored-by: ho0215 <ho0215@users.noreply.github.com>
</commit_message>
<xml_diff>
--- a/docs/presentation/ppt/Aniverse_발표_강사용.pptx
+++ b/docs/presentation/ppt/Aniverse_발표_강사용.pptx
@@ -22,6 +22,7 @@
     <p:sldId id="270" r:id="rId21"/>
     <p:sldId id="271" r:id="rId22"/>
     <p:sldId id="272" r:id="rId23"/>
+    <p:sldId id="273" r:id="rId24"/>
   </p:sldIdLst>
   <p:sldSz cx="12191695" cy="6858000" type="screen4x3"/>
   <p:notesSz cx="6858000" cy="9144000"/>
@@ -3913,7 +3914,7 @@
                 <a:ea typeface="맑은 고딕"/>
                 <a:cs typeface="맑은 고딕"/>
               </a:rPr>
-              <a:t>Aniverse · 온프레미스 3-tier → AWS   |   10/17</a:t>
+              <a:t>Aniverse · 온프레미스 3-tier → AWS   |   10/18</a:t>
             </a:r>
           </a:p>
         </p:txBody>
@@ -4089,7 +4090,7 @@
                 <a:ea typeface="맑은 고딕"/>
                 <a:cs typeface="맑은 고딕"/>
               </a:rPr>
-              <a:t>Aniverse · 온프레미스 3-tier → AWS   |   11/17</a:t>
+              <a:t>Aniverse · 온프레미스 3-tier → AWS   |   11/18</a:t>
             </a:r>
           </a:p>
         </p:txBody>
@@ -4533,7 +4534,7 @@
                 <a:ea typeface="맑은 고딕"/>
                 <a:cs typeface="맑은 고딕"/>
               </a:rPr>
-              <a:t>Aniverse · 온프레미스 3-tier → AWS   |   12/17</a:t>
+              <a:t>Aniverse · 온프레미스 3-tier → AWS   |   12/18</a:t>
             </a:r>
           </a:p>
         </p:txBody>
@@ -4709,7 +4710,7 @@
                 <a:ea typeface="맑은 고딕"/>
                 <a:cs typeface="맑은 고딕"/>
               </a:rPr>
-              <a:t>Aniverse · 온프레미스 3-tier → AWS   |   13/17</a:t>
+              <a:t>Aniverse · 온프레미스 3-tier → AWS   |   13/18</a:t>
             </a:r>
           </a:p>
         </p:txBody>
@@ -5319,7 +5320,7 @@
                 <a:ea typeface="맑은 고딕"/>
                 <a:cs typeface="맑은 고딕"/>
               </a:rPr>
-              <a:t>Aniverse · 온프레미스 3-tier → AWS   |   14/17</a:t>
+              <a:t>Aniverse · 온프레미스 3-tier → AWS   |   14/18</a:t>
             </a:r>
           </a:p>
         </p:txBody>
@@ -5495,7 +5496,7 @@
                 <a:ea typeface="맑은 고딕"/>
                 <a:cs typeface="맑은 고딕"/>
               </a:rPr>
-              <a:t>Aniverse · 온프레미스 3-tier → AWS   |   15/17</a:t>
+              <a:t>Aniverse · 온프레미스 3-tier → AWS   |   15/18</a:t>
             </a:r>
           </a:p>
         </p:txBody>
@@ -5975,7 +5976,7 @@
                 <a:ea typeface="맑은 고딕"/>
                 <a:cs typeface="맑은 고딕"/>
               </a:rPr>
-              <a:t>Aniverse · 온프레미스 3-tier → AWS   |   16/17</a:t>
+              <a:t>Aniverse · 온프레미스 3-tier → AWS   |   16/18</a:t>
             </a:r>
           </a:p>
         </p:txBody>
@@ -6007,6 +6008,182 @@
         <p:spPr>
           <a:xfrm>
             <a:off x="0" y="0"/>
+            <a:ext cx="12191695" cy="777240"/>
+          </a:xfrm>
+          <a:prstGeom prst="rect">
+            <a:avLst/>
+          </a:prstGeom>
+          <a:solidFill>
+            <a:srgbClr val="0F172A"/>
+          </a:solidFill>
+          <a:ln>
+            <a:noFill/>
+          </a:ln>
+        </p:spPr>
+        <p:style>
+          <a:lnRef idx="1">
+            <a:schemeClr val="accent1"/>
+          </a:lnRef>
+          <a:fillRef idx="3">
+            <a:schemeClr val="accent1"/>
+          </a:fillRef>
+          <a:effectRef idx="2">
+            <a:schemeClr val="accent1"/>
+          </a:effectRef>
+          <a:fontRef idx="minor">
+            <a:schemeClr val="lt1"/>
+          </a:fontRef>
+        </p:style>
+        <p:txBody>
+          <a:bodyPr rtlCol="0" anchor="ctr"/>
+          <a:lstStyle/>
+          <a:p>
+            <a:pPr algn="ctr"/>
+          </a:p>
+        </p:txBody>
+      </p:sp>
+      <p:sp>
+        <p:nvSpPr>
+          <p:cNvPr id="3" name="TextBox 2"/>
+          <p:cNvSpPr txBox="1"/>
+          <p:nvPr/>
+        </p:nvSpPr>
+        <p:spPr>
+          <a:xfrm>
+            <a:off x="411480" y="109728"/>
+            <a:ext cx="11338560" cy="594360"/>
+          </a:xfrm>
+          <a:prstGeom prst="rect">
+            <a:avLst/>
+          </a:prstGeom>
+          <a:noFill/>
+        </p:spPr>
+        <p:txBody>
+          <a:bodyPr wrap="square" lIns="109728" rIns="109728" tIns="73152" bIns="73152">
+            <a:spAutoFit/>
+          </a:bodyPr>
+          <a:lstStyle/>
+          <a:p>
+            <a:r>
+              <a:rPr sz="2200" b="1">
+                <a:solidFill>
+                  <a:srgbClr val="FFFFFF"/>
+                </a:solidFill>
+                <a:latin typeface="맑은 고딕"/>
+                <a:ea typeface="맑은 고딕"/>
+                <a:cs typeface="맑은 고딕"/>
+              </a:rPr>
+              <a:t>7. 사용한 AWS · GitHub</a:t>
+            </a:r>
+          </a:p>
+          <a:p>
+            <a:pPr>
+              <a:spcBef>
+                <a:spcPts val="200"/>
+              </a:spcBef>
+            </a:pPr>
+            <a:r>
+              <a:rPr sz="1200" b="0">
+                <a:solidFill>
+                  <a:srgbClr val="93C5FD"/>
+                </a:solidFill>
+                <a:latin typeface="맑은 고딕"/>
+                <a:ea typeface="맑은 고딕"/>
+                <a:cs typeface="맑은 고딕"/>
+              </a:rPr>
+              <a:t>인프라 서비스와 자동화 도구를 한 장으로</a:t>
+            </a:r>
+          </a:p>
+        </p:txBody>
+      </p:sp>
+      <p:pic>
+        <p:nvPicPr>
+          <p:cNvPr id="4" name="Picture 3" descr="07_aws_github_stack.png"/>
+          <p:cNvPicPr>
+            <a:picLocks noChangeAspect="1"/>
+          </p:cNvPicPr>
+          <p:nvPr/>
+        </p:nvPicPr>
+        <p:blipFill>
+          <a:blip r:embed="rId2"/>
+          <a:stretch>
+            <a:fillRect/>
+          </a:stretch>
+        </p:blipFill>
+        <p:spPr>
+          <a:xfrm>
+            <a:off x="1244600" y="914400"/>
+            <a:ext cx="9672320" cy="5440680"/>
+          </a:xfrm>
+          <a:prstGeom prst="rect">
+            <a:avLst/>
+          </a:prstGeom>
+        </p:spPr>
+      </p:pic>
+      <p:sp>
+        <p:nvSpPr>
+          <p:cNvPr id="5" name="TextBox 4"/>
+          <p:cNvSpPr txBox="1"/>
+          <p:nvPr/>
+        </p:nvSpPr>
+        <p:spPr>
+          <a:xfrm>
+            <a:off x="411480" y="6446520"/>
+            <a:ext cx="11338560" cy="274320"/>
+          </a:xfrm>
+          <a:prstGeom prst="rect">
+            <a:avLst/>
+          </a:prstGeom>
+          <a:noFill/>
+        </p:spPr>
+        <p:txBody>
+          <a:bodyPr wrap="none">
+            <a:spAutoFit/>
+          </a:bodyPr>
+          <a:lstStyle/>
+          <a:p>
+            <a:pPr algn="r"/>
+            <a:r>
+              <a:rPr sz="1000" b="0">
+                <a:solidFill>
+                  <a:srgbClr val="475569"/>
+                </a:solidFill>
+                <a:latin typeface="맑은 고딕"/>
+                <a:ea typeface="맑은 고딕"/>
+                <a:cs typeface="맑은 고딕"/>
+              </a:rPr>
+              <a:t>Aniverse · 온프레미스 3-tier → AWS   |   17/18</a:t>
+            </a:r>
+          </a:p>
+        </p:txBody>
+      </p:sp>
+    </p:spTree>
+  </p:cSld>
+  <p:clrMapOvr>
+    <a:masterClrMapping/>
+  </p:clrMapOvr>
+</p:sld>
+</file>
+
+<file path=ppt/slides/slide18.xml><?xml version="1.0" encoding="utf-8"?>
+<p:sld xmlns:a="http://schemas.openxmlformats.org/drawingml/2006/main" xmlns:p="http://schemas.openxmlformats.org/presentationml/2006/main" xmlns:r="http://schemas.openxmlformats.org/officeDocument/2006/relationships">
+  <p:cSld>
+    <p:spTree>
+      <p:nvGrpSpPr>
+        <p:cNvPr id="1" name=""/>
+        <p:cNvGrpSpPr/>
+        <p:nvPr/>
+      </p:nvGrpSpPr>
+      <p:grpSpPr/>
+      <p:sp>
+        <p:nvSpPr>
+          <p:cNvPr id="2" name="Rectangle 1"/>
+          <p:cNvSpPr/>
+          <p:nvPr/>
+        </p:nvSpPr>
+        <p:spPr>
+          <a:xfrm>
+            <a:off x="0" y="0"/>
             <a:ext cx="12191695" cy="6858000"/>
           </a:xfrm>
           <a:prstGeom prst="rect">
@@ -6236,8 +6413,8 @@
         </p:nvSpPr>
         <p:spPr>
           <a:xfrm>
-            <a:off x="640080" y="1051560"/>
-            <a:ext cx="10881360" cy="685800"/>
+            <a:off x="640080" y="1005840"/>
+            <a:ext cx="10881360" cy="621792"/>
           </a:xfrm>
           <a:prstGeom prst="roundRect">
             <a:avLst/>
@@ -6271,7 +6448,7 @@
           <a:p>
             <a:pPr algn="ctr"/>
             <a:r>
-              <a:rPr sz="1800" b="1">
+              <a:rPr sz="1700" b="1">
                 <a:solidFill>
                   <a:srgbClr val="0F172A"/>
                 </a:solidFill>
@@ -6292,8 +6469,8 @@
         </p:nvSpPr>
         <p:spPr>
           <a:xfrm>
-            <a:off x="640080" y="1856232"/>
-            <a:ext cx="10881360" cy="685800"/>
+            <a:off x="640080" y="1719072"/>
+            <a:ext cx="10881360" cy="621792"/>
           </a:xfrm>
           <a:prstGeom prst="roundRect">
             <a:avLst/>
@@ -6327,7 +6504,7 @@
           <a:p>
             <a:pPr algn="ctr"/>
             <a:r>
-              <a:rPr sz="1800" b="1">
+              <a:rPr sz="1700" b="1">
                 <a:solidFill>
                   <a:srgbClr val="0F172A"/>
                 </a:solidFill>
@@ -6348,8 +6525,8 @@
         </p:nvSpPr>
         <p:spPr>
           <a:xfrm>
-            <a:off x="640080" y="2660904"/>
-            <a:ext cx="10881360" cy="685800"/>
+            <a:off x="640080" y="2432304"/>
+            <a:ext cx="10881360" cy="621792"/>
           </a:xfrm>
           <a:prstGeom prst="roundRect">
             <a:avLst/>
@@ -6383,7 +6560,7 @@
           <a:p>
             <a:pPr algn="ctr"/>
             <a:r>
-              <a:rPr sz="1800" b="1">
+              <a:rPr sz="1700" b="1">
                 <a:solidFill>
                   <a:srgbClr val="0F172A"/>
                 </a:solidFill>
@@ -6404,8 +6581,8 @@
         </p:nvSpPr>
         <p:spPr>
           <a:xfrm>
-            <a:off x="640080" y="3465576"/>
-            <a:ext cx="10881360" cy="685800"/>
+            <a:off x="640080" y="3145536"/>
+            <a:ext cx="10881360" cy="621792"/>
           </a:xfrm>
           <a:prstGeom prst="roundRect">
             <a:avLst/>
@@ -6439,7 +6616,7 @@
           <a:p>
             <a:pPr algn="ctr"/>
             <a:r>
-              <a:rPr sz="1800" b="1">
+              <a:rPr sz="1700" b="1">
                 <a:solidFill>
                   <a:srgbClr val="0F172A"/>
                 </a:solidFill>
@@ -6460,8 +6637,8 @@
         </p:nvSpPr>
         <p:spPr>
           <a:xfrm>
-            <a:off x="640080" y="4270248"/>
-            <a:ext cx="10881360" cy="685800"/>
+            <a:off x="640080" y="3858768"/>
+            <a:ext cx="10881360" cy="621792"/>
           </a:xfrm>
           <a:prstGeom prst="roundRect">
             <a:avLst/>
@@ -6495,7 +6672,7 @@
           <a:p>
             <a:pPr algn="ctr"/>
             <a:r>
-              <a:rPr sz="1800" b="1">
+              <a:rPr sz="1700" b="1">
                 <a:solidFill>
                   <a:srgbClr val="0F172A"/>
                 </a:solidFill>
@@ -6516,8 +6693,8 @@
         </p:nvSpPr>
         <p:spPr>
           <a:xfrm>
-            <a:off x="640080" y="5074920"/>
-            <a:ext cx="10881360" cy="685800"/>
+            <a:off x="640080" y="4572000"/>
+            <a:ext cx="10881360" cy="621792"/>
           </a:xfrm>
           <a:prstGeom prst="roundRect">
             <a:avLst/>
@@ -6551,7 +6728,7 @@
           <a:p>
             <a:pPr algn="ctr"/>
             <a:r>
-              <a:rPr sz="1800" b="1">
+              <a:rPr sz="1700" b="1">
                 <a:solidFill>
                   <a:srgbClr val="0F172A"/>
                 </a:solidFill>
@@ -6566,7 +6743,63 @@
       </p:sp>
       <p:sp>
         <p:nvSpPr>
-          <p:cNvPr id="10" name="TextBox 9"/>
+          <p:cNvPr id="10" name="Rounded Rectangle 9"/>
+          <p:cNvSpPr/>
+          <p:nvPr/>
+        </p:nvSpPr>
+        <p:spPr>
+          <a:xfrm>
+            <a:off x="640080" y="5285232"/>
+            <a:ext cx="10881360" cy="621792"/>
+          </a:xfrm>
+          <a:prstGeom prst="roundRect">
+            <a:avLst/>
+          </a:prstGeom>
+          <a:solidFill>
+            <a:srgbClr val="F8FAFC"/>
+          </a:solidFill>
+          <a:ln w="19050">
+            <a:solidFill>
+              <a:srgbClr val="2563EB"/>
+            </a:solidFill>
+          </a:ln>
+        </p:spPr>
+        <p:style>
+          <a:lnRef idx="1">
+            <a:schemeClr val="accent1"/>
+          </a:lnRef>
+          <a:fillRef idx="3">
+            <a:schemeClr val="accent1"/>
+          </a:fillRef>
+          <a:effectRef idx="2">
+            <a:schemeClr val="accent1"/>
+          </a:effectRef>
+          <a:fontRef idx="minor">
+            <a:schemeClr val="lt1"/>
+          </a:fontRef>
+        </p:style>
+        <p:txBody>
+          <a:bodyPr rtlCol="0" anchor="ctr" wrap="square" lIns="109728" rIns="109728" tIns="73152" bIns="73152"/>
+          <a:lstStyle/>
+          <a:p>
+            <a:pPr algn="ctr"/>
+            <a:r>
+              <a:rPr sz="1700" b="1">
+                <a:solidFill>
+                  <a:srgbClr val="0F172A"/>
+                </a:solidFill>
+                <a:latin typeface="맑은 고딕"/>
+                <a:ea typeface="맑은 고딕"/>
+                <a:cs typeface="맑은 고딕"/>
+              </a:rPr>
+              <a:t>07  사용한 AWS · GitHub 한 장 정리</a:t>
+            </a:r>
+          </a:p>
+        </p:txBody>
+      </p:sp>
+      <p:sp>
+        <p:nvSpPr>
+          <p:cNvPr id="11" name="TextBox 10"/>
           <p:cNvSpPr txBox="1"/>
           <p:nvPr/>
         </p:nvSpPr>
@@ -6596,7 +6829,7 @@
                 <a:ea typeface="맑은 고딕"/>
                 <a:cs typeface="맑은 고딕"/>
               </a:rPr>
-              <a:t>Aniverse · 온프레미스 3-tier → AWS   |   2/17</a:t>
+              <a:t>Aniverse · 온프레미스 3-tier → AWS   |   2/18</a:t>
             </a:r>
           </a:p>
         </p:txBody>
@@ -7272,7 +7505,7 @@
                 <a:ea typeface="맑은 고딕"/>
                 <a:cs typeface="맑은 고딕"/>
               </a:rPr>
-              <a:t>Aniverse · 온프레미스 3-tier → AWS   |   3/17</a:t>
+              <a:t>Aniverse · 온프레미스 3-tier → AWS   |   3/18</a:t>
             </a:r>
           </a:p>
         </p:txBody>
@@ -7448,7 +7681,7 @@
                 <a:ea typeface="맑은 고딕"/>
                 <a:cs typeface="맑은 고딕"/>
               </a:rPr>
-              <a:t>Aniverse · 온프레미스 3-tier → AWS   |   4/17</a:t>
+              <a:t>Aniverse · 온프레미스 3-tier → AWS   |   4/18</a:t>
             </a:r>
           </a:p>
         </p:txBody>
@@ -8040,7 +8273,7 @@
                 <a:ea typeface="맑은 고딕"/>
                 <a:cs typeface="맑은 고딕"/>
               </a:rPr>
-              <a:t>Aniverse · 온프레미스 3-tier → AWS   |   5/17</a:t>
+              <a:t>Aniverse · 온프레미스 3-tier → AWS   |   5/18</a:t>
             </a:r>
           </a:p>
         </p:txBody>
@@ -8216,7 +8449,7 @@
                 <a:ea typeface="맑은 고딕"/>
                 <a:cs typeface="맑은 고딕"/>
               </a:rPr>
-              <a:t>Aniverse · 온프레미스 3-tier → AWS   |   6/17</a:t>
+              <a:t>Aniverse · 온프레미스 3-tier → AWS   |   6/18</a:t>
             </a:r>
           </a:p>
         </p:txBody>
@@ -8392,7 +8625,7 @@
                 <a:ea typeface="맑은 고딕"/>
                 <a:cs typeface="맑은 고딕"/>
               </a:rPr>
-              <a:t>Aniverse · 온프레미스 3-tier → AWS   |   7/17</a:t>
+              <a:t>Aniverse · 온프레미스 3-tier → AWS   |   7/18</a:t>
             </a:r>
           </a:p>
         </p:txBody>
@@ -8962,7 +9195,7 @@
                 <a:ea typeface="맑은 고딕"/>
                 <a:cs typeface="맑은 고딕"/>
               </a:rPr>
-              <a:t>Aniverse · 온프레미스 3-tier → AWS   |   8/17</a:t>
+              <a:t>Aniverse · 온프레미스 3-tier → AWS   |   8/18</a:t>
             </a:r>
           </a:p>
         </p:txBody>
@@ -9626,7 +9859,7 @@
                 <a:ea typeface="맑은 고딕"/>
                 <a:cs typeface="맑은 고딕"/>
               </a:rPr>
-              <a:t>Aniverse · 온프레미스 3-tier → AWS   |   9/17</a:t>
+              <a:t>Aniverse · 온프레미스 3-tier → AWS   |   9/18</a:t>
             </a:r>
           </a:p>
         </p:txBody>

</xml_diff>

<commit_message>
docs(presentation): 기술 스택 슬라이드를 Terraform 앞으로 이동
- 끝부분 「AWS·GitHub 한 장 정리」→ 「3. 기술 스택」으로 변경
- 온프렘 어려움(5p) 다음 · Terraform(7p) 직전(6p)에 배치
- 목차·섹션 번호·VIEW·발표 노트·07 이미지 제목 동기화

Co-authored-by: ho0215 <ho0215@users.noreply.github.com>
</commit_message>
<xml_diff>
--- a/docs/presentation/ppt/Aniverse_발표_강사용.pptx
+++ b/docs/presentation/ppt/Aniverse_발표_강사용.pptx
@@ -3330,7 +3330,7 @@
                 <a:ea typeface="맑은 고딕"/>
                 <a:cs typeface="맑은 고딕"/>
               </a:rPr>
-              <a:t>3. S3 · EFS · RDS — 저장 역할 정리</a:t>
+              <a:t>4. 데이터베이스·스토리지 구성</a:t>
             </a:r>
           </a:p>
           <a:p>
@@ -3348,614 +3348,38 @@
                 <a:ea typeface="맑은 고딕"/>
                 <a:cs typeface="맑은 고딕"/>
               </a:rPr>
-              <a:t>RDS=구조화 데이터 · EFS=공유 파일 · S3=객체/배포</a:t>
-            </a:r>
-          </a:p>
-        </p:txBody>
-      </p:sp>
-      <p:sp>
-        <p:nvSpPr>
-          <p:cNvPr id="4" name="Rounded Rectangle 3"/>
-          <p:cNvSpPr/>
+              <a:t>김윤주 Data &amp; Storage — RDS · EFS · S3 (AWS 공식 아이콘)</a:t>
+            </a:r>
+          </a:p>
+        </p:txBody>
+      </p:sp>
+      <p:pic>
+        <p:nvPicPr>
+          <p:cNvPr id="4" name="Picture 3" descr="08_storage_roles.png"/>
+          <p:cNvPicPr>
+            <a:picLocks noChangeAspect="1"/>
+          </p:cNvPicPr>
           <p:nvPr/>
-        </p:nvSpPr>
-        <p:spPr>
-          <a:xfrm>
-            <a:off x="320040" y="1051560"/>
-            <a:ext cx="3657600" cy="5074920"/>
-          </a:xfrm>
-          <a:prstGeom prst="roundRect">
+        </p:nvPicPr>
+        <p:blipFill>
+          <a:blip r:embed="rId2"/>
+          <a:stretch>
+            <a:fillRect/>
+          </a:stretch>
+        </p:blipFill>
+        <p:spPr>
+          <a:xfrm>
+            <a:off x="1203960" y="868680"/>
+            <a:ext cx="9753600" cy="5486400"/>
+          </a:xfrm>
+          <a:prstGeom prst="rect">
             <a:avLst/>
           </a:prstGeom>
-          <a:solidFill>
-            <a:srgbClr val="F8FAFC"/>
-          </a:solidFill>
-          <a:ln w="19050">
-            <a:solidFill>
-              <a:srgbClr val="16A34A"/>
-            </a:solidFill>
-          </a:ln>
-        </p:spPr>
-        <p:style>
-          <a:lnRef idx="1">
-            <a:schemeClr val="accent1"/>
-          </a:lnRef>
-          <a:fillRef idx="3">
-            <a:schemeClr val="accent1"/>
-          </a:fillRef>
-          <a:effectRef idx="2">
-            <a:schemeClr val="accent1"/>
-          </a:effectRef>
-          <a:fontRef idx="minor">
-            <a:schemeClr val="lt1"/>
-          </a:fontRef>
-        </p:style>
-        <p:txBody>
-          <a:bodyPr rtlCol="0" anchor="ctr" wrap="square" lIns="109728" rIns="109728" tIns="73152" bIns="73152"/>
-          <a:lstStyle/>
-          <a:p>
-            <a:pPr algn="ctr"/>
-            <a:r>
-              <a:rPr sz="1600" b="1">
-                <a:solidFill>
-                  <a:srgbClr val="16A34A"/>
-                </a:solidFill>
-                <a:latin typeface="맑은 고딕"/>
-                <a:ea typeface="맑은 고딕"/>
-                <a:cs typeface="맑은 고딕"/>
-              </a:rPr>
-              <a:t>RDS (MariaDB)</a:t>
-            </a:r>
-          </a:p>
-          <a:p>
-            <a:pPr>
-              <a:spcBef>
-                <a:spcPts val="600"/>
-              </a:spcBef>
-            </a:pPr>
-            <a:r>
-              <a:rPr sz="1300" b="0">
-                <a:solidFill>
-                  <a:srgbClr val="0F172A"/>
-                </a:solidFill>
-                <a:latin typeface="맑은 고딕"/>
-                <a:ea typeface="맑은 고딕"/>
-                <a:cs typeface="맑은 고딕"/>
-              </a:rPr>
-              <a:t>• 회원 · 로그인 계정</a:t>
-            </a:r>
-          </a:p>
-          <a:p>
-            <a:pPr>
-              <a:spcBef>
-                <a:spcPts val="600"/>
-              </a:spcBef>
-            </a:pPr>
-            <a:r>
-              <a:rPr sz="1300" b="0">
-                <a:solidFill>
-                  <a:srgbClr val="0F172A"/>
-                </a:solidFill>
-                <a:latin typeface="맑은 고딕"/>
-                <a:ea typeface="맑은 고딕"/>
-                <a:cs typeface="맑은 고딕"/>
-              </a:rPr>
-              <a:t>• 커뮤니티 글 · 댓글</a:t>
-            </a:r>
-          </a:p>
-          <a:p>
-            <a:pPr>
-              <a:spcBef>
-                <a:spcPts val="600"/>
-              </a:spcBef>
-            </a:pPr>
-            <a:r>
-              <a:rPr sz="1300" b="0">
-                <a:solidFill>
-                  <a:srgbClr val="0F172A"/>
-                </a:solidFill>
-                <a:latin typeface="맑은 고딕"/>
-                <a:ea typeface="맑은 고딕"/>
-                <a:cs typeface="맑은 고딕"/>
-              </a:rPr>
-              <a:t>• 거래 · 채팅 메타</a:t>
-            </a:r>
-          </a:p>
-          <a:p>
-            <a:pPr>
-              <a:spcBef>
-                <a:spcPts val="600"/>
-              </a:spcBef>
-            </a:pPr>
-            <a:r>
-              <a:rPr sz="1300" b="0">
-                <a:solidFill>
-                  <a:srgbClr val="0F172A"/>
-                </a:solidFill>
-                <a:latin typeface="맑은 고딕"/>
-                <a:ea typeface="맑은 고딕"/>
-                <a:cs typeface="맑은 고딕"/>
-              </a:rPr>
-              <a:t>• 창작물 제목·본문</a:t>
-            </a:r>
-          </a:p>
-          <a:p>
-            <a:pPr>
-              <a:spcBef>
-                <a:spcPts val="600"/>
-              </a:spcBef>
-            </a:pPr>
-            <a:r>
-              <a:rPr sz="1300" b="0">
-                <a:solidFill>
-                  <a:srgbClr val="0F172A"/>
-                </a:solidFill>
-                <a:latin typeface="맑은 고딕"/>
-                <a:ea typeface="맑은 고딕"/>
-                <a:cs typeface="맑은 고딕"/>
-              </a:rPr>
-              <a:t>• 관계·트랜잭션 필요 값</a:t>
-            </a:r>
-          </a:p>
-          <a:p>
-            <a:pPr>
-              <a:spcBef>
-                <a:spcPts val="600"/>
-              </a:spcBef>
-            </a:pPr>
-            <a:r>
-              <a:rPr sz="1300" b="0">
-                <a:solidFill>
-                  <a:srgbClr val="0F172A"/>
-                </a:solidFill>
-                <a:latin typeface="맑은 고딕"/>
-                <a:ea typeface="맑은 고딕"/>
-                <a:cs typeface="맑은 고딕"/>
-              </a:rPr>
-              <a:t/>
-            </a:r>
-          </a:p>
-          <a:p>
-            <a:pPr>
-              <a:spcBef>
-                <a:spcPts val="600"/>
-              </a:spcBef>
-            </a:pPr>
-            <a:r>
-              <a:rPr sz="1300" b="0">
-                <a:solidFill>
-                  <a:srgbClr val="0F172A"/>
-                </a:solidFill>
-                <a:latin typeface="맑은 고딕"/>
-                <a:ea typeface="맑은 고딕"/>
-                <a:cs typeface="맑은 고딕"/>
-              </a:rPr>
-              <a:t>modules/database</a:t>
-            </a:r>
-          </a:p>
-          <a:p>
-            <a:pPr>
-              <a:spcBef>
-                <a:spcPts val="600"/>
-              </a:spcBef>
-            </a:pPr>
-            <a:r>
-              <a:rPr sz="1300" b="0">
-                <a:solidFill>
-                  <a:srgbClr val="0F172A"/>
-                </a:solidFill>
-                <a:latin typeface="맑은 고딕"/>
-                <a:ea typeface="맑은 고딕"/>
-                <a:cs typeface="맑은 고딕"/>
-              </a:rPr>
-              <a:t>Private subnet · Secrets</a:t>
-            </a:r>
-          </a:p>
-        </p:txBody>
-      </p:sp>
-      <p:sp>
-        <p:nvSpPr>
-          <p:cNvPr id="5" name="Rounded Rectangle 4"/>
-          <p:cNvSpPr/>
-          <p:nvPr/>
-        </p:nvSpPr>
-        <p:spPr>
-          <a:xfrm>
-            <a:off x="4251960" y="1051560"/>
-            <a:ext cx="3657600" cy="5074920"/>
-          </a:xfrm>
-          <a:prstGeom prst="roundRect">
-            <a:avLst/>
-          </a:prstGeom>
-          <a:solidFill>
-            <a:srgbClr val="F8FAFC"/>
-          </a:solidFill>
-          <a:ln w="19050">
-            <a:solidFill>
-              <a:srgbClr val="0D9488"/>
-            </a:solidFill>
-          </a:ln>
-        </p:spPr>
-        <p:style>
-          <a:lnRef idx="1">
-            <a:schemeClr val="accent1"/>
-          </a:lnRef>
-          <a:fillRef idx="3">
-            <a:schemeClr val="accent1"/>
-          </a:fillRef>
-          <a:effectRef idx="2">
-            <a:schemeClr val="accent1"/>
-          </a:effectRef>
-          <a:fontRef idx="minor">
-            <a:schemeClr val="lt1"/>
-          </a:fontRef>
-        </p:style>
-        <p:txBody>
-          <a:bodyPr rtlCol="0" anchor="ctr" wrap="square" lIns="109728" rIns="109728" tIns="73152" bIns="73152"/>
-          <a:lstStyle/>
-          <a:p>
-            <a:pPr algn="ctr"/>
-            <a:r>
-              <a:rPr sz="1600" b="1">
-                <a:solidFill>
-                  <a:srgbClr val="0D9488"/>
-                </a:solidFill>
-                <a:latin typeface="맑은 고딕"/>
-                <a:ea typeface="맑은 고딕"/>
-                <a:cs typeface="맑은 고딕"/>
-              </a:rPr>
-              <a:t>EFS</a:t>
-            </a:r>
-          </a:p>
-          <a:p>
-            <a:pPr>
-              <a:spcBef>
-                <a:spcPts val="600"/>
-              </a:spcBef>
-            </a:pPr>
-            <a:r>
-              <a:rPr sz="1300" b="0">
-                <a:solidFill>
-                  <a:srgbClr val="0F172A"/>
-                </a:solidFill>
-                <a:latin typeface="맑은 고딕"/>
-                <a:ea typeface="맑은 고딕"/>
-                <a:cs typeface="맑은 고딕"/>
-              </a:rPr>
-              <a:t>• EC2 media/ NFS 마운트</a:t>
-            </a:r>
-          </a:p>
-          <a:p>
-            <a:pPr>
-              <a:spcBef>
-                <a:spcPts val="600"/>
-              </a:spcBef>
-            </a:pPr>
-            <a:r>
-              <a:rPr sz="1300" b="0">
-                <a:solidFill>
-                  <a:srgbClr val="0F172A"/>
-                </a:solidFill>
-                <a:latin typeface="맑은 고딕"/>
-                <a:ea typeface="맑은 고딕"/>
-                <a:cs typeface="맑은 고딕"/>
-              </a:rPr>
-              <a:t>• 인스턴스 교체돼도 유지</a:t>
-            </a:r>
-          </a:p>
-          <a:p>
-            <a:pPr>
-              <a:spcBef>
-                <a:spcPts val="600"/>
-              </a:spcBef>
-            </a:pPr>
-            <a:r>
-              <a:rPr sz="1300" b="0">
-                <a:solidFill>
-                  <a:srgbClr val="0F172A"/>
-                </a:solidFill>
-                <a:latin typeface="맑은 고딕"/>
-                <a:ea typeface="맑은 고딕"/>
-                <a:cs typeface="맑은 고딕"/>
-              </a:rPr>
-              <a:t>• 여러 EC2가 같은 media</a:t>
-            </a:r>
-          </a:p>
-          <a:p>
-            <a:pPr>
-              <a:spcBef>
-                <a:spcPts val="600"/>
-              </a:spcBef>
-            </a:pPr>
-            <a:r>
-              <a:rPr sz="1300" b="0">
-                <a:solidFill>
-                  <a:srgbClr val="0F172A"/>
-                </a:solidFill>
-                <a:latin typeface="맑은 고딕"/>
-                <a:ea typeface="맑은 고딕"/>
-                <a:cs typeface="맑은 고딕"/>
-              </a:rPr>
-              <a:t>• 온프렘 NFS 대체</a:t>
-            </a:r>
-          </a:p>
-          <a:p>
-            <a:pPr>
-              <a:spcBef>
-                <a:spcPts val="600"/>
-              </a:spcBef>
-            </a:pPr>
-            <a:r>
-              <a:rPr sz="1300" b="0">
-                <a:solidFill>
-                  <a:srgbClr val="0F172A"/>
-                </a:solidFill>
-                <a:latin typeface="맑은 고딕"/>
-                <a:ea typeface="맑은 고딕"/>
-                <a:cs typeface="맑은 고딕"/>
-              </a:rPr>
-              <a:t>• Nginx /media 서빙</a:t>
-            </a:r>
-          </a:p>
-          <a:p>
-            <a:pPr>
-              <a:spcBef>
-                <a:spcPts val="600"/>
-              </a:spcBef>
-            </a:pPr>
-            <a:r>
-              <a:rPr sz="1300" b="0">
-                <a:solidFill>
-                  <a:srgbClr val="0F172A"/>
-                </a:solidFill>
-                <a:latin typeface="맑은 고딕"/>
-                <a:ea typeface="맑은 고딕"/>
-                <a:cs typeface="맑은 고딕"/>
-              </a:rPr>
-              <a:t/>
-            </a:r>
-          </a:p>
-          <a:p>
-            <a:pPr>
-              <a:spcBef>
-                <a:spcPts val="600"/>
-              </a:spcBef>
-            </a:pPr>
-            <a:r>
-              <a:rPr sz="1300" b="0">
-                <a:solidFill>
-                  <a:srgbClr val="0F172A"/>
-                </a:solidFill>
-                <a:latin typeface="맑은 고딕"/>
-                <a:ea typeface="맑은 고딕"/>
-                <a:cs typeface="맑은 고딕"/>
-              </a:rPr>
-              <a:t>modules/storage</a:t>
-            </a:r>
-          </a:p>
-          <a:p>
-            <a:pPr>
-              <a:spcBef>
-                <a:spcPts val="600"/>
-              </a:spcBef>
-            </a:pPr>
-            <a:r>
-              <a:rPr sz="1300" b="0">
-                <a:solidFill>
-                  <a:srgbClr val="0F172A"/>
-                </a:solidFill>
-                <a:latin typeface="맑은 고딕"/>
-                <a:ea typeface="맑은 고딕"/>
-                <a:cs typeface="맑은 고딕"/>
-              </a:rPr>
-              <a:t>ASG 공유 파일 공간</a:t>
-            </a:r>
-          </a:p>
-        </p:txBody>
-      </p:sp>
-      <p:sp>
-        <p:nvSpPr>
-          <p:cNvPr id="6" name="Rounded Rectangle 5"/>
-          <p:cNvSpPr/>
-          <p:nvPr/>
-        </p:nvSpPr>
-        <p:spPr>
-          <a:xfrm>
-            <a:off x="8183879" y="1051560"/>
-            <a:ext cx="3657600" cy="5074920"/>
-          </a:xfrm>
-          <a:prstGeom prst="roundRect">
-            <a:avLst/>
-          </a:prstGeom>
-          <a:solidFill>
-            <a:srgbClr val="F8FAFC"/>
-          </a:solidFill>
-          <a:ln w="19050">
-            <a:solidFill>
-              <a:srgbClr val="EA580C"/>
-            </a:solidFill>
-          </a:ln>
-        </p:spPr>
-        <p:style>
-          <a:lnRef idx="1">
-            <a:schemeClr val="accent1"/>
-          </a:lnRef>
-          <a:fillRef idx="3">
-            <a:schemeClr val="accent1"/>
-          </a:fillRef>
-          <a:effectRef idx="2">
-            <a:schemeClr val="accent1"/>
-          </a:effectRef>
-          <a:fontRef idx="minor">
-            <a:schemeClr val="lt1"/>
-          </a:fontRef>
-        </p:style>
-        <p:txBody>
-          <a:bodyPr rtlCol="0" anchor="ctr" wrap="square" lIns="109728" rIns="109728" tIns="73152" bIns="73152"/>
-          <a:lstStyle/>
-          <a:p>
-            <a:pPr algn="ctr"/>
-            <a:r>
-              <a:rPr sz="1600" b="1">
-                <a:solidFill>
-                  <a:srgbClr val="EA580C"/>
-                </a:solidFill>
-                <a:latin typeface="맑은 고딕"/>
-                <a:ea typeface="맑은 고딕"/>
-                <a:cs typeface="맑은 고딕"/>
-              </a:rPr>
-              <a:t>S3</a:t>
-            </a:r>
-          </a:p>
-          <a:p>
-            <a:pPr>
-              <a:spcBef>
-                <a:spcPts val="600"/>
-              </a:spcBef>
-            </a:pPr>
-            <a:r>
-              <a:rPr sz="1300" b="0">
-                <a:solidFill>
-                  <a:srgbClr val="0F172A"/>
-                </a:solidFill>
-                <a:latin typeface="맑은 고딕"/>
-                <a:ea typeface="맑은 고딕"/>
-                <a:cs typeface="맑은 고딕"/>
-              </a:rPr>
-              <a:t>• 업로드 이미지 원본</a:t>
-            </a:r>
-          </a:p>
-          <a:p>
-            <a:pPr>
-              <a:spcBef>
-                <a:spcPts val="600"/>
-              </a:spcBef>
-            </a:pPr>
-            <a:r>
-              <a:rPr sz="1300" b="0">
-                <a:solidFill>
-                  <a:srgbClr val="0F172A"/>
-                </a:solidFill>
-                <a:latin typeface="맑은 고딕"/>
-                <a:ea typeface="맑은 고딕"/>
-                <a:cs typeface="맑은 고딕"/>
-              </a:rPr>
-              <a:t>• community / goods / works</a:t>
-            </a:r>
-          </a:p>
-          <a:p>
-            <a:pPr>
-              <a:spcBef>
-                <a:spcPts val="600"/>
-              </a:spcBef>
-            </a:pPr>
-            <a:r>
-              <a:rPr sz="1300" b="0">
-                <a:solidFill>
-                  <a:srgbClr val="0F172A"/>
-                </a:solidFill>
-                <a:latin typeface="맑은 고딕"/>
-                <a:ea typeface="맑은 고딕"/>
-                <a:cs typeface="맑은 고딕"/>
-              </a:rPr>
-              <a:t>• 공개 URL 제공</a:t>
-            </a:r>
-          </a:p>
-          <a:p>
-            <a:pPr>
-              <a:spcBef>
-                <a:spcPts val="600"/>
-              </a:spcBef>
-            </a:pPr>
-            <a:r>
-              <a:rPr sz="1300" b="0">
-                <a:solidFill>
-                  <a:srgbClr val="0F172A"/>
-                </a:solidFill>
-                <a:latin typeface="맑은 고딕"/>
-                <a:ea typeface="맑은 고딕"/>
-                <a:cs typeface="맑은 고딕"/>
-              </a:rPr>
-              <a:t>• 배포 zip 패키지</a:t>
-            </a:r>
-          </a:p>
-          <a:p>
-            <a:pPr>
-              <a:spcBef>
-                <a:spcPts val="600"/>
-              </a:spcBef>
-            </a:pPr>
-            <a:r>
-              <a:rPr sz="1300" b="0">
-                <a:solidFill>
-                  <a:srgbClr val="0F172A"/>
-                </a:solidFill>
-                <a:latin typeface="맑은 고딕"/>
-                <a:ea typeface="맑은 고딕"/>
-                <a:cs typeface="맑은 고딕"/>
-              </a:rPr>
-              <a:t>• tfstate 버킷 (별도)</a:t>
-            </a:r>
-          </a:p>
-          <a:p>
-            <a:pPr>
-              <a:spcBef>
-                <a:spcPts val="600"/>
-              </a:spcBef>
-            </a:pPr>
-            <a:r>
-              <a:rPr sz="1300" b="0">
-                <a:solidFill>
-                  <a:srgbClr val="0F172A"/>
-                </a:solidFill>
-                <a:latin typeface="맑은 고딕"/>
-                <a:ea typeface="맑은 고딕"/>
-                <a:cs typeface="맑은 고딕"/>
-              </a:rPr>
-              <a:t/>
-            </a:r>
-          </a:p>
-          <a:p>
-            <a:pPr>
-              <a:spcBef>
-                <a:spcPts val="600"/>
-              </a:spcBef>
-            </a:pPr>
-            <a:r>
-              <a:rPr sz="1300" b="0">
-                <a:solidFill>
-                  <a:srgbClr val="0F172A"/>
-                </a:solidFill>
-                <a:latin typeface="맑은 고딕"/>
-                <a:ea typeface="맑은 고딕"/>
-                <a:cs typeface="맑은 고딕"/>
-              </a:rPr>
-              <a:t>CORS · Lifecycle</a:t>
-            </a:r>
-          </a:p>
-          <a:p>
-            <a:pPr>
-              <a:spcBef>
-                <a:spcPts val="600"/>
-              </a:spcBef>
-            </a:pPr>
-            <a:r>
-              <a:rPr sz="1300" b="0">
-                <a:solidFill>
-                  <a:srgbClr val="0F172A"/>
-                </a:solidFill>
-                <a:latin typeface="맑은 고딕"/>
-                <a:ea typeface="맑은 고딕"/>
-                <a:cs typeface="맑은 고딕"/>
-              </a:rPr>
-              <a:t>DynamoDB State Lock</a:t>
-            </a:r>
-          </a:p>
-        </p:txBody>
-      </p:sp>
-      <p:sp>
-        <p:nvSpPr>
-          <p:cNvPr id="7" name="TextBox 6"/>
+        </p:spPr>
+      </p:pic>
+      <p:sp>
+        <p:nvSpPr>
+          <p:cNvPr id="5" name="TextBox 4"/>
           <p:cNvSpPr txBox="1"/>
           <p:nvPr/>
         </p:nvSpPr>
@@ -4082,7 +3506,7 @@
                 <a:ea typeface="맑은 고딕"/>
                 <a:cs typeface="맑은 고딕"/>
               </a:rPr>
-              <a:t>4. GitHub Actions (1)</a:t>
+              <a:t>4. S3 · EFS · RDS — 저장 역할 정리</a:t>
             </a:r>
           </a:p>
           <a:p>
@@ -4100,38 +3524,614 @@
                 <a:ea typeface="맑은 고딕"/>
                 <a:cs typeface="맑은 고딕"/>
               </a:rPr>
-              <a:t>GitHub · AWS 공식 아이콘으로 본 CI/CD Pipeline</a:t>
-            </a:r>
-          </a:p>
-        </p:txBody>
-      </p:sp>
-      <p:pic>
-        <p:nvPicPr>
-          <p:cNvPr id="4" name="Picture 3" descr="04_github_actions.png"/>
-          <p:cNvPicPr>
-            <a:picLocks noChangeAspect="1"/>
-          </p:cNvPicPr>
+              <a:t>RDS=구조화 데이터 · EFS=공유 파일 · S3=객체/배포</a:t>
+            </a:r>
+          </a:p>
+        </p:txBody>
+      </p:sp>
+      <p:sp>
+        <p:nvSpPr>
+          <p:cNvPr id="4" name="Rounded Rectangle 3"/>
+          <p:cNvSpPr/>
           <p:nvPr/>
-        </p:nvPicPr>
-        <p:blipFill>
-          <a:blip r:embed="rId2"/>
-          <a:stretch>
-            <a:fillRect/>
-          </a:stretch>
-        </p:blipFill>
-        <p:spPr>
-          <a:xfrm>
-            <a:off x="1965960" y="868680"/>
-            <a:ext cx="8229600" cy="5486400"/>
-          </a:xfrm>
-          <a:prstGeom prst="rect">
+        </p:nvSpPr>
+        <p:spPr>
+          <a:xfrm>
+            <a:off x="320040" y="1051560"/>
+            <a:ext cx="3657600" cy="5074920"/>
+          </a:xfrm>
+          <a:prstGeom prst="roundRect">
             <a:avLst/>
           </a:prstGeom>
-        </p:spPr>
-      </p:pic>
-      <p:sp>
-        <p:nvSpPr>
-          <p:cNvPr id="5" name="TextBox 4"/>
+          <a:solidFill>
+            <a:srgbClr val="F8FAFC"/>
+          </a:solidFill>
+          <a:ln w="19050">
+            <a:solidFill>
+              <a:srgbClr val="16A34A"/>
+            </a:solidFill>
+          </a:ln>
+        </p:spPr>
+        <p:style>
+          <a:lnRef idx="1">
+            <a:schemeClr val="accent1"/>
+          </a:lnRef>
+          <a:fillRef idx="3">
+            <a:schemeClr val="accent1"/>
+          </a:fillRef>
+          <a:effectRef idx="2">
+            <a:schemeClr val="accent1"/>
+          </a:effectRef>
+          <a:fontRef idx="minor">
+            <a:schemeClr val="lt1"/>
+          </a:fontRef>
+        </p:style>
+        <p:txBody>
+          <a:bodyPr rtlCol="0" anchor="ctr" wrap="square" lIns="109728" rIns="109728" tIns="73152" bIns="73152"/>
+          <a:lstStyle/>
+          <a:p>
+            <a:pPr algn="ctr"/>
+            <a:r>
+              <a:rPr sz="1600" b="1">
+                <a:solidFill>
+                  <a:srgbClr val="16A34A"/>
+                </a:solidFill>
+                <a:latin typeface="맑은 고딕"/>
+                <a:ea typeface="맑은 고딕"/>
+                <a:cs typeface="맑은 고딕"/>
+              </a:rPr>
+              <a:t>RDS (MariaDB)</a:t>
+            </a:r>
+          </a:p>
+          <a:p>
+            <a:pPr>
+              <a:spcBef>
+                <a:spcPts val="600"/>
+              </a:spcBef>
+            </a:pPr>
+            <a:r>
+              <a:rPr sz="1300" b="0">
+                <a:solidFill>
+                  <a:srgbClr val="0F172A"/>
+                </a:solidFill>
+                <a:latin typeface="맑은 고딕"/>
+                <a:ea typeface="맑은 고딕"/>
+                <a:cs typeface="맑은 고딕"/>
+              </a:rPr>
+              <a:t>• 회원 · 로그인 계정</a:t>
+            </a:r>
+          </a:p>
+          <a:p>
+            <a:pPr>
+              <a:spcBef>
+                <a:spcPts val="600"/>
+              </a:spcBef>
+            </a:pPr>
+            <a:r>
+              <a:rPr sz="1300" b="0">
+                <a:solidFill>
+                  <a:srgbClr val="0F172A"/>
+                </a:solidFill>
+                <a:latin typeface="맑은 고딕"/>
+                <a:ea typeface="맑은 고딕"/>
+                <a:cs typeface="맑은 고딕"/>
+              </a:rPr>
+              <a:t>• 커뮤니티 글 · 댓글</a:t>
+            </a:r>
+          </a:p>
+          <a:p>
+            <a:pPr>
+              <a:spcBef>
+                <a:spcPts val="600"/>
+              </a:spcBef>
+            </a:pPr>
+            <a:r>
+              <a:rPr sz="1300" b="0">
+                <a:solidFill>
+                  <a:srgbClr val="0F172A"/>
+                </a:solidFill>
+                <a:latin typeface="맑은 고딕"/>
+                <a:ea typeface="맑은 고딕"/>
+                <a:cs typeface="맑은 고딕"/>
+              </a:rPr>
+              <a:t>• 거래 · 채팅 메타</a:t>
+            </a:r>
+          </a:p>
+          <a:p>
+            <a:pPr>
+              <a:spcBef>
+                <a:spcPts val="600"/>
+              </a:spcBef>
+            </a:pPr>
+            <a:r>
+              <a:rPr sz="1300" b="0">
+                <a:solidFill>
+                  <a:srgbClr val="0F172A"/>
+                </a:solidFill>
+                <a:latin typeface="맑은 고딕"/>
+                <a:ea typeface="맑은 고딕"/>
+                <a:cs typeface="맑은 고딕"/>
+              </a:rPr>
+              <a:t>• 창작물 제목·본문</a:t>
+            </a:r>
+          </a:p>
+          <a:p>
+            <a:pPr>
+              <a:spcBef>
+                <a:spcPts val="600"/>
+              </a:spcBef>
+            </a:pPr>
+            <a:r>
+              <a:rPr sz="1300" b="0">
+                <a:solidFill>
+                  <a:srgbClr val="0F172A"/>
+                </a:solidFill>
+                <a:latin typeface="맑은 고딕"/>
+                <a:ea typeface="맑은 고딕"/>
+                <a:cs typeface="맑은 고딕"/>
+              </a:rPr>
+              <a:t>• 관계·트랜잭션 필요 값</a:t>
+            </a:r>
+          </a:p>
+          <a:p>
+            <a:pPr>
+              <a:spcBef>
+                <a:spcPts val="600"/>
+              </a:spcBef>
+            </a:pPr>
+            <a:r>
+              <a:rPr sz="1300" b="0">
+                <a:solidFill>
+                  <a:srgbClr val="0F172A"/>
+                </a:solidFill>
+                <a:latin typeface="맑은 고딕"/>
+                <a:ea typeface="맑은 고딕"/>
+                <a:cs typeface="맑은 고딕"/>
+              </a:rPr>
+              <a:t/>
+            </a:r>
+          </a:p>
+          <a:p>
+            <a:pPr>
+              <a:spcBef>
+                <a:spcPts val="600"/>
+              </a:spcBef>
+            </a:pPr>
+            <a:r>
+              <a:rPr sz="1300" b="0">
+                <a:solidFill>
+                  <a:srgbClr val="0F172A"/>
+                </a:solidFill>
+                <a:latin typeface="맑은 고딕"/>
+                <a:ea typeface="맑은 고딕"/>
+                <a:cs typeface="맑은 고딕"/>
+              </a:rPr>
+              <a:t>modules/database</a:t>
+            </a:r>
+          </a:p>
+          <a:p>
+            <a:pPr>
+              <a:spcBef>
+                <a:spcPts val="600"/>
+              </a:spcBef>
+            </a:pPr>
+            <a:r>
+              <a:rPr sz="1300" b="0">
+                <a:solidFill>
+                  <a:srgbClr val="0F172A"/>
+                </a:solidFill>
+                <a:latin typeface="맑은 고딕"/>
+                <a:ea typeface="맑은 고딕"/>
+                <a:cs typeface="맑은 고딕"/>
+              </a:rPr>
+              <a:t>Private subnet · Secrets</a:t>
+            </a:r>
+          </a:p>
+        </p:txBody>
+      </p:sp>
+      <p:sp>
+        <p:nvSpPr>
+          <p:cNvPr id="5" name="Rounded Rectangle 4"/>
+          <p:cNvSpPr/>
+          <p:nvPr/>
+        </p:nvSpPr>
+        <p:spPr>
+          <a:xfrm>
+            <a:off x="4251960" y="1051560"/>
+            <a:ext cx="3657600" cy="5074920"/>
+          </a:xfrm>
+          <a:prstGeom prst="roundRect">
+            <a:avLst/>
+          </a:prstGeom>
+          <a:solidFill>
+            <a:srgbClr val="F8FAFC"/>
+          </a:solidFill>
+          <a:ln w="19050">
+            <a:solidFill>
+              <a:srgbClr val="0D9488"/>
+            </a:solidFill>
+          </a:ln>
+        </p:spPr>
+        <p:style>
+          <a:lnRef idx="1">
+            <a:schemeClr val="accent1"/>
+          </a:lnRef>
+          <a:fillRef idx="3">
+            <a:schemeClr val="accent1"/>
+          </a:fillRef>
+          <a:effectRef idx="2">
+            <a:schemeClr val="accent1"/>
+          </a:effectRef>
+          <a:fontRef idx="minor">
+            <a:schemeClr val="lt1"/>
+          </a:fontRef>
+        </p:style>
+        <p:txBody>
+          <a:bodyPr rtlCol="0" anchor="ctr" wrap="square" lIns="109728" rIns="109728" tIns="73152" bIns="73152"/>
+          <a:lstStyle/>
+          <a:p>
+            <a:pPr algn="ctr"/>
+            <a:r>
+              <a:rPr sz="1600" b="1">
+                <a:solidFill>
+                  <a:srgbClr val="0D9488"/>
+                </a:solidFill>
+                <a:latin typeface="맑은 고딕"/>
+                <a:ea typeface="맑은 고딕"/>
+                <a:cs typeface="맑은 고딕"/>
+              </a:rPr>
+              <a:t>EFS</a:t>
+            </a:r>
+          </a:p>
+          <a:p>
+            <a:pPr>
+              <a:spcBef>
+                <a:spcPts val="600"/>
+              </a:spcBef>
+            </a:pPr>
+            <a:r>
+              <a:rPr sz="1300" b="0">
+                <a:solidFill>
+                  <a:srgbClr val="0F172A"/>
+                </a:solidFill>
+                <a:latin typeface="맑은 고딕"/>
+                <a:ea typeface="맑은 고딕"/>
+                <a:cs typeface="맑은 고딕"/>
+              </a:rPr>
+              <a:t>• EC2 media/ NFS 마운트</a:t>
+            </a:r>
+          </a:p>
+          <a:p>
+            <a:pPr>
+              <a:spcBef>
+                <a:spcPts val="600"/>
+              </a:spcBef>
+            </a:pPr>
+            <a:r>
+              <a:rPr sz="1300" b="0">
+                <a:solidFill>
+                  <a:srgbClr val="0F172A"/>
+                </a:solidFill>
+                <a:latin typeface="맑은 고딕"/>
+                <a:ea typeface="맑은 고딕"/>
+                <a:cs typeface="맑은 고딕"/>
+              </a:rPr>
+              <a:t>• 인스턴스 교체돼도 유지</a:t>
+            </a:r>
+          </a:p>
+          <a:p>
+            <a:pPr>
+              <a:spcBef>
+                <a:spcPts val="600"/>
+              </a:spcBef>
+            </a:pPr>
+            <a:r>
+              <a:rPr sz="1300" b="0">
+                <a:solidFill>
+                  <a:srgbClr val="0F172A"/>
+                </a:solidFill>
+                <a:latin typeface="맑은 고딕"/>
+                <a:ea typeface="맑은 고딕"/>
+                <a:cs typeface="맑은 고딕"/>
+              </a:rPr>
+              <a:t>• 여러 EC2가 같은 media</a:t>
+            </a:r>
+          </a:p>
+          <a:p>
+            <a:pPr>
+              <a:spcBef>
+                <a:spcPts val="600"/>
+              </a:spcBef>
+            </a:pPr>
+            <a:r>
+              <a:rPr sz="1300" b="0">
+                <a:solidFill>
+                  <a:srgbClr val="0F172A"/>
+                </a:solidFill>
+                <a:latin typeface="맑은 고딕"/>
+                <a:ea typeface="맑은 고딕"/>
+                <a:cs typeface="맑은 고딕"/>
+              </a:rPr>
+              <a:t>• 온프렘 NFS 대체</a:t>
+            </a:r>
+          </a:p>
+          <a:p>
+            <a:pPr>
+              <a:spcBef>
+                <a:spcPts val="600"/>
+              </a:spcBef>
+            </a:pPr>
+            <a:r>
+              <a:rPr sz="1300" b="0">
+                <a:solidFill>
+                  <a:srgbClr val="0F172A"/>
+                </a:solidFill>
+                <a:latin typeface="맑은 고딕"/>
+                <a:ea typeface="맑은 고딕"/>
+                <a:cs typeface="맑은 고딕"/>
+              </a:rPr>
+              <a:t>• Nginx /media 서빙</a:t>
+            </a:r>
+          </a:p>
+          <a:p>
+            <a:pPr>
+              <a:spcBef>
+                <a:spcPts val="600"/>
+              </a:spcBef>
+            </a:pPr>
+            <a:r>
+              <a:rPr sz="1300" b="0">
+                <a:solidFill>
+                  <a:srgbClr val="0F172A"/>
+                </a:solidFill>
+                <a:latin typeface="맑은 고딕"/>
+                <a:ea typeface="맑은 고딕"/>
+                <a:cs typeface="맑은 고딕"/>
+              </a:rPr>
+              <a:t/>
+            </a:r>
+          </a:p>
+          <a:p>
+            <a:pPr>
+              <a:spcBef>
+                <a:spcPts val="600"/>
+              </a:spcBef>
+            </a:pPr>
+            <a:r>
+              <a:rPr sz="1300" b="0">
+                <a:solidFill>
+                  <a:srgbClr val="0F172A"/>
+                </a:solidFill>
+                <a:latin typeface="맑은 고딕"/>
+                <a:ea typeface="맑은 고딕"/>
+                <a:cs typeface="맑은 고딕"/>
+              </a:rPr>
+              <a:t>modules/storage</a:t>
+            </a:r>
+          </a:p>
+          <a:p>
+            <a:pPr>
+              <a:spcBef>
+                <a:spcPts val="600"/>
+              </a:spcBef>
+            </a:pPr>
+            <a:r>
+              <a:rPr sz="1300" b="0">
+                <a:solidFill>
+                  <a:srgbClr val="0F172A"/>
+                </a:solidFill>
+                <a:latin typeface="맑은 고딕"/>
+                <a:ea typeface="맑은 고딕"/>
+                <a:cs typeface="맑은 고딕"/>
+              </a:rPr>
+              <a:t>ASG 공유 파일 공간</a:t>
+            </a:r>
+          </a:p>
+        </p:txBody>
+      </p:sp>
+      <p:sp>
+        <p:nvSpPr>
+          <p:cNvPr id="6" name="Rounded Rectangle 5"/>
+          <p:cNvSpPr/>
+          <p:nvPr/>
+        </p:nvSpPr>
+        <p:spPr>
+          <a:xfrm>
+            <a:off x="8183879" y="1051560"/>
+            <a:ext cx="3657600" cy="5074920"/>
+          </a:xfrm>
+          <a:prstGeom prst="roundRect">
+            <a:avLst/>
+          </a:prstGeom>
+          <a:solidFill>
+            <a:srgbClr val="F8FAFC"/>
+          </a:solidFill>
+          <a:ln w="19050">
+            <a:solidFill>
+              <a:srgbClr val="EA580C"/>
+            </a:solidFill>
+          </a:ln>
+        </p:spPr>
+        <p:style>
+          <a:lnRef idx="1">
+            <a:schemeClr val="accent1"/>
+          </a:lnRef>
+          <a:fillRef idx="3">
+            <a:schemeClr val="accent1"/>
+          </a:fillRef>
+          <a:effectRef idx="2">
+            <a:schemeClr val="accent1"/>
+          </a:effectRef>
+          <a:fontRef idx="minor">
+            <a:schemeClr val="lt1"/>
+          </a:fontRef>
+        </p:style>
+        <p:txBody>
+          <a:bodyPr rtlCol="0" anchor="ctr" wrap="square" lIns="109728" rIns="109728" tIns="73152" bIns="73152"/>
+          <a:lstStyle/>
+          <a:p>
+            <a:pPr algn="ctr"/>
+            <a:r>
+              <a:rPr sz="1600" b="1">
+                <a:solidFill>
+                  <a:srgbClr val="EA580C"/>
+                </a:solidFill>
+                <a:latin typeface="맑은 고딕"/>
+                <a:ea typeface="맑은 고딕"/>
+                <a:cs typeface="맑은 고딕"/>
+              </a:rPr>
+              <a:t>S3</a:t>
+            </a:r>
+          </a:p>
+          <a:p>
+            <a:pPr>
+              <a:spcBef>
+                <a:spcPts val="600"/>
+              </a:spcBef>
+            </a:pPr>
+            <a:r>
+              <a:rPr sz="1300" b="0">
+                <a:solidFill>
+                  <a:srgbClr val="0F172A"/>
+                </a:solidFill>
+                <a:latin typeface="맑은 고딕"/>
+                <a:ea typeface="맑은 고딕"/>
+                <a:cs typeface="맑은 고딕"/>
+              </a:rPr>
+              <a:t>• 업로드 이미지 원본</a:t>
+            </a:r>
+          </a:p>
+          <a:p>
+            <a:pPr>
+              <a:spcBef>
+                <a:spcPts val="600"/>
+              </a:spcBef>
+            </a:pPr>
+            <a:r>
+              <a:rPr sz="1300" b="0">
+                <a:solidFill>
+                  <a:srgbClr val="0F172A"/>
+                </a:solidFill>
+                <a:latin typeface="맑은 고딕"/>
+                <a:ea typeface="맑은 고딕"/>
+                <a:cs typeface="맑은 고딕"/>
+              </a:rPr>
+              <a:t>• community / goods / works</a:t>
+            </a:r>
+          </a:p>
+          <a:p>
+            <a:pPr>
+              <a:spcBef>
+                <a:spcPts val="600"/>
+              </a:spcBef>
+            </a:pPr>
+            <a:r>
+              <a:rPr sz="1300" b="0">
+                <a:solidFill>
+                  <a:srgbClr val="0F172A"/>
+                </a:solidFill>
+                <a:latin typeface="맑은 고딕"/>
+                <a:ea typeface="맑은 고딕"/>
+                <a:cs typeface="맑은 고딕"/>
+              </a:rPr>
+              <a:t>• 공개 URL 제공</a:t>
+            </a:r>
+          </a:p>
+          <a:p>
+            <a:pPr>
+              <a:spcBef>
+                <a:spcPts val="600"/>
+              </a:spcBef>
+            </a:pPr>
+            <a:r>
+              <a:rPr sz="1300" b="0">
+                <a:solidFill>
+                  <a:srgbClr val="0F172A"/>
+                </a:solidFill>
+                <a:latin typeface="맑은 고딕"/>
+                <a:ea typeface="맑은 고딕"/>
+                <a:cs typeface="맑은 고딕"/>
+              </a:rPr>
+              <a:t>• 배포 zip 패키지</a:t>
+            </a:r>
+          </a:p>
+          <a:p>
+            <a:pPr>
+              <a:spcBef>
+                <a:spcPts val="600"/>
+              </a:spcBef>
+            </a:pPr>
+            <a:r>
+              <a:rPr sz="1300" b="0">
+                <a:solidFill>
+                  <a:srgbClr val="0F172A"/>
+                </a:solidFill>
+                <a:latin typeface="맑은 고딕"/>
+                <a:ea typeface="맑은 고딕"/>
+                <a:cs typeface="맑은 고딕"/>
+              </a:rPr>
+              <a:t>• tfstate 버킷 (별도)</a:t>
+            </a:r>
+          </a:p>
+          <a:p>
+            <a:pPr>
+              <a:spcBef>
+                <a:spcPts val="600"/>
+              </a:spcBef>
+            </a:pPr>
+            <a:r>
+              <a:rPr sz="1300" b="0">
+                <a:solidFill>
+                  <a:srgbClr val="0F172A"/>
+                </a:solidFill>
+                <a:latin typeface="맑은 고딕"/>
+                <a:ea typeface="맑은 고딕"/>
+                <a:cs typeface="맑은 고딕"/>
+              </a:rPr>
+              <a:t/>
+            </a:r>
+          </a:p>
+          <a:p>
+            <a:pPr>
+              <a:spcBef>
+                <a:spcPts val="600"/>
+              </a:spcBef>
+            </a:pPr>
+            <a:r>
+              <a:rPr sz="1300" b="0">
+                <a:solidFill>
+                  <a:srgbClr val="0F172A"/>
+                </a:solidFill>
+                <a:latin typeface="맑은 고딕"/>
+                <a:ea typeface="맑은 고딕"/>
+                <a:cs typeface="맑은 고딕"/>
+              </a:rPr>
+              <a:t>CORS · Lifecycle</a:t>
+            </a:r>
+          </a:p>
+          <a:p>
+            <a:pPr>
+              <a:spcBef>
+                <a:spcPts val="600"/>
+              </a:spcBef>
+            </a:pPr>
+            <a:r>
+              <a:rPr sz="1300" b="0">
+                <a:solidFill>
+                  <a:srgbClr val="0F172A"/>
+                </a:solidFill>
+                <a:latin typeface="맑은 고딕"/>
+                <a:ea typeface="맑은 고딕"/>
+                <a:cs typeface="맑은 고딕"/>
+              </a:rPr>
+              <a:t>DynamoDB State Lock</a:t>
+            </a:r>
+          </a:p>
+        </p:txBody>
+      </p:sp>
+      <p:sp>
+        <p:nvSpPr>
+          <p:cNvPr id="7" name="TextBox 6"/>
           <p:cNvSpPr txBox="1"/>
           <p:nvPr/>
         </p:nvSpPr>
@@ -4258,7 +4258,7 @@
                 <a:ea typeface="맑은 고딕"/>
                 <a:cs typeface="맑은 고딕"/>
               </a:rPr>
-              <a:t>4. GitHub Actions (2)</a:t>
+              <a:t>5. GitHub Actions (1)</a:t>
             </a:r>
           </a:p>
           <a:p>
@@ -4276,306 +4276,38 @@
                 <a:ea typeface="맑은 고딕"/>
                 <a:cs typeface="맑은 고딕"/>
               </a:rPr>
-              <a:t>실제로 돌아가는 파이프라인</a:t>
-            </a:r>
-          </a:p>
-        </p:txBody>
-      </p:sp>
-      <p:sp>
-        <p:nvSpPr>
-          <p:cNvPr id="4" name="Rounded Rectangle 3"/>
-          <p:cNvSpPr/>
+              <a:t>GitHub · AWS 공식 아이콘으로 본 CI/CD Pipeline</a:t>
+            </a:r>
+          </a:p>
+        </p:txBody>
+      </p:sp>
+      <p:pic>
+        <p:nvPicPr>
+          <p:cNvPr id="4" name="Picture 3" descr="04_github_actions.png"/>
+          <p:cNvPicPr>
+            <a:picLocks noChangeAspect="1"/>
+          </p:cNvPicPr>
           <p:nvPr/>
-        </p:nvSpPr>
-        <p:spPr>
-          <a:xfrm>
-            <a:off x="320040" y="1051560"/>
-            <a:ext cx="5715000" cy="5074920"/>
-          </a:xfrm>
-          <a:prstGeom prst="roundRect">
+        </p:nvPicPr>
+        <p:blipFill>
+          <a:blip r:embed="rId2"/>
+          <a:stretch>
+            <a:fillRect/>
+          </a:stretch>
+        </p:blipFill>
+        <p:spPr>
+          <a:xfrm>
+            <a:off x="1965960" y="868680"/>
+            <a:ext cx="8229600" cy="5486400"/>
+          </a:xfrm>
+          <a:prstGeom prst="rect">
             <a:avLst/>
           </a:prstGeom>
-          <a:solidFill>
-            <a:srgbClr val="EFF6FF"/>
-          </a:solidFill>
-          <a:ln w="19050">
-            <a:solidFill>
-              <a:srgbClr val="2563EB"/>
-            </a:solidFill>
-          </a:ln>
-        </p:spPr>
-        <p:style>
-          <a:lnRef idx="1">
-            <a:schemeClr val="accent1"/>
-          </a:lnRef>
-          <a:fillRef idx="3">
-            <a:schemeClr val="accent1"/>
-          </a:fillRef>
-          <a:effectRef idx="2">
-            <a:schemeClr val="accent1"/>
-          </a:effectRef>
-          <a:fontRef idx="minor">
-            <a:schemeClr val="lt1"/>
-          </a:fontRef>
-        </p:style>
-        <p:txBody>
-          <a:bodyPr rtlCol="0" anchor="ctr" wrap="square" lIns="109728" rIns="109728" tIns="73152" bIns="73152"/>
-          <a:lstStyle/>
-          <a:p>
-            <a:pPr algn="ctr"/>
-            <a:r>
-              <a:rPr sz="1500" b="1">
-                <a:solidFill>
-                  <a:srgbClr val="2563EB"/>
-                </a:solidFill>
-                <a:latin typeface="맑은 고딕"/>
-                <a:ea typeface="맑은 고딕"/>
-                <a:cs typeface="맑은 고딕"/>
-              </a:rPr>
-              <a:t>anime-project-infra</a:t>
-            </a:r>
-          </a:p>
-          <a:p>
-            <a:pPr>
-              <a:spcBef>
-                <a:spcPts val="800"/>
-              </a:spcBef>
-            </a:pPr>
-            <a:r>
-              <a:rPr sz="1200" b="0">
-                <a:solidFill>
-                  <a:srgbClr val="0F172A"/>
-                </a:solidFill>
-                <a:latin typeface="맑은 고딕"/>
-                <a:ea typeface="맑은 고딕"/>
-                <a:cs typeface="맑은 고딕"/>
-              </a:rPr>
-              <a:t>• trigger: main push / workflow_dispatch</a:t>
-            </a:r>
-          </a:p>
-          <a:p>
-            <a:pPr>
-              <a:spcBef>
-                <a:spcPts val="800"/>
-              </a:spcBef>
-            </a:pPr>
-            <a:r>
-              <a:rPr sz="1200" b="0">
-                <a:solidFill>
-                  <a:srgbClr val="0F172A"/>
-                </a:solidFill>
-                <a:latin typeface="맑은 고딕"/>
-                <a:ea typeface="맑은 고딕"/>
-                <a:cs typeface="맑은 고딕"/>
-              </a:rPr>
-              <a:t>• steps: checkout → setup TF → fmt</a:t>
-            </a:r>
-          </a:p>
-          <a:p>
-            <a:pPr>
-              <a:spcBef>
-                <a:spcPts val="800"/>
-              </a:spcBef>
-            </a:pPr>
-            <a:r>
-              <a:rPr sz="1200" b="0">
-                <a:solidFill>
-                  <a:srgbClr val="0F172A"/>
-                </a:solidFill>
-                <a:latin typeface="맑은 고딕"/>
-                <a:ea typeface="맑은 고딕"/>
-                <a:cs typeface="맑은 고딕"/>
-              </a:rPr>
-              <a:t>•         validate → plan → apply</a:t>
-            </a:r>
-          </a:p>
-          <a:p>
-            <a:pPr>
-              <a:spcBef>
-                <a:spcPts val="800"/>
-              </a:spcBef>
-            </a:pPr>
-            <a:r>
-              <a:rPr sz="1200" b="0">
-                <a:solidFill>
-                  <a:srgbClr val="0F172A"/>
-                </a:solidFill>
-                <a:latin typeface="맑은 고딕"/>
-                <a:ea typeface="맑은 고딕"/>
-                <a:cs typeface="맑은 고딕"/>
-              </a:rPr>
-              <a:t>• 결과: VPC/ALB/ASG/RDS/S3/WAF 갱신</a:t>
-            </a:r>
-          </a:p>
-          <a:p>
-            <a:pPr>
-              <a:spcBef>
-                <a:spcPts val="800"/>
-              </a:spcBef>
-            </a:pPr>
-            <a:r>
-              <a:rPr sz="1200" b="0">
-                <a:solidFill>
-                  <a:srgbClr val="0F172A"/>
-                </a:solidFill>
-                <a:latin typeface="맑은 고딕"/>
-                <a:ea typeface="맑은 고딕"/>
-                <a:cs typeface="맑은 고딕"/>
-              </a:rPr>
-              <a:t>• Secrets: AWS 자격증명, TF_VAR_*</a:t>
-            </a:r>
-          </a:p>
-        </p:txBody>
-      </p:sp>
-      <p:sp>
-        <p:nvSpPr>
-          <p:cNvPr id="5" name="Rounded Rectangle 4"/>
-          <p:cNvSpPr/>
-          <p:nvPr/>
-        </p:nvSpPr>
-        <p:spPr>
-          <a:xfrm>
-            <a:off x="6263640" y="1051560"/>
-            <a:ext cx="5577840" cy="5074920"/>
-          </a:xfrm>
-          <a:prstGeom prst="roundRect">
-            <a:avLst/>
-          </a:prstGeom>
-          <a:solidFill>
-            <a:srgbClr val="FFF7ED"/>
-          </a:solidFill>
-          <a:ln w="19050">
-            <a:solidFill>
-              <a:srgbClr val="EA580C"/>
-            </a:solidFill>
-          </a:ln>
-        </p:spPr>
-        <p:style>
-          <a:lnRef idx="1">
-            <a:schemeClr val="accent1"/>
-          </a:lnRef>
-          <a:fillRef idx="3">
-            <a:schemeClr val="accent1"/>
-          </a:fillRef>
-          <a:effectRef idx="2">
-            <a:schemeClr val="accent1"/>
-          </a:effectRef>
-          <a:fontRef idx="minor">
-            <a:schemeClr val="lt1"/>
-          </a:fontRef>
-        </p:style>
-        <p:txBody>
-          <a:bodyPr rtlCol="0" anchor="ctr" wrap="square" lIns="109728" rIns="109728" tIns="73152" bIns="73152"/>
-          <a:lstStyle/>
-          <a:p>
-            <a:pPr algn="ctr"/>
-            <a:r>
-              <a:rPr sz="1500" b="1">
-                <a:solidFill>
-                  <a:srgbClr val="EA580C"/>
-                </a:solidFill>
-                <a:latin typeface="맑은 고딕"/>
-                <a:ea typeface="맑은 고딕"/>
-                <a:cs typeface="맑은 고딕"/>
-              </a:rPr>
-              <a:t>anime-project</a:t>
-            </a:r>
-          </a:p>
-          <a:p>
-            <a:pPr>
-              <a:spcBef>
-                <a:spcPts val="800"/>
-              </a:spcBef>
-            </a:pPr>
-            <a:r>
-              <a:rPr sz="1200" b="0">
-                <a:solidFill>
-                  <a:srgbClr val="0F172A"/>
-                </a:solidFill>
-                <a:latin typeface="맑은 고딕"/>
-                <a:ea typeface="맑은 고딕"/>
-                <a:cs typeface="맑은 고딕"/>
-              </a:rPr>
-              <a:t>• trigger: main push / workflow_dispatch</a:t>
-            </a:r>
-          </a:p>
-          <a:p>
-            <a:pPr>
-              <a:spcBef>
-                <a:spcPts val="800"/>
-              </a:spcBef>
-            </a:pPr>
-            <a:r>
-              <a:rPr sz="1200" b="0">
-                <a:solidFill>
-                  <a:srgbClr val="0F172A"/>
-                </a:solidFill>
-                <a:latin typeface="맑은 고딕"/>
-                <a:ea typeface="맑은 고딕"/>
-                <a:cs typeface="맑은 고딕"/>
-              </a:rPr>
-              <a:t>• steps: media → S3 sync</a:t>
-            </a:r>
-          </a:p>
-          <a:p>
-            <a:pPr>
-              <a:spcBef>
-                <a:spcPts val="800"/>
-              </a:spcBef>
-            </a:pPr>
-            <a:r>
-              <a:rPr sz="1200" b="0">
-                <a:solidFill>
-                  <a:srgbClr val="0F172A"/>
-                </a:solidFill>
-                <a:latin typeface="맑은 고딕"/>
-                <a:ea typeface="맑은 고딕"/>
-                <a:cs typeface="맑은 고딕"/>
-              </a:rPr>
-              <a:t>•         앱 zip 패키징 → deploy S3</a:t>
-            </a:r>
-          </a:p>
-          <a:p>
-            <a:pPr>
-              <a:spcBef>
-                <a:spcPts val="800"/>
-              </a:spcBef>
-            </a:pPr>
-            <a:r>
-              <a:rPr sz="1200" b="0">
-                <a:solidFill>
-                  <a:srgbClr val="0F172A"/>
-                </a:solidFill>
-                <a:latin typeface="맑은 고딕"/>
-                <a:ea typeface="맑은 고딕"/>
-                <a:cs typeface="맑은 고딕"/>
-              </a:rPr>
-              <a:t>•         CodeDeploy → ASG 배포</a:t>
-            </a:r>
-          </a:p>
-          <a:p>
-            <a:pPr>
-              <a:spcBef>
-                <a:spcPts val="800"/>
-              </a:spcBef>
-            </a:pPr>
-            <a:r>
-              <a:rPr sz="1200" b="0">
-                <a:solidFill>
-                  <a:srgbClr val="0F172A"/>
-                </a:solidFill>
-                <a:latin typeface="맑은 고딕"/>
-                <a:ea typeface="맑은 고딕"/>
-                <a:cs typeface="맑은 고딕"/>
-              </a:rPr>
-              <a:t>• hooks: install → migrate → Daphne 기동</a:t>
-            </a:r>
-          </a:p>
-        </p:txBody>
-      </p:sp>
-      <p:sp>
-        <p:nvSpPr>
-          <p:cNvPr id="6" name="TextBox 5"/>
+        </p:spPr>
+      </p:pic>
+      <p:sp>
+        <p:nvSpPr>
+          <p:cNvPr id="5" name="TextBox 4"/>
           <p:cNvSpPr txBox="1"/>
           <p:nvPr/>
         </p:nvSpPr>
@@ -4702,7 +4434,7 @@
                 <a:ea typeface="맑은 고딕"/>
                 <a:cs typeface="맑은 고딕"/>
               </a:rPr>
-              <a:t>5. CI/CD · HA · 모니터링 · 보안</a:t>
+              <a:t>5. GitHub Actions (2)</a:t>
             </a:r>
           </a:p>
           <a:p>
@@ -4720,38 +4452,306 @@
                 <a:ea typeface="맑은 고딕"/>
                 <a:cs typeface="맑은 고딕"/>
               </a:rPr>
-              <a:t>AWS·GitHub 공식 아이콘으로 한 장 요약</a:t>
-            </a:r>
-          </a:p>
-        </p:txBody>
-      </p:sp>
-      <p:pic>
-        <p:nvPicPr>
-          <p:cNvPr id="4" name="Picture 3" descr="05_ops_security.png"/>
-          <p:cNvPicPr>
-            <a:picLocks noChangeAspect="1"/>
-          </p:cNvPicPr>
+              <a:t>실제로 돌아가는 파이프라인</a:t>
+            </a:r>
+          </a:p>
+        </p:txBody>
+      </p:sp>
+      <p:sp>
+        <p:nvSpPr>
+          <p:cNvPr id="4" name="Rounded Rectangle 3"/>
+          <p:cNvSpPr/>
           <p:nvPr/>
-        </p:nvPicPr>
-        <p:blipFill>
-          <a:blip r:embed="rId2"/>
-          <a:stretch>
-            <a:fillRect/>
-          </a:stretch>
-        </p:blipFill>
-        <p:spPr>
-          <a:xfrm>
-            <a:off x="1203960" y="868680"/>
-            <a:ext cx="9753600" cy="5486400"/>
-          </a:xfrm>
-          <a:prstGeom prst="rect">
+        </p:nvSpPr>
+        <p:spPr>
+          <a:xfrm>
+            <a:off x="320040" y="1051560"/>
+            <a:ext cx="5715000" cy="5074920"/>
+          </a:xfrm>
+          <a:prstGeom prst="roundRect">
             <a:avLst/>
           </a:prstGeom>
-        </p:spPr>
-      </p:pic>
-      <p:sp>
-        <p:nvSpPr>
-          <p:cNvPr id="5" name="TextBox 4"/>
+          <a:solidFill>
+            <a:srgbClr val="EFF6FF"/>
+          </a:solidFill>
+          <a:ln w="19050">
+            <a:solidFill>
+              <a:srgbClr val="2563EB"/>
+            </a:solidFill>
+          </a:ln>
+        </p:spPr>
+        <p:style>
+          <a:lnRef idx="1">
+            <a:schemeClr val="accent1"/>
+          </a:lnRef>
+          <a:fillRef idx="3">
+            <a:schemeClr val="accent1"/>
+          </a:fillRef>
+          <a:effectRef idx="2">
+            <a:schemeClr val="accent1"/>
+          </a:effectRef>
+          <a:fontRef idx="minor">
+            <a:schemeClr val="lt1"/>
+          </a:fontRef>
+        </p:style>
+        <p:txBody>
+          <a:bodyPr rtlCol="0" anchor="ctr" wrap="square" lIns="109728" rIns="109728" tIns="73152" bIns="73152"/>
+          <a:lstStyle/>
+          <a:p>
+            <a:pPr algn="ctr"/>
+            <a:r>
+              <a:rPr sz="1500" b="1">
+                <a:solidFill>
+                  <a:srgbClr val="2563EB"/>
+                </a:solidFill>
+                <a:latin typeface="맑은 고딕"/>
+                <a:ea typeface="맑은 고딕"/>
+                <a:cs typeface="맑은 고딕"/>
+              </a:rPr>
+              <a:t>anime-project-infra</a:t>
+            </a:r>
+          </a:p>
+          <a:p>
+            <a:pPr>
+              <a:spcBef>
+                <a:spcPts val="800"/>
+              </a:spcBef>
+            </a:pPr>
+            <a:r>
+              <a:rPr sz="1200" b="0">
+                <a:solidFill>
+                  <a:srgbClr val="0F172A"/>
+                </a:solidFill>
+                <a:latin typeface="맑은 고딕"/>
+                <a:ea typeface="맑은 고딕"/>
+                <a:cs typeface="맑은 고딕"/>
+              </a:rPr>
+              <a:t>• trigger: main push / workflow_dispatch</a:t>
+            </a:r>
+          </a:p>
+          <a:p>
+            <a:pPr>
+              <a:spcBef>
+                <a:spcPts val="800"/>
+              </a:spcBef>
+            </a:pPr>
+            <a:r>
+              <a:rPr sz="1200" b="0">
+                <a:solidFill>
+                  <a:srgbClr val="0F172A"/>
+                </a:solidFill>
+                <a:latin typeface="맑은 고딕"/>
+                <a:ea typeface="맑은 고딕"/>
+                <a:cs typeface="맑은 고딕"/>
+              </a:rPr>
+              <a:t>• steps: checkout → setup TF → fmt</a:t>
+            </a:r>
+          </a:p>
+          <a:p>
+            <a:pPr>
+              <a:spcBef>
+                <a:spcPts val="800"/>
+              </a:spcBef>
+            </a:pPr>
+            <a:r>
+              <a:rPr sz="1200" b="0">
+                <a:solidFill>
+                  <a:srgbClr val="0F172A"/>
+                </a:solidFill>
+                <a:latin typeface="맑은 고딕"/>
+                <a:ea typeface="맑은 고딕"/>
+                <a:cs typeface="맑은 고딕"/>
+              </a:rPr>
+              <a:t>•         validate → plan → apply</a:t>
+            </a:r>
+          </a:p>
+          <a:p>
+            <a:pPr>
+              <a:spcBef>
+                <a:spcPts val="800"/>
+              </a:spcBef>
+            </a:pPr>
+            <a:r>
+              <a:rPr sz="1200" b="0">
+                <a:solidFill>
+                  <a:srgbClr val="0F172A"/>
+                </a:solidFill>
+                <a:latin typeface="맑은 고딕"/>
+                <a:ea typeface="맑은 고딕"/>
+                <a:cs typeface="맑은 고딕"/>
+              </a:rPr>
+              <a:t>• 결과: VPC/ALB/ASG/RDS/S3/WAF 갱신</a:t>
+            </a:r>
+          </a:p>
+          <a:p>
+            <a:pPr>
+              <a:spcBef>
+                <a:spcPts val="800"/>
+              </a:spcBef>
+            </a:pPr>
+            <a:r>
+              <a:rPr sz="1200" b="0">
+                <a:solidFill>
+                  <a:srgbClr val="0F172A"/>
+                </a:solidFill>
+                <a:latin typeface="맑은 고딕"/>
+                <a:ea typeface="맑은 고딕"/>
+                <a:cs typeface="맑은 고딕"/>
+              </a:rPr>
+              <a:t>• Secrets: AWS 자격증명, TF_VAR_*</a:t>
+            </a:r>
+          </a:p>
+        </p:txBody>
+      </p:sp>
+      <p:sp>
+        <p:nvSpPr>
+          <p:cNvPr id="5" name="Rounded Rectangle 4"/>
+          <p:cNvSpPr/>
+          <p:nvPr/>
+        </p:nvSpPr>
+        <p:spPr>
+          <a:xfrm>
+            <a:off x="6263640" y="1051560"/>
+            <a:ext cx="5577840" cy="5074920"/>
+          </a:xfrm>
+          <a:prstGeom prst="roundRect">
+            <a:avLst/>
+          </a:prstGeom>
+          <a:solidFill>
+            <a:srgbClr val="FFF7ED"/>
+          </a:solidFill>
+          <a:ln w="19050">
+            <a:solidFill>
+              <a:srgbClr val="EA580C"/>
+            </a:solidFill>
+          </a:ln>
+        </p:spPr>
+        <p:style>
+          <a:lnRef idx="1">
+            <a:schemeClr val="accent1"/>
+          </a:lnRef>
+          <a:fillRef idx="3">
+            <a:schemeClr val="accent1"/>
+          </a:fillRef>
+          <a:effectRef idx="2">
+            <a:schemeClr val="accent1"/>
+          </a:effectRef>
+          <a:fontRef idx="minor">
+            <a:schemeClr val="lt1"/>
+          </a:fontRef>
+        </p:style>
+        <p:txBody>
+          <a:bodyPr rtlCol="0" anchor="ctr" wrap="square" lIns="109728" rIns="109728" tIns="73152" bIns="73152"/>
+          <a:lstStyle/>
+          <a:p>
+            <a:pPr algn="ctr"/>
+            <a:r>
+              <a:rPr sz="1500" b="1">
+                <a:solidFill>
+                  <a:srgbClr val="EA580C"/>
+                </a:solidFill>
+                <a:latin typeface="맑은 고딕"/>
+                <a:ea typeface="맑은 고딕"/>
+                <a:cs typeface="맑은 고딕"/>
+              </a:rPr>
+              <a:t>anime-project</a:t>
+            </a:r>
+          </a:p>
+          <a:p>
+            <a:pPr>
+              <a:spcBef>
+                <a:spcPts val="800"/>
+              </a:spcBef>
+            </a:pPr>
+            <a:r>
+              <a:rPr sz="1200" b="0">
+                <a:solidFill>
+                  <a:srgbClr val="0F172A"/>
+                </a:solidFill>
+                <a:latin typeface="맑은 고딕"/>
+                <a:ea typeface="맑은 고딕"/>
+                <a:cs typeface="맑은 고딕"/>
+              </a:rPr>
+              <a:t>• trigger: main push / workflow_dispatch</a:t>
+            </a:r>
+          </a:p>
+          <a:p>
+            <a:pPr>
+              <a:spcBef>
+                <a:spcPts val="800"/>
+              </a:spcBef>
+            </a:pPr>
+            <a:r>
+              <a:rPr sz="1200" b="0">
+                <a:solidFill>
+                  <a:srgbClr val="0F172A"/>
+                </a:solidFill>
+                <a:latin typeface="맑은 고딕"/>
+                <a:ea typeface="맑은 고딕"/>
+                <a:cs typeface="맑은 고딕"/>
+              </a:rPr>
+              <a:t>• steps: media → S3 sync</a:t>
+            </a:r>
+          </a:p>
+          <a:p>
+            <a:pPr>
+              <a:spcBef>
+                <a:spcPts val="800"/>
+              </a:spcBef>
+            </a:pPr>
+            <a:r>
+              <a:rPr sz="1200" b="0">
+                <a:solidFill>
+                  <a:srgbClr val="0F172A"/>
+                </a:solidFill>
+                <a:latin typeface="맑은 고딕"/>
+                <a:ea typeface="맑은 고딕"/>
+                <a:cs typeface="맑은 고딕"/>
+              </a:rPr>
+              <a:t>•         앱 zip 패키징 → deploy S3</a:t>
+            </a:r>
+          </a:p>
+          <a:p>
+            <a:pPr>
+              <a:spcBef>
+                <a:spcPts val="800"/>
+              </a:spcBef>
+            </a:pPr>
+            <a:r>
+              <a:rPr sz="1200" b="0">
+                <a:solidFill>
+                  <a:srgbClr val="0F172A"/>
+                </a:solidFill>
+                <a:latin typeface="맑은 고딕"/>
+                <a:ea typeface="맑은 고딕"/>
+                <a:cs typeface="맑은 고딕"/>
+              </a:rPr>
+              <a:t>•         CodeDeploy → ASG 배포</a:t>
+            </a:r>
+          </a:p>
+          <a:p>
+            <a:pPr>
+              <a:spcBef>
+                <a:spcPts val="800"/>
+              </a:spcBef>
+            </a:pPr>
+            <a:r>
+              <a:rPr sz="1200" b="0">
+                <a:solidFill>
+                  <a:srgbClr val="0F172A"/>
+                </a:solidFill>
+                <a:latin typeface="맑은 고딕"/>
+                <a:ea typeface="맑은 고딕"/>
+                <a:cs typeface="맑은 고딕"/>
+              </a:rPr>
+              <a:t>• hooks: install → migrate → Daphne 기동</a:t>
+            </a:r>
+          </a:p>
+        </p:txBody>
+      </p:sp>
+      <p:sp>
+        <p:nvSpPr>
+          <p:cNvPr id="6" name="TextBox 5"/>
           <p:cNvSpPr txBox="1"/>
           <p:nvPr/>
         </p:nvSpPr>
@@ -4878,7 +4878,7 @@
                 <a:ea typeface="맑은 고딕"/>
                 <a:cs typeface="맑은 고딕"/>
               </a:rPr>
-              <a:t>5. 적용 내용 상세</a:t>
+              <a:t>6. CI/CD · HA · 모니터링 · 보안</a:t>
             </a:r>
           </a:p>
           <a:p>
@@ -4896,472 +4896,38 @@
                 <a:ea typeface="맑은 고딕"/>
                 <a:cs typeface="맑은 고딕"/>
               </a:rPr>
-              <a:t>서비스가 실제로 어떻게 버티는지</a:t>
-            </a:r>
-          </a:p>
-        </p:txBody>
-      </p:sp>
-      <p:sp>
-        <p:nvSpPr>
-          <p:cNvPr id="4" name="Rounded Rectangle 3"/>
-          <p:cNvSpPr/>
+              <a:t>AWS·GitHub 공식 아이콘으로 한 장 요약</a:t>
+            </a:r>
+          </a:p>
+        </p:txBody>
+      </p:sp>
+      <p:pic>
+        <p:nvPicPr>
+          <p:cNvPr id="4" name="Picture 3" descr="05_ops_security.png"/>
+          <p:cNvPicPr>
+            <a:picLocks noChangeAspect="1"/>
+          </p:cNvPicPr>
           <p:nvPr/>
-        </p:nvSpPr>
-        <p:spPr>
-          <a:xfrm>
-            <a:off x="320040" y="1051560"/>
-            <a:ext cx="5669280" cy="2468880"/>
-          </a:xfrm>
-          <a:prstGeom prst="roundRect">
+        </p:nvPicPr>
+        <p:blipFill>
+          <a:blip r:embed="rId2"/>
+          <a:stretch>
+            <a:fillRect/>
+          </a:stretch>
+        </p:blipFill>
+        <p:spPr>
+          <a:xfrm>
+            <a:off x="1203960" y="868680"/>
+            <a:ext cx="9753600" cy="5486400"/>
+          </a:xfrm>
+          <a:prstGeom prst="rect">
             <a:avLst/>
           </a:prstGeom>
-          <a:solidFill>
-            <a:srgbClr val="F8FAFC"/>
-          </a:solidFill>
-          <a:ln w="19050">
-            <a:solidFill>
-              <a:srgbClr val="2563EB"/>
-            </a:solidFill>
-          </a:ln>
-        </p:spPr>
-        <p:style>
-          <a:lnRef idx="1">
-            <a:schemeClr val="accent1"/>
-          </a:lnRef>
-          <a:fillRef idx="3">
-            <a:schemeClr val="accent1"/>
-          </a:fillRef>
-          <a:effectRef idx="2">
-            <a:schemeClr val="accent1"/>
-          </a:effectRef>
-          <a:fontRef idx="minor">
-            <a:schemeClr val="lt1"/>
-          </a:fontRef>
-        </p:style>
-        <p:txBody>
-          <a:bodyPr rtlCol="0" anchor="ctr" wrap="square" lIns="109728" rIns="109728" tIns="73152" bIns="73152"/>
-          <a:lstStyle/>
-          <a:p>
-            <a:pPr algn="ctr"/>
-            <a:r>
-              <a:rPr sz="1600" b="1">
-                <a:solidFill>
-                  <a:srgbClr val="2563EB"/>
-                </a:solidFill>
-                <a:latin typeface="맑은 고딕"/>
-                <a:ea typeface="맑은 고딕"/>
-                <a:cs typeface="맑은 고딕"/>
-              </a:rPr>
-              <a:t>CI/CD</a:t>
-            </a:r>
-          </a:p>
-          <a:p>
-            <a:pPr>
-              <a:spcBef>
-                <a:spcPts val="500"/>
-              </a:spcBef>
-            </a:pPr>
-            <a:r>
-              <a:rPr sz="1200" b="0">
-                <a:solidFill>
-                  <a:srgbClr val="0F172A"/>
-                </a:solidFill>
-                <a:latin typeface="맑은 고딕"/>
-                <a:ea typeface="맑은 고딕"/>
-                <a:cs typeface="맑은 고딕"/>
-              </a:rPr>
-              <a:t>• Actions + CodeDeploy로 배포 경로 고정</a:t>
-            </a:r>
-          </a:p>
-          <a:p>
-            <a:pPr>
-              <a:spcBef>
-                <a:spcPts val="500"/>
-              </a:spcBef>
-            </a:pPr>
-            <a:r>
-              <a:rPr sz="1200" b="0">
-                <a:solidFill>
-                  <a:srgbClr val="0F172A"/>
-                </a:solidFill>
-                <a:latin typeface="맑은 고딕"/>
-                <a:ea typeface="맑은 고딕"/>
-                <a:cs typeface="맑은 고딕"/>
-              </a:rPr>
-              <a:t>• ALB /health/ 로 배포 성공 판정</a:t>
-            </a:r>
-          </a:p>
-          <a:p>
-            <a:pPr>
-              <a:spcBef>
-                <a:spcPts val="500"/>
-              </a:spcBef>
-            </a:pPr>
-            <a:r>
-              <a:rPr sz="1200" b="0">
-                <a:solidFill>
-                  <a:srgbClr val="0F172A"/>
-                </a:solidFill>
-                <a:latin typeface="맑은 고딕"/>
-                <a:ea typeface="맑은 고딕"/>
-                <a:cs typeface="맑은 고딕"/>
-              </a:rPr>
-              <a:t>• 실패 시 Actions·배포 로그로 추적</a:t>
-            </a:r>
-          </a:p>
-        </p:txBody>
-      </p:sp>
-      <p:sp>
-        <p:nvSpPr>
-          <p:cNvPr id="5" name="Rounded Rectangle 4"/>
-          <p:cNvSpPr/>
-          <p:nvPr/>
-        </p:nvSpPr>
-        <p:spPr>
-          <a:xfrm>
-            <a:off x="6217920" y="1051560"/>
-            <a:ext cx="5669280" cy="2468880"/>
-          </a:xfrm>
-          <a:prstGeom prst="roundRect">
-            <a:avLst/>
-          </a:prstGeom>
-          <a:solidFill>
-            <a:srgbClr val="F8FAFC"/>
-          </a:solidFill>
-          <a:ln w="19050">
-            <a:solidFill>
-              <a:srgbClr val="EA580C"/>
-            </a:solidFill>
-          </a:ln>
-        </p:spPr>
-        <p:style>
-          <a:lnRef idx="1">
-            <a:schemeClr val="accent1"/>
-          </a:lnRef>
-          <a:fillRef idx="3">
-            <a:schemeClr val="accent1"/>
-          </a:fillRef>
-          <a:effectRef idx="2">
-            <a:schemeClr val="accent1"/>
-          </a:effectRef>
-          <a:fontRef idx="minor">
-            <a:schemeClr val="lt1"/>
-          </a:fontRef>
-        </p:style>
-        <p:txBody>
-          <a:bodyPr rtlCol="0" anchor="ctr" wrap="square" lIns="109728" rIns="109728" tIns="73152" bIns="73152"/>
-          <a:lstStyle/>
-          <a:p>
-            <a:pPr algn="ctr"/>
-            <a:r>
-              <a:rPr sz="1600" b="1">
-                <a:solidFill>
-                  <a:srgbClr val="EA580C"/>
-                </a:solidFill>
-                <a:latin typeface="맑은 고딕"/>
-                <a:ea typeface="맑은 고딕"/>
-                <a:cs typeface="맑은 고딕"/>
-              </a:rPr>
-              <a:t>고가용성</a:t>
-            </a:r>
-          </a:p>
-          <a:p>
-            <a:pPr>
-              <a:spcBef>
-                <a:spcPts val="500"/>
-              </a:spcBef>
-            </a:pPr>
-            <a:r>
-              <a:rPr sz="1200" b="0">
-                <a:solidFill>
-                  <a:srgbClr val="0F172A"/>
-                </a:solidFill>
-                <a:latin typeface="맑은 고딕"/>
-                <a:ea typeface="맑은 고딕"/>
-                <a:cs typeface="맑은 고딕"/>
-              </a:rPr>
-              <a:t>• ALB로 트래픽 분산</a:t>
-            </a:r>
-          </a:p>
-          <a:p>
-            <a:pPr>
-              <a:spcBef>
-                <a:spcPts val="500"/>
-              </a:spcBef>
-            </a:pPr>
-            <a:r>
-              <a:rPr sz="1200" b="0">
-                <a:solidFill>
-                  <a:srgbClr val="0F172A"/>
-                </a:solidFill>
-                <a:latin typeface="맑은 고딕"/>
-                <a:ea typeface="맑은 고딕"/>
-                <a:cs typeface="맑은 고딕"/>
-              </a:rPr>
-              <a:t>• ASG로 인스턴스 교체·확장</a:t>
-            </a:r>
-          </a:p>
-          <a:p>
-            <a:pPr>
-              <a:spcBef>
-                <a:spcPts val="500"/>
-              </a:spcBef>
-            </a:pPr>
-            <a:r>
-              <a:rPr sz="1200" b="0">
-                <a:solidFill>
-                  <a:srgbClr val="0F172A"/>
-                </a:solidFill>
-                <a:latin typeface="맑은 고딕"/>
-                <a:ea typeface="맑은 고딕"/>
-                <a:cs typeface="맑은 고딕"/>
-              </a:rPr>
-              <a:t>• EFS로 media 파일 유지 (교체 후에도)</a:t>
-            </a:r>
-          </a:p>
-        </p:txBody>
-      </p:sp>
-      <p:sp>
-        <p:nvSpPr>
-          <p:cNvPr id="6" name="Rounded Rectangle 5"/>
-          <p:cNvSpPr/>
-          <p:nvPr/>
-        </p:nvSpPr>
-        <p:spPr>
-          <a:xfrm>
-            <a:off x="320040" y="3657600"/>
-            <a:ext cx="5669280" cy="2468880"/>
-          </a:xfrm>
-          <a:prstGeom prst="roundRect">
-            <a:avLst/>
-          </a:prstGeom>
-          <a:solidFill>
-            <a:srgbClr val="F8FAFC"/>
-          </a:solidFill>
-          <a:ln w="19050">
-            <a:solidFill>
-              <a:srgbClr val="0D9488"/>
-            </a:solidFill>
-          </a:ln>
-        </p:spPr>
-        <p:style>
-          <a:lnRef idx="1">
-            <a:schemeClr val="accent1"/>
-          </a:lnRef>
-          <a:fillRef idx="3">
-            <a:schemeClr val="accent1"/>
-          </a:fillRef>
-          <a:effectRef idx="2">
-            <a:schemeClr val="accent1"/>
-          </a:effectRef>
-          <a:fontRef idx="minor">
-            <a:schemeClr val="lt1"/>
-          </a:fontRef>
-        </p:style>
-        <p:txBody>
-          <a:bodyPr rtlCol="0" anchor="ctr" wrap="square" lIns="109728" rIns="109728" tIns="73152" bIns="73152"/>
-          <a:lstStyle/>
-          <a:p>
-            <a:pPr algn="ctr"/>
-            <a:r>
-              <a:rPr sz="1600" b="1">
-                <a:solidFill>
-                  <a:srgbClr val="0D9488"/>
-                </a:solidFill>
-                <a:latin typeface="맑은 고딕"/>
-                <a:ea typeface="맑은 고딕"/>
-                <a:cs typeface="맑은 고딕"/>
-              </a:rPr>
-              <a:t>모니터링</a:t>
-            </a:r>
-          </a:p>
-          <a:p>
-            <a:pPr>
-              <a:spcBef>
-                <a:spcPts val="500"/>
-              </a:spcBef>
-            </a:pPr>
-            <a:r>
-              <a:rPr sz="1200" b="0">
-                <a:solidFill>
-                  <a:srgbClr val="0F172A"/>
-                </a:solidFill>
-                <a:latin typeface="맑은 고딕"/>
-                <a:ea typeface="맑은 고딕"/>
-                <a:cs typeface="맑은 고딕"/>
-              </a:rPr>
-              <a:t>• CloudWatch 알람</a:t>
-            </a:r>
-          </a:p>
-          <a:p>
-            <a:pPr>
-              <a:spcBef>
-                <a:spcPts val="500"/>
-              </a:spcBef>
-            </a:pPr>
-            <a:r>
-              <a:rPr sz="1200" b="0">
-                <a:solidFill>
-                  <a:srgbClr val="0F172A"/>
-                </a:solidFill>
-                <a:latin typeface="맑은 고딕"/>
-                <a:ea typeface="맑은 고딕"/>
-                <a:cs typeface="맑은 고딕"/>
-              </a:rPr>
-              <a:t>• Target Group health 확인</a:t>
-            </a:r>
-          </a:p>
-          <a:p>
-            <a:pPr>
-              <a:spcBef>
-                <a:spcPts val="500"/>
-              </a:spcBef>
-            </a:pPr>
-            <a:r>
-              <a:rPr sz="1200" b="0">
-                <a:solidFill>
-                  <a:srgbClr val="0F172A"/>
-                </a:solidFill>
-                <a:latin typeface="맑은 고딕"/>
-                <a:ea typeface="맑은 고딕"/>
-                <a:cs typeface="맑은 고딕"/>
-              </a:rPr>
-              <a:t>• SSM으로 서버 점검</a:t>
-            </a:r>
-          </a:p>
-        </p:txBody>
-      </p:sp>
-      <p:sp>
-        <p:nvSpPr>
-          <p:cNvPr id="7" name="Rounded Rectangle 6"/>
-          <p:cNvSpPr/>
-          <p:nvPr/>
-        </p:nvSpPr>
-        <p:spPr>
-          <a:xfrm>
-            <a:off x="6217920" y="3657600"/>
-            <a:ext cx="5669280" cy="2468880"/>
-          </a:xfrm>
-          <a:prstGeom prst="roundRect">
-            <a:avLst/>
-          </a:prstGeom>
-          <a:solidFill>
-            <a:srgbClr val="F8FAFC"/>
-          </a:solidFill>
-          <a:ln w="19050">
-            <a:solidFill>
-              <a:srgbClr val="DC2626"/>
-            </a:solidFill>
-          </a:ln>
-        </p:spPr>
-        <p:style>
-          <a:lnRef idx="1">
-            <a:schemeClr val="accent1"/>
-          </a:lnRef>
-          <a:fillRef idx="3">
-            <a:schemeClr val="accent1"/>
-          </a:fillRef>
-          <a:effectRef idx="2">
-            <a:schemeClr val="accent1"/>
-          </a:effectRef>
-          <a:fontRef idx="minor">
-            <a:schemeClr val="lt1"/>
-          </a:fontRef>
-        </p:style>
-        <p:txBody>
-          <a:bodyPr rtlCol="0" anchor="ctr" wrap="square" lIns="109728" rIns="109728" tIns="73152" bIns="73152"/>
-          <a:lstStyle/>
-          <a:p>
-            <a:pPr algn="ctr"/>
-            <a:r>
-              <a:rPr sz="1600" b="1">
-                <a:solidFill>
-                  <a:srgbClr val="DC2626"/>
-                </a:solidFill>
-                <a:latin typeface="맑은 고딕"/>
-                <a:ea typeface="맑은 고딕"/>
-                <a:cs typeface="맑은 고딕"/>
-              </a:rPr>
-              <a:t>보안</a:t>
-            </a:r>
-          </a:p>
-          <a:p>
-            <a:pPr>
-              <a:spcBef>
-                <a:spcPts val="500"/>
-              </a:spcBef>
-            </a:pPr>
-            <a:r>
-              <a:rPr sz="1200" b="0">
-                <a:solidFill>
-                  <a:srgbClr val="0F172A"/>
-                </a:solidFill>
-                <a:latin typeface="맑은 고딕"/>
-                <a:ea typeface="맑은 고딕"/>
-                <a:cs typeface="맑은 고딕"/>
-              </a:rPr>
-              <a:t>• SG 최소 포트 개방</a:t>
-            </a:r>
-          </a:p>
-          <a:p>
-            <a:pPr>
-              <a:spcBef>
-                <a:spcPts val="500"/>
-              </a:spcBef>
-            </a:pPr>
-            <a:r>
-              <a:rPr sz="1200" b="0">
-                <a:solidFill>
-                  <a:srgbClr val="0F172A"/>
-                </a:solidFill>
-                <a:latin typeface="맑은 고딕"/>
-                <a:ea typeface="맑은 고딕"/>
-                <a:cs typeface="맑은 고딕"/>
-              </a:rPr>
-              <a:t>• DB subnet NACL 설정</a:t>
-            </a:r>
-          </a:p>
-          <a:p>
-            <a:pPr>
-              <a:spcBef>
-                <a:spcPts val="500"/>
-              </a:spcBef>
-            </a:pPr>
-            <a:r>
-              <a:rPr sz="1200" b="0">
-                <a:solidFill>
-                  <a:srgbClr val="0F172A"/>
-                </a:solidFill>
-                <a:latin typeface="맑은 고딕"/>
-                <a:ea typeface="맑은 고딕"/>
-                <a:cs typeface="맑은 고딕"/>
-              </a:rPr>
-              <a:t>• Secrets Manager로 키 주입</a:t>
-            </a:r>
-          </a:p>
-          <a:p>
-            <a:pPr>
-              <a:spcBef>
-                <a:spcPts val="500"/>
-              </a:spcBef>
-            </a:pPr>
-            <a:r>
-              <a:rPr sz="1200" b="0">
-                <a:solidFill>
-                  <a:srgbClr val="0F172A"/>
-                </a:solidFill>
-                <a:latin typeface="맑은 고딕"/>
-                <a:ea typeface="맑은 고딕"/>
-                <a:cs typeface="맑은 고딕"/>
-              </a:rPr>
-              <a:t>• HTTPS(암호화) + WAF(공격 차단)</a:t>
-            </a:r>
-          </a:p>
-        </p:txBody>
-      </p:sp>
-      <p:sp>
-        <p:nvSpPr>
-          <p:cNvPr id="8" name="TextBox 7"/>
+        </p:spPr>
+      </p:pic>
+      <p:sp>
+        <p:nvSpPr>
+          <p:cNvPr id="5" name="TextBox 4"/>
           <p:cNvSpPr txBox="1"/>
           <p:nvPr/>
         </p:nvSpPr>
@@ -5488,7 +5054,7 @@
                 <a:ea typeface="맑은 고딕"/>
                 <a:cs typeface="맑은 고딕"/>
               </a:rPr>
-              <a:t>6. HTTPS · WAF (1)</a:t>
+              <a:t>6. 적용 내용 상세</a:t>
             </a:r>
           </a:p>
           <a:p>
@@ -5506,38 +5072,472 @@
                 <a:ea typeface="맑은 고딕"/>
                 <a:cs typeface="맑은 고딕"/>
               </a:rPr>
-              <a:t>Route 53 · WAF · ACM · ALB · EC2 (AWS 공식 아이콘)</a:t>
-            </a:r>
-          </a:p>
-        </p:txBody>
-      </p:sp>
-      <p:pic>
-        <p:nvPicPr>
-          <p:cNvPr id="4" name="Picture 3" descr="06_https_waf.png"/>
-          <p:cNvPicPr>
-            <a:picLocks noChangeAspect="1"/>
-          </p:cNvPicPr>
+              <a:t>서비스가 실제로 어떻게 버티는지</a:t>
+            </a:r>
+          </a:p>
+        </p:txBody>
+      </p:sp>
+      <p:sp>
+        <p:nvSpPr>
+          <p:cNvPr id="4" name="Rounded Rectangle 3"/>
+          <p:cNvSpPr/>
           <p:nvPr/>
-        </p:nvPicPr>
-        <p:blipFill>
-          <a:blip r:embed="rId2"/>
-          <a:stretch>
-            <a:fillRect/>
-          </a:stretch>
-        </p:blipFill>
-        <p:spPr>
-          <a:xfrm>
-            <a:off x="1203960" y="868680"/>
-            <a:ext cx="9753600" cy="5486400"/>
-          </a:xfrm>
-          <a:prstGeom prst="rect">
+        </p:nvSpPr>
+        <p:spPr>
+          <a:xfrm>
+            <a:off x="320040" y="1051560"/>
+            <a:ext cx="5669280" cy="2468880"/>
+          </a:xfrm>
+          <a:prstGeom prst="roundRect">
             <a:avLst/>
           </a:prstGeom>
-        </p:spPr>
-      </p:pic>
-      <p:sp>
-        <p:nvSpPr>
-          <p:cNvPr id="5" name="TextBox 4"/>
+          <a:solidFill>
+            <a:srgbClr val="F8FAFC"/>
+          </a:solidFill>
+          <a:ln w="19050">
+            <a:solidFill>
+              <a:srgbClr val="2563EB"/>
+            </a:solidFill>
+          </a:ln>
+        </p:spPr>
+        <p:style>
+          <a:lnRef idx="1">
+            <a:schemeClr val="accent1"/>
+          </a:lnRef>
+          <a:fillRef idx="3">
+            <a:schemeClr val="accent1"/>
+          </a:fillRef>
+          <a:effectRef idx="2">
+            <a:schemeClr val="accent1"/>
+          </a:effectRef>
+          <a:fontRef idx="minor">
+            <a:schemeClr val="lt1"/>
+          </a:fontRef>
+        </p:style>
+        <p:txBody>
+          <a:bodyPr rtlCol="0" anchor="ctr" wrap="square" lIns="109728" rIns="109728" tIns="73152" bIns="73152"/>
+          <a:lstStyle/>
+          <a:p>
+            <a:pPr algn="ctr"/>
+            <a:r>
+              <a:rPr sz="1600" b="1">
+                <a:solidFill>
+                  <a:srgbClr val="2563EB"/>
+                </a:solidFill>
+                <a:latin typeface="맑은 고딕"/>
+                <a:ea typeface="맑은 고딕"/>
+                <a:cs typeface="맑은 고딕"/>
+              </a:rPr>
+              <a:t>CI/CD</a:t>
+            </a:r>
+          </a:p>
+          <a:p>
+            <a:pPr>
+              <a:spcBef>
+                <a:spcPts val="500"/>
+              </a:spcBef>
+            </a:pPr>
+            <a:r>
+              <a:rPr sz="1200" b="0">
+                <a:solidFill>
+                  <a:srgbClr val="0F172A"/>
+                </a:solidFill>
+                <a:latin typeface="맑은 고딕"/>
+                <a:ea typeface="맑은 고딕"/>
+                <a:cs typeface="맑은 고딕"/>
+              </a:rPr>
+              <a:t>• Actions + CodeDeploy로 배포 경로 고정</a:t>
+            </a:r>
+          </a:p>
+          <a:p>
+            <a:pPr>
+              <a:spcBef>
+                <a:spcPts val="500"/>
+              </a:spcBef>
+            </a:pPr>
+            <a:r>
+              <a:rPr sz="1200" b="0">
+                <a:solidFill>
+                  <a:srgbClr val="0F172A"/>
+                </a:solidFill>
+                <a:latin typeface="맑은 고딕"/>
+                <a:ea typeface="맑은 고딕"/>
+                <a:cs typeface="맑은 고딕"/>
+              </a:rPr>
+              <a:t>• ALB /health/ 로 배포 성공 판정</a:t>
+            </a:r>
+          </a:p>
+          <a:p>
+            <a:pPr>
+              <a:spcBef>
+                <a:spcPts val="500"/>
+              </a:spcBef>
+            </a:pPr>
+            <a:r>
+              <a:rPr sz="1200" b="0">
+                <a:solidFill>
+                  <a:srgbClr val="0F172A"/>
+                </a:solidFill>
+                <a:latin typeface="맑은 고딕"/>
+                <a:ea typeface="맑은 고딕"/>
+                <a:cs typeface="맑은 고딕"/>
+              </a:rPr>
+              <a:t>• 실패 시 Actions·배포 로그로 추적</a:t>
+            </a:r>
+          </a:p>
+        </p:txBody>
+      </p:sp>
+      <p:sp>
+        <p:nvSpPr>
+          <p:cNvPr id="5" name="Rounded Rectangle 4"/>
+          <p:cNvSpPr/>
+          <p:nvPr/>
+        </p:nvSpPr>
+        <p:spPr>
+          <a:xfrm>
+            <a:off x="6217920" y="1051560"/>
+            <a:ext cx="5669280" cy="2468880"/>
+          </a:xfrm>
+          <a:prstGeom prst="roundRect">
+            <a:avLst/>
+          </a:prstGeom>
+          <a:solidFill>
+            <a:srgbClr val="F8FAFC"/>
+          </a:solidFill>
+          <a:ln w="19050">
+            <a:solidFill>
+              <a:srgbClr val="EA580C"/>
+            </a:solidFill>
+          </a:ln>
+        </p:spPr>
+        <p:style>
+          <a:lnRef idx="1">
+            <a:schemeClr val="accent1"/>
+          </a:lnRef>
+          <a:fillRef idx="3">
+            <a:schemeClr val="accent1"/>
+          </a:fillRef>
+          <a:effectRef idx="2">
+            <a:schemeClr val="accent1"/>
+          </a:effectRef>
+          <a:fontRef idx="minor">
+            <a:schemeClr val="lt1"/>
+          </a:fontRef>
+        </p:style>
+        <p:txBody>
+          <a:bodyPr rtlCol="0" anchor="ctr" wrap="square" lIns="109728" rIns="109728" tIns="73152" bIns="73152"/>
+          <a:lstStyle/>
+          <a:p>
+            <a:pPr algn="ctr"/>
+            <a:r>
+              <a:rPr sz="1600" b="1">
+                <a:solidFill>
+                  <a:srgbClr val="EA580C"/>
+                </a:solidFill>
+                <a:latin typeface="맑은 고딕"/>
+                <a:ea typeface="맑은 고딕"/>
+                <a:cs typeface="맑은 고딕"/>
+              </a:rPr>
+              <a:t>고가용성</a:t>
+            </a:r>
+          </a:p>
+          <a:p>
+            <a:pPr>
+              <a:spcBef>
+                <a:spcPts val="500"/>
+              </a:spcBef>
+            </a:pPr>
+            <a:r>
+              <a:rPr sz="1200" b="0">
+                <a:solidFill>
+                  <a:srgbClr val="0F172A"/>
+                </a:solidFill>
+                <a:latin typeface="맑은 고딕"/>
+                <a:ea typeface="맑은 고딕"/>
+                <a:cs typeface="맑은 고딕"/>
+              </a:rPr>
+              <a:t>• ALB로 트래픽 분산</a:t>
+            </a:r>
+          </a:p>
+          <a:p>
+            <a:pPr>
+              <a:spcBef>
+                <a:spcPts val="500"/>
+              </a:spcBef>
+            </a:pPr>
+            <a:r>
+              <a:rPr sz="1200" b="0">
+                <a:solidFill>
+                  <a:srgbClr val="0F172A"/>
+                </a:solidFill>
+                <a:latin typeface="맑은 고딕"/>
+                <a:ea typeface="맑은 고딕"/>
+                <a:cs typeface="맑은 고딕"/>
+              </a:rPr>
+              <a:t>• ASG로 인스턴스 교체·확장</a:t>
+            </a:r>
+          </a:p>
+          <a:p>
+            <a:pPr>
+              <a:spcBef>
+                <a:spcPts val="500"/>
+              </a:spcBef>
+            </a:pPr>
+            <a:r>
+              <a:rPr sz="1200" b="0">
+                <a:solidFill>
+                  <a:srgbClr val="0F172A"/>
+                </a:solidFill>
+                <a:latin typeface="맑은 고딕"/>
+                <a:ea typeface="맑은 고딕"/>
+                <a:cs typeface="맑은 고딕"/>
+              </a:rPr>
+              <a:t>• EFS로 media 파일 유지 (교체 후에도)</a:t>
+            </a:r>
+          </a:p>
+        </p:txBody>
+      </p:sp>
+      <p:sp>
+        <p:nvSpPr>
+          <p:cNvPr id="6" name="Rounded Rectangle 5"/>
+          <p:cNvSpPr/>
+          <p:nvPr/>
+        </p:nvSpPr>
+        <p:spPr>
+          <a:xfrm>
+            <a:off x="320040" y="3657600"/>
+            <a:ext cx="5669280" cy="2468880"/>
+          </a:xfrm>
+          <a:prstGeom prst="roundRect">
+            <a:avLst/>
+          </a:prstGeom>
+          <a:solidFill>
+            <a:srgbClr val="F8FAFC"/>
+          </a:solidFill>
+          <a:ln w="19050">
+            <a:solidFill>
+              <a:srgbClr val="0D9488"/>
+            </a:solidFill>
+          </a:ln>
+        </p:spPr>
+        <p:style>
+          <a:lnRef idx="1">
+            <a:schemeClr val="accent1"/>
+          </a:lnRef>
+          <a:fillRef idx="3">
+            <a:schemeClr val="accent1"/>
+          </a:fillRef>
+          <a:effectRef idx="2">
+            <a:schemeClr val="accent1"/>
+          </a:effectRef>
+          <a:fontRef idx="minor">
+            <a:schemeClr val="lt1"/>
+          </a:fontRef>
+        </p:style>
+        <p:txBody>
+          <a:bodyPr rtlCol="0" anchor="ctr" wrap="square" lIns="109728" rIns="109728" tIns="73152" bIns="73152"/>
+          <a:lstStyle/>
+          <a:p>
+            <a:pPr algn="ctr"/>
+            <a:r>
+              <a:rPr sz="1600" b="1">
+                <a:solidFill>
+                  <a:srgbClr val="0D9488"/>
+                </a:solidFill>
+                <a:latin typeface="맑은 고딕"/>
+                <a:ea typeface="맑은 고딕"/>
+                <a:cs typeface="맑은 고딕"/>
+              </a:rPr>
+              <a:t>모니터링</a:t>
+            </a:r>
+          </a:p>
+          <a:p>
+            <a:pPr>
+              <a:spcBef>
+                <a:spcPts val="500"/>
+              </a:spcBef>
+            </a:pPr>
+            <a:r>
+              <a:rPr sz="1200" b="0">
+                <a:solidFill>
+                  <a:srgbClr val="0F172A"/>
+                </a:solidFill>
+                <a:latin typeface="맑은 고딕"/>
+                <a:ea typeface="맑은 고딕"/>
+                <a:cs typeface="맑은 고딕"/>
+              </a:rPr>
+              <a:t>• CloudWatch 알람</a:t>
+            </a:r>
+          </a:p>
+          <a:p>
+            <a:pPr>
+              <a:spcBef>
+                <a:spcPts val="500"/>
+              </a:spcBef>
+            </a:pPr>
+            <a:r>
+              <a:rPr sz="1200" b="0">
+                <a:solidFill>
+                  <a:srgbClr val="0F172A"/>
+                </a:solidFill>
+                <a:latin typeface="맑은 고딕"/>
+                <a:ea typeface="맑은 고딕"/>
+                <a:cs typeface="맑은 고딕"/>
+              </a:rPr>
+              <a:t>• Target Group health 확인</a:t>
+            </a:r>
+          </a:p>
+          <a:p>
+            <a:pPr>
+              <a:spcBef>
+                <a:spcPts val="500"/>
+              </a:spcBef>
+            </a:pPr>
+            <a:r>
+              <a:rPr sz="1200" b="0">
+                <a:solidFill>
+                  <a:srgbClr val="0F172A"/>
+                </a:solidFill>
+                <a:latin typeface="맑은 고딕"/>
+                <a:ea typeface="맑은 고딕"/>
+                <a:cs typeface="맑은 고딕"/>
+              </a:rPr>
+              <a:t>• SSM으로 서버 점검</a:t>
+            </a:r>
+          </a:p>
+        </p:txBody>
+      </p:sp>
+      <p:sp>
+        <p:nvSpPr>
+          <p:cNvPr id="7" name="Rounded Rectangle 6"/>
+          <p:cNvSpPr/>
+          <p:nvPr/>
+        </p:nvSpPr>
+        <p:spPr>
+          <a:xfrm>
+            <a:off x="6217920" y="3657600"/>
+            <a:ext cx="5669280" cy="2468880"/>
+          </a:xfrm>
+          <a:prstGeom prst="roundRect">
+            <a:avLst/>
+          </a:prstGeom>
+          <a:solidFill>
+            <a:srgbClr val="F8FAFC"/>
+          </a:solidFill>
+          <a:ln w="19050">
+            <a:solidFill>
+              <a:srgbClr val="DC2626"/>
+            </a:solidFill>
+          </a:ln>
+        </p:spPr>
+        <p:style>
+          <a:lnRef idx="1">
+            <a:schemeClr val="accent1"/>
+          </a:lnRef>
+          <a:fillRef idx="3">
+            <a:schemeClr val="accent1"/>
+          </a:fillRef>
+          <a:effectRef idx="2">
+            <a:schemeClr val="accent1"/>
+          </a:effectRef>
+          <a:fontRef idx="minor">
+            <a:schemeClr val="lt1"/>
+          </a:fontRef>
+        </p:style>
+        <p:txBody>
+          <a:bodyPr rtlCol="0" anchor="ctr" wrap="square" lIns="109728" rIns="109728" tIns="73152" bIns="73152"/>
+          <a:lstStyle/>
+          <a:p>
+            <a:pPr algn="ctr"/>
+            <a:r>
+              <a:rPr sz="1600" b="1">
+                <a:solidFill>
+                  <a:srgbClr val="DC2626"/>
+                </a:solidFill>
+                <a:latin typeface="맑은 고딕"/>
+                <a:ea typeface="맑은 고딕"/>
+                <a:cs typeface="맑은 고딕"/>
+              </a:rPr>
+              <a:t>보안</a:t>
+            </a:r>
+          </a:p>
+          <a:p>
+            <a:pPr>
+              <a:spcBef>
+                <a:spcPts val="500"/>
+              </a:spcBef>
+            </a:pPr>
+            <a:r>
+              <a:rPr sz="1200" b="0">
+                <a:solidFill>
+                  <a:srgbClr val="0F172A"/>
+                </a:solidFill>
+                <a:latin typeface="맑은 고딕"/>
+                <a:ea typeface="맑은 고딕"/>
+                <a:cs typeface="맑은 고딕"/>
+              </a:rPr>
+              <a:t>• SG 최소 포트 개방</a:t>
+            </a:r>
+          </a:p>
+          <a:p>
+            <a:pPr>
+              <a:spcBef>
+                <a:spcPts val="500"/>
+              </a:spcBef>
+            </a:pPr>
+            <a:r>
+              <a:rPr sz="1200" b="0">
+                <a:solidFill>
+                  <a:srgbClr val="0F172A"/>
+                </a:solidFill>
+                <a:latin typeface="맑은 고딕"/>
+                <a:ea typeface="맑은 고딕"/>
+                <a:cs typeface="맑은 고딕"/>
+              </a:rPr>
+              <a:t>• DB subnet NACL 설정</a:t>
+            </a:r>
+          </a:p>
+          <a:p>
+            <a:pPr>
+              <a:spcBef>
+                <a:spcPts val="500"/>
+              </a:spcBef>
+            </a:pPr>
+            <a:r>
+              <a:rPr sz="1200" b="0">
+                <a:solidFill>
+                  <a:srgbClr val="0F172A"/>
+                </a:solidFill>
+                <a:latin typeface="맑은 고딕"/>
+                <a:ea typeface="맑은 고딕"/>
+                <a:cs typeface="맑은 고딕"/>
+              </a:rPr>
+              <a:t>• Secrets Manager로 키 주입</a:t>
+            </a:r>
+          </a:p>
+          <a:p>
+            <a:pPr>
+              <a:spcBef>
+                <a:spcPts val="500"/>
+              </a:spcBef>
+            </a:pPr>
+            <a:r>
+              <a:rPr sz="1200" b="0">
+                <a:solidFill>
+                  <a:srgbClr val="0F172A"/>
+                </a:solidFill>
+                <a:latin typeface="맑은 고딕"/>
+                <a:ea typeface="맑은 고딕"/>
+                <a:cs typeface="맑은 고딕"/>
+              </a:rPr>
+              <a:t>• HTTPS(암호화) + WAF(공격 차단)</a:t>
+            </a:r>
+          </a:p>
+        </p:txBody>
+      </p:sp>
+      <p:sp>
+        <p:nvSpPr>
+          <p:cNvPr id="8" name="TextBox 7"/>
           <p:cNvSpPr txBox="1"/>
           <p:nvPr/>
         </p:nvSpPr>
@@ -5664,7 +5664,7 @@
                 <a:ea typeface="맑은 고딕"/>
                 <a:cs typeface="맑은 고딕"/>
               </a:rPr>
-              <a:t>6. HTTPS · WAF (2)</a:t>
+              <a:t>7. HTTPS · WAF (1)</a:t>
             </a:r>
           </a:p>
           <a:p>
@@ -5682,342 +5682,38 @@
                 <a:ea typeface="맑은 고딕"/>
                 <a:cs typeface="맑은 고딕"/>
               </a:rPr>
-              <a:t>용어 말고 ‘무엇을 했는지’만</a:t>
-            </a:r>
-          </a:p>
-        </p:txBody>
-      </p:sp>
-      <p:sp>
-        <p:nvSpPr>
-          <p:cNvPr id="4" name="Rounded Rectangle 3"/>
-          <p:cNvSpPr/>
+              <a:t>Route 53 · WAF · ACM · ALB · EC2 (AWS 공식 아이콘)</a:t>
+            </a:r>
+          </a:p>
+        </p:txBody>
+      </p:sp>
+      <p:pic>
+        <p:nvPicPr>
+          <p:cNvPr id="4" name="Picture 3" descr="06_https_waf.png"/>
+          <p:cNvPicPr>
+            <a:picLocks noChangeAspect="1"/>
+          </p:cNvPicPr>
           <p:nvPr/>
-        </p:nvSpPr>
-        <p:spPr>
-          <a:xfrm>
-            <a:off x="320040" y="1051560"/>
-            <a:ext cx="5669280" cy="5074920"/>
-          </a:xfrm>
-          <a:prstGeom prst="roundRect">
+        </p:nvPicPr>
+        <p:blipFill>
+          <a:blip r:embed="rId2"/>
+          <a:stretch>
+            <a:fillRect/>
+          </a:stretch>
+        </p:blipFill>
+        <p:spPr>
+          <a:xfrm>
+            <a:off x="1203960" y="868680"/>
+            <a:ext cx="9753600" cy="5486400"/>
+          </a:xfrm>
+          <a:prstGeom prst="rect">
             <a:avLst/>
           </a:prstGeom>
-          <a:solidFill>
-            <a:srgbClr val="EFF6FF"/>
-          </a:solidFill>
-          <a:ln w="19050">
-            <a:solidFill>
-              <a:srgbClr val="0D9488"/>
-            </a:solidFill>
-          </a:ln>
-        </p:spPr>
-        <p:style>
-          <a:lnRef idx="1">
-            <a:schemeClr val="accent1"/>
-          </a:lnRef>
-          <a:fillRef idx="3">
-            <a:schemeClr val="accent1"/>
-          </a:fillRef>
-          <a:effectRef idx="2">
-            <a:schemeClr val="accent1"/>
-          </a:effectRef>
-          <a:fontRef idx="minor">
-            <a:schemeClr val="lt1"/>
-          </a:fontRef>
-        </p:style>
-        <p:txBody>
-          <a:bodyPr rtlCol="0" anchor="ctr" wrap="square" lIns="109728" rIns="109728" tIns="73152" bIns="73152"/>
-          <a:lstStyle/>
-          <a:p>
-            <a:pPr algn="ctr"/>
-            <a:r>
-              <a:rPr sz="1700" b="1">
-                <a:solidFill>
-                  <a:srgbClr val="0D9488"/>
-                </a:solidFill>
-                <a:latin typeface="맑은 고딕"/>
-                <a:ea typeface="맑은 고딕"/>
-                <a:cs typeface="맑은 고딕"/>
-              </a:rPr>
-              <a:t>HTTPS — 통신 암호화</a:t>
-            </a:r>
-          </a:p>
-          <a:p>
-            <a:pPr>
-              <a:spcBef>
-                <a:spcPts val="800"/>
-              </a:spcBef>
-            </a:pPr>
-            <a:r>
-              <a:rPr sz="1200" b="1">
-                <a:solidFill>
-                  <a:srgbClr val="475569"/>
-                </a:solidFill>
-                <a:latin typeface="맑은 고딕"/>
-                <a:ea typeface="맑은 고딕"/>
-                <a:cs typeface="맑은 고딕"/>
-              </a:rPr>
-              <a:t>쉽게: 사이트와 사용자 사이 내용을 남이 못 보게 잠근다</a:t>
-            </a:r>
-          </a:p>
-          <a:p>
-            <a:pPr>
-              <a:spcBef>
-                <a:spcPts val="1000"/>
-              </a:spcBef>
-            </a:pPr>
-            <a:r>
-              <a:rPr sz="1400" b="0">
-                <a:solidFill>
-                  <a:srgbClr val="0F172A"/>
-                </a:solidFill>
-                <a:latin typeface="맑은 고딕"/>
-                <a:ea typeface="맑은 고딕"/>
-                <a:cs typeface="맑은 고딕"/>
-              </a:rPr>
-              <a:t>• ACM = 인증서(자물쇠) 발급 서비스</a:t>
-            </a:r>
-          </a:p>
-          <a:p>
-            <a:pPr>
-              <a:spcBef>
-                <a:spcPts val="1000"/>
-              </a:spcBef>
-            </a:pPr>
-            <a:r>
-              <a:rPr sz="1400" b="0">
-                <a:solidFill>
-                  <a:srgbClr val="0F172A"/>
-                </a:solidFill>
-                <a:latin typeface="맑은 고딕"/>
-                <a:ea typeface="맑은 고딕"/>
-                <a:cs typeface="맑은 고딕"/>
-              </a:rPr>
-              <a:t>• aniverse.my 용 인증서를 ALB에 붙임</a:t>
-            </a:r>
-          </a:p>
-          <a:p>
-            <a:pPr>
-              <a:spcBef>
-                <a:spcPts val="1000"/>
-              </a:spcBef>
-            </a:pPr>
-            <a:r>
-              <a:rPr sz="1400" b="0">
-                <a:solidFill>
-                  <a:srgbClr val="0F172A"/>
-                </a:solidFill>
-                <a:latin typeface="맑은 고딕"/>
-                <a:ea typeface="맑은 고딕"/>
-                <a:cs typeface="맑은 고딕"/>
-              </a:rPr>
-              <a:t>• https(443)로 접속 받기</a:t>
-            </a:r>
-          </a:p>
-          <a:p>
-            <a:pPr>
-              <a:spcBef>
-                <a:spcPts val="1000"/>
-              </a:spcBef>
-            </a:pPr>
-            <a:r>
-              <a:rPr sz="1400" b="0">
-                <a:solidFill>
-                  <a:srgbClr val="0F172A"/>
-                </a:solidFill>
-                <a:latin typeface="맑은 고딕"/>
-                <a:ea typeface="맑은 고딕"/>
-                <a:cs typeface="맑은 고딕"/>
-              </a:rPr>
-              <a:t>• http로 들어오면 https로 자동 이동</a:t>
-            </a:r>
-          </a:p>
-          <a:p>
-            <a:pPr>
-              <a:spcBef>
-                <a:spcPts val="1000"/>
-              </a:spcBef>
-            </a:pPr>
-            <a:r>
-              <a:rPr sz="1400" b="0">
-                <a:solidFill>
-                  <a:srgbClr val="0F172A"/>
-                </a:solidFill>
-                <a:latin typeface="맑은 고딕"/>
-                <a:ea typeface="맑은 고딕"/>
-                <a:cs typeface="맑은 고딕"/>
-              </a:rPr>
-              <a:t>• 결과: https://aniverse.my + 자물쇠</a:t>
-            </a:r>
-          </a:p>
-        </p:txBody>
-      </p:sp>
-      <p:sp>
-        <p:nvSpPr>
-          <p:cNvPr id="5" name="Rounded Rectangle 4"/>
-          <p:cNvSpPr/>
-          <p:nvPr/>
-        </p:nvSpPr>
-        <p:spPr>
-          <a:xfrm>
-            <a:off x="6217920" y="1051560"/>
-            <a:ext cx="5623560" cy="5074920"/>
-          </a:xfrm>
-          <a:prstGeom prst="roundRect">
-            <a:avLst/>
-          </a:prstGeom>
-          <a:solidFill>
-            <a:srgbClr val="FEF2F2"/>
-          </a:solidFill>
-          <a:ln w="19050">
-            <a:solidFill>
-              <a:srgbClr val="DC2626"/>
-            </a:solidFill>
-          </a:ln>
-        </p:spPr>
-        <p:style>
-          <a:lnRef idx="1">
-            <a:schemeClr val="accent1"/>
-          </a:lnRef>
-          <a:fillRef idx="3">
-            <a:schemeClr val="accent1"/>
-          </a:fillRef>
-          <a:effectRef idx="2">
-            <a:schemeClr val="accent1"/>
-          </a:effectRef>
-          <a:fontRef idx="minor">
-            <a:schemeClr val="lt1"/>
-          </a:fontRef>
-        </p:style>
-        <p:txBody>
-          <a:bodyPr rtlCol="0" anchor="ctr" wrap="square" lIns="109728" rIns="109728" tIns="73152" bIns="73152"/>
-          <a:lstStyle/>
-          <a:p>
-            <a:pPr algn="ctr"/>
-            <a:r>
-              <a:rPr sz="1700" b="1">
-                <a:solidFill>
-                  <a:srgbClr val="DC2626"/>
-                </a:solidFill>
-                <a:latin typeface="맑은 고딕"/>
-                <a:ea typeface="맑은 고딕"/>
-                <a:cs typeface="맑은 고딕"/>
-              </a:rPr>
-              <a:t>WAF — 앞단 문지기</a:t>
-            </a:r>
-          </a:p>
-          <a:p>
-            <a:pPr>
-              <a:spcBef>
-                <a:spcPts val="800"/>
-              </a:spcBef>
-            </a:pPr>
-            <a:r>
-              <a:rPr sz="1200" b="1">
-                <a:solidFill>
-                  <a:srgbClr val="475569"/>
-                </a:solidFill>
-                <a:latin typeface="맑은 고딕"/>
-                <a:ea typeface="맑은 고딕"/>
-                <a:cs typeface="맑은 고딕"/>
-              </a:rPr>
-              <a:t>쉽게: 서버 들어가기 전에 나쁜 요청을 막는다</a:t>
-            </a:r>
-          </a:p>
-          <a:p>
-            <a:pPr>
-              <a:spcBef>
-                <a:spcPts val="1000"/>
-              </a:spcBef>
-            </a:pPr>
-            <a:r>
-              <a:rPr sz="1400" b="0">
-                <a:solidFill>
-                  <a:srgbClr val="0F172A"/>
-                </a:solidFill>
-                <a:latin typeface="맑은 고딕"/>
-                <a:ea typeface="맑은 고딕"/>
-                <a:cs typeface="맑은 고딕"/>
-              </a:rPr>
-              <a:t>• WAF = 웹 방화벽 (ALB 앞)</a:t>
-            </a:r>
-          </a:p>
-          <a:p>
-            <a:pPr>
-              <a:spcBef>
-                <a:spcPts val="1000"/>
-              </a:spcBef>
-            </a:pPr>
-            <a:r>
-              <a:rPr sz="1400" b="0">
-                <a:solidFill>
-                  <a:srgbClr val="0F172A"/>
-                </a:solidFill>
-                <a:latin typeface="맑은 고딕"/>
-                <a:ea typeface="맑은 고딕"/>
-                <a:cs typeface="맑은 고딕"/>
-              </a:rPr>
-              <a:t>• SQL 삽입·이상한 입력 차단</a:t>
-            </a:r>
-          </a:p>
-          <a:p>
-            <a:pPr>
-              <a:spcBef>
-                <a:spcPts val="1000"/>
-              </a:spcBef>
-            </a:pPr>
-            <a:r>
-              <a:rPr sz="1400" b="0">
-                <a:solidFill>
-                  <a:srgbClr val="0F172A"/>
-                </a:solidFill>
-                <a:latin typeface="맑은 고딕"/>
-                <a:ea typeface="맑은 고딕"/>
-                <a:cs typeface="맑은 고딕"/>
-              </a:rPr>
-              <a:t>• 한 IP가 너무 자주 치면 차단</a:t>
-            </a:r>
-          </a:p>
-          <a:p>
-            <a:pPr>
-              <a:spcBef>
-                <a:spcPts val="1000"/>
-              </a:spcBef>
-            </a:pPr>
-            <a:r>
-              <a:rPr sz="1400" b="0">
-                <a:solidFill>
-                  <a:srgbClr val="0F172A"/>
-                </a:solidFill>
-                <a:latin typeface="맑은 고딕"/>
-                <a:ea typeface="맑은 고딕"/>
-                <a:cs typeface="맑은 고딕"/>
-              </a:rPr>
-              <a:t>• 통과한 요청만 EC2로 전달</a:t>
-            </a:r>
-          </a:p>
-          <a:p>
-            <a:pPr>
-              <a:spcBef>
-                <a:spcPts val="1000"/>
-              </a:spcBef>
-            </a:pPr>
-            <a:r>
-              <a:rPr sz="1400" b="0">
-                <a:solidFill>
-                  <a:srgbClr val="0F172A"/>
-                </a:solidFill>
-                <a:latin typeface="맑은 고딕"/>
-                <a:ea typeface="맑은 고딕"/>
-                <a:cs typeface="맑은 고딕"/>
-              </a:rPr>
-              <a:t>• 결과: 공격성 트래픽을 입구에서 감소</a:t>
-            </a:r>
-          </a:p>
-        </p:txBody>
-      </p:sp>
-      <p:sp>
-        <p:nvSpPr>
-          <p:cNvPr id="6" name="TextBox 5"/>
+        </p:spPr>
+      </p:pic>
+      <p:sp>
+        <p:nvSpPr>
+          <p:cNvPr id="5" name="TextBox 4"/>
           <p:cNvSpPr txBox="1"/>
           <p:nvPr/>
         </p:nvSpPr>
@@ -6144,7 +5840,7 @@
                 <a:ea typeface="맑은 고딕"/>
                 <a:cs typeface="맑은 고딕"/>
               </a:rPr>
-              <a:t>7. 사용한 AWS · GitHub</a:t>
+              <a:t>7. HTTPS · WAF (2)</a:t>
             </a:r>
           </a:p>
           <a:p>
@@ -6162,38 +5858,342 @@
                 <a:ea typeface="맑은 고딕"/>
                 <a:cs typeface="맑은 고딕"/>
               </a:rPr>
-              <a:t>인프라 서비스와 자동화 도구를 한 장으로</a:t>
-            </a:r>
-          </a:p>
-        </p:txBody>
-      </p:sp>
-      <p:pic>
-        <p:nvPicPr>
-          <p:cNvPr id="4" name="Picture 3" descr="07_aws_github_stack.png"/>
-          <p:cNvPicPr>
-            <a:picLocks noChangeAspect="1"/>
-          </p:cNvPicPr>
+              <a:t>용어 말고 ‘무엇을 했는지’만</a:t>
+            </a:r>
+          </a:p>
+        </p:txBody>
+      </p:sp>
+      <p:sp>
+        <p:nvSpPr>
+          <p:cNvPr id="4" name="Rounded Rectangle 3"/>
+          <p:cNvSpPr/>
           <p:nvPr/>
-        </p:nvPicPr>
-        <p:blipFill>
-          <a:blip r:embed="rId2"/>
-          <a:stretch>
-            <a:fillRect/>
-          </a:stretch>
-        </p:blipFill>
-        <p:spPr>
-          <a:xfrm>
-            <a:off x="1244600" y="914400"/>
-            <a:ext cx="9672320" cy="5440680"/>
-          </a:xfrm>
-          <a:prstGeom prst="rect">
+        </p:nvSpPr>
+        <p:spPr>
+          <a:xfrm>
+            <a:off x="320040" y="1051560"/>
+            <a:ext cx="5669280" cy="5074920"/>
+          </a:xfrm>
+          <a:prstGeom prst="roundRect">
             <a:avLst/>
           </a:prstGeom>
-        </p:spPr>
-      </p:pic>
-      <p:sp>
-        <p:nvSpPr>
-          <p:cNvPr id="5" name="TextBox 4"/>
+          <a:solidFill>
+            <a:srgbClr val="EFF6FF"/>
+          </a:solidFill>
+          <a:ln w="19050">
+            <a:solidFill>
+              <a:srgbClr val="0D9488"/>
+            </a:solidFill>
+          </a:ln>
+        </p:spPr>
+        <p:style>
+          <a:lnRef idx="1">
+            <a:schemeClr val="accent1"/>
+          </a:lnRef>
+          <a:fillRef idx="3">
+            <a:schemeClr val="accent1"/>
+          </a:fillRef>
+          <a:effectRef idx="2">
+            <a:schemeClr val="accent1"/>
+          </a:effectRef>
+          <a:fontRef idx="minor">
+            <a:schemeClr val="lt1"/>
+          </a:fontRef>
+        </p:style>
+        <p:txBody>
+          <a:bodyPr rtlCol="0" anchor="ctr" wrap="square" lIns="109728" rIns="109728" tIns="73152" bIns="73152"/>
+          <a:lstStyle/>
+          <a:p>
+            <a:pPr algn="ctr"/>
+            <a:r>
+              <a:rPr sz="1700" b="1">
+                <a:solidFill>
+                  <a:srgbClr val="0D9488"/>
+                </a:solidFill>
+                <a:latin typeface="맑은 고딕"/>
+                <a:ea typeface="맑은 고딕"/>
+                <a:cs typeface="맑은 고딕"/>
+              </a:rPr>
+              <a:t>HTTPS — 통신 암호화</a:t>
+            </a:r>
+          </a:p>
+          <a:p>
+            <a:pPr>
+              <a:spcBef>
+                <a:spcPts val="800"/>
+              </a:spcBef>
+            </a:pPr>
+            <a:r>
+              <a:rPr sz="1200" b="1">
+                <a:solidFill>
+                  <a:srgbClr val="475569"/>
+                </a:solidFill>
+                <a:latin typeface="맑은 고딕"/>
+                <a:ea typeface="맑은 고딕"/>
+                <a:cs typeface="맑은 고딕"/>
+              </a:rPr>
+              <a:t>쉽게: 사이트와 사용자 사이 내용을 남이 못 보게 잠근다</a:t>
+            </a:r>
+          </a:p>
+          <a:p>
+            <a:pPr>
+              <a:spcBef>
+                <a:spcPts val="1000"/>
+              </a:spcBef>
+            </a:pPr>
+            <a:r>
+              <a:rPr sz="1400" b="0">
+                <a:solidFill>
+                  <a:srgbClr val="0F172A"/>
+                </a:solidFill>
+                <a:latin typeface="맑은 고딕"/>
+                <a:ea typeface="맑은 고딕"/>
+                <a:cs typeface="맑은 고딕"/>
+              </a:rPr>
+              <a:t>• ACM = 인증서(자물쇠) 발급 서비스</a:t>
+            </a:r>
+          </a:p>
+          <a:p>
+            <a:pPr>
+              <a:spcBef>
+                <a:spcPts val="1000"/>
+              </a:spcBef>
+            </a:pPr>
+            <a:r>
+              <a:rPr sz="1400" b="0">
+                <a:solidFill>
+                  <a:srgbClr val="0F172A"/>
+                </a:solidFill>
+                <a:latin typeface="맑은 고딕"/>
+                <a:ea typeface="맑은 고딕"/>
+                <a:cs typeface="맑은 고딕"/>
+              </a:rPr>
+              <a:t>• aniverse.my 용 인증서를 ALB에 붙임</a:t>
+            </a:r>
+          </a:p>
+          <a:p>
+            <a:pPr>
+              <a:spcBef>
+                <a:spcPts val="1000"/>
+              </a:spcBef>
+            </a:pPr>
+            <a:r>
+              <a:rPr sz="1400" b="0">
+                <a:solidFill>
+                  <a:srgbClr val="0F172A"/>
+                </a:solidFill>
+                <a:latin typeface="맑은 고딕"/>
+                <a:ea typeface="맑은 고딕"/>
+                <a:cs typeface="맑은 고딕"/>
+              </a:rPr>
+              <a:t>• https(443)로 접속 받기</a:t>
+            </a:r>
+          </a:p>
+          <a:p>
+            <a:pPr>
+              <a:spcBef>
+                <a:spcPts val="1000"/>
+              </a:spcBef>
+            </a:pPr>
+            <a:r>
+              <a:rPr sz="1400" b="0">
+                <a:solidFill>
+                  <a:srgbClr val="0F172A"/>
+                </a:solidFill>
+                <a:latin typeface="맑은 고딕"/>
+                <a:ea typeface="맑은 고딕"/>
+                <a:cs typeface="맑은 고딕"/>
+              </a:rPr>
+              <a:t>• http로 들어오면 https로 자동 이동</a:t>
+            </a:r>
+          </a:p>
+          <a:p>
+            <a:pPr>
+              <a:spcBef>
+                <a:spcPts val="1000"/>
+              </a:spcBef>
+            </a:pPr>
+            <a:r>
+              <a:rPr sz="1400" b="0">
+                <a:solidFill>
+                  <a:srgbClr val="0F172A"/>
+                </a:solidFill>
+                <a:latin typeface="맑은 고딕"/>
+                <a:ea typeface="맑은 고딕"/>
+                <a:cs typeface="맑은 고딕"/>
+              </a:rPr>
+              <a:t>• 결과: https://aniverse.my + 자물쇠</a:t>
+            </a:r>
+          </a:p>
+        </p:txBody>
+      </p:sp>
+      <p:sp>
+        <p:nvSpPr>
+          <p:cNvPr id="5" name="Rounded Rectangle 4"/>
+          <p:cNvSpPr/>
+          <p:nvPr/>
+        </p:nvSpPr>
+        <p:spPr>
+          <a:xfrm>
+            <a:off x="6217920" y="1051560"/>
+            <a:ext cx="5623560" cy="5074920"/>
+          </a:xfrm>
+          <a:prstGeom prst="roundRect">
+            <a:avLst/>
+          </a:prstGeom>
+          <a:solidFill>
+            <a:srgbClr val="FEF2F2"/>
+          </a:solidFill>
+          <a:ln w="19050">
+            <a:solidFill>
+              <a:srgbClr val="DC2626"/>
+            </a:solidFill>
+          </a:ln>
+        </p:spPr>
+        <p:style>
+          <a:lnRef idx="1">
+            <a:schemeClr val="accent1"/>
+          </a:lnRef>
+          <a:fillRef idx="3">
+            <a:schemeClr val="accent1"/>
+          </a:fillRef>
+          <a:effectRef idx="2">
+            <a:schemeClr val="accent1"/>
+          </a:effectRef>
+          <a:fontRef idx="minor">
+            <a:schemeClr val="lt1"/>
+          </a:fontRef>
+        </p:style>
+        <p:txBody>
+          <a:bodyPr rtlCol="0" anchor="ctr" wrap="square" lIns="109728" rIns="109728" tIns="73152" bIns="73152"/>
+          <a:lstStyle/>
+          <a:p>
+            <a:pPr algn="ctr"/>
+            <a:r>
+              <a:rPr sz="1700" b="1">
+                <a:solidFill>
+                  <a:srgbClr val="DC2626"/>
+                </a:solidFill>
+                <a:latin typeface="맑은 고딕"/>
+                <a:ea typeface="맑은 고딕"/>
+                <a:cs typeface="맑은 고딕"/>
+              </a:rPr>
+              <a:t>WAF — 앞단 문지기</a:t>
+            </a:r>
+          </a:p>
+          <a:p>
+            <a:pPr>
+              <a:spcBef>
+                <a:spcPts val="800"/>
+              </a:spcBef>
+            </a:pPr>
+            <a:r>
+              <a:rPr sz="1200" b="1">
+                <a:solidFill>
+                  <a:srgbClr val="475569"/>
+                </a:solidFill>
+                <a:latin typeface="맑은 고딕"/>
+                <a:ea typeface="맑은 고딕"/>
+                <a:cs typeface="맑은 고딕"/>
+              </a:rPr>
+              <a:t>쉽게: 서버 들어가기 전에 나쁜 요청을 막는다</a:t>
+            </a:r>
+          </a:p>
+          <a:p>
+            <a:pPr>
+              <a:spcBef>
+                <a:spcPts val="1000"/>
+              </a:spcBef>
+            </a:pPr>
+            <a:r>
+              <a:rPr sz="1400" b="0">
+                <a:solidFill>
+                  <a:srgbClr val="0F172A"/>
+                </a:solidFill>
+                <a:latin typeface="맑은 고딕"/>
+                <a:ea typeface="맑은 고딕"/>
+                <a:cs typeface="맑은 고딕"/>
+              </a:rPr>
+              <a:t>• WAF = 웹 방화벽 (ALB 앞)</a:t>
+            </a:r>
+          </a:p>
+          <a:p>
+            <a:pPr>
+              <a:spcBef>
+                <a:spcPts val="1000"/>
+              </a:spcBef>
+            </a:pPr>
+            <a:r>
+              <a:rPr sz="1400" b="0">
+                <a:solidFill>
+                  <a:srgbClr val="0F172A"/>
+                </a:solidFill>
+                <a:latin typeface="맑은 고딕"/>
+                <a:ea typeface="맑은 고딕"/>
+                <a:cs typeface="맑은 고딕"/>
+              </a:rPr>
+              <a:t>• SQL 삽입·이상한 입력 차단</a:t>
+            </a:r>
+          </a:p>
+          <a:p>
+            <a:pPr>
+              <a:spcBef>
+                <a:spcPts val="1000"/>
+              </a:spcBef>
+            </a:pPr>
+            <a:r>
+              <a:rPr sz="1400" b="0">
+                <a:solidFill>
+                  <a:srgbClr val="0F172A"/>
+                </a:solidFill>
+                <a:latin typeface="맑은 고딕"/>
+                <a:ea typeface="맑은 고딕"/>
+                <a:cs typeface="맑은 고딕"/>
+              </a:rPr>
+              <a:t>• 한 IP가 너무 자주 치면 차단</a:t>
+            </a:r>
+          </a:p>
+          <a:p>
+            <a:pPr>
+              <a:spcBef>
+                <a:spcPts val="1000"/>
+              </a:spcBef>
+            </a:pPr>
+            <a:r>
+              <a:rPr sz="1400" b="0">
+                <a:solidFill>
+                  <a:srgbClr val="0F172A"/>
+                </a:solidFill>
+                <a:latin typeface="맑은 고딕"/>
+                <a:ea typeface="맑은 고딕"/>
+                <a:cs typeface="맑은 고딕"/>
+              </a:rPr>
+              <a:t>• 통과한 요청만 EC2로 전달</a:t>
+            </a:r>
+          </a:p>
+          <a:p>
+            <a:pPr>
+              <a:spcBef>
+                <a:spcPts val="1000"/>
+              </a:spcBef>
+            </a:pPr>
+            <a:r>
+              <a:rPr sz="1400" b="0">
+                <a:solidFill>
+                  <a:srgbClr val="0F172A"/>
+                </a:solidFill>
+                <a:latin typeface="맑은 고딕"/>
+                <a:ea typeface="맑은 고딕"/>
+                <a:cs typeface="맑은 고딕"/>
+              </a:rPr>
+              <a:t>• 결과: 공격성 트래픽을 입구에서 감소</a:t>
+            </a:r>
+          </a:p>
+        </p:txBody>
+      </p:sp>
+      <p:sp>
+        <p:nvSpPr>
+          <p:cNvPr id="6" name="TextBox 5"/>
           <p:cNvSpPr txBox="1"/>
           <p:nvPr/>
         </p:nvSpPr>
@@ -6639,7 +6639,7 @@
                 <a:ea typeface="맑은 고딕"/>
                 <a:cs typeface="맑은 고딕"/>
               </a:rPr>
-              <a:t>03  Terraform으로 구성한 인프라</a:t>
+              <a:t>03  기술 스택 (AWS · GitHub)</a:t>
             </a:r>
           </a:p>
         </p:txBody>
@@ -6695,7 +6695,7 @@
                 <a:ea typeface="맑은 고딕"/>
                 <a:cs typeface="맑은 고딕"/>
               </a:rPr>
-              <a:t>04  GitHub Actions 자동화</a:t>
+              <a:t>04  Terraform으로 구성한 인프라</a:t>
             </a:r>
           </a:p>
         </p:txBody>
@@ -6751,7 +6751,7 @@
                 <a:ea typeface="맑은 고딕"/>
                 <a:cs typeface="맑은 고딕"/>
               </a:rPr>
-              <a:t>05  CI/CD · 고가용성 · 모니터링 · 보안</a:t>
+              <a:t>05  GitHub Actions 자동화</a:t>
             </a:r>
           </a:p>
         </p:txBody>
@@ -6807,7 +6807,7 @@
                 <a:ea typeface="맑은 고딕"/>
                 <a:cs typeface="맑은 고딕"/>
               </a:rPr>
-              <a:t>06  HTTPS · WAF</a:t>
+              <a:t>06  CI/CD · 고가용성 · 모니터링 · 보안</a:t>
             </a:r>
           </a:p>
         </p:txBody>
@@ -6863,7 +6863,7 @@
                 <a:ea typeface="맑은 고딕"/>
                 <a:cs typeface="맑은 고딕"/>
               </a:rPr>
-              <a:t>07  사용한 AWS · GitHub 한 장 정리</a:t>
+              <a:t>07  HTTPS · WAF</a:t>
             </a:r>
           </a:p>
         </p:txBody>
@@ -7941,7 +7941,7 @@
                 <a:ea typeface="맑은 고딕"/>
                 <a:cs typeface="맑은 고딕"/>
               </a:rPr>
-              <a:t>3. Terraform 인프라 구성 (1)</a:t>
+              <a:t>3. 기술 스택</a:t>
             </a:r>
           </a:p>
           <a:p>
@@ -7959,14 +7959,14 @@
                 <a:ea typeface="맑은 고딕"/>
                 <a:cs typeface="맑은 고딕"/>
               </a:rPr>
-              <a:t>온프레미스 3-Tier를 AWS 서비스로 대응</a:t>
+              <a:t>이제부터 쓸 AWS · GitHub 도구를 한 장으로 먼저 보기</a:t>
             </a:r>
           </a:p>
         </p:txBody>
       </p:sp>
       <p:pic>
         <p:nvPicPr>
-          <p:cNvPr id="4" name="Picture 3" descr="02_aws_overview.png"/>
+          <p:cNvPr id="4" name="Picture 3" descr="07_aws_github_stack.png"/>
           <p:cNvPicPr>
             <a:picLocks noChangeAspect="1"/>
           </p:cNvPicPr>
@@ -7980,8 +7980,8 @@
         </p:blipFill>
         <p:spPr>
           <a:xfrm>
-            <a:off x="1285240" y="960120"/>
-            <a:ext cx="9591040" cy="5394960"/>
+            <a:off x="1203960" y="868680"/>
+            <a:ext cx="9753600" cy="5486400"/>
           </a:xfrm>
           <a:prstGeom prst="rect">
             <a:avLst/>
@@ -8117,7 +8117,7 @@
                 <a:ea typeface="맑은 고딕"/>
                 <a:cs typeface="맑은 고딕"/>
               </a:rPr>
-              <a:t>3. Terraform 인프라 구성 (2)</a:t>
+              <a:t>4. Terraform 인프라 구성 (1)</a:t>
             </a:r>
           </a:p>
           <a:p>
@@ -8135,14 +8135,14 @@
                 <a:ea typeface="맑은 고딕"/>
                 <a:cs typeface="맑은 고딕"/>
               </a:rPr>
-              <a:t>모듈을 나눠 만들고 environments/dev 에서 조립</a:t>
+              <a:t>온프레미스 3-Tier를 AWS 서비스로 대응</a:t>
             </a:r>
           </a:p>
         </p:txBody>
       </p:sp>
       <p:pic>
         <p:nvPicPr>
-          <p:cNvPr id="4" name="Picture 3" descr="03_terraform_modules.png"/>
+          <p:cNvPr id="4" name="Picture 3" descr="02_aws_overview.png"/>
           <p:cNvPicPr>
             <a:picLocks noChangeAspect="1"/>
           </p:cNvPicPr>
@@ -8156,8 +8156,8 @@
         </p:blipFill>
         <p:spPr>
           <a:xfrm>
-            <a:off x="1244600" y="914400"/>
-            <a:ext cx="9672320" cy="5440680"/>
+            <a:off x="1285240" y="960120"/>
+            <a:ext cx="9591040" cy="5394960"/>
           </a:xfrm>
           <a:prstGeom prst="rect">
             <a:avLst/>
@@ -8293,7 +8293,7 @@
                 <a:ea typeface="맑은 고딕"/>
                 <a:cs typeface="맑은 고딕"/>
               </a:rPr>
-              <a:t>3. Terraform 인프라 구성 (3)</a:t>
+              <a:t>4. Terraform 인프라 구성 (2)</a:t>
             </a:r>
           </a:p>
           <a:p>
@@ -8311,432 +8311,38 @@
                 <a:ea typeface="맑은 고딕"/>
                 <a:cs typeface="맑은 고딕"/>
               </a:rPr>
-              <a:t>주요 리소스와 연결 관계</a:t>
-            </a:r>
-          </a:p>
-        </p:txBody>
-      </p:sp>
-      <p:sp>
-        <p:nvSpPr>
-          <p:cNvPr id="4" name="Rounded Rectangle 3"/>
-          <p:cNvSpPr/>
+              <a:t>모듈을 나눠 만들고 environments/dev 에서 조립</a:t>
+            </a:r>
+          </a:p>
+        </p:txBody>
+      </p:sp>
+      <p:pic>
+        <p:nvPicPr>
+          <p:cNvPr id="4" name="Picture 3" descr="03_terraform_modules.png"/>
+          <p:cNvPicPr>
+            <a:picLocks noChangeAspect="1"/>
+          </p:cNvPicPr>
           <p:nvPr/>
-        </p:nvSpPr>
-        <p:spPr>
-          <a:xfrm>
-            <a:off x="320040" y="1051560"/>
-            <a:ext cx="5715000" cy="5074920"/>
-          </a:xfrm>
-          <a:prstGeom prst="roundRect">
+        </p:nvPicPr>
+        <p:blipFill>
+          <a:blip r:embed="rId2"/>
+          <a:stretch>
+            <a:fillRect/>
+          </a:stretch>
+        </p:blipFill>
+        <p:spPr>
+          <a:xfrm>
+            <a:off x="1244600" y="914400"/>
+            <a:ext cx="9672320" cy="5440680"/>
+          </a:xfrm>
+          <a:prstGeom prst="rect">
             <a:avLst/>
           </a:prstGeom>
-          <a:solidFill>
-            <a:srgbClr val="EFF6FF"/>
-          </a:solidFill>
-          <a:ln w="19050">
-            <a:solidFill>
-              <a:srgbClr val="2563EB"/>
-            </a:solidFill>
-          </a:ln>
-        </p:spPr>
-        <p:style>
-          <a:lnRef idx="1">
-            <a:schemeClr val="accent1"/>
-          </a:lnRef>
-          <a:fillRef idx="3">
-            <a:schemeClr val="accent1"/>
-          </a:fillRef>
-          <a:effectRef idx="2">
-            <a:schemeClr val="accent1"/>
-          </a:effectRef>
-          <a:fontRef idx="minor">
-            <a:schemeClr val="lt1"/>
-          </a:fontRef>
-        </p:style>
-        <p:txBody>
-          <a:bodyPr rtlCol="0" anchor="ctr" wrap="square" lIns="109728" rIns="109728" tIns="73152" bIns="73152"/>
-          <a:lstStyle/>
-          <a:p>
-            <a:pPr algn="ctr"/>
-            <a:r>
-              <a:rPr sz="1600" b="1">
-                <a:solidFill>
-                  <a:srgbClr val="2563EB"/>
-                </a:solidFill>
-                <a:latin typeface="맑은 고딕"/>
-                <a:ea typeface="맑은 고딕"/>
-                <a:cs typeface="맑은 고딕"/>
-              </a:rPr>
-              <a:t>계층별 구성</a:t>
-            </a:r>
-          </a:p>
-          <a:p>
-            <a:pPr>
-              <a:spcBef>
-                <a:spcPts val="700"/>
-              </a:spcBef>
-            </a:pPr>
-            <a:r>
-              <a:rPr sz="1200" b="0">
-                <a:solidFill>
-                  <a:srgbClr val="0F172A"/>
-                </a:solidFill>
-                <a:latin typeface="맑은 고딕"/>
-                <a:ea typeface="맑은 고딕"/>
-                <a:cs typeface="맑은 고딕"/>
-              </a:rPr>
-              <a:t>• Network: VPC · Public/Private Subnet · IGW · NAT</a:t>
-            </a:r>
-          </a:p>
-          <a:p>
-            <a:pPr>
-              <a:spcBef>
-                <a:spcPts val="700"/>
-              </a:spcBef>
-            </a:pPr>
-            <a:r>
-              <a:rPr sz="1200" b="0">
-                <a:solidFill>
-                  <a:srgbClr val="0F172A"/>
-                </a:solidFill>
-                <a:latin typeface="맑은 고딕"/>
-                <a:ea typeface="맑은 고딕"/>
-                <a:cs typeface="맑은 고딕"/>
-              </a:rPr>
-              <a:t>• Security: ALB / App / NAT / DB / EFS</a:t>
-            </a:r>
-          </a:p>
-          <a:p>
-            <a:pPr>
-              <a:spcBef>
-                <a:spcPts val="700"/>
-              </a:spcBef>
-            </a:pPr>
-            <a:r>
-              <a:rPr sz="1200" b="0">
-                <a:solidFill>
-                  <a:srgbClr val="0F172A"/>
-                </a:solidFill>
-                <a:latin typeface="맑은 고딕"/>
-                <a:ea typeface="맑은 고딕"/>
-                <a:cs typeface="맑은 고딕"/>
-              </a:rPr>
-              <a:t>    Redis / endpoints 용 Security Group</a:t>
-            </a:r>
-          </a:p>
-          <a:p>
-            <a:pPr>
-              <a:spcBef>
-                <a:spcPts val="700"/>
-              </a:spcBef>
-            </a:pPr>
-            <a:r>
-              <a:rPr sz="1200" b="0">
-                <a:solidFill>
-                  <a:srgbClr val="0F172A"/>
-                </a:solidFill>
-                <a:latin typeface="맑은 고딕"/>
-                <a:ea typeface="맑은 고딕"/>
-                <a:cs typeface="맑은 고딕"/>
-              </a:rPr>
-              <a:t>• Traffic: ALB · Target Group · HTTPS Listener</a:t>
-            </a:r>
-          </a:p>
-          <a:p>
-            <a:pPr>
-              <a:spcBef>
-                <a:spcPts val="700"/>
-              </a:spcBef>
-            </a:pPr>
-            <a:r>
-              <a:rPr sz="1200" b="0">
-                <a:solidFill>
-                  <a:srgbClr val="0F172A"/>
-                </a:solidFill>
-                <a:latin typeface="맑은 고딕"/>
-                <a:ea typeface="맑은 고딕"/>
-                <a:cs typeface="맑은 고딕"/>
-              </a:rPr>
-              <a:t>• Compute: Launch Template · ASG · IAM Role</a:t>
-            </a:r>
-          </a:p>
-          <a:p>
-            <a:pPr>
-              <a:spcBef>
-                <a:spcPts val="700"/>
-              </a:spcBef>
-            </a:pPr>
-            <a:r>
-              <a:rPr sz="1200" b="0">
-                <a:solidFill>
-                  <a:srgbClr val="0F172A"/>
-                </a:solidFill>
-                <a:latin typeface="맑은 고딕"/>
-                <a:ea typeface="맑은 고딕"/>
-                <a:cs typeface="맑은 고딕"/>
-              </a:rPr>
-              <a:t>• Data: RDS MariaDB · EFS · S3</a:t>
-            </a:r>
-          </a:p>
-          <a:p>
-            <a:pPr>
-              <a:spcBef>
-                <a:spcPts val="700"/>
-              </a:spcBef>
-            </a:pPr>
-            <a:r>
-              <a:rPr sz="1200" b="0">
-                <a:solidFill>
-                  <a:srgbClr val="0F172A"/>
-                </a:solidFill>
-                <a:latin typeface="맑은 고딕"/>
-                <a:ea typeface="맑은 고딕"/>
-                <a:cs typeface="맑은 고딕"/>
-              </a:rPr>
-              <a:t>• Ops: Secrets Manager · WAF · Redis · CodeDeploy</a:t>
-            </a:r>
-          </a:p>
-        </p:txBody>
-      </p:sp>
-      <p:sp>
-        <p:nvSpPr>
-          <p:cNvPr id="5" name="Rounded Rectangle 4"/>
-          <p:cNvSpPr/>
-          <p:nvPr/>
-        </p:nvSpPr>
-        <p:spPr>
-          <a:xfrm>
-            <a:off x="6263640" y="1051560"/>
-            <a:ext cx="5577840" cy="5074920"/>
-          </a:xfrm>
-          <a:prstGeom prst="roundRect">
-            <a:avLst/>
-          </a:prstGeom>
-          <a:solidFill>
-            <a:srgbClr val="F8FAFC"/>
-          </a:solidFill>
-          <a:ln w="19050">
-            <a:solidFill>
-              <a:srgbClr val="0D9488"/>
-            </a:solidFill>
-          </a:ln>
-        </p:spPr>
-        <p:style>
-          <a:lnRef idx="1">
-            <a:schemeClr val="accent1"/>
-          </a:lnRef>
-          <a:fillRef idx="3">
-            <a:schemeClr val="accent1"/>
-          </a:fillRef>
-          <a:effectRef idx="2">
-            <a:schemeClr val="accent1"/>
-          </a:effectRef>
-          <a:fontRef idx="minor">
-            <a:schemeClr val="lt1"/>
-          </a:fontRef>
-        </p:style>
-        <p:txBody>
-          <a:bodyPr rtlCol="0" anchor="ctr" wrap="square" lIns="109728" rIns="109728" tIns="73152" bIns="73152"/>
-          <a:lstStyle/>
-          <a:p>
-            <a:pPr algn="ctr"/>
-            <a:r>
-              <a:rPr sz="1600" b="1">
-                <a:solidFill>
-                  <a:srgbClr val="0D9488"/>
-                </a:solidFill>
-                <a:latin typeface="맑은 고딕"/>
-                <a:ea typeface="맑은 고딕"/>
-                <a:cs typeface="맑은 고딕"/>
-              </a:rPr>
-              <a:t>조립 방식</a:t>
-            </a:r>
-          </a:p>
-          <a:p>
-            <a:pPr>
-              <a:spcBef>
-                <a:spcPts val="500"/>
-              </a:spcBef>
-            </a:pPr>
-            <a:r>
-              <a:rPr sz="1200" b="0">
-                <a:solidFill>
-                  <a:srgbClr val="0F172A"/>
-                </a:solidFill>
-                <a:latin typeface="맑은 고딕"/>
-                <a:ea typeface="맑은 고딕"/>
-                <a:cs typeface="맑은 고딕"/>
-              </a:rPr>
-              <a:t>1) S3 + DynamoDB로 Remote State 환경 선구축</a:t>
-            </a:r>
-          </a:p>
-          <a:p>
-            <a:pPr>
-              <a:spcBef>
-                <a:spcPts val="500"/>
-              </a:spcBef>
-            </a:pPr>
-            <a:r>
-              <a:rPr sz="1200" b="0">
-                <a:solidFill>
-                  <a:srgbClr val="0F172A"/>
-                </a:solidFill>
-                <a:latin typeface="맑은 고딕"/>
-                <a:ea typeface="맑은 고딕"/>
-                <a:cs typeface="맑은 고딕"/>
-              </a:rPr>
-              <a:t>2) 팀원이 모듈 PR로 기능 단위 작성</a:t>
-            </a:r>
-          </a:p>
-          <a:p>
-            <a:pPr>
-              <a:spcBef>
-                <a:spcPts val="500"/>
-              </a:spcBef>
-            </a:pPr>
-            <a:r>
-              <a:rPr sz="1200" b="0">
-                <a:solidFill>
-                  <a:srgbClr val="0F172A"/>
-                </a:solidFill>
-                <a:latin typeface="맑은 고딕"/>
-                <a:ea typeface="맑은 고딕"/>
-                <a:cs typeface="맑은 고딕"/>
-              </a:rPr>
-              <a:t>3) outputs.tf 로 vpc_id, sg_id 등 연결</a:t>
-            </a:r>
-          </a:p>
-          <a:p>
-            <a:pPr>
-              <a:spcBef>
-                <a:spcPts val="500"/>
-              </a:spcBef>
-            </a:pPr>
-            <a:r>
-              <a:rPr sz="1200" b="0">
-                <a:solidFill>
-                  <a:srgbClr val="0F172A"/>
-                </a:solidFill>
-                <a:latin typeface="맑은 고딕"/>
-                <a:ea typeface="맑은 고딕"/>
-                <a:cs typeface="맑은 고딕"/>
-              </a:rPr>
-              <a:t>4) environments/dev/main.tf 에서 module 호출</a:t>
-            </a:r>
-          </a:p>
-          <a:p>
-            <a:pPr>
-              <a:spcBef>
-                <a:spcPts val="500"/>
-              </a:spcBef>
-            </a:pPr>
-            <a:r>
-              <a:rPr sz="1200" b="0">
-                <a:solidFill>
-                  <a:srgbClr val="0F172A"/>
-                </a:solidFill>
-                <a:latin typeface="맑은 고딕"/>
-                <a:ea typeface="맑은 고딕"/>
-                <a:cs typeface="맑은 고딕"/>
-              </a:rPr>
-              <a:t>5) terraform plan / apply 로 한 번에 반영</a:t>
-            </a:r>
-          </a:p>
-          <a:p>
-            <a:pPr>
-              <a:spcBef>
-                <a:spcPts val="500"/>
-              </a:spcBef>
-            </a:pPr>
-            <a:r>
-              <a:rPr sz="1200" b="0">
-                <a:solidFill>
-                  <a:srgbClr val="0F172A"/>
-                </a:solidFill>
-                <a:latin typeface="맑은 고딕"/>
-                <a:ea typeface="맑은 고딕"/>
-                <a:cs typeface="맑은 고딕"/>
-              </a:rPr>
-              <a:t/>
-            </a:r>
-          </a:p>
-          <a:p>
-            <a:pPr>
-              <a:spcBef>
-                <a:spcPts val="500"/>
-              </a:spcBef>
-            </a:pPr>
-            <a:r>
-              <a:rPr sz="1200" b="0">
-                <a:solidFill>
-                  <a:srgbClr val="0F172A"/>
-                </a:solidFill>
-                <a:latin typeface="맑은 고딕"/>
-                <a:ea typeface="맑은 고딕"/>
-                <a:cs typeface="맑은 고딕"/>
-              </a:rPr>
-              <a:t>결과</a:t>
-            </a:r>
-          </a:p>
-          <a:p>
-            <a:pPr>
-              <a:spcBef>
-                <a:spcPts val="500"/>
-              </a:spcBef>
-            </a:pPr>
-            <a:r>
-              <a:rPr sz="1200" b="0">
-                <a:solidFill>
-                  <a:srgbClr val="0F172A"/>
-                </a:solidFill>
-                <a:latin typeface="맑은 고딕"/>
-                <a:ea typeface="맑은 고딕"/>
-                <a:cs typeface="맑은 고딕"/>
-              </a:rPr>
-              <a:t>• 인프라가 코드로 리뷰·재현 가능</a:t>
-            </a:r>
-          </a:p>
-          <a:p>
-            <a:pPr>
-              <a:spcBef>
-                <a:spcPts val="500"/>
-              </a:spcBef>
-            </a:pPr>
-            <a:r>
-              <a:rPr sz="1200" b="0">
-                <a:solidFill>
-                  <a:srgbClr val="0F172A"/>
-                </a:solidFill>
-                <a:latin typeface="맑은 고딕"/>
-                <a:ea typeface="맑은 고딕"/>
-                <a:cs typeface="맑은 고딕"/>
-              </a:rPr>
-              <a:t>• 서버 ‘기억 의존’ 감소</a:t>
-            </a:r>
-          </a:p>
-          <a:p>
-            <a:pPr>
-              <a:spcBef>
-                <a:spcPts val="500"/>
-              </a:spcBef>
-            </a:pPr>
-            <a:r>
-              <a:rPr sz="1200" b="0">
-                <a:solidFill>
-                  <a:srgbClr val="0F172A"/>
-                </a:solidFill>
-                <a:latin typeface="맑은 고딕"/>
-                <a:ea typeface="맑은 고딕"/>
-                <a:cs typeface="맑은 고딕"/>
-              </a:rPr>
-              <a:t>• 팀 전체가 충돌 없이 동시 작업 가능 (State Lock)</a:t>
-            </a:r>
-          </a:p>
-        </p:txBody>
-      </p:sp>
-      <p:sp>
-        <p:nvSpPr>
-          <p:cNvPr id="6" name="TextBox 5"/>
+        </p:spPr>
+      </p:pic>
+      <p:sp>
+        <p:nvSpPr>
+          <p:cNvPr id="5" name="TextBox 4"/>
           <p:cNvSpPr txBox="1"/>
           <p:nvPr/>
         </p:nvSpPr>
@@ -8863,7 +8469,7 @@
                 <a:ea typeface="맑은 고딕"/>
                 <a:cs typeface="맑은 고딕"/>
               </a:rPr>
-              <a:t>3. 데이터베이스·스토리지 구성</a:t>
+              <a:t>4. Terraform 인프라 구성 (3)</a:t>
             </a:r>
           </a:p>
           <a:p>
@@ -8881,38 +8487,432 @@
                 <a:ea typeface="맑은 고딕"/>
                 <a:cs typeface="맑은 고딕"/>
               </a:rPr>
-              <a:t>김윤주 Data &amp; Storage — RDS · EFS · S3 (AWS 공식 아이콘)</a:t>
-            </a:r>
-          </a:p>
-        </p:txBody>
-      </p:sp>
-      <p:pic>
-        <p:nvPicPr>
-          <p:cNvPr id="4" name="Picture 3" descr="08_storage_roles.png"/>
-          <p:cNvPicPr>
-            <a:picLocks noChangeAspect="1"/>
-          </p:cNvPicPr>
+              <a:t>주요 리소스와 연결 관계</a:t>
+            </a:r>
+          </a:p>
+        </p:txBody>
+      </p:sp>
+      <p:sp>
+        <p:nvSpPr>
+          <p:cNvPr id="4" name="Rounded Rectangle 3"/>
+          <p:cNvSpPr/>
           <p:nvPr/>
-        </p:nvPicPr>
-        <p:blipFill>
-          <a:blip r:embed="rId2"/>
-          <a:stretch>
-            <a:fillRect/>
-          </a:stretch>
-        </p:blipFill>
-        <p:spPr>
-          <a:xfrm>
-            <a:off x="1203960" y="868680"/>
-            <a:ext cx="9753600" cy="5486400"/>
-          </a:xfrm>
-          <a:prstGeom prst="rect">
+        </p:nvSpPr>
+        <p:spPr>
+          <a:xfrm>
+            <a:off x="320040" y="1051560"/>
+            <a:ext cx="5715000" cy="5074920"/>
+          </a:xfrm>
+          <a:prstGeom prst="roundRect">
             <a:avLst/>
           </a:prstGeom>
-        </p:spPr>
-      </p:pic>
-      <p:sp>
-        <p:nvSpPr>
-          <p:cNvPr id="5" name="TextBox 4"/>
+          <a:solidFill>
+            <a:srgbClr val="EFF6FF"/>
+          </a:solidFill>
+          <a:ln w="19050">
+            <a:solidFill>
+              <a:srgbClr val="2563EB"/>
+            </a:solidFill>
+          </a:ln>
+        </p:spPr>
+        <p:style>
+          <a:lnRef idx="1">
+            <a:schemeClr val="accent1"/>
+          </a:lnRef>
+          <a:fillRef idx="3">
+            <a:schemeClr val="accent1"/>
+          </a:fillRef>
+          <a:effectRef idx="2">
+            <a:schemeClr val="accent1"/>
+          </a:effectRef>
+          <a:fontRef idx="minor">
+            <a:schemeClr val="lt1"/>
+          </a:fontRef>
+        </p:style>
+        <p:txBody>
+          <a:bodyPr rtlCol="0" anchor="ctr" wrap="square" lIns="109728" rIns="109728" tIns="73152" bIns="73152"/>
+          <a:lstStyle/>
+          <a:p>
+            <a:pPr algn="ctr"/>
+            <a:r>
+              <a:rPr sz="1600" b="1">
+                <a:solidFill>
+                  <a:srgbClr val="2563EB"/>
+                </a:solidFill>
+                <a:latin typeface="맑은 고딕"/>
+                <a:ea typeface="맑은 고딕"/>
+                <a:cs typeface="맑은 고딕"/>
+              </a:rPr>
+              <a:t>계층별 구성</a:t>
+            </a:r>
+          </a:p>
+          <a:p>
+            <a:pPr>
+              <a:spcBef>
+                <a:spcPts val="700"/>
+              </a:spcBef>
+            </a:pPr>
+            <a:r>
+              <a:rPr sz="1200" b="0">
+                <a:solidFill>
+                  <a:srgbClr val="0F172A"/>
+                </a:solidFill>
+                <a:latin typeface="맑은 고딕"/>
+                <a:ea typeface="맑은 고딕"/>
+                <a:cs typeface="맑은 고딕"/>
+              </a:rPr>
+              <a:t>• Network: VPC · Public/Private Subnet · IGW · NAT</a:t>
+            </a:r>
+          </a:p>
+          <a:p>
+            <a:pPr>
+              <a:spcBef>
+                <a:spcPts val="700"/>
+              </a:spcBef>
+            </a:pPr>
+            <a:r>
+              <a:rPr sz="1200" b="0">
+                <a:solidFill>
+                  <a:srgbClr val="0F172A"/>
+                </a:solidFill>
+                <a:latin typeface="맑은 고딕"/>
+                <a:ea typeface="맑은 고딕"/>
+                <a:cs typeface="맑은 고딕"/>
+              </a:rPr>
+              <a:t>• Security: ALB / App / NAT / DB / EFS</a:t>
+            </a:r>
+          </a:p>
+          <a:p>
+            <a:pPr>
+              <a:spcBef>
+                <a:spcPts val="700"/>
+              </a:spcBef>
+            </a:pPr>
+            <a:r>
+              <a:rPr sz="1200" b="0">
+                <a:solidFill>
+                  <a:srgbClr val="0F172A"/>
+                </a:solidFill>
+                <a:latin typeface="맑은 고딕"/>
+                <a:ea typeface="맑은 고딕"/>
+                <a:cs typeface="맑은 고딕"/>
+              </a:rPr>
+              <a:t>    Redis / endpoints 용 Security Group</a:t>
+            </a:r>
+          </a:p>
+          <a:p>
+            <a:pPr>
+              <a:spcBef>
+                <a:spcPts val="700"/>
+              </a:spcBef>
+            </a:pPr>
+            <a:r>
+              <a:rPr sz="1200" b="0">
+                <a:solidFill>
+                  <a:srgbClr val="0F172A"/>
+                </a:solidFill>
+                <a:latin typeface="맑은 고딕"/>
+                <a:ea typeface="맑은 고딕"/>
+                <a:cs typeface="맑은 고딕"/>
+              </a:rPr>
+              <a:t>• Traffic: ALB · Target Group · HTTPS Listener</a:t>
+            </a:r>
+          </a:p>
+          <a:p>
+            <a:pPr>
+              <a:spcBef>
+                <a:spcPts val="700"/>
+              </a:spcBef>
+            </a:pPr>
+            <a:r>
+              <a:rPr sz="1200" b="0">
+                <a:solidFill>
+                  <a:srgbClr val="0F172A"/>
+                </a:solidFill>
+                <a:latin typeface="맑은 고딕"/>
+                <a:ea typeface="맑은 고딕"/>
+                <a:cs typeface="맑은 고딕"/>
+              </a:rPr>
+              <a:t>• Compute: Launch Template · ASG · IAM Role</a:t>
+            </a:r>
+          </a:p>
+          <a:p>
+            <a:pPr>
+              <a:spcBef>
+                <a:spcPts val="700"/>
+              </a:spcBef>
+            </a:pPr>
+            <a:r>
+              <a:rPr sz="1200" b="0">
+                <a:solidFill>
+                  <a:srgbClr val="0F172A"/>
+                </a:solidFill>
+                <a:latin typeface="맑은 고딕"/>
+                <a:ea typeface="맑은 고딕"/>
+                <a:cs typeface="맑은 고딕"/>
+              </a:rPr>
+              <a:t>• Data: RDS MariaDB · EFS · S3</a:t>
+            </a:r>
+          </a:p>
+          <a:p>
+            <a:pPr>
+              <a:spcBef>
+                <a:spcPts val="700"/>
+              </a:spcBef>
+            </a:pPr>
+            <a:r>
+              <a:rPr sz="1200" b="0">
+                <a:solidFill>
+                  <a:srgbClr val="0F172A"/>
+                </a:solidFill>
+                <a:latin typeface="맑은 고딕"/>
+                <a:ea typeface="맑은 고딕"/>
+                <a:cs typeface="맑은 고딕"/>
+              </a:rPr>
+              <a:t>• Ops: Secrets Manager · WAF · Redis · CodeDeploy</a:t>
+            </a:r>
+          </a:p>
+        </p:txBody>
+      </p:sp>
+      <p:sp>
+        <p:nvSpPr>
+          <p:cNvPr id="5" name="Rounded Rectangle 4"/>
+          <p:cNvSpPr/>
+          <p:nvPr/>
+        </p:nvSpPr>
+        <p:spPr>
+          <a:xfrm>
+            <a:off x="6263640" y="1051560"/>
+            <a:ext cx="5577840" cy="5074920"/>
+          </a:xfrm>
+          <a:prstGeom prst="roundRect">
+            <a:avLst/>
+          </a:prstGeom>
+          <a:solidFill>
+            <a:srgbClr val="F8FAFC"/>
+          </a:solidFill>
+          <a:ln w="19050">
+            <a:solidFill>
+              <a:srgbClr val="0D9488"/>
+            </a:solidFill>
+          </a:ln>
+        </p:spPr>
+        <p:style>
+          <a:lnRef idx="1">
+            <a:schemeClr val="accent1"/>
+          </a:lnRef>
+          <a:fillRef idx="3">
+            <a:schemeClr val="accent1"/>
+          </a:fillRef>
+          <a:effectRef idx="2">
+            <a:schemeClr val="accent1"/>
+          </a:effectRef>
+          <a:fontRef idx="minor">
+            <a:schemeClr val="lt1"/>
+          </a:fontRef>
+        </p:style>
+        <p:txBody>
+          <a:bodyPr rtlCol="0" anchor="ctr" wrap="square" lIns="109728" rIns="109728" tIns="73152" bIns="73152"/>
+          <a:lstStyle/>
+          <a:p>
+            <a:pPr algn="ctr"/>
+            <a:r>
+              <a:rPr sz="1600" b="1">
+                <a:solidFill>
+                  <a:srgbClr val="0D9488"/>
+                </a:solidFill>
+                <a:latin typeface="맑은 고딕"/>
+                <a:ea typeface="맑은 고딕"/>
+                <a:cs typeface="맑은 고딕"/>
+              </a:rPr>
+              <a:t>조립 방식</a:t>
+            </a:r>
+          </a:p>
+          <a:p>
+            <a:pPr>
+              <a:spcBef>
+                <a:spcPts val="500"/>
+              </a:spcBef>
+            </a:pPr>
+            <a:r>
+              <a:rPr sz="1200" b="0">
+                <a:solidFill>
+                  <a:srgbClr val="0F172A"/>
+                </a:solidFill>
+                <a:latin typeface="맑은 고딕"/>
+                <a:ea typeface="맑은 고딕"/>
+                <a:cs typeface="맑은 고딕"/>
+              </a:rPr>
+              <a:t>1) S3 + DynamoDB로 Remote State 환경 선구축</a:t>
+            </a:r>
+          </a:p>
+          <a:p>
+            <a:pPr>
+              <a:spcBef>
+                <a:spcPts val="500"/>
+              </a:spcBef>
+            </a:pPr>
+            <a:r>
+              <a:rPr sz="1200" b="0">
+                <a:solidFill>
+                  <a:srgbClr val="0F172A"/>
+                </a:solidFill>
+                <a:latin typeface="맑은 고딕"/>
+                <a:ea typeface="맑은 고딕"/>
+                <a:cs typeface="맑은 고딕"/>
+              </a:rPr>
+              <a:t>2) 팀원이 모듈 PR로 기능 단위 작성</a:t>
+            </a:r>
+          </a:p>
+          <a:p>
+            <a:pPr>
+              <a:spcBef>
+                <a:spcPts val="500"/>
+              </a:spcBef>
+            </a:pPr>
+            <a:r>
+              <a:rPr sz="1200" b="0">
+                <a:solidFill>
+                  <a:srgbClr val="0F172A"/>
+                </a:solidFill>
+                <a:latin typeface="맑은 고딕"/>
+                <a:ea typeface="맑은 고딕"/>
+                <a:cs typeface="맑은 고딕"/>
+              </a:rPr>
+              <a:t>3) outputs.tf 로 vpc_id, sg_id 등 연결</a:t>
+            </a:r>
+          </a:p>
+          <a:p>
+            <a:pPr>
+              <a:spcBef>
+                <a:spcPts val="500"/>
+              </a:spcBef>
+            </a:pPr>
+            <a:r>
+              <a:rPr sz="1200" b="0">
+                <a:solidFill>
+                  <a:srgbClr val="0F172A"/>
+                </a:solidFill>
+                <a:latin typeface="맑은 고딕"/>
+                <a:ea typeface="맑은 고딕"/>
+                <a:cs typeface="맑은 고딕"/>
+              </a:rPr>
+              <a:t>4) environments/dev/main.tf 에서 module 호출</a:t>
+            </a:r>
+          </a:p>
+          <a:p>
+            <a:pPr>
+              <a:spcBef>
+                <a:spcPts val="500"/>
+              </a:spcBef>
+            </a:pPr>
+            <a:r>
+              <a:rPr sz="1200" b="0">
+                <a:solidFill>
+                  <a:srgbClr val="0F172A"/>
+                </a:solidFill>
+                <a:latin typeface="맑은 고딕"/>
+                <a:ea typeface="맑은 고딕"/>
+                <a:cs typeface="맑은 고딕"/>
+              </a:rPr>
+              <a:t>5) terraform plan / apply 로 한 번에 반영</a:t>
+            </a:r>
+          </a:p>
+          <a:p>
+            <a:pPr>
+              <a:spcBef>
+                <a:spcPts val="500"/>
+              </a:spcBef>
+            </a:pPr>
+            <a:r>
+              <a:rPr sz="1200" b="0">
+                <a:solidFill>
+                  <a:srgbClr val="0F172A"/>
+                </a:solidFill>
+                <a:latin typeface="맑은 고딕"/>
+                <a:ea typeface="맑은 고딕"/>
+                <a:cs typeface="맑은 고딕"/>
+              </a:rPr>
+              <a:t/>
+            </a:r>
+          </a:p>
+          <a:p>
+            <a:pPr>
+              <a:spcBef>
+                <a:spcPts val="500"/>
+              </a:spcBef>
+            </a:pPr>
+            <a:r>
+              <a:rPr sz="1200" b="0">
+                <a:solidFill>
+                  <a:srgbClr val="0F172A"/>
+                </a:solidFill>
+                <a:latin typeface="맑은 고딕"/>
+                <a:ea typeface="맑은 고딕"/>
+                <a:cs typeface="맑은 고딕"/>
+              </a:rPr>
+              <a:t>결과</a:t>
+            </a:r>
+          </a:p>
+          <a:p>
+            <a:pPr>
+              <a:spcBef>
+                <a:spcPts val="500"/>
+              </a:spcBef>
+            </a:pPr>
+            <a:r>
+              <a:rPr sz="1200" b="0">
+                <a:solidFill>
+                  <a:srgbClr val="0F172A"/>
+                </a:solidFill>
+                <a:latin typeface="맑은 고딕"/>
+                <a:ea typeface="맑은 고딕"/>
+                <a:cs typeface="맑은 고딕"/>
+              </a:rPr>
+              <a:t>• 인프라가 코드로 리뷰·재현 가능</a:t>
+            </a:r>
+          </a:p>
+          <a:p>
+            <a:pPr>
+              <a:spcBef>
+                <a:spcPts val="500"/>
+              </a:spcBef>
+            </a:pPr>
+            <a:r>
+              <a:rPr sz="1200" b="0">
+                <a:solidFill>
+                  <a:srgbClr val="0F172A"/>
+                </a:solidFill>
+                <a:latin typeface="맑은 고딕"/>
+                <a:ea typeface="맑은 고딕"/>
+                <a:cs typeface="맑은 고딕"/>
+              </a:rPr>
+              <a:t>• 서버 ‘기억 의존’ 감소</a:t>
+            </a:r>
+          </a:p>
+          <a:p>
+            <a:pPr>
+              <a:spcBef>
+                <a:spcPts val="500"/>
+              </a:spcBef>
+            </a:pPr>
+            <a:r>
+              <a:rPr sz="1200" b="0">
+                <a:solidFill>
+                  <a:srgbClr val="0F172A"/>
+                </a:solidFill>
+                <a:latin typeface="맑은 고딕"/>
+                <a:ea typeface="맑은 고딕"/>
+                <a:cs typeface="맑은 고딕"/>
+              </a:rPr>
+              <a:t>• 팀 전체가 충돌 없이 동시 작업 가능 (State Lock)</a:t>
+            </a:r>
+          </a:p>
+        </p:txBody>
+      </p:sp>
+      <p:sp>
+        <p:nvSpPr>
+          <p:cNvPr id="6" name="TextBox 5"/>
           <p:cNvSpPr txBox="1"/>
           <p:nvPr/>
         </p:nvSpPr>

</xml_diff>